<commit_message>
Add Contents/TOC slide after the title slide
Insert a five-item table of contents matching the deck's section
dividers, and renumber all page numbers to stay continuous.

Co-Authored-By: Claude Sonnet 4.6 <noreply@anthropic.com>
Claude-Session: https://claude.ai/code/session_01UcZX9gdfC56CAidpRSm7mN
</commit_message>
<xml_diff>
--- a/presentation_full.pptx
+++ b/presentation_full.pptx
@@ -9,10 +9,10 @@
   </p:notesMasterIdLst>
   <p:sldIdLst>
     <p:sldId id="256" r:id="rId2"/>
+    <p:sldId id="260" r:id="rId11"/>
     <p:sldId id="257" r:id="rId3"/>
     <p:sldId id="258" r:id="rId4"/>
     <p:sldId id="259" r:id="rId5"/>
-    <p:sldId id="260" r:id="rId11"/>
     <p:sldId id="261" r:id="rId12"/>
     <p:sldId id="262" r:id="rId13"/>
     <p:sldId id="263" r:id="rId14"/>
@@ -37,6 +37,7 @@
     <p:sldId id="282" r:id="rId33"/>
     <p:sldId id="283" r:id="rId34"/>
     <p:sldId id="284" r:id="rId35"/>
+    <p:sldId id="285" r:id="rId36"/>
   </p:sldIdLst>
   <p:sldSz cx="9144000" cy="5143500" type="screen16x9"/>
   <p:notesSz cx="5143500" cy="9144000"/>
@@ -1256,7 +1257,7 @@
                 <a:ea typeface="Noto Sans CJK KR" pitchFamily="34" charset="-122"/>
                 <a:cs typeface="Noto Sans CJK KR" pitchFamily="34" charset="-120"/>
               </a:rPr>
-              <a:t>DLL - MAC: 동기화와 타임슬롯</a:t>
+              <a:t>DLL - Master 프레임 구조</a:t>
             </a:r>
             <a:endParaRPr lang="en-US" sz="3600" dirty="0"/>
           </a:p>
@@ -1271,7 +1272,7 @@
         <p:spPr>
           <a:xfrm>
             <a:off x="548640" y="1234440"/>
-            <a:ext cx="8046720" cy="1371600"/>
+            <a:ext cx="8046720" cy="2057400"/>
           </a:xfrm>
           <a:prstGeom prst="rect">
             <a:avLst/>
@@ -1284,6 +1285,27 @@
           <a:lstStyle/>
           <a:p>
             <a:pPr marL="342900" indent="-342900">
+              <a:spcAft>
+                <a:spcPts val="800"/>
+              </a:spcAft>
+              <a:buSzPct val="100000"/>
+              <a:buChar char="•"/>
+            </a:pPr>
+            <a:r>
+              <a:rPr lang="en-US" sz="1900" dirty="0">
+                <a:solidFill>
+                  <a:srgbClr val="222222"/>
+                </a:solidFill>
+                <a:latin typeface="Noto Sans CJK KR" pitchFamily="34" charset="0"/>
+                <a:ea typeface="Noto Sans CJK KR" pitchFamily="34" charset="-122"/>
+                <a:cs typeface="Noto Sans CJK KR" pitchFamily="34" charset="-120"/>
+              </a:rPr>
+              <a:t>필드 구성</a:t>
+            </a:r>
+            <a:endParaRPr lang="en-US" sz="1900" dirty="0"/>
+          </a:p>
+          <a:p>
+            <a:pPr lvl="1" marL="685800" indent="-342900">
               <a:spcAft>
                 <a:spcPts val="600"/>
               </a:spcAft>
@@ -1291,41 +1313,41 @@
               <a:buChar char="•"/>
             </a:pPr>
             <a:r>
-              <a:rPr lang="en-US" sz="1800" dirty="0">
-                <a:solidFill>
-                  <a:srgbClr val="222222"/>
-                </a:solidFill>
-                <a:latin typeface="Noto Sans CJK KR" pitchFamily="34" charset="0"/>
-                <a:ea typeface="Noto Sans CJK KR" pitchFamily="34" charset="-122"/>
-                <a:cs typeface="Noto Sans CJK KR" pitchFamily="34" charset="-120"/>
-              </a:rPr>
-              <a:t>Sync 기준점</a:t>
-            </a:r>
-            <a:endParaRPr lang="en-US" sz="1800" dirty="0"/>
-          </a:p>
-          <a:p>
-            <a:pPr lvl="1" marL="685800" indent="-342900">
+              <a:rPr lang="en-US" sz="1600" dirty="0">
+                <a:solidFill>
+                  <a:srgbClr val="444444"/>
+                </a:solidFill>
+                <a:latin typeface="Noto Sans CJK KR" pitchFamily="34" charset="0"/>
+                <a:ea typeface="Noto Sans CJK KR" pitchFamily="34" charset="-122"/>
+                <a:cs typeface="Noto Sans CJK KR" pitchFamily="34" charset="-120"/>
+              </a:rPr>
+              <a:t>preamble(8) + halt_cmd(8) + guard_ticks(10) + reserved(17) + hamming parity(7)</a:t>
+            </a:r>
+            <a:endParaRPr lang="en-US" sz="1900" dirty="0"/>
+          </a:p>
+          <a:p>
+            <a:pPr marL="342900" indent="-342900">
               <a:spcAft>
-                <a:spcPts val="400"/>
+                <a:spcPts val="800"/>
               </a:spcAft>
               <a:buSzPct val="100000"/>
               <a:buChar char="•"/>
             </a:pPr>
             <a:r>
-              <a:rPr lang="en-US" sz="1500" dirty="0">
-                <a:solidFill>
-                  <a:srgbClr val="444444"/>
-                </a:solidFill>
-                <a:latin typeface="Noto Sans CJK KR" pitchFamily="34" charset="0"/>
-                <a:ea typeface="Noto Sans CJK KR" pitchFamily="34" charset="-122"/>
-                <a:cs typeface="Noto Sans CJK KR" pitchFamily="34" charset="-120"/>
-              </a:rPr>
-              <a:t>Master가 매 사이클 마지막 슬롯에서 전송한 sync를 다음 사이클 슬롯 계산 기준점으로 사용</a:t>
-            </a:r>
-            <a:endParaRPr lang="en-US" sz="1800" dirty="0"/>
-          </a:p>
-          <a:p>
-            <a:pPr marL="342900" indent="-342900">
+              <a:rPr lang="en-US" sz="1900" dirty="0">
+                <a:solidFill>
+                  <a:srgbClr val="222222"/>
+                </a:solidFill>
+                <a:latin typeface="Noto Sans CJK KR" pitchFamily="34" charset="0"/>
+                <a:ea typeface="Noto Sans CJK KR" pitchFamily="34" charset="-122"/>
+                <a:cs typeface="Noto Sans CJK KR" pitchFamily="34" charset="-120"/>
+              </a:rPr>
+              <a:t>halt_cmd</a:t>
+            </a:r>
+            <a:endParaRPr lang="en-US" sz="1900" dirty="0"/>
+          </a:p>
+          <a:p>
+            <a:pPr lvl="1" marL="685800" indent="-342900">
               <a:spcAft>
                 <a:spcPts val="600"/>
               </a:spcAft>
@@ -1333,49 +1355,28 @@
               <a:buChar char="•"/>
             </a:pPr>
             <a:r>
-              <a:rPr lang="en-US" sz="1800" dirty="0">
-                <a:solidFill>
-                  <a:srgbClr val="222222"/>
-                </a:solidFill>
-                <a:latin typeface="Noto Sans CJK KR" pitchFamily="34" charset="0"/>
-                <a:ea typeface="Noto Sans CJK KR" pitchFamily="34" charset="-122"/>
-                <a:cs typeface="Noto Sans CJK KR" pitchFamily="34" charset="-120"/>
-              </a:rPr>
-              <a:t>슬롯 내부 구조</a:t>
-            </a:r>
-            <a:endParaRPr lang="en-US" sz="1800" dirty="0"/>
-          </a:p>
-          <a:p>
-            <a:pPr lvl="1" marL="685800" indent="-342900">
+              <a:rPr lang="en-US" sz="1600" dirty="0">
+                <a:solidFill>
+                  <a:srgbClr val="444444"/>
+                </a:solidFill>
+                <a:latin typeface="Noto Sans CJK KR" pitchFamily="34" charset="0"/>
+                <a:ea typeface="Noto Sans CJK KR" pitchFamily="34" charset="-122"/>
+                <a:cs typeface="Noto Sans CJK KR" pitchFamily="34" charset="-120"/>
+              </a:rPr>
+              <a:t>슬레이브별 1비트 마스크 — err_cnt가 임계치(FAULT_TH) 초과 시 해당 비트 set, 고장 슬레이브 중단 명령</a:t>
+            </a:r>
+            <a:endParaRPr lang="en-US" sz="1900" dirty="0"/>
+          </a:p>
+          <a:p>
+            <a:pPr marL="342900" indent="-342900">
               <a:spcAft>
-                <a:spcPts val="400"/>
+                <a:spcPts val="800"/>
               </a:spcAft>
               <a:buSzPct val="100000"/>
               <a:buChar char="•"/>
             </a:pPr>
             <a:r>
-              <a:rPr lang="en-US" sz="1500" dirty="0">
-                <a:solidFill>
-                  <a:srgbClr val="444444"/>
-                </a:solidFill>
-                <a:latin typeface="Noto Sans CJK KR" pitchFamily="34" charset="0"/>
-                <a:ea typeface="Noto Sans CJK KR" pitchFamily="34" charset="-122"/>
-                <a:cs typeface="Noto Sans CJK KR" pitchFamily="34" charset="-120"/>
-              </a:rPr>
-              <a:t>½ guard tick 대기 → 데이터 전송 → ½ guard tick 대기</a:t>
-            </a:r>
-            <a:endParaRPr lang="en-US" sz="1800" dirty="0"/>
-          </a:p>
-          <a:p>
-            <a:pPr marL="342900" indent="-342900">
-              <a:spcAft>
-                <a:spcPts val="600"/>
-              </a:spcAft>
-              <a:buSzPct val="100000"/>
-              <a:buChar char="•"/>
-            </a:pPr>
-            <a:r>
-              <a:rPr lang="en-US" sz="1800" dirty="0">
+              <a:rPr lang="en-US" sz="1900" dirty="0">
                 <a:solidFill>
                   <a:srgbClr val="222222"/>
                 </a:solidFill>
@@ -1383,9 +1384,9 @@
                 <a:ea typeface="Noto Sans CJK KR" pitchFamily="34" charset="-122"/>
                 <a:cs typeface="Noto Sans CJK KR" pitchFamily="34" charset="-120"/>
               </a:rPr>
-              <a:t>Guard Tick의 역할</a:t>
-            </a:r>
-            <a:endParaRPr lang="en-US" sz="1800" dirty="0"/>
+              <a:t>에러 검출/정정</a:t>
+            </a:r>
+            <a:endParaRPr lang="en-US" sz="1900" dirty="0"/>
           </a:p>
           <a:p>
             <a:pPr lvl="1" marL="685800" indent="-342900">
@@ -1393,7 +1394,7 @@
               <a:buChar char="•"/>
             </a:pPr>
             <a:r>
-              <a:rPr lang="en-US" sz="1500" dirty="0">
+              <a:rPr lang="en-US" sz="1600" dirty="0">
                 <a:solidFill>
                   <a:srgbClr val="444444"/>
                 </a:solidFill>
@@ -1401,15 +1402,15 @@
                 <a:ea typeface="Noto Sans CJK KR" pitchFamily="34" charset="-122"/>
                 <a:cs typeface="Noto Sans CJK KR" pitchFamily="34" charset="-120"/>
               </a:rPr>
-              <a:t>인접 슬롯의 절반씩이 경계에서 맞물려 슬롯 침범 방지</a:t>
-            </a:r>
-            <a:endParaRPr lang="en-US" sz="1800" dirty="0"/>
+              <a:t>Slave 프레임과 동일한 SEC-DED 방식 적용</a:t>
+            </a:r>
+            <a:endParaRPr lang="en-US" sz="1900" dirty="0"/>
           </a:p>
         </p:txBody>
       </p:sp>
       <p:pic>
         <p:nvPicPr>
-          <p:cNvPr id="4" name="Image 0" descr="/home/user/SoC_Design_and_Programming/diagrams/slot_timeline.png">    </p:cNvPr>
+          <p:cNvPr id="4" name="Image 0" descr="/home/user/SoC_Design_and_Programming/diagrams/master_frame.png">    </p:cNvPr>
           <p:cNvPicPr>
             <a:picLocks noChangeAspect="1"/>
           </p:cNvPicPr>
@@ -1422,8 +1423,8 @@
         </p:blipFill>
         <p:spPr>
           <a:xfrm>
-            <a:off x="1371600" y="2743200"/>
-            <a:ext cx="6400800" cy="2081893"/>
+            <a:off x="548640" y="3383280"/>
+            <a:ext cx="8046720" cy="563270"/>
           </a:xfrm>
           <a:prstGeom prst="rect">
             <a:avLst/>
@@ -1438,8 +1439,8 @@
         </p:nvSpPr>
         <p:spPr>
           <a:xfrm>
-            <a:off x="1371600" y="4916533"/>
-            <a:ext cx="6400800" cy="228600"/>
+            <a:off x="548640" y="4037990"/>
+            <a:ext cx="8046720" cy="228600"/>
           </a:xfrm>
           <a:prstGeom prst="rect">
             <a:avLst/>
@@ -1463,7 +1464,7 @@
                 <a:ea typeface="Noto Sans CJK KR" pitchFamily="34" charset="-122"/>
                 <a:cs typeface="Noto Sans CJK KR" pitchFamily="34" charset="-120"/>
               </a:rPr>
-              <a:t>Sync → [½G · 데이터 · ½G] × (Slot 0...N) → Sync</a:t>
+              <a:t>Master 프레임 비트필드 (전송 순서: preamble → halt_cmd → guard_ticks → reserved → hamming)</a:t>
             </a:r>
             <a:endParaRPr lang="en-US" sz="900" dirty="0"/>
           </a:p>
@@ -1559,7 +1560,7 @@
                 <a:ea typeface="Noto Sans CJK KR" pitchFamily="34" charset="-122"/>
                 <a:cs typeface="Noto Sans CJK KR" pitchFamily="34" charset="-120"/>
               </a:rPr>
-              <a:t>DLL - Flow Control</a:t>
+              <a:t>DLL - MAC: 동기화와 타임슬롯</a:t>
             </a:r>
             <a:endParaRPr lang="en-US" sz="3600" dirty="0"/>
           </a:p>
@@ -1574,7 +1575,7 @@
         <p:spPr>
           <a:xfrm>
             <a:off x="548640" y="1234440"/>
-            <a:ext cx="4023360" cy="2971800"/>
+            <a:ext cx="8046720" cy="1371600"/>
           </a:xfrm>
           <a:prstGeom prst="rect">
             <a:avLst/>
@@ -1588,13 +1589,13 @@
           <a:p>
             <a:pPr marL="342900" indent="-342900">
               <a:spcAft>
-                <a:spcPts val="1200"/>
+                <a:spcPts val="600"/>
               </a:spcAft>
               <a:buSzPct val="100000"/>
               <a:buChar char="•"/>
             </a:pPr>
             <a:r>
-              <a:rPr lang="en-US" sz="2000" dirty="0">
+              <a:rPr lang="en-US" sz="1800" dirty="0">
                 <a:solidFill>
                   <a:srgbClr val="222222"/>
                 </a:solidFill>
@@ -1602,20 +1603,20 @@
                 <a:ea typeface="Noto Sans CJK KR" pitchFamily="34" charset="-122"/>
                 <a:cs typeface="Noto Sans CJK KR" pitchFamily="34" charset="-120"/>
               </a:rPr>
-              <a:t>1비트 에러</a:t>
-            </a:r>
-            <a:endParaRPr lang="en-US" sz="2000" dirty="0"/>
+              <a:t>Sync 기준점</a:t>
+            </a:r>
+            <a:endParaRPr lang="en-US" sz="1800" dirty="0"/>
           </a:p>
           <a:p>
             <a:pPr lvl="1" marL="685800" indent="-342900">
               <a:spcAft>
-                <a:spcPts val="800"/>
+                <a:spcPts val="400"/>
               </a:spcAft>
               <a:buSzPct val="100000"/>
               <a:buChar char="•"/>
             </a:pPr>
             <a:r>
-              <a:rPr lang="en-US" sz="1700" dirty="0">
+              <a:rPr lang="en-US" sz="1500" dirty="0">
                 <a:solidFill>
                   <a:srgbClr val="444444"/>
                 </a:solidFill>
@@ -1623,20 +1624,20 @@
                 <a:ea typeface="Noto Sans CJK KR" pitchFamily="34" charset="-122"/>
                 <a:cs typeface="Noto Sans CJK KR" pitchFamily="34" charset="-120"/>
               </a:rPr>
-              <a:t>Hamming으로 정정하여 정상 데이터로 사용</a:t>
-            </a:r>
-            <a:endParaRPr lang="en-US" sz="2000" dirty="0"/>
+              <a:t>Master가 매 사이클 마지막 슬롯에서 전송한 sync를 다음 사이클 슬롯 계산 기준점으로 사용</a:t>
+            </a:r>
+            <a:endParaRPr lang="en-US" sz="1800" dirty="0"/>
           </a:p>
           <a:p>
             <a:pPr marL="342900" indent="-342900">
               <a:spcAft>
-                <a:spcPts val="1200"/>
+                <a:spcPts val="600"/>
               </a:spcAft>
               <a:buSzPct val="100000"/>
               <a:buChar char="•"/>
             </a:pPr>
             <a:r>
-              <a:rPr lang="en-US" sz="2000" dirty="0">
+              <a:rPr lang="en-US" sz="1800" dirty="0">
                 <a:solidFill>
                   <a:srgbClr val="222222"/>
                 </a:solidFill>
@@ -1644,20 +1645,20 @@
                 <a:ea typeface="Noto Sans CJK KR" pitchFamily="34" charset="-122"/>
                 <a:cs typeface="Noto Sans CJK KR" pitchFamily="34" charset="-120"/>
               </a:rPr>
-              <a:t>2비트 에러 (정정 불가)</a:t>
-            </a:r>
-            <a:endParaRPr lang="en-US" sz="2000" dirty="0"/>
+              <a:t>슬롯 내부 구조</a:t>
+            </a:r>
+            <a:endParaRPr lang="en-US" sz="1800" dirty="0"/>
           </a:p>
           <a:p>
             <a:pPr lvl="1" marL="685800" indent="-342900">
               <a:spcAft>
-                <a:spcPts val="800"/>
+                <a:spcPts val="400"/>
               </a:spcAft>
               <a:buSzPct val="100000"/>
               <a:buChar char="•"/>
             </a:pPr>
             <a:r>
-              <a:rPr lang="en-US" sz="1700" dirty="0">
+              <a:rPr lang="en-US" sz="1500" dirty="0">
                 <a:solidFill>
                   <a:srgbClr val="444444"/>
                 </a:solidFill>
@@ -1665,20 +1666,20 @@
                 <a:ea typeface="Noto Sans CJK KR" pitchFamily="34" charset="-122"/>
                 <a:cs typeface="Noto Sans CJK KR" pitchFamily="34" charset="-120"/>
               </a:rPr>
-              <a:t>해당 프레임을 무효 처리하고 폐기, 이전 값 유지</a:t>
-            </a:r>
-            <a:endParaRPr lang="en-US" sz="2000" dirty="0"/>
+              <a:t>½ guard tick 대기 → 데이터 전송 → ½ guard tick 대기</a:t>
+            </a:r>
+            <a:endParaRPr lang="en-US" sz="1800" dirty="0"/>
           </a:p>
           <a:p>
             <a:pPr marL="342900" indent="-342900">
               <a:spcAft>
-                <a:spcPts val="1200"/>
+                <a:spcPts val="600"/>
               </a:spcAft>
               <a:buSzPct val="100000"/>
               <a:buChar char="•"/>
             </a:pPr>
             <a:r>
-              <a:rPr lang="en-US" sz="2000" dirty="0">
+              <a:rPr lang="en-US" sz="1800" dirty="0">
                 <a:solidFill>
                   <a:srgbClr val="222222"/>
                 </a:solidFill>
@@ -1686,9 +1687,9 @@
                 <a:ea typeface="Noto Sans CJK KR" pitchFamily="34" charset="-122"/>
                 <a:cs typeface="Noto Sans CJK KR" pitchFamily="34" charset="-120"/>
               </a:rPr>
-              <a:t>Implicit Flow Control</a:t>
-            </a:r>
-            <a:endParaRPr lang="en-US" sz="2000" dirty="0"/>
+              <a:t>Guard Tick의 역할</a:t>
+            </a:r>
+            <a:endParaRPr lang="en-US" sz="1800" dirty="0"/>
           </a:p>
           <a:p>
             <a:pPr lvl="1" marL="685800" indent="-342900">
@@ -1696,7 +1697,7 @@
               <a:buChar char="•"/>
             </a:pPr>
             <a:r>
-              <a:rPr lang="en-US" sz="1700" dirty="0">
+              <a:rPr lang="en-US" sz="1500" dirty="0">
                 <a:solidFill>
                   <a:srgbClr val="444444"/>
                 </a:solidFill>
@@ -1704,15 +1705,15 @@
                 <a:ea typeface="Noto Sans CJK KR" pitchFamily="34" charset="-122"/>
                 <a:cs typeface="Noto Sans CJK KR" pitchFamily="34" charset="-120"/>
               </a:rPr>
-              <a:t>명시적 재전송 요청(ARQ/NACK) 없음 — 다음 TDMA 사이클의 갱신 데이터를 기다림</a:t>
-            </a:r>
-            <a:endParaRPr lang="en-US" sz="2000" dirty="0"/>
+              <a:t>인접 슬롯의 절반씩이 경계에서 맞물려 슬롯 침범 방지</a:t>
+            </a:r>
+            <a:endParaRPr lang="en-US" sz="1800" dirty="0"/>
           </a:p>
         </p:txBody>
       </p:sp>
       <p:pic>
         <p:nvPicPr>
-          <p:cNvPr id="4" name="Image 0" descr="/home/user/SoC_Design_and_Programming/diagrams/flow_control.png">    </p:cNvPr>
+          <p:cNvPr id="4" name="Image 0" descr="/home/user/SoC_Design_and_Programming/diagrams/slot_timeline.png">    </p:cNvPr>
           <p:cNvPicPr>
             <a:picLocks noChangeAspect="1"/>
           </p:cNvPicPr>
@@ -1725,8 +1726,8 @@
         </p:blipFill>
         <p:spPr>
           <a:xfrm>
-            <a:off x="5029200" y="1371600"/>
-            <a:ext cx="3200400" cy="2319606"/>
+            <a:off x="1371600" y="2743200"/>
+            <a:ext cx="6400800" cy="2081893"/>
           </a:xfrm>
           <a:prstGeom prst="rect">
             <a:avLst/>
@@ -1736,6 +1737,45 @@
       <p:sp>
         <p:nvSpPr>
           <p:cNvPr id="5" name="Text 2"/>
+          <p:cNvSpPr/>
+          <p:nvPr/>
+        </p:nvSpPr>
+        <p:spPr>
+          <a:xfrm>
+            <a:off x="1371600" y="4916533"/>
+            <a:ext cx="6400800" cy="228600"/>
+          </a:xfrm>
+          <a:prstGeom prst="rect">
+            <a:avLst/>
+          </a:prstGeom>
+          <a:noFill/>
+          <a:ln/>
+        </p:spPr>
+        <p:txBody>
+          <a:bodyPr wrap="square" rtlCol="0" anchor="ctr"/>
+          <a:lstStyle/>
+          <a:p>
+            <a:pPr algn="ctr" indent="0" marL="0">
+              <a:buNone/>
+            </a:pPr>
+            <a:r>
+              <a:rPr lang="en-US" sz="900" dirty="0">
+                <a:solidFill>
+                  <a:srgbClr val="999999"/>
+                </a:solidFill>
+                <a:latin typeface="Noto Sans CJK KR" pitchFamily="34" charset="0"/>
+                <a:ea typeface="Noto Sans CJK KR" pitchFamily="34" charset="-122"/>
+                <a:cs typeface="Noto Sans CJK KR" pitchFamily="34" charset="-120"/>
+              </a:rPr>
+              <a:t>Sync → [½G · 데이터 · ½G] × (Slot 0...N) → Sync</a:t>
+            </a:r>
+            <a:endParaRPr lang="en-US" sz="900" dirty="0"/>
+          </a:p>
+        </p:txBody>
+      </p:sp>
+      <p:sp>
+        <p:nvSpPr>
+          <p:cNvPr id="6" name="Text 3"/>
           <p:cNvSpPr/>
           <p:nvPr/>
         </p:nvSpPr>
@@ -1781,6 +1821,270 @@
 </file>
 
 <file path=ppt/slides/slide12.xml><?xml version="1.0" encoding="utf-8"?>
+<p:sld xmlns:a="http://schemas.openxmlformats.org/drawingml/2006/main" xmlns:p="http://schemas.openxmlformats.org/presentationml/2006/main" xmlns:r="http://schemas.openxmlformats.org/officeDocument/2006/relationships">
+  <p:cSld>
+    <p:spTree>
+      <p:nvGrpSpPr>
+        <p:cNvPr id="1" name=""/>
+        <p:cNvGrpSpPr/>
+        <p:nvPr/>
+      </p:nvGrpSpPr>
+      <p:grpSpPr/>
+      <p:sp>
+        <p:nvSpPr>
+          <p:cNvPr id="2" name="Text 0"/>
+          <p:cNvSpPr/>
+          <p:nvPr/>
+        </p:nvSpPr>
+        <p:spPr>
+          <a:xfrm>
+            <a:off x="548640" y="274320"/>
+            <a:ext cx="8046720" cy="777240"/>
+          </a:xfrm>
+          <a:prstGeom prst="rect">
+            <a:avLst/>
+          </a:prstGeom>
+          <a:noFill/>
+          <a:ln/>
+        </p:spPr>
+        <p:txBody>
+          <a:bodyPr wrap="square" lIns="0" tIns="0" rIns="0" bIns="0" rtlCol="0" anchor="ctr"/>
+          <a:lstStyle/>
+          <a:p>
+            <a:pPr indent="0" marL="0">
+              <a:buNone/>
+            </a:pPr>
+            <a:r>
+              <a:rPr lang="en-US" sz="3600" b="1" dirty="0">
+                <a:solidFill>
+                  <a:srgbClr val="111111"/>
+                </a:solidFill>
+                <a:latin typeface="Noto Sans CJK KR" pitchFamily="34" charset="0"/>
+                <a:ea typeface="Noto Sans CJK KR" pitchFamily="34" charset="-122"/>
+                <a:cs typeface="Noto Sans CJK KR" pitchFamily="34" charset="-120"/>
+              </a:rPr>
+              <a:t>DLL - Flow Control</a:t>
+            </a:r>
+            <a:endParaRPr lang="en-US" sz="3600" dirty="0"/>
+          </a:p>
+        </p:txBody>
+      </p:sp>
+      <p:sp>
+        <p:nvSpPr>
+          <p:cNvPr id="3" name="Text 1"/>
+          <p:cNvSpPr/>
+          <p:nvPr/>
+        </p:nvSpPr>
+        <p:spPr>
+          <a:xfrm>
+            <a:off x="548640" y="1234440"/>
+            <a:ext cx="4023360" cy="2971800"/>
+          </a:xfrm>
+          <a:prstGeom prst="rect">
+            <a:avLst/>
+          </a:prstGeom>
+          <a:noFill/>
+          <a:ln/>
+        </p:spPr>
+        <p:txBody>
+          <a:bodyPr wrap="square" rtlCol="0" anchor="t"/>
+          <a:lstStyle/>
+          <a:p>
+            <a:pPr marL="342900" indent="-342900">
+              <a:spcAft>
+                <a:spcPts val="1200"/>
+              </a:spcAft>
+              <a:buSzPct val="100000"/>
+              <a:buChar char="•"/>
+            </a:pPr>
+            <a:r>
+              <a:rPr lang="en-US" sz="2000" dirty="0">
+                <a:solidFill>
+                  <a:srgbClr val="222222"/>
+                </a:solidFill>
+                <a:latin typeface="Noto Sans CJK KR" pitchFamily="34" charset="0"/>
+                <a:ea typeface="Noto Sans CJK KR" pitchFamily="34" charset="-122"/>
+                <a:cs typeface="Noto Sans CJK KR" pitchFamily="34" charset="-120"/>
+              </a:rPr>
+              <a:t>1비트 에러</a:t>
+            </a:r>
+            <a:endParaRPr lang="en-US" sz="2000" dirty="0"/>
+          </a:p>
+          <a:p>
+            <a:pPr lvl="1" marL="685800" indent="-342900">
+              <a:spcAft>
+                <a:spcPts val="800"/>
+              </a:spcAft>
+              <a:buSzPct val="100000"/>
+              <a:buChar char="•"/>
+            </a:pPr>
+            <a:r>
+              <a:rPr lang="en-US" sz="1700" dirty="0">
+                <a:solidFill>
+                  <a:srgbClr val="444444"/>
+                </a:solidFill>
+                <a:latin typeface="Noto Sans CJK KR" pitchFamily="34" charset="0"/>
+                <a:ea typeface="Noto Sans CJK KR" pitchFamily="34" charset="-122"/>
+                <a:cs typeface="Noto Sans CJK KR" pitchFamily="34" charset="-120"/>
+              </a:rPr>
+              <a:t>Hamming으로 정정하여 정상 데이터로 사용</a:t>
+            </a:r>
+            <a:endParaRPr lang="en-US" sz="2000" dirty="0"/>
+          </a:p>
+          <a:p>
+            <a:pPr marL="342900" indent="-342900">
+              <a:spcAft>
+                <a:spcPts val="1200"/>
+              </a:spcAft>
+              <a:buSzPct val="100000"/>
+              <a:buChar char="•"/>
+            </a:pPr>
+            <a:r>
+              <a:rPr lang="en-US" sz="2000" dirty="0">
+                <a:solidFill>
+                  <a:srgbClr val="222222"/>
+                </a:solidFill>
+                <a:latin typeface="Noto Sans CJK KR" pitchFamily="34" charset="0"/>
+                <a:ea typeface="Noto Sans CJK KR" pitchFamily="34" charset="-122"/>
+                <a:cs typeface="Noto Sans CJK KR" pitchFamily="34" charset="-120"/>
+              </a:rPr>
+              <a:t>2비트 에러 (정정 불가)</a:t>
+            </a:r>
+            <a:endParaRPr lang="en-US" sz="2000" dirty="0"/>
+          </a:p>
+          <a:p>
+            <a:pPr lvl="1" marL="685800" indent="-342900">
+              <a:spcAft>
+                <a:spcPts val="800"/>
+              </a:spcAft>
+              <a:buSzPct val="100000"/>
+              <a:buChar char="•"/>
+            </a:pPr>
+            <a:r>
+              <a:rPr lang="en-US" sz="1700" dirty="0">
+                <a:solidFill>
+                  <a:srgbClr val="444444"/>
+                </a:solidFill>
+                <a:latin typeface="Noto Sans CJK KR" pitchFamily="34" charset="0"/>
+                <a:ea typeface="Noto Sans CJK KR" pitchFamily="34" charset="-122"/>
+                <a:cs typeface="Noto Sans CJK KR" pitchFamily="34" charset="-120"/>
+              </a:rPr>
+              <a:t>해당 프레임을 무효 처리하고 폐기, 이전 값 유지</a:t>
+            </a:r>
+            <a:endParaRPr lang="en-US" sz="2000" dirty="0"/>
+          </a:p>
+          <a:p>
+            <a:pPr marL="342900" indent="-342900">
+              <a:spcAft>
+                <a:spcPts val="1200"/>
+              </a:spcAft>
+              <a:buSzPct val="100000"/>
+              <a:buChar char="•"/>
+            </a:pPr>
+            <a:r>
+              <a:rPr lang="en-US" sz="2000" dirty="0">
+                <a:solidFill>
+                  <a:srgbClr val="222222"/>
+                </a:solidFill>
+                <a:latin typeface="Noto Sans CJK KR" pitchFamily="34" charset="0"/>
+                <a:ea typeface="Noto Sans CJK KR" pitchFamily="34" charset="-122"/>
+                <a:cs typeface="Noto Sans CJK KR" pitchFamily="34" charset="-120"/>
+              </a:rPr>
+              <a:t>Implicit Flow Control</a:t>
+            </a:r>
+            <a:endParaRPr lang="en-US" sz="2000" dirty="0"/>
+          </a:p>
+          <a:p>
+            <a:pPr lvl="1" marL="685800" indent="-342900">
+              <a:buSzPct val="100000"/>
+              <a:buChar char="•"/>
+            </a:pPr>
+            <a:r>
+              <a:rPr lang="en-US" sz="1700" dirty="0">
+                <a:solidFill>
+                  <a:srgbClr val="444444"/>
+                </a:solidFill>
+                <a:latin typeface="Noto Sans CJK KR" pitchFamily="34" charset="0"/>
+                <a:ea typeface="Noto Sans CJK KR" pitchFamily="34" charset="-122"/>
+                <a:cs typeface="Noto Sans CJK KR" pitchFamily="34" charset="-120"/>
+              </a:rPr>
+              <a:t>명시적 재전송 요청(ARQ/NACK) 없음 — 다음 TDMA 사이클의 갱신 데이터를 기다림</a:t>
+            </a:r>
+            <a:endParaRPr lang="en-US" sz="2000" dirty="0"/>
+          </a:p>
+        </p:txBody>
+      </p:sp>
+      <p:pic>
+        <p:nvPicPr>
+          <p:cNvPr id="4" name="Image 0" descr="/home/user/SoC_Design_and_Programming/diagrams/flow_control.png">    </p:cNvPr>
+          <p:cNvPicPr>
+            <a:picLocks noChangeAspect="1"/>
+          </p:cNvPicPr>
+          <p:nvPr/>
+        </p:nvPicPr>
+        <p:blipFill>
+          <a:blip r:embed="rId2"/>
+          <a:srcRect l="0" r="0" t="0" b="0"/>
+          <a:stretch/>
+        </p:blipFill>
+        <p:spPr>
+          <a:xfrm>
+            <a:off x="5029200" y="1371600"/>
+            <a:ext cx="3200400" cy="2319606"/>
+          </a:xfrm>
+          <a:prstGeom prst="rect">
+            <a:avLst/>
+          </a:prstGeom>
+        </p:spPr>
+      </p:pic>
+      <p:sp>
+        <p:nvSpPr>
+          <p:cNvPr id="5" name="Text 2"/>
+          <p:cNvSpPr/>
+          <p:nvPr/>
+        </p:nvSpPr>
+        <p:spPr>
+          <a:xfrm>
+            <a:off x="8503920" y="4754880"/>
+            <a:ext cx="457200" cy="274320"/>
+          </a:xfrm>
+          <a:prstGeom prst="rect">
+            <a:avLst/>
+          </a:prstGeom>
+          <a:noFill/>
+          <a:ln/>
+        </p:spPr>
+        <p:txBody>
+          <a:bodyPr wrap="square" rtlCol="0" anchor="ctr"/>
+          <a:lstStyle/>
+          <a:p>
+            <a:pPr algn="r" indent="0" marL="0">
+              <a:buNone/>
+            </a:pPr>
+            <a:r>
+              <a:rPr lang="en-US" sz="1200" dirty="0">
+                <a:solidFill>
+                  <a:srgbClr val="999999"/>
+                </a:solidFill>
+                <a:latin typeface="Noto Sans CJK KR" pitchFamily="34" charset="0"/>
+                <a:ea typeface="Noto Sans CJK KR" pitchFamily="34" charset="-122"/>
+                <a:cs typeface="Noto Sans CJK KR" pitchFamily="34" charset="-120"/>
+              </a:rPr>
+              <a:t>12</a:t>
+            </a:r>
+            <a:endParaRPr lang="en-US" sz="1200" dirty="0"/>
+          </a:p>
+        </p:txBody>
+      </p:sp>
+    </p:spTree>
+  </p:cSld>
+  <p:clrMapOvr>
+    <a:masterClrMapping/>
+  </p:clrMapOvr>
+</p:sld>
+</file>
+
+<file path=ppt/slides/slide13.xml><?xml version="1.0" encoding="utf-8"?>
 <p:sld xmlns:a="http://schemas.openxmlformats.org/drawingml/2006/main" xmlns:p="http://schemas.openxmlformats.org/presentationml/2006/main" xmlns:r="http://schemas.openxmlformats.org/officeDocument/2006/relationships">
   <p:cSld>
     <p:bg>
@@ -1878,189 +2182,6 @@
       <p:sp>
         <p:nvSpPr>
           <p:cNvPr id="4" name="Text 2"/>
-          <p:cNvSpPr/>
-          <p:nvPr/>
-        </p:nvSpPr>
-        <p:spPr>
-          <a:xfrm>
-            <a:off x="8503920" y="4754880"/>
-            <a:ext cx="457200" cy="274320"/>
-          </a:xfrm>
-          <a:prstGeom prst="rect">
-            <a:avLst/>
-          </a:prstGeom>
-          <a:noFill/>
-          <a:ln/>
-        </p:spPr>
-        <p:txBody>
-          <a:bodyPr wrap="square" rtlCol="0" anchor="ctr"/>
-          <a:lstStyle/>
-          <a:p>
-            <a:pPr algn="r" indent="0" marL="0">
-              <a:buNone/>
-            </a:pPr>
-            <a:r>
-              <a:rPr lang="en-US" sz="1200" dirty="0">
-                <a:solidFill>
-                  <a:srgbClr val="999999"/>
-                </a:solidFill>
-                <a:latin typeface="Noto Sans CJK KR" pitchFamily="34" charset="0"/>
-                <a:ea typeface="Noto Sans CJK KR" pitchFamily="34" charset="-122"/>
-                <a:cs typeface="Noto Sans CJK KR" pitchFamily="34" charset="-120"/>
-              </a:rPr>
-              <a:t>12</a:t>
-            </a:r>
-            <a:endParaRPr lang="en-US" sz="1200" dirty="0"/>
-          </a:p>
-        </p:txBody>
-      </p:sp>
-    </p:spTree>
-  </p:cSld>
-  <p:clrMapOvr>
-    <a:masterClrMapping/>
-  </p:clrMapOvr>
-</p:sld>
-</file>
-
-<file path=ppt/slides/slide13.xml><?xml version="1.0" encoding="utf-8"?>
-<p:sld xmlns:a="http://schemas.openxmlformats.org/drawingml/2006/main" xmlns:p="http://schemas.openxmlformats.org/presentationml/2006/main" xmlns:r="http://schemas.openxmlformats.org/officeDocument/2006/relationships">
-  <p:cSld>
-    <p:spTree>
-      <p:nvGrpSpPr>
-        <p:cNvPr id="1" name=""/>
-        <p:cNvGrpSpPr/>
-        <p:nvPr/>
-      </p:nvGrpSpPr>
-      <p:grpSpPr/>
-      <p:sp>
-        <p:nvSpPr>
-          <p:cNvPr id="2" name="Text 0"/>
-          <p:cNvSpPr/>
-          <p:nvPr/>
-        </p:nvSpPr>
-        <p:spPr>
-          <a:xfrm>
-            <a:off x="548640" y="274320"/>
-            <a:ext cx="8046720" cy="777240"/>
-          </a:xfrm>
-          <a:prstGeom prst="rect">
-            <a:avLst/>
-          </a:prstGeom>
-          <a:noFill/>
-          <a:ln/>
-        </p:spPr>
-        <p:txBody>
-          <a:bodyPr wrap="square" lIns="0" tIns="0" rIns="0" bIns="0" rtlCol="0" anchor="ctr"/>
-          <a:lstStyle/>
-          <a:p>
-            <a:pPr indent="0" marL="0">
-              <a:buNone/>
-            </a:pPr>
-            <a:r>
-              <a:rPr lang="en-US" sz="3600" b="1" dirty="0">
-                <a:solidFill>
-                  <a:srgbClr val="111111"/>
-                </a:solidFill>
-                <a:latin typeface="Noto Sans CJK KR" pitchFamily="34" charset="0"/>
-                <a:ea typeface="Noto Sans CJK KR" pitchFamily="34" charset="-122"/>
-                <a:cs typeface="Noto Sans CJK KR" pitchFamily="34" charset="-120"/>
-              </a:rPr>
-              <a:t>Master 전체 구조</a:t>
-            </a:r>
-            <a:endParaRPr lang="en-US" sz="3600" dirty="0"/>
-          </a:p>
-        </p:txBody>
-      </p:sp>
-      <p:sp>
-        <p:nvSpPr>
-          <p:cNvPr id="3" name="Text 1"/>
-          <p:cNvSpPr/>
-          <p:nvPr/>
-        </p:nvSpPr>
-        <p:spPr>
-          <a:xfrm>
-            <a:off x="548640" y="1188720"/>
-            <a:ext cx="8046720" cy="594360"/>
-          </a:xfrm>
-          <a:prstGeom prst="rect">
-            <a:avLst/>
-          </a:prstGeom>
-          <a:noFill/>
-          <a:ln/>
-        </p:spPr>
-        <p:txBody>
-          <a:bodyPr wrap="square" rtlCol="0" anchor="t"/>
-          <a:lstStyle/>
-          <a:p>
-            <a:pPr marL="342900" indent="-342900">
-              <a:spcAft>
-                <a:spcPts val="600"/>
-              </a:spcAft>
-              <a:buSzPct val="100000"/>
-              <a:buChar char="•"/>
-            </a:pPr>
-            <a:r>
-              <a:rPr lang="en-US" sz="1700" dirty="0">
-                <a:solidFill>
-                  <a:srgbClr val="222222"/>
-                </a:solidFill>
-                <a:latin typeface="Noto Sans CJK KR" pitchFamily="34" charset="0"/>
-                <a:ea typeface="Noto Sans CJK KR" pitchFamily="34" charset="-122"/>
-                <a:cs typeface="Noto Sans CJK KR" pitchFamily="34" charset="-120"/>
-              </a:rPr>
-              <a:t>테스트 장치 · PS · PL(Master IP 포함) · GPIO 네 영역으로 구성</a:t>
-            </a:r>
-            <a:endParaRPr lang="en-US" sz="1700" dirty="0"/>
-          </a:p>
-          <a:p>
-            <a:pPr marL="342900" indent="-342900">
-              <a:spcAft>
-                <a:spcPts val="600"/>
-              </a:spcAft>
-              <a:buSzPct val="100000"/>
-              <a:buChar char="•"/>
-            </a:pPr>
-            <a:r>
-              <a:rPr lang="en-US" sz="1700" dirty="0">
-                <a:solidFill>
-                  <a:srgbClr val="222222"/>
-                </a:solidFill>
-                <a:latin typeface="Noto Sans CJK KR" pitchFamily="34" charset="0"/>
-                <a:ea typeface="Noto Sans CJK KR" pitchFamily="34" charset="-122"/>
-                <a:cs typeface="Noto Sans CJK KR" pitchFamily="34" charset="-120"/>
-              </a:rPr>
-              <a:t>GPIO를 통해 Slave와 TX/RX 시리얼로 연결 — 이후 슬라이드에서 블록을 하나씩 확대</a:t>
-            </a:r>
-            <a:endParaRPr lang="en-US" sz="1700" dirty="0"/>
-          </a:p>
-        </p:txBody>
-      </p:sp>
-      <p:pic>
-        <p:nvPicPr>
-          <p:cNvPr id="4" name="Image 0" descr="/home/user/SoC_Design_and_Programming/diagrams/section3/zoom/master_overview.png">    </p:cNvPr>
-          <p:cNvPicPr>
-            <a:picLocks noChangeAspect="1"/>
-          </p:cNvPicPr>
-          <p:nvPr/>
-        </p:nvPicPr>
-        <p:blipFill>
-          <a:blip r:embed="rId2"/>
-          <a:srcRect l="0" r="0" t="0" b="0"/>
-          <a:stretch/>
-        </p:blipFill>
-        <p:spPr>
-          <a:xfrm>
-            <a:off x="548640" y="2061599"/>
-            <a:ext cx="8046720" cy="2186162"/>
-          </a:xfrm>
-          <a:prstGeom prst="rect">
-            <a:avLst/>
-          </a:prstGeom>
-        </p:spPr>
-      </p:pic>
-      <p:sp>
-        <p:nvSpPr>
-          <p:cNvPr id="5" name="Text 2"/>
           <p:cNvSpPr/>
           <p:nvPr/>
         </p:nvSpPr>
@@ -2148,7 +2269,7 @@
                 <a:ea typeface="Noto Sans CJK KR" pitchFamily="34" charset="-122"/>
                 <a:cs typeface="Noto Sans CJK KR" pitchFamily="34" charset="-120"/>
               </a:rPr>
-              <a:t>Master - GPIO 확대</a:t>
+              <a:t>Master 전체 구조</a:t>
             </a:r>
             <a:endParaRPr lang="en-US" sz="3600" dirty="0"/>
           </a:p>
@@ -2162,8 +2283,8 @@
         </p:nvSpPr>
         <p:spPr>
           <a:xfrm>
-            <a:off x="548640" y="1234440"/>
-            <a:ext cx="4023360" cy="2971800"/>
+            <a:off x="548640" y="1188720"/>
+            <a:ext cx="8046720" cy="594360"/>
           </a:xfrm>
           <a:prstGeom prst="rect">
             <a:avLst/>
@@ -2177,13 +2298,13 @@
           <a:p>
             <a:pPr marL="342900" indent="-342900">
               <a:spcAft>
-                <a:spcPts val="1000"/>
+                <a:spcPts val="600"/>
               </a:spcAft>
               <a:buSzPct val="100000"/>
               <a:buChar char="•"/>
             </a:pPr>
             <a:r>
-              <a:rPr lang="en-US" sz="1800" dirty="0">
+              <a:rPr lang="en-US" sz="1700" dirty="0">
                 <a:solidFill>
                   <a:srgbClr val="222222"/>
                 </a:solidFill>
@@ -2191,20 +2312,20 @@
                 <a:ea typeface="Noto Sans CJK KR" pitchFamily="34" charset="-122"/>
                 <a:cs typeface="Noto Sans CJK KR" pitchFamily="34" charset="-120"/>
               </a:rPr>
-              <a:t>GND / RX 포트 / TX 포트로 구성</a:t>
-            </a:r>
-            <a:endParaRPr lang="en-US" sz="1800" dirty="0"/>
+              <a:t>테스트 장치 · PS · PL(Master IP 포함) · GPIO 네 영역으로 구성</a:t>
+            </a:r>
+            <a:endParaRPr lang="en-US" sz="1700" dirty="0"/>
           </a:p>
           <a:p>
             <a:pPr marL="342900" indent="-342900">
               <a:spcAft>
-                <a:spcPts val="1000"/>
+                <a:spcPts val="600"/>
               </a:spcAft>
               <a:buSzPct val="100000"/>
               <a:buChar char="•"/>
             </a:pPr>
             <a:r>
-              <a:rPr lang="en-US" sz="1800" dirty="0">
+              <a:rPr lang="en-US" sz="1700" dirty="0">
                 <a:solidFill>
                   <a:srgbClr val="222222"/>
                 </a:solidFill>
@@ -2212,15 +2333,15 @@
                 <a:ea typeface="Noto Sans CJK KR" pitchFamily="34" charset="-122"/>
                 <a:cs typeface="Noto Sans CJK KR" pitchFamily="34" charset="-120"/>
               </a:rPr>
-              <a:t>TX·RX는 PL(Master IP)과 Slave 사이를 잇는 물리 연결 — 외부 장치-PS-PL 경로와는 분리된 통신 채널</a:t>
-            </a:r>
-            <a:endParaRPr lang="en-US" sz="1800" dirty="0"/>
+              <a:t>GPIO를 통해 Slave와 TX/RX 시리얼로 연결 — 이후 슬라이드에서 블록을 하나씩 확대</a:t>
+            </a:r>
+            <a:endParaRPr lang="en-US" sz="1700" dirty="0"/>
           </a:p>
         </p:txBody>
       </p:sp>
       <p:pic>
         <p:nvPicPr>
-          <p:cNvPr id="4" name="Image 0" descr="/home/user/SoC_Design_and_Programming/diagrams/section3/zoom/m_gpio.png">    </p:cNvPr>
+          <p:cNvPr id="4" name="Image 0" descr="/home/user/SoC_Design_and_Programming/diagrams/section3/zoom/master_overview.png">    </p:cNvPr>
           <p:cNvPicPr>
             <a:picLocks noChangeAspect="1"/>
           </p:cNvPicPr>
@@ -2233,8 +2354,8 @@
         </p:blipFill>
         <p:spPr>
           <a:xfrm>
-            <a:off x="4846320" y="1916974"/>
-            <a:ext cx="3749040" cy="1606731"/>
+            <a:off x="548640" y="2061599"/>
+            <a:ext cx="8046720" cy="2186162"/>
           </a:xfrm>
           <a:prstGeom prst="rect">
             <a:avLst/>
@@ -2331,7 +2452,7 @@
                 <a:ea typeface="Noto Sans CJK KR" pitchFamily="34" charset="-122"/>
                 <a:cs typeface="Noto Sans CJK KR" pitchFamily="34" charset="-120"/>
               </a:rPr>
-              <a:t>Master - PS 확대</a:t>
+              <a:t>Master - GPIO 확대</a:t>
             </a:r>
             <a:endParaRPr lang="en-US" sz="3600" dirty="0"/>
           </a:p>
@@ -2345,8 +2466,8 @@
         </p:nvSpPr>
         <p:spPr>
           <a:xfrm>
-            <a:off x="548640" y="1188720"/>
-            <a:ext cx="8046720" cy="594360"/>
+            <a:off x="548640" y="1234440"/>
+            <a:ext cx="4023360" cy="2971800"/>
           </a:xfrm>
           <a:prstGeom prst="rect">
             <a:avLst/>
@@ -2360,13 +2481,13 @@
           <a:p>
             <a:pPr marL="342900" indent="-342900">
               <a:spcAft>
-                <a:spcPts val="600"/>
+                <a:spcPts val="1000"/>
               </a:spcAft>
               <a:buSzPct val="100000"/>
               <a:buChar char="•"/>
             </a:pPr>
             <a:r>
-              <a:rPr lang="en-US" sz="1700" dirty="0">
+              <a:rPr lang="en-US" sz="1800" dirty="0">
                 <a:solidFill>
                   <a:srgbClr val="222222"/>
                 </a:solidFill>
@@ -2374,20 +2495,20 @@
                 <a:ea typeface="Noto Sans CJK KR" pitchFamily="34" charset="-122"/>
                 <a:cs typeface="Noto Sans CJK KR" pitchFamily="34" charset="-120"/>
               </a:rPr>
-              <a:t>외부 테스트 장치에서 초깃값을 입력받아 Master를 초기 구동</a:t>
-            </a:r>
-            <a:endParaRPr lang="en-US" sz="1700" dirty="0"/>
+              <a:t>GND / RX 포트 / TX 포트로 구성</a:t>
+            </a:r>
+            <a:endParaRPr lang="en-US" sz="1800" dirty="0"/>
           </a:p>
           <a:p>
             <a:pPr marL="342900" indent="-342900">
               <a:spcAft>
-                <a:spcPts val="600"/>
+                <a:spcPts val="1000"/>
               </a:spcAft>
               <a:buSzPct val="100000"/>
               <a:buChar char="•"/>
             </a:pPr>
             <a:r>
-              <a:rPr lang="en-US" sz="1700" dirty="0">
+              <a:rPr lang="en-US" sz="1800" dirty="0">
                 <a:solidFill>
                   <a:srgbClr val="222222"/>
                 </a:solidFill>
@@ -2395,15 +2516,15 @@
                 <a:ea typeface="Noto Sans CJK KR" pitchFamily="34" charset="-122"/>
                 <a:cs typeface="Noto Sans CJK KR" pitchFamily="34" charset="-120"/>
               </a:rPr>
-              <a:t>구동 중인 Master 값을 주기적으로 읽고, Master가 발생시키는 인터럽트를 수신</a:t>
-            </a:r>
-            <a:endParaRPr lang="en-US" sz="1700" dirty="0"/>
+              <a:t>TX·RX는 PL(Master IP)과 Slave 사이를 잇는 물리 연결 — 외부 장치-PS-PL 경로와는 분리된 통신 채널</a:t>
+            </a:r>
+            <a:endParaRPr lang="en-US" sz="1800" dirty="0"/>
           </a:p>
         </p:txBody>
       </p:sp>
       <p:pic>
         <p:nvPicPr>
-          <p:cNvPr id="4" name="Image 0" descr="/home/user/SoC_Design_and_Programming/diagrams/section3/zoom/m_ps.png">    </p:cNvPr>
+          <p:cNvPr id="4" name="Image 0" descr="/home/user/SoC_Design_and_Programming/diagrams/section3/zoom/m_gpio.png">    </p:cNvPr>
           <p:cNvPicPr>
             <a:picLocks noChangeAspect="1"/>
           </p:cNvPicPr>
@@ -2416,8 +2537,8 @@
         </p:blipFill>
         <p:spPr>
           <a:xfrm>
-            <a:off x="745187" y="1783080"/>
-            <a:ext cx="7653626" cy="2743200"/>
+            <a:off x="4846320" y="1916974"/>
+            <a:ext cx="3749040" cy="1606731"/>
           </a:xfrm>
           <a:prstGeom prst="rect">
             <a:avLst/>
@@ -2514,7 +2635,7 @@
                 <a:ea typeface="Noto Sans CJK KR" pitchFamily="34" charset="-122"/>
                 <a:cs typeface="Noto Sans CJK KR" pitchFamily="34" charset="-120"/>
               </a:rPr>
-              <a:t>Master - PL 확대</a:t>
+              <a:t>Master - PS 확대</a:t>
             </a:r>
             <a:endParaRPr lang="en-US" sz="3600" dirty="0"/>
           </a:p>
@@ -2528,8 +2649,8 @@
         </p:nvSpPr>
         <p:spPr>
           <a:xfrm>
-            <a:off x="548640" y="1234440"/>
-            <a:ext cx="4023360" cy="2971800"/>
+            <a:off x="548640" y="1188720"/>
+            <a:ext cx="8046720" cy="594360"/>
           </a:xfrm>
           <a:prstGeom prst="rect">
             <a:avLst/>
@@ -2543,13 +2664,13 @@
           <a:p>
             <a:pPr marL="342900" indent="-342900">
               <a:spcAft>
-                <a:spcPts val="1000"/>
+                <a:spcPts val="600"/>
               </a:spcAft>
               <a:buSzPct val="100000"/>
               <a:buChar char="•"/>
             </a:pPr>
             <a:r>
-              <a:rPr lang="en-US" sz="1800" dirty="0">
+              <a:rPr lang="en-US" sz="1700" dirty="0">
                 <a:solidFill>
                   <a:srgbClr val="222222"/>
                 </a:solidFill>
@@ -2557,20 +2678,20 @@
                 <a:ea typeface="Noto Sans CJK KR" pitchFamily="34" charset="-122"/>
                 <a:cs typeface="Noto Sans CJK KR" pitchFamily="34" charset="-120"/>
               </a:rPr>
-              <a:t>LED · 푸시버튼 · DIP 스위치 · 7-seg와 Master IP로 보드 자체의 입출력 구성</a:t>
-            </a:r>
-            <a:endParaRPr lang="en-US" sz="1800" dirty="0"/>
+              <a:t>외부 테스트 장치에서 초깃값을 입력받아 Master를 초기 구동</a:t>
+            </a:r>
+            <a:endParaRPr lang="en-US" sz="1700" dirty="0"/>
           </a:p>
           <a:p>
             <a:pPr marL="342900" indent="-342900">
               <a:spcAft>
-                <a:spcPts val="1000"/>
+                <a:spcPts val="600"/>
               </a:spcAft>
               <a:buSzPct val="100000"/>
               <a:buChar char="•"/>
             </a:pPr>
             <a:r>
-              <a:rPr lang="en-US" sz="1800" dirty="0">
+              <a:rPr lang="en-US" sz="1700" dirty="0">
                 <a:solidFill>
                   <a:srgbClr val="222222"/>
                 </a:solidFill>
@@ -2578,36 +2699,15 @@
                 <a:ea typeface="Noto Sans CJK KR" pitchFamily="34" charset="-122"/>
                 <a:cs typeface="Noto Sans CJK KR" pitchFamily="34" charset="-120"/>
               </a:rPr>
-              <a:t>LED는 RX/TX 이진 신호를 그대로 받아 통신 상태를 표시</a:t>
-            </a:r>
-            <a:endParaRPr lang="en-US" sz="1800" dirty="0"/>
-          </a:p>
-          <a:p>
-            <a:pPr marL="342900" indent="-342900">
-              <a:spcAft>
-                <a:spcPts val="1000"/>
-              </a:spcAft>
-              <a:buSzPct val="100000"/>
-              <a:buChar char="•"/>
-            </a:pPr>
-            <a:r>
-              <a:rPr lang="en-US" sz="1800" dirty="0">
-                <a:solidFill>
-                  <a:srgbClr val="222222"/>
-                </a:solidFill>
-                <a:latin typeface="Noto Sans CJK KR" pitchFamily="34" charset="0"/>
-                <a:ea typeface="Noto Sans CJK KR" pitchFamily="34" charset="-122"/>
-                <a:cs typeface="Noto Sans CJK KR" pitchFamily="34" charset="-120"/>
-              </a:rPr>
-              <a:t>DIP 스위치·7-seg는 슬롯별 통신 상태와 수신 데이터를 출력 — Master IP가 이들을 조율</a:t>
-            </a:r>
-            <a:endParaRPr lang="en-US" sz="1800" dirty="0"/>
+              <a:t>구동 중인 Master 값을 주기적으로 읽고, Master가 발생시키는 인터럽트를 수신</a:t>
+            </a:r>
+            <a:endParaRPr lang="en-US" sz="1700" dirty="0"/>
           </a:p>
         </p:txBody>
       </p:sp>
       <p:pic>
         <p:nvPicPr>
-          <p:cNvPr id="4" name="Image 0" descr="/home/user/SoC_Design_and_Programming/diagrams/section3/zoom/m_pl.png">    </p:cNvPr>
+          <p:cNvPr id="4" name="Image 0" descr="/home/user/SoC_Design_and_Programming/diagrams/section3/zoom/m_ps.png">    </p:cNvPr>
           <p:cNvPicPr>
             <a:picLocks noChangeAspect="1"/>
           </p:cNvPicPr>
@@ -2620,8 +2720,8 @@
         </p:blipFill>
         <p:spPr>
           <a:xfrm>
-            <a:off x="4846320" y="1653968"/>
-            <a:ext cx="3749040" cy="2132745"/>
+            <a:off x="745187" y="1783080"/>
+            <a:ext cx="7653626" cy="2743200"/>
           </a:xfrm>
           <a:prstGeom prst="rect">
             <a:avLst/>
@@ -2718,7 +2818,7 @@
                 <a:ea typeface="Noto Sans CJK KR" pitchFamily="34" charset="-122"/>
                 <a:cs typeface="Noto Sans CJK KR" pitchFamily="34" charset="-120"/>
               </a:rPr>
-              <a:t>Master - Master IP 확대</a:t>
+              <a:t>Master - PL 확대</a:t>
             </a:r>
             <a:endParaRPr lang="en-US" sz="3600" dirty="0"/>
           </a:p>
@@ -2732,8 +2832,8 @@
         </p:nvSpPr>
         <p:spPr>
           <a:xfrm>
-            <a:off x="548640" y="1188720"/>
-            <a:ext cx="8046720" cy="594360"/>
+            <a:off x="548640" y="1234440"/>
+            <a:ext cx="4023360" cy="2971800"/>
           </a:xfrm>
           <a:prstGeom prst="rect">
             <a:avLst/>
@@ -2747,13 +2847,13 @@
           <a:p>
             <a:pPr marL="342900" indent="-342900">
               <a:spcAft>
-                <a:spcPts val="600"/>
+                <a:spcPts val="1000"/>
               </a:spcAft>
               <a:buSzPct val="100000"/>
               <a:buChar char="•"/>
             </a:pPr>
             <a:r>
-              <a:rPr lang="en-US" sz="1700" dirty="0">
+              <a:rPr lang="en-US" sz="1800" dirty="0">
                 <a:solidFill>
                   <a:srgbClr val="222222"/>
                 </a:solidFill>
@@ -2761,20 +2861,20 @@
                 <a:ea typeface="Noto Sans CJK KR" pitchFamily="34" charset="-122"/>
                 <a:cs typeface="Noto Sans CJK KR" pitchFamily="34" charset="-120"/>
               </a:rPr>
-              <a:t>PS에서 설정값을 받아 동기 메시지를 송신, 각 Slave의 응답을 수신</a:t>
-            </a:r>
-            <a:endParaRPr lang="en-US" sz="1700" dirty="0"/>
+              <a:t>LED · 푸시버튼 · DIP 스위치 · 7-seg와 Master IP로 보드 자체의 입출력 구성</a:t>
+            </a:r>
+            <a:endParaRPr lang="en-US" sz="1800" dirty="0"/>
           </a:p>
           <a:p>
             <a:pPr marL="342900" indent="-342900">
               <a:spcAft>
-                <a:spcPts val="600"/>
+                <a:spcPts val="1000"/>
               </a:spcAft>
               <a:buSzPct val="100000"/>
               <a:buChar char="•"/>
             </a:pPr>
             <a:r>
-              <a:rPr lang="en-US" sz="1700" dirty="0">
+              <a:rPr lang="en-US" sz="1800" dirty="0">
                 <a:solidFill>
                   <a:srgbClr val="222222"/>
                 </a:solidFill>
@@ -2782,15 +2882,36 @@
                 <a:ea typeface="Noto Sans CJK KR" pitchFamily="34" charset="-122"/>
                 <a:cs typeface="Noto Sans CJK KR" pitchFamily="34" charset="-120"/>
               </a:rPr>
-              <a:t>에러·데이터 전송 여부·형식·슬롯 침범 여부를 확인해 내부에서 고장 처리 후 PS에 보고</a:t>
-            </a:r>
-            <a:endParaRPr lang="en-US" sz="1700" dirty="0"/>
+              <a:t>LED는 RX/TX 이진 신호를 그대로 받아 통신 상태를 표시</a:t>
+            </a:r>
+            <a:endParaRPr lang="en-US" sz="1800" dirty="0"/>
+          </a:p>
+          <a:p>
+            <a:pPr marL="342900" indent="-342900">
+              <a:spcAft>
+                <a:spcPts val="1000"/>
+              </a:spcAft>
+              <a:buSzPct val="100000"/>
+              <a:buChar char="•"/>
+            </a:pPr>
+            <a:r>
+              <a:rPr lang="en-US" sz="1800" dirty="0">
+                <a:solidFill>
+                  <a:srgbClr val="222222"/>
+                </a:solidFill>
+                <a:latin typeface="Noto Sans CJK KR" pitchFamily="34" charset="0"/>
+                <a:ea typeface="Noto Sans CJK KR" pitchFamily="34" charset="-122"/>
+                <a:cs typeface="Noto Sans CJK KR" pitchFamily="34" charset="-120"/>
+              </a:rPr>
+              <a:t>DIP 스위치·7-seg는 슬롯별 통신 상태와 수신 데이터를 출력 — Master IP가 이들을 조율</a:t>
+            </a:r>
+            <a:endParaRPr lang="en-US" sz="1800" dirty="0"/>
           </a:p>
         </p:txBody>
       </p:sp>
       <p:pic>
         <p:nvPicPr>
-          <p:cNvPr id="4" name="Image 0" descr="/home/user/SoC_Design_and_Programming/diagrams/section3/zoom/m_masterip.png">    </p:cNvPr>
+          <p:cNvPr id="4" name="Image 0" descr="/home/user/SoC_Design_and_Programming/diagrams/section3/zoom/m_pl.png">    </p:cNvPr>
           <p:cNvPicPr>
             <a:picLocks noChangeAspect="1"/>
           </p:cNvPicPr>
@@ -2803,8 +2924,8 @@
         </p:blipFill>
         <p:spPr>
           <a:xfrm>
-            <a:off x="548640" y="2087258"/>
-            <a:ext cx="8046720" cy="2134844"/>
+            <a:off x="4846320" y="1653968"/>
+            <a:ext cx="3749040" cy="2132745"/>
           </a:xfrm>
           <a:prstGeom prst="rect">
             <a:avLst/>
@@ -2901,7 +3022,7 @@
                 <a:ea typeface="Noto Sans CJK KR" pitchFamily="34" charset="-122"/>
                 <a:cs typeface="Noto Sans CJK KR" pitchFamily="34" charset="-120"/>
               </a:rPr>
-              <a:t>Slave 전체 구조</a:t>
+              <a:t>Master - Master IP 확대</a:t>
             </a:r>
             <a:endParaRPr lang="en-US" sz="3600" dirty="0"/>
           </a:p>
@@ -2944,7 +3065,7 @@
                 <a:ea typeface="Noto Sans CJK KR" pitchFamily="34" charset="-122"/>
                 <a:cs typeface="Noto Sans CJK KR" pitchFamily="34" charset="-120"/>
               </a:rPr>
-              <a:t>GPIO · PL(Slave IP 포함) 두 영역으로 구성</a:t>
+              <a:t>PS에서 설정값을 받아 동기 메시지를 송신, 각 Slave의 응답을 수신</a:t>
             </a:r>
             <a:endParaRPr lang="en-US" sz="1700" dirty="0"/>
           </a:p>
@@ -2965,7 +3086,7 @@
                 <a:ea typeface="Noto Sans CJK KR" pitchFamily="34" charset="-122"/>
                 <a:cs typeface="Noto Sans CJK KR" pitchFamily="34" charset="-120"/>
               </a:rPr>
-              <a:t>GPIO를 통해 Master와 TX/RX 시리얼로 연결</a:t>
+              <a:t>에러·데이터 전송 여부·형식·슬롯 침범 여부를 확인해 내부에서 고장 처리 후 PS에 보고</a:t>
             </a:r>
             <a:endParaRPr lang="en-US" sz="1700" dirty="0"/>
           </a:p>
@@ -2973,7 +3094,7 @@
       </p:sp>
       <p:pic>
         <p:nvPicPr>
-          <p:cNvPr id="4" name="Image 0" descr="/home/user/SoC_Design_and_Programming/diagrams/section3/zoom/slave_overview.png">    </p:cNvPr>
+          <p:cNvPr id="4" name="Image 0" descr="/home/user/SoC_Design_and_Programming/diagrams/section3/zoom/m_masterip.png">    </p:cNvPr>
           <p:cNvPicPr>
             <a:picLocks noChangeAspect="1"/>
           </p:cNvPicPr>
@@ -2986,8 +3107,8 @@
         </p:blipFill>
         <p:spPr>
           <a:xfrm>
-            <a:off x="636404" y="1783080"/>
-            <a:ext cx="7871192" cy="2743200"/>
+            <a:off x="548640" y="2087258"/>
+            <a:ext cx="8046720" cy="2134844"/>
           </a:xfrm>
           <a:prstGeom prst="rect">
             <a:avLst/>
@@ -3084,7 +3205,7 @@
                 <a:ea typeface="Noto Sans CJK KR" pitchFamily="34" charset="-122"/>
                 <a:cs typeface="Noto Sans CJK KR" pitchFamily="34" charset="-120"/>
               </a:rPr>
-              <a:t>Slave - GPIO 확대</a:t>
+              <a:t>Slave 전체 구조</a:t>
             </a:r>
             <a:endParaRPr lang="en-US" sz="3600" dirty="0"/>
           </a:p>
@@ -3098,8 +3219,8 @@
         </p:nvSpPr>
         <p:spPr>
           <a:xfrm>
-            <a:off x="548640" y="1234440"/>
-            <a:ext cx="4023360" cy="2971800"/>
+            <a:off x="548640" y="1188720"/>
+            <a:ext cx="8046720" cy="594360"/>
           </a:xfrm>
           <a:prstGeom prst="rect">
             <a:avLst/>
@@ -3113,13 +3234,13 @@
           <a:p>
             <a:pPr marL="342900" indent="-342900">
               <a:spcAft>
-                <a:spcPts val="1000"/>
+                <a:spcPts val="600"/>
               </a:spcAft>
               <a:buSzPct val="100000"/>
               <a:buChar char="•"/>
             </a:pPr>
             <a:r>
-              <a:rPr lang="en-US" sz="1800" dirty="0">
+              <a:rPr lang="en-US" sz="1700" dirty="0">
                 <a:solidFill>
                   <a:srgbClr val="222222"/>
                 </a:solidFill>
@@ -3127,20 +3248,20 @@
                 <a:ea typeface="Noto Sans CJK KR" pitchFamily="34" charset="-122"/>
                 <a:cs typeface="Noto Sans CJK KR" pitchFamily="34" charset="-120"/>
               </a:rPr>
-              <a:t>GND / RX 포트 / TX 포트로 구성</a:t>
-            </a:r>
-            <a:endParaRPr lang="en-US" sz="1800" dirty="0"/>
+              <a:t>GPIO · PL(Slave IP 포함) 두 영역으로 구성</a:t>
+            </a:r>
+            <a:endParaRPr lang="en-US" sz="1700" dirty="0"/>
           </a:p>
           <a:p>
             <a:pPr marL="342900" indent="-342900">
               <a:spcAft>
-                <a:spcPts val="1000"/>
+                <a:spcPts val="600"/>
               </a:spcAft>
               <a:buSzPct val="100000"/>
               <a:buChar char="•"/>
             </a:pPr>
             <a:r>
-              <a:rPr lang="en-US" sz="1800" dirty="0">
+              <a:rPr lang="en-US" sz="1700" dirty="0">
                 <a:solidFill>
                   <a:srgbClr val="222222"/>
                 </a:solidFill>
@@ -3148,15 +3269,15 @@
                 <a:ea typeface="Noto Sans CJK KR" pitchFamily="34" charset="-122"/>
                 <a:cs typeface="Noto Sans CJK KR" pitchFamily="34" charset="-120"/>
               </a:rPr>
-              <a:t>RX·TX는 LED에 직결되어 통신 상태를 표시 (Master와 표현 통일)</a:t>
-            </a:r>
-            <a:endParaRPr lang="en-US" sz="1800" dirty="0"/>
+              <a:t>GPIO를 통해 Master와 TX/RX 시리얼로 연결</a:t>
+            </a:r>
+            <a:endParaRPr lang="en-US" sz="1700" dirty="0"/>
           </a:p>
         </p:txBody>
       </p:sp>
       <p:pic>
         <p:nvPicPr>
-          <p:cNvPr id="4" name="Image 0" descr="/home/user/SoC_Design_and_Programming/diagrams/section3/zoom/s_gpio.png">    </p:cNvPr>
+          <p:cNvPr id="4" name="Image 0" descr="/home/user/SoC_Design_and_Programming/diagrams/section3/zoom/slave_overview.png">    </p:cNvPr>
           <p:cNvPicPr>
             <a:picLocks noChangeAspect="1"/>
           </p:cNvPicPr>
@@ -3169,8 +3290,8 @@
         </p:blipFill>
         <p:spPr>
           <a:xfrm>
-            <a:off x="4846320" y="1618103"/>
-            <a:ext cx="3749040" cy="2204474"/>
+            <a:off x="636404" y="1783080"/>
+            <a:ext cx="7871192" cy="2743200"/>
           </a:xfrm>
           <a:prstGeom prst="rect">
             <a:avLst/>
@@ -3502,7 +3623,7 @@
                 <a:ea typeface="Noto Sans CJK KR" pitchFamily="34" charset="-122"/>
                 <a:cs typeface="Noto Sans CJK KR" pitchFamily="34" charset="-120"/>
               </a:rPr>
-              <a:t>2</a:t>
+              <a:t>3</a:t>
             </a:r>
             <a:endParaRPr lang="en-US" sz="1200" dirty="0"/>
           </a:p>
@@ -3559,7 +3680,7 @@
                 <a:ea typeface="Noto Sans CJK KR" pitchFamily="34" charset="-122"/>
                 <a:cs typeface="Noto Sans CJK KR" pitchFamily="34" charset="-120"/>
               </a:rPr>
-              <a:t>Slave - PL 확대</a:t>
+              <a:t>Slave - GPIO 확대</a:t>
             </a:r>
             <a:endParaRPr lang="en-US" sz="3600" dirty="0"/>
           </a:p>
@@ -3602,7 +3723,7 @@
                 <a:ea typeface="Noto Sans CJK KR" pitchFamily="34" charset="-122"/>
                 <a:cs typeface="Noto Sans CJK KR" pitchFamily="34" charset="-120"/>
               </a:rPr>
-              <a:t>LED와 Slave IP로 구성</a:t>
+              <a:t>GND / RX 포트 / TX 포트로 구성</a:t>
             </a:r>
             <a:endParaRPr lang="en-US" sz="1800" dirty="0"/>
           </a:p>
@@ -3623,7 +3744,7 @@
                 <a:ea typeface="Noto Sans CJK KR" pitchFamily="34" charset="-122"/>
                 <a:cs typeface="Noto Sans CJK KR" pitchFamily="34" charset="-120"/>
               </a:rPr>
-              <a:t>구조는 단순하지만 일관성을 위해 동일하게 확대해서 표시</a:t>
+              <a:t>RX·TX는 LED에 직결되어 통신 상태를 표시 (Master와 표현 통일)</a:t>
             </a:r>
             <a:endParaRPr lang="en-US" sz="1800" dirty="0"/>
           </a:p>
@@ -3631,7 +3752,7 @@
       </p:sp>
       <p:pic>
         <p:nvPicPr>
-          <p:cNvPr id="4" name="Image 0" descr="/home/user/SoC_Design_and_Programming/diagrams/section3/zoom/s_pl.png">    </p:cNvPr>
+          <p:cNvPr id="4" name="Image 0" descr="/home/user/SoC_Design_and_Programming/diagrams/section3/zoom/s_gpio.png">    </p:cNvPr>
           <p:cNvPicPr>
             <a:picLocks noChangeAspect="1"/>
           </p:cNvPicPr>
@@ -3644,8 +3765,8 @@
         </p:blipFill>
         <p:spPr>
           <a:xfrm>
-            <a:off x="4846320" y="1484484"/>
-            <a:ext cx="3749040" cy="2471712"/>
+            <a:off x="4846320" y="1618103"/>
+            <a:ext cx="3749040" cy="2204474"/>
           </a:xfrm>
           <a:prstGeom prst="rect">
             <a:avLst/>
@@ -3742,7 +3863,7 @@
                 <a:ea typeface="Noto Sans CJK KR" pitchFamily="34" charset="-122"/>
                 <a:cs typeface="Noto Sans CJK KR" pitchFamily="34" charset="-120"/>
               </a:rPr>
-              <a:t>Slave - Slave IP 확대</a:t>
+              <a:t>Slave - PL 확대</a:t>
             </a:r>
             <a:endParaRPr lang="en-US" sz="3600" dirty="0"/>
           </a:p>
@@ -3756,8 +3877,8 @@
         </p:nvSpPr>
         <p:spPr>
           <a:xfrm>
-            <a:off x="548640" y="1188720"/>
-            <a:ext cx="8046720" cy="594360"/>
+            <a:off x="548640" y="1234440"/>
+            <a:ext cx="4023360" cy="2971800"/>
           </a:xfrm>
           <a:prstGeom prst="rect">
             <a:avLst/>
@@ -3771,13 +3892,13 @@
           <a:p>
             <a:pPr marL="342900" indent="-342900">
               <a:spcAft>
-                <a:spcPts val="600"/>
+                <a:spcPts val="1000"/>
               </a:spcAft>
               <a:buSzPct val="100000"/>
               <a:buChar char="•"/>
             </a:pPr>
             <a:r>
-              <a:rPr lang="en-US" sz="1700" dirty="0">
+              <a:rPr lang="en-US" sz="1800" dirty="0">
                 <a:solidFill>
                   <a:srgbClr val="222222"/>
                 </a:solidFill>
@@ -3785,20 +3906,20 @@
                 <a:ea typeface="Noto Sans CJK KR" pitchFamily="34" charset="-122"/>
                 <a:cs typeface="Noto Sans CJK KR" pitchFamily="34" charset="-120"/>
               </a:rPr>
-              <a:t>Master의 동기 메시지를 받으면 자신의 슬롯 시간대를 계산해 적시에 메시지를 전송</a:t>
-            </a:r>
-            <a:endParaRPr lang="en-US" sz="1700" dirty="0"/>
+              <a:t>LED와 Slave IP로 구성</a:t>
+            </a:r>
+            <a:endParaRPr lang="en-US" sz="1800" dirty="0"/>
           </a:p>
           <a:p>
             <a:pPr marL="342900" indent="-342900">
               <a:spcAft>
-                <a:spcPts val="600"/>
+                <a:spcPts val="1000"/>
               </a:spcAft>
               <a:buSzPct val="100000"/>
               <a:buChar char="•"/>
             </a:pPr>
             <a:r>
-              <a:rPr lang="en-US" sz="1700" dirty="0">
+              <a:rPr lang="en-US" sz="1800" dirty="0">
                 <a:solidFill>
                   <a:srgbClr val="222222"/>
                 </a:solidFill>
@@ -3806,15 +3927,15 @@
                 <a:ea typeface="Noto Sans CJK KR" pitchFamily="34" charset="-122"/>
                 <a:cs typeface="Noto Sans CJK KR" pitchFamily="34" charset="-120"/>
               </a:rPr>
-              <a:t>Master가 송신 중단을 명령하면 송신을 중지하는 등 고장 처리를 수행</a:t>
-            </a:r>
-            <a:endParaRPr lang="en-US" sz="1700" dirty="0"/>
+              <a:t>구조는 단순하지만 일관성을 위해 동일하게 확대해서 표시</a:t>
+            </a:r>
+            <a:endParaRPr lang="en-US" sz="1800" dirty="0"/>
           </a:p>
         </p:txBody>
       </p:sp>
       <p:pic>
         <p:nvPicPr>
-          <p:cNvPr id="4" name="Image 0" descr="/home/user/SoC_Design_and_Programming/diagrams/section3/zoom/s_slaveip.png">    </p:cNvPr>
+          <p:cNvPr id="4" name="Image 0" descr="/home/user/SoC_Design_and_Programming/diagrams/section3/zoom/s_pl.png">    </p:cNvPr>
           <p:cNvPicPr>
             <a:picLocks noChangeAspect="1"/>
           </p:cNvPicPr>
@@ -3827,8 +3948,8 @@
         </p:blipFill>
         <p:spPr>
           <a:xfrm>
-            <a:off x="745187" y="1783080"/>
-            <a:ext cx="7653626" cy="2743200"/>
+            <a:off x="4846320" y="1484484"/>
+            <a:ext cx="3749040" cy="2471712"/>
           </a:xfrm>
           <a:prstGeom prst="rect">
             <a:avLst/>
@@ -3925,7 +4046,7 @@
                 <a:ea typeface="Noto Sans CJK KR" pitchFamily="34" charset="-122"/>
                 <a:cs typeface="Noto Sans CJK KR" pitchFamily="34" charset="-120"/>
               </a:rPr>
-              <a:t>Slave의 멀티 슬롯 시뮬레이션</a:t>
+              <a:t>Slave - Slave IP 확대</a:t>
             </a:r>
             <a:endParaRPr lang="en-US" sz="3600" dirty="0"/>
           </a:p>
@@ -3939,8 +4060,8 @@
         </p:nvSpPr>
         <p:spPr>
           <a:xfrm>
-            <a:off x="548640" y="1234440"/>
-            <a:ext cx="8046720" cy="2971800"/>
+            <a:off x="548640" y="1188720"/>
+            <a:ext cx="8046720" cy="594360"/>
           </a:xfrm>
           <a:prstGeom prst="rect">
             <a:avLst/>
@@ -3954,13 +4075,13 @@
           <a:p>
             <a:pPr marL="342900" indent="-342900">
               <a:spcAft>
-                <a:spcPts val="1200"/>
+                <a:spcPts val="600"/>
               </a:spcAft>
               <a:buSzPct val="100000"/>
               <a:buChar char="•"/>
             </a:pPr>
             <a:r>
-              <a:rPr lang="en-US" sz="2000" dirty="0">
+              <a:rPr lang="en-US" sz="1700" dirty="0">
                 <a:solidFill>
                   <a:srgbClr val="222222"/>
                 </a:solidFill>
@@ -3968,20 +4089,20 @@
                 <a:ea typeface="Noto Sans CJK KR" pitchFamily="34" charset="-122"/>
                 <a:cs typeface="Noto Sans CJK KR" pitchFamily="34" charset="-120"/>
               </a:rPr>
-              <a:t>통신 시연에서는 하나의 물리 시퀀서가 8개의 슬롯(슬롯 인덱스 0~7)을 순차 처리 — 슬롯 위치가 식별자 역할을 함</a:t>
-            </a:r>
-            <a:endParaRPr lang="en-US" sz="2000" dirty="0"/>
+              <a:t>Master의 동기 메시지를 받으면 자신의 슬롯 시간대를 계산해 적시에 메시지를 전송</a:t>
+            </a:r>
+            <a:endParaRPr lang="en-US" sz="1700" dirty="0"/>
           </a:p>
           <a:p>
             <a:pPr marL="342900" indent="-342900">
               <a:spcAft>
-                <a:spcPts val="1200"/>
+                <a:spcPts val="600"/>
               </a:spcAft>
               <a:buSzPct val="100000"/>
               <a:buChar char="•"/>
             </a:pPr>
             <a:r>
-              <a:rPr lang="en-US" sz="2000" dirty="0">
+              <a:rPr lang="en-US" sz="1700" dirty="0">
                 <a:solidFill>
                   <a:srgbClr val="222222"/>
                 </a:solidFill>
@@ -3989,57 +4110,38 @@
                 <a:ea typeface="Noto Sans CJK KR" pitchFamily="34" charset="-122"/>
                 <a:cs typeface="Noto Sans CJK KR" pitchFamily="34" charset="-120"/>
               </a:rPr>
-              <a:t>각 슬롯은 자신의 타임슬롯에서 자신의 payload를 전송 (슬롯별 절대 타겟 틱을 기준으로 순회)</a:t>
-            </a:r>
-            <a:endParaRPr lang="en-US" sz="2000" dirty="0"/>
-          </a:p>
-          <a:p>
-            <a:pPr marL="342900" indent="-342900">
-              <a:spcAft>
-                <a:spcPts val="1200"/>
-              </a:spcAft>
-              <a:buSzPct val="100000"/>
-              <a:buChar char="•"/>
-            </a:pPr>
-            <a:r>
-              <a:rPr lang="en-US" sz="2000" dirty="0">
-                <a:solidFill>
-                  <a:srgbClr val="222222"/>
-                </a:solidFill>
-                <a:latin typeface="Noto Sans CJK KR" pitchFamily="34" charset="0"/>
-                <a:ea typeface="Noto Sans CJK KR" pitchFamily="34" charset="-122"/>
-                <a:cs typeface="Noto Sans CJK KR" pitchFamily="34" charset="-120"/>
-              </a:rPr>
-              <a:t>슬롯 0~5는 AXI 레지스터, 슬롯 6~7은 외부 PL 버스에서 payload를 가져옴</a:t>
-            </a:r>
-            <a:endParaRPr lang="en-US" sz="2000" dirty="0"/>
-          </a:p>
-          <a:p>
-            <a:pPr marL="342900" indent="-342900">
-              <a:spcAft>
-                <a:spcPts val="1200"/>
-              </a:spcAft>
-              <a:buSzPct val="100000"/>
-              <a:buChar char="•"/>
-            </a:pPr>
-            <a:r>
-              <a:rPr lang="en-US" sz="2000" dirty="0">
-                <a:solidFill>
-                  <a:srgbClr val="222222"/>
-                </a:solidFill>
-                <a:latin typeface="Noto Sans CJK KR" pitchFamily="34" charset="0"/>
-                <a:ea typeface="Noto Sans CJK KR" pitchFamily="34" charset="-122"/>
-                <a:cs typeface="Noto Sans CJK KR" pitchFamily="34" charset="-120"/>
-              </a:rPr>
-              <a:t>시연에서는 버튼으로 payload 값을 바꾸고, 변경된 값이 Master에서 정확히 수신되는지 확인</a:t>
-            </a:r>
-            <a:endParaRPr lang="en-US" sz="2000" dirty="0"/>
-          </a:p>
-        </p:txBody>
-      </p:sp>
-      <p:sp>
-        <p:nvSpPr>
-          <p:cNvPr id="4" name="Text 2"/>
+              <a:t>Master가 송신 중단을 명령하면 송신을 중지하는 등 고장 처리를 수행</a:t>
+            </a:r>
+            <a:endParaRPr lang="en-US" sz="1700" dirty="0"/>
+          </a:p>
+        </p:txBody>
+      </p:sp>
+      <p:pic>
+        <p:nvPicPr>
+          <p:cNvPr id="4" name="Image 0" descr="/home/user/SoC_Design_and_Programming/diagrams/section3/zoom/s_slaveip.png">    </p:cNvPr>
+          <p:cNvPicPr>
+            <a:picLocks noChangeAspect="1"/>
+          </p:cNvPicPr>
+          <p:nvPr/>
+        </p:nvPicPr>
+        <p:blipFill>
+          <a:blip r:embed="rId2"/>
+          <a:srcRect l="0" r="0" t="0" b="0"/>
+          <a:stretch/>
+        </p:blipFill>
+        <p:spPr>
+          <a:xfrm>
+            <a:off x="745187" y="1783080"/>
+            <a:ext cx="7653626" cy="2743200"/>
+          </a:xfrm>
+          <a:prstGeom prst="rect">
+            <a:avLst/>
+          </a:prstGeom>
+        </p:spPr>
+      </p:pic>
+      <p:sp>
+        <p:nvSpPr>
+          <p:cNvPr id="5" name="Text 2"/>
           <p:cNvSpPr/>
           <p:nvPr/>
         </p:nvSpPr>
@@ -4085,6 +4187,208 @@
 </file>
 
 <file path=ppt/slides/slide23.xml><?xml version="1.0" encoding="utf-8"?>
+<p:sld xmlns:a="http://schemas.openxmlformats.org/drawingml/2006/main" xmlns:p="http://schemas.openxmlformats.org/presentationml/2006/main" xmlns:r="http://schemas.openxmlformats.org/officeDocument/2006/relationships">
+  <p:cSld>
+    <p:spTree>
+      <p:nvGrpSpPr>
+        <p:cNvPr id="1" name=""/>
+        <p:cNvGrpSpPr/>
+        <p:nvPr/>
+      </p:nvGrpSpPr>
+      <p:grpSpPr/>
+      <p:sp>
+        <p:nvSpPr>
+          <p:cNvPr id="2" name="Text 0"/>
+          <p:cNvSpPr/>
+          <p:nvPr/>
+        </p:nvSpPr>
+        <p:spPr>
+          <a:xfrm>
+            <a:off x="548640" y="274320"/>
+            <a:ext cx="8046720" cy="777240"/>
+          </a:xfrm>
+          <a:prstGeom prst="rect">
+            <a:avLst/>
+          </a:prstGeom>
+          <a:noFill/>
+          <a:ln/>
+        </p:spPr>
+        <p:txBody>
+          <a:bodyPr wrap="square" lIns="0" tIns="0" rIns="0" bIns="0" rtlCol="0" anchor="ctr"/>
+          <a:lstStyle/>
+          <a:p>
+            <a:pPr indent="0" marL="0">
+              <a:buNone/>
+            </a:pPr>
+            <a:r>
+              <a:rPr lang="en-US" sz="3600" b="1" dirty="0">
+                <a:solidFill>
+                  <a:srgbClr val="111111"/>
+                </a:solidFill>
+                <a:latin typeface="Noto Sans CJK KR" pitchFamily="34" charset="0"/>
+                <a:ea typeface="Noto Sans CJK KR" pitchFamily="34" charset="-122"/>
+                <a:cs typeface="Noto Sans CJK KR" pitchFamily="34" charset="-120"/>
+              </a:rPr>
+              <a:t>Slave의 멀티 슬롯 시뮬레이션</a:t>
+            </a:r>
+            <a:endParaRPr lang="en-US" sz="3600" dirty="0"/>
+          </a:p>
+        </p:txBody>
+      </p:sp>
+      <p:sp>
+        <p:nvSpPr>
+          <p:cNvPr id="3" name="Text 1"/>
+          <p:cNvSpPr/>
+          <p:nvPr/>
+        </p:nvSpPr>
+        <p:spPr>
+          <a:xfrm>
+            <a:off x="548640" y="1234440"/>
+            <a:ext cx="8046720" cy="2971800"/>
+          </a:xfrm>
+          <a:prstGeom prst="rect">
+            <a:avLst/>
+          </a:prstGeom>
+          <a:noFill/>
+          <a:ln/>
+        </p:spPr>
+        <p:txBody>
+          <a:bodyPr wrap="square" rtlCol="0" anchor="t"/>
+          <a:lstStyle/>
+          <a:p>
+            <a:pPr marL="342900" indent="-342900">
+              <a:spcAft>
+                <a:spcPts val="1200"/>
+              </a:spcAft>
+              <a:buSzPct val="100000"/>
+              <a:buChar char="•"/>
+            </a:pPr>
+            <a:r>
+              <a:rPr lang="en-US" sz="2000" dirty="0">
+                <a:solidFill>
+                  <a:srgbClr val="222222"/>
+                </a:solidFill>
+                <a:latin typeface="Noto Sans CJK KR" pitchFamily="34" charset="0"/>
+                <a:ea typeface="Noto Sans CJK KR" pitchFamily="34" charset="-122"/>
+                <a:cs typeface="Noto Sans CJK KR" pitchFamily="34" charset="-120"/>
+              </a:rPr>
+              <a:t>통신 시연에서는 하나의 물리 시퀀서가 8개의 슬롯(슬롯 인덱스 0~7)을 순차 처리 — 슬롯 위치가 식별자 역할을 함</a:t>
+            </a:r>
+            <a:endParaRPr lang="en-US" sz="2000" dirty="0"/>
+          </a:p>
+          <a:p>
+            <a:pPr marL="342900" indent="-342900">
+              <a:spcAft>
+                <a:spcPts val="1200"/>
+              </a:spcAft>
+              <a:buSzPct val="100000"/>
+              <a:buChar char="•"/>
+            </a:pPr>
+            <a:r>
+              <a:rPr lang="en-US" sz="2000" dirty="0">
+                <a:solidFill>
+                  <a:srgbClr val="222222"/>
+                </a:solidFill>
+                <a:latin typeface="Noto Sans CJK KR" pitchFamily="34" charset="0"/>
+                <a:ea typeface="Noto Sans CJK KR" pitchFamily="34" charset="-122"/>
+                <a:cs typeface="Noto Sans CJK KR" pitchFamily="34" charset="-120"/>
+              </a:rPr>
+              <a:t>각 슬롯은 자신의 타임슬롯에서 자신의 payload를 전송 (슬롯별 절대 타겟 틱을 기준으로 순회)</a:t>
+            </a:r>
+            <a:endParaRPr lang="en-US" sz="2000" dirty="0"/>
+          </a:p>
+          <a:p>
+            <a:pPr marL="342900" indent="-342900">
+              <a:spcAft>
+                <a:spcPts val="1200"/>
+              </a:spcAft>
+              <a:buSzPct val="100000"/>
+              <a:buChar char="•"/>
+            </a:pPr>
+            <a:r>
+              <a:rPr lang="en-US" sz="2000" dirty="0">
+                <a:solidFill>
+                  <a:srgbClr val="222222"/>
+                </a:solidFill>
+                <a:latin typeface="Noto Sans CJK KR" pitchFamily="34" charset="0"/>
+                <a:ea typeface="Noto Sans CJK KR" pitchFamily="34" charset="-122"/>
+                <a:cs typeface="Noto Sans CJK KR" pitchFamily="34" charset="-120"/>
+              </a:rPr>
+              <a:t>슬롯 0~5는 AXI 레지스터, 슬롯 6~7은 외부 PL 버스에서 payload를 가져옴</a:t>
+            </a:r>
+            <a:endParaRPr lang="en-US" sz="2000" dirty="0"/>
+          </a:p>
+          <a:p>
+            <a:pPr marL="342900" indent="-342900">
+              <a:spcAft>
+                <a:spcPts val="1200"/>
+              </a:spcAft>
+              <a:buSzPct val="100000"/>
+              <a:buChar char="•"/>
+            </a:pPr>
+            <a:r>
+              <a:rPr lang="en-US" sz="2000" dirty="0">
+                <a:solidFill>
+                  <a:srgbClr val="222222"/>
+                </a:solidFill>
+                <a:latin typeface="Noto Sans CJK KR" pitchFamily="34" charset="0"/>
+                <a:ea typeface="Noto Sans CJK KR" pitchFamily="34" charset="-122"/>
+                <a:cs typeface="Noto Sans CJK KR" pitchFamily="34" charset="-120"/>
+              </a:rPr>
+              <a:t>시연에서는 버튼으로 payload 값을 바꾸고, 변경된 값이 Master에서 정확히 수신되는지 확인</a:t>
+            </a:r>
+            <a:endParaRPr lang="en-US" sz="2000" dirty="0"/>
+          </a:p>
+        </p:txBody>
+      </p:sp>
+      <p:sp>
+        <p:nvSpPr>
+          <p:cNvPr id="4" name="Text 2"/>
+          <p:cNvSpPr/>
+          <p:nvPr/>
+        </p:nvSpPr>
+        <p:spPr>
+          <a:xfrm>
+            <a:off x="8503920" y="4754880"/>
+            <a:ext cx="457200" cy="274320"/>
+          </a:xfrm>
+          <a:prstGeom prst="rect">
+            <a:avLst/>
+          </a:prstGeom>
+          <a:noFill/>
+          <a:ln/>
+        </p:spPr>
+        <p:txBody>
+          <a:bodyPr wrap="square" rtlCol="0" anchor="ctr"/>
+          <a:lstStyle/>
+          <a:p>
+            <a:pPr algn="r" indent="0" marL="0">
+              <a:buNone/>
+            </a:pPr>
+            <a:r>
+              <a:rPr lang="en-US" sz="1200" dirty="0">
+                <a:solidFill>
+                  <a:srgbClr val="999999"/>
+                </a:solidFill>
+                <a:latin typeface="Noto Sans CJK KR" pitchFamily="34" charset="0"/>
+                <a:ea typeface="Noto Sans CJK KR" pitchFamily="34" charset="-122"/>
+                <a:cs typeface="Noto Sans CJK KR" pitchFamily="34" charset="-120"/>
+              </a:rPr>
+              <a:t>23</a:t>
+            </a:r>
+            <a:endParaRPr lang="en-US" sz="1200" dirty="0"/>
+          </a:p>
+        </p:txBody>
+      </p:sp>
+    </p:spTree>
+  </p:cSld>
+  <p:clrMapOvr>
+    <a:masterClrMapping/>
+  </p:clrMapOvr>
+</p:sld>
+</file>
+
+<file path=ppt/slides/slide24.xml><?xml version="1.0" encoding="utf-8"?>
 <p:sld xmlns:a="http://schemas.openxmlformats.org/drawingml/2006/main" xmlns:p="http://schemas.openxmlformats.org/presentationml/2006/main" xmlns:r="http://schemas.openxmlformats.org/officeDocument/2006/relationships">
   <p:cSld>
     <p:spTree>
@@ -5465,208 +5769,6 @@
                 <a:ea typeface="Noto Sans CJK KR" pitchFamily="34" charset="-122"/>
                 <a:cs typeface="Noto Sans CJK KR" pitchFamily="34" charset="-120"/>
               </a:rPr>
-              <a:t>23</a:t>
-            </a:r>
-            <a:endParaRPr lang="en-US" sz="1200" dirty="0"/>
-          </a:p>
-        </p:txBody>
-      </p:sp>
-    </p:spTree>
-  </p:cSld>
-  <p:clrMapOvr>
-    <a:masterClrMapping/>
-  </p:clrMapOvr>
-</p:sld>
-</file>
-
-<file path=ppt/slides/slide24.xml><?xml version="1.0" encoding="utf-8"?>
-<p:sld xmlns:a="http://schemas.openxmlformats.org/drawingml/2006/main" xmlns:p="http://schemas.openxmlformats.org/presentationml/2006/main" xmlns:r="http://schemas.openxmlformats.org/officeDocument/2006/relationships">
-  <p:cSld>
-    <p:spTree>
-      <p:nvGrpSpPr>
-        <p:cNvPr id="1" name=""/>
-        <p:cNvGrpSpPr/>
-        <p:nvPr/>
-      </p:nvGrpSpPr>
-      <p:grpSpPr/>
-      <p:sp>
-        <p:nvSpPr>
-          <p:cNvPr id="2" name="Text 0"/>
-          <p:cNvSpPr/>
-          <p:nvPr/>
-        </p:nvSpPr>
-        <p:spPr>
-          <a:xfrm>
-            <a:off x="548640" y="274320"/>
-            <a:ext cx="8046720" cy="777240"/>
-          </a:xfrm>
-          <a:prstGeom prst="rect">
-            <a:avLst/>
-          </a:prstGeom>
-          <a:noFill/>
-          <a:ln/>
-        </p:spPr>
-        <p:txBody>
-          <a:bodyPr wrap="square" lIns="0" tIns="0" rIns="0" bIns="0" rtlCol="0" anchor="ctr"/>
-          <a:lstStyle/>
-          <a:p>
-            <a:pPr indent="0" marL="0">
-              <a:buNone/>
-            </a:pPr>
-            <a:r>
-              <a:rPr lang="en-US" sz="3600" b="1" dirty="0">
-                <a:solidFill>
-                  <a:srgbClr val="111111"/>
-                </a:solidFill>
-                <a:latin typeface="Noto Sans CJK KR" pitchFamily="34" charset="0"/>
-                <a:ea typeface="Noto Sans CJK KR" pitchFamily="34" charset="-122"/>
-                <a:cs typeface="Noto Sans CJK KR" pitchFamily="34" charset="-120"/>
-              </a:rPr>
-              <a:t>클럭 동기의 어려움</a:t>
-            </a:r>
-            <a:endParaRPr lang="en-US" sz="3600" dirty="0"/>
-          </a:p>
-        </p:txBody>
-      </p:sp>
-      <p:sp>
-        <p:nvSpPr>
-          <p:cNvPr id="3" name="Text 1"/>
-          <p:cNvSpPr/>
-          <p:nvPr/>
-        </p:nvSpPr>
-        <p:spPr>
-          <a:xfrm>
-            <a:off x="548640" y="1234440"/>
-            <a:ext cx="8046720" cy="2971800"/>
-          </a:xfrm>
-          <a:prstGeom prst="rect">
-            <a:avLst/>
-          </a:prstGeom>
-          <a:noFill/>
-          <a:ln/>
-        </p:spPr>
-        <p:txBody>
-          <a:bodyPr wrap="square" rtlCol="0" anchor="t"/>
-          <a:lstStyle/>
-          <a:p>
-            <a:pPr marL="342900" indent="-342900">
-              <a:spcAft>
-                <a:spcPts val="1200"/>
-              </a:spcAft>
-              <a:buSzPct val="100000"/>
-              <a:buChar char="•"/>
-            </a:pPr>
-            <a:r>
-              <a:rPr lang="en-US" sz="2000" dirty="0">
-                <a:solidFill>
-                  <a:srgbClr val="222222"/>
-                </a:solidFill>
-                <a:latin typeface="Noto Sans CJK KR" pitchFamily="34" charset="0"/>
-                <a:ea typeface="Noto Sans CJK KR" pitchFamily="34" charset="-122"/>
-                <a:cs typeface="Noto Sans CJK KR" pitchFamily="34" charset="-120"/>
-              </a:rPr>
-              <a:t>Master·Slave는 클럭을 공유하지 않음 — 클럭 오차가 통신에 치명적인 방해 요인</a:t>
-            </a:r>
-            <a:endParaRPr lang="en-US" sz="2000" dirty="0"/>
-          </a:p>
-          <a:p>
-            <a:pPr marL="342900" indent="-342900">
-              <a:spcAft>
-                <a:spcPts val="1200"/>
-              </a:spcAft>
-              <a:buSzPct val="100000"/>
-              <a:buChar char="•"/>
-            </a:pPr>
-            <a:r>
-              <a:rPr lang="en-US" sz="2000" dirty="0">
-                <a:solidFill>
-                  <a:srgbClr val="222222"/>
-                </a:solidFill>
-                <a:latin typeface="Noto Sans CJK KR" pitchFamily="34" charset="0"/>
-                <a:ea typeface="Noto Sans CJK KR" pitchFamily="34" charset="-122"/>
-                <a:cs typeface="Noto Sans CJK KR" pitchFamily="34" charset="-120"/>
-              </a:rPr>
-              <a:t>DIV 값을 AXI 레지스터로 설정해 클럭을 분주, Master·Slave 양쪽에 동일한 DIV 값을 쓴다고 가정</a:t>
-            </a:r>
-            <a:endParaRPr lang="en-US" sz="2000" dirty="0"/>
-          </a:p>
-          <a:p>
-            <a:pPr marL="342900" indent="-342900">
-              <a:spcAft>
-                <a:spcPts val="1200"/>
-              </a:spcAft>
-              <a:buSzPct val="100000"/>
-              <a:buChar char="•"/>
-            </a:pPr>
-            <a:r>
-              <a:rPr lang="en-US" sz="2000" dirty="0">
-                <a:solidFill>
-                  <a:srgbClr val="222222"/>
-                </a:solidFill>
-                <a:latin typeface="Noto Sans CJK KR" pitchFamily="34" charset="0"/>
-                <a:ea typeface="Noto Sans CJK KR" pitchFamily="34" charset="-122"/>
-                <a:cs typeface="Noto Sans CJK KR" pitchFamily="34" charset="-120"/>
-              </a:rPr>
-              <a:t>분주 클럭은 메인 클럭 / (DIV + 1)</a:t>
-            </a:r>
-            <a:endParaRPr lang="en-US" sz="2000" dirty="0"/>
-          </a:p>
-          <a:p>
-            <a:pPr marL="342900" indent="-342900">
-              <a:spcAft>
-                <a:spcPts val="1200"/>
-              </a:spcAft>
-              <a:buSzPct val="100000"/>
-              <a:buChar char="•"/>
-            </a:pPr>
-            <a:r>
-              <a:rPr lang="en-US" sz="2000" dirty="0">
-                <a:solidFill>
-                  <a:srgbClr val="222222"/>
-                </a:solidFill>
-                <a:latin typeface="Noto Sans CJK KR" pitchFamily="34" charset="0"/>
-                <a:ea typeface="Noto Sans CJK KR" pitchFamily="34" charset="-122"/>
-                <a:cs typeface="Noto Sans CJK KR" pitchFamily="34" charset="-120"/>
-              </a:rPr>
-              <a:t>수신 샘플링은 비트 구간의 중간 지점에서 1회만 수행</a:t>
-            </a:r>
-            <a:endParaRPr lang="en-US" sz="2000" dirty="0"/>
-          </a:p>
-        </p:txBody>
-      </p:sp>
-      <p:sp>
-        <p:nvSpPr>
-          <p:cNvPr id="4" name="Text 2"/>
-          <p:cNvSpPr/>
-          <p:nvPr/>
-        </p:nvSpPr>
-        <p:spPr>
-          <a:xfrm>
-            <a:off x="8503920" y="4754880"/>
-            <a:ext cx="457200" cy="274320"/>
-          </a:xfrm>
-          <a:prstGeom prst="rect">
-            <a:avLst/>
-          </a:prstGeom>
-          <a:noFill/>
-          <a:ln/>
-        </p:spPr>
-        <p:txBody>
-          <a:bodyPr wrap="square" rtlCol="0" anchor="ctr"/>
-          <a:lstStyle/>
-          <a:p>
-            <a:pPr algn="r" indent="0" marL="0">
-              <a:buNone/>
-            </a:pPr>
-            <a:r>
-              <a:rPr lang="en-US" sz="1200" dirty="0">
-                <a:solidFill>
-                  <a:srgbClr val="999999"/>
-                </a:solidFill>
-                <a:latin typeface="Noto Sans CJK KR" pitchFamily="34" charset="0"/>
-                <a:ea typeface="Noto Sans CJK KR" pitchFamily="34" charset="-122"/>
-                <a:cs typeface="Noto Sans CJK KR" pitchFamily="34" charset="-120"/>
-              </a:rPr>
               <a:t>24</a:t>
             </a:r>
             <a:endParaRPr lang="en-US" sz="1200" dirty="0"/>
@@ -5724,7 +5826,7 @@
                 <a:ea typeface="Noto Sans CJK KR" pitchFamily="34" charset="-122"/>
                 <a:cs typeface="Noto Sans CJK KR" pitchFamily="34" charset="-120"/>
               </a:rPr>
-              <a:t>Master의 고장 처리</a:t>
+              <a:t>클럭 동기의 어려움</a:t>
             </a:r>
             <a:endParaRPr lang="en-US" sz="3600" dirty="0"/>
           </a:p>
@@ -5767,7 +5869,7 @@
                 <a:ea typeface="Noto Sans CJK KR" pitchFamily="34" charset="-122"/>
                 <a:cs typeface="Noto Sans CJK KR" pitchFamily="34" charset="-120"/>
               </a:rPr>
-              <a:t>슬롯별 4가지 카운터(preamble_err_cnt, slot_timeout_cnt, hamming_err_cnt, silent_cnt)로 임계치 기반 고장 판정</a:t>
+              <a:t>Master·Slave는 클럭을 공유하지 않음 — 클럭 오차가 통신에 치명적인 방해 요인</a:t>
             </a:r>
             <a:endParaRPr lang="en-US" sz="2000" dirty="0"/>
           </a:p>
@@ -5788,7 +5890,7 @@
                 <a:ea typeface="Noto Sans CJK KR" pitchFamily="34" charset="-122"/>
                 <a:cs typeface="Noto Sans CJK KR" pitchFamily="34" charset="-120"/>
               </a:rPr>
-              <a:t>slot_timeout_cnt는 심각한 타이밍/주소 불일치 시 즉시 255로 saturate, 약한 가드 경계 오류 시 +6</a:t>
+              <a:t>DIV 값을 AXI 레지스터로 설정해 클럭을 분주, Master·Slave 양쪽에 동일한 DIV 값을 쓴다고 가정</a:t>
             </a:r>
             <a:endParaRPr lang="en-US" sz="2000" dirty="0"/>
           </a:p>
@@ -5809,7 +5911,7 @@
                 <a:ea typeface="Noto Sans CJK KR" pitchFamily="34" charset="-122"/>
                 <a:cs typeface="Noto Sans CJK KR" pitchFamily="34" charset="-120"/>
               </a:rPr>
-              <a:t>판정 임곗값(FAULT_TH, SILENT_TH)은 PS가 AXI 레지스터로 설정</a:t>
+              <a:t>분주 클럭은 메인 클럭 / (DIV + 1)</a:t>
             </a:r>
             <a:endParaRPr lang="en-US" sz="2000" dirty="0"/>
           </a:p>
@@ -5830,7 +5932,7 @@
                 <a:ea typeface="Noto Sans CJK KR" pitchFamily="34" charset="-122"/>
                 <a:cs typeface="Noto Sans CJK KR" pitchFamily="34" charset="-120"/>
               </a:rPr>
-              <a:t>(preamble_err_cnt + slot_timeout_cnt + hamming_err_cnt) &gt; FAULT_TH 이면 halt_cmd=1 → 동기 프레임에 실어 전송 (silent_cnt는 표시용으로 합산에서 제외)</a:t>
+              <a:t>수신 샘플링은 비트 구간의 중간 지점에서 1회만 수행</a:t>
             </a:r>
             <a:endParaRPr lang="en-US" sz="2000" dirty="0"/>
           </a:p>
@@ -5926,7 +6028,7 @@
                 <a:ea typeface="Noto Sans CJK KR" pitchFamily="34" charset="-122"/>
                 <a:cs typeface="Noto Sans CJK KR" pitchFamily="34" charset="-120"/>
               </a:rPr>
-              <a:t>Master 고장 처리 흐름도</a:t>
+              <a:t>Master의 고장 처리</a:t>
             </a:r>
             <a:endParaRPr lang="en-US" sz="3600" dirty="0"/>
           </a:p>
@@ -5940,8 +6042,8 @@
         </p:nvSpPr>
         <p:spPr>
           <a:xfrm>
-            <a:off x="548640" y="1188720"/>
-            <a:ext cx="8046720" cy="685800"/>
+            <a:off x="548640" y="1234440"/>
+            <a:ext cx="8046720" cy="2971800"/>
           </a:xfrm>
           <a:prstGeom prst="rect">
             <a:avLst/>
@@ -5955,13 +6057,13 @@
           <a:p>
             <a:pPr marL="342900" indent="-342900">
               <a:spcAft>
-                <a:spcPts val="600"/>
+                <a:spcPts val="1200"/>
               </a:spcAft>
               <a:buSzPct val="100000"/>
               <a:buChar char="•"/>
             </a:pPr>
             <a:r>
-              <a:rPr lang="en-US" sz="1600" dirty="0">
+              <a:rPr lang="en-US" sz="2000" dirty="0">
                 <a:solidFill>
                   <a:srgbClr val="222222"/>
                 </a:solidFill>
@@ -5969,20 +6071,20 @@
                 <a:ea typeface="Noto Sans CJK KR" pitchFamily="34" charset="-122"/>
                 <a:cs typeface="Noto Sans CJK KR" pitchFamily="34" charset="-120"/>
               </a:rPr>
-              <a:t>슬롯마다 프리앰블 → 타이밍 → Hamming 순으로 검사</a:t>
-            </a:r>
-            <a:endParaRPr lang="en-US" sz="1600" dirty="0"/>
+              <a:t>슬롯별 4가지 카운터(preamble_err_cnt, slot_timeout_cnt, hamming_err_cnt, silent_cnt)로 임계치 기반 고장 판정</a:t>
+            </a:r>
+            <a:endParaRPr lang="en-US" sz="2000" dirty="0"/>
           </a:p>
           <a:p>
             <a:pPr marL="342900" indent="-342900">
               <a:spcAft>
-                <a:spcPts val="600"/>
+                <a:spcPts val="1200"/>
               </a:spcAft>
               <a:buSzPct val="100000"/>
               <a:buChar char="•"/>
             </a:pPr>
             <a:r>
-              <a:rPr lang="en-US" sz="1600" dirty="0">
+              <a:rPr lang="en-US" sz="2000" dirty="0">
                 <a:solidFill>
                   <a:srgbClr val="222222"/>
                 </a:solidFill>
@@ -5990,20 +6092,20 @@
                 <a:ea typeface="Noto Sans CJK KR" pitchFamily="34" charset="-122"/>
                 <a:cs typeface="Noto Sans CJK KR" pitchFamily="34" charset="-120"/>
               </a:rPr>
-              <a:t>각 단계의 오류는 해당 카운터를 증가시킴</a:t>
-            </a:r>
-            <a:endParaRPr lang="en-US" sz="1600" dirty="0"/>
+              <a:t>slot_timeout_cnt는 심각한 타이밍/주소 불일치 시 즉시 255로 saturate, 약한 가드 경계 오류 시 +6</a:t>
+            </a:r>
+            <a:endParaRPr lang="en-US" sz="2000" dirty="0"/>
           </a:p>
           <a:p>
             <a:pPr marL="342900" indent="-342900">
               <a:spcAft>
-                <a:spcPts val="600"/>
+                <a:spcPts val="1200"/>
               </a:spcAft>
               <a:buSzPct val="100000"/>
               <a:buChar char="•"/>
             </a:pPr>
             <a:r>
-              <a:rPr lang="en-US" sz="1600" dirty="0">
+              <a:rPr lang="en-US" sz="2000" dirty="0">
                 <a:solidFill>
                   <a:srgbClr val="222222"/>
                 </a:solidFill>
@@ -6011,20 +6113,20 @@
                 <a:ea typeface="Noto Sans CJK KR" pitchFamily="34" charset="-122"/>
                 <a:cs typeface="Noto Sans CJK KR" pitchFamily="34" charset="-120"/>
               </a:rPr>
-              <a:t>누적합이 FAULT_TH를 넘으면 halt_cmd=1, 이후 카운터는 동결됨</a:t>
-            </a:r>
-            <a:endParaRPr lang="en-US" sz="1600" dirty="0"/>
+              <a:t>판정 임곗값(FAULT_TH, SILENT_TH)은 PS가 AXI 레지스터로 설정</a:t>
+            </a:r>
+            <a:endParaRPr lang="en-US" sz="2000" dirty="0"/>
           </a:p>
           <a:p>
             <a:pPr marL="342900" indent="-342900">
               <a:spcAft>
-                <a:spcPts val="600"/>
+                <a:spcPts val="1200"/>
               </a:spcAft>
               <a:buSzPct val="100000"/>
               <a:buChar char="•"/>
             </a:pPr>
             <a:r>
-              <a:rPr lang="en-US" sz="1600" dirty="0">
+              <a:rPr lang="en-US" sz="2000" dirty="0">
                 <a:solidFill>
                   <a:srgbClr val="222222"/>
                 </a:solidFill>
@@ -6032,38 +6134,15 @@
                 <a:ea typeface="Noto Sans CJK KR" pitchFamily="34" charset="-122"/>
                 <a:cs typeface="Noto Sans CJK KR" pitchFamily="34" charset="-120"/>
               </a:rPr>
-              <a:t>halt_cmd는 리셋 전까지 유지되며, 취소 경로는 없음</a:t>
-            </a:r>
-            <a:endParaRPr lang="en-US" sz="1600" dirty="0"/>
-          </a:p>
-        </p:txBody>
-      </p:sp>
-      <p:pic>
-        <p:nvPicPr>
-          <p:cNvPr id="4" name="Image 0" descr="/home/user/SoC_Design_and_Programming/diagrams/section3/zoom/master_fault_flow.png">    </p:cNvPr>
-          <p:cNvPicPr>
-            <a:picLocks noChangeAspect="1"/>
-          </p:cNvPicPr>
-          <p:nvPr/>
-        </p:nvPicPr>
-        <p:blipFill>
-          <a:blip r:embed="rId2"/>
-          <a:srcRect l="0" r="0" t="0" b="0"/>
-          <a:stretch/>
-        </p:blipFill>
-        <p:spPr>
-          <a:xfrm>
-            <a:off x="548640" y="2404499"/>
-            <a:ext cx="8046720" cy="1683242"/>
-          </a:xfrm>
-          <a:prstGeom prst="rect">
-            <a:avLst/>
-          </a:prstGeom>
-        </p:spPr>
-      </p:pic>
-      <p:sp>
-        <p:nvSpPr>
-          <p:cNvPr id="5" name="Text 2"/>
+              <a:t>(preamble_err_cnt + slot_timeout_cnt + hamming_err_cnt) &gt; FAULT_TH 이면 halt_cmd=1 → 동기 프레임에 실어 전송 (silent_cnt는 표시용으로 합산에서 제외)</a:t>
+            </a:r>
+            <a:endParaRPr lang="en-US" sz="2000" dirty="0"/>
+          </a:p>
+        </p:txBody>
+      </p:sp>
+      <p:sp>
+        <p:nvSpPr>
+          <p:cNvPr id="4" name="Text 2"/>
           <p:cNvSpPr/>
           <p:nvPr/>
         </p:nvSpPr>
@@ -6151,7 +6230,7 @@
                 <a:ea typeface="Noto Sans CJK KR" pitchFamily="34" charset="-122"/>
                 <a:cs typeface="Noto Sans CJK KR" pitchFamily="34" charset="-120"/>
               </a:rPr>
-              <a:t>Slave의 고장 처리</a:t>
+              <a:t>Master 고장 처리 흐름도</a:t>
             </a:r>
             <a:endParaRPr lang="en-US" sz="3600" dirty="0"/>
           </a:p>
@@ -6165,8 +6244,8 @@
         </p:nvSpPr>
         <p:spPr>
           <a:xfrm>
-            <a:off x="548640" y="1234440"/>
-            <a:ext cx="8046720" cy="2971800"/>
+            <a:off x="548640" y="1188720"/>
+            <a:ext cx="8046720" cy="685800"/>
           </a:xfrm>
           <a:prstGeom prst="rect">
             <a:avLst/>
@@ -6180,13 +6259,13 @@
           <a:p>
             <a:pPr marL="342900" indent="-342900">
               <a:spcAft>
-                <a:spcPts val="1200"/>
+                <a:spcPts val="600"/>
               </a:spcAft>
               <a:buSzPct val="100000"/>
               <a:buChar char="•"/>
             </a:pPr>
             <a:r>
-              <a:rPr lang="en-US" sz="2000" dirty="0">
+              <a:rPr lang="en-US" sz="1600" dirty="0">
                 <a:solidFill>
                   <a:srgbClr val="222222"/>
                 </a:solidFill>
@@ -6194,20 +6273,20 @@
                 <a:ea typeface="Noto Sans CJK KR" pitchFamily="34" charset="-122"/>
                 <a:cs typeface="Noto Sans CJK KR" pitchFamily="34" charset="-120"/>
               </a:rPr>
-              <a:t>Master broadcast 프레임의 halt_cmd(halt_mask) 필드를 수신하면 해당 슬롯은 송신 중단</a:t>
-            </a:r>
-            <a:endParaRPr lang="en-US" sz="2000" dirty="0"/>
+              <a:t>슬롯마다 프리앰블 → 타이밍 → Hamming 순으로 검사</a:t>
+            </a:r>
+            <a:endParaRPr lang="en-US" sz="1600" dirty="0"/>
           </a:p>
           <a:p>
             <a:pPr marL="342900" indent="-342900">
               <a:spcAft>
-                <a:spcPts val="1200"/>
+                <a:spcPts val="600"/>
               </a:spcAft>
               <a:buSzPct val="100000"/>
               <a:buChar char="•"/>
             </a:pPr>
             <a:r>
-              <a:rPr lang="en-US" sz="2000" dirty="0">
+              <a:rPr lang="en-US" sz="1600" dirty="0">
                 <a:solidFill>
                   <a:srgbClr val="222222"/>
                 </a:solidFill>
@@ -6215,20 +6294,20 @@
                 <a:ea typeface="Noto Sans CJK KR" pitchFamily="34" charset="-122"/>
                 <a:cs typeface="Noto Sans CJK KR" pitchFamily="34" charset="-120"/>
               </a:rPr>
-              <a:t>Master가 다음 broadcast에서 해당 비트를 0으로 보내면 다음 사이클부터 자동으로 재개</a:t>
-            </a:r>
-            <a:endParaRPr lang="en-US" sz="2000" dirty="0"/>
+              <a:t>각 단계의 오류는 해당 카운터를 증가시킴</a:t>
+            </a:r>
+            <a:endParaRPr lang="en-US" sz="1600" dirty="0"/>
           </a:p>
           <a:p>
             <a:pPr marL="342900" indent="-342900">
               <a:spcAft>
-                <a:spcPts val="1200"/>
+                <a:spcPts val="600"/>
               </a:spcAft>
               <a:buSzPct val="100000"/>
               <a:buChar char="•"/>
             </a:pPr>
             <a:r>
-              <a:rPr lang="en-US" sz="2000" dirty="0">
+              <a:rPr lang="en-US" sz="1600" dirty="0">
                 <a:solidFill>
                   <a:srgbClr val="222222"/>
                 </a:solidFill>
@@ -6236,15 +6315,59 @@
                 <a:ea typeface="Noto Sans CJK KR" pitchFamily="34" charset="-122"/>
                 <a:cs typeface="Noto Sans CJK KR" pitchFamily="34" charset="-120"/>
               </a:rPr>
-              <a:t>Slave 자체 감지 고장(tx_overlap, slot_timing_invalid, pl_payload6/7_invalid, rx_ham_2bit)은 플래그로 누적되어 인터럽트 신호만 발생, 별도 조치는 없음</a:t>
-            </a:r>
-            <a:endParaRPr lang="en-US" sz="2000" dirty="0"/>
-          </a:p>
-        </p:txBody>
-      </p:sp>
-      <p:sp>
-        <p:nvSpPr>
-          <p:cNvPr id="4" name="Text 2"/>
+              <a:t>누적합이 FAULT_TH를 넘으면 halt_cmd=1, 이후 카운터는 동결됨</a:t>
+            </a:r>
+            <a:endParaRPr lang="en-US" sz="1600" dirty="0"/>
+          </a:p>
+          <a:p>
+            <a:pPr marL="342900" indent="-342900">
+              <a:spcAft>
+                <a:spcPts val="600"/>
+              </a:spcAft>
+              <a:buSzPct val="100000"/>
+              <a:buChar char="•"/>
+            </a:pPr>
+            <a:r>
+              <a:rPr lang="en-US" sz="1600" dirty="0">
+                <a:solidFill>
+                  <a:srgbClr val="222222"/>
+                </a:solidFill>
+                <a:latin typeface="Noto Sans CJK KR" pitchFamily="34" charset="0"/>
+                <a:ea typeface="Noto Sans CJK KR" pitchFamily="34" charset="-122"/>
+                <a:cs typeface="Noto Sans CJK KR" pitchFamily="34" charset="-120"/>
+              </a:rPr>
+              <a:t>halt_cmd는 리셋 전까지 유지되며, 취소 경로는 없음</a:t>
+            </a:r>
+            <a:endParaRPr lang="en-US" sz="1600" dirty="0"/>
+          </a:p>
+        </p:txBody>
+      </p:sp>
+      <p:pic>
+        <p:nvPicPr>
+          <p:cNvPr id="4" name="Image 0" descr="/home/user/SoC_Design_and_Programming/diagrams/section3/zoom/master_fault_flow.png">    </p:cNvPr>
+          <p:cNvPicPr>
+            <a:picLocks noChangeAspect="1"/>
+          </p:cNvPicPr>
+          <p:nvPr/>
+        </p:nvPicPr>
+        <p:blipFill>
+          <a:blip r:embed="rId2"/>
+          <a:srcRect l="0" r="0" t="0" b="0"/>
+          <a:stretch/>
+        </p:blipFill>
+        <p:spPr>
+          <a:xfrm>
+            <a:off x="548640" y="2404499"/>
+            <a:ext cx="8046720" cy="1683242"/>
+          </a:xfrm>
+          <a:prstGeom prst="rect">
+            <a:avLst/>
+          </a:prstGeom>
+        </p:spPr>
+      </p:pic>
+      <p:sp>
+        <p:nvSpPr>
+          <p:cNvPr id="5" name="Text 2"/>
           <p:cNvSpPr/>
           <p:nvPr/>
         </p:nvSpPr>
@@ -6292,14 +6415,6 @@
 <file path=ppt/slides/slide28.xml><?xml version="1.0" encoding="utf-8"?>
 <p:sld xmlns:a="http://schemas.openxmlformats.org/drawingml/2006/main" xmlns:p="http://schemas.openxmlformats.org/presentationml/2006/main" xmlns:r="http://schemas.openxmlformats.org/officeDocument/2006/relationships">
   <p:cSld>
-    <p:bg>
-      <p:bgPr>
-        <a:solidFill>
-          <a:srgbClr val="F2F2F2"/>
-        </a:solidFill>
-        <a:effectLst/>
-      </p:bgPr>
-    </p:bg>
     <p:spTree>
       <p:nvGrpSpPr>
         <p:cNvPr id="1" name=""/>
@@ -6309,43 +6424,132 @@
       <p:grpSpPr/>
       <p:sp>
         <p:nvSpPr>
-          <p:cNvPr id="2" name="TextBox 1"/>
-          <p:cNvSpPr txBox="1"/>
-          <p:nvPr/>
-        </p:nvSpPr>
-        <p:spPr>
-          <a:xfrm>
-            <a:off x="548640" y="1828800"/>
-            <a:ext cx="8046720" cy="1371600"/>
-          </a:xfrm>
-          <a:prstGeom prst="rect">
-            <a:avLst/>
-          </a:prstGeom>
-          <a:noFill/>
-        </p:spPr>
-        <p:txBody>
-          <a:bodyPr wrap="square">
-            <a:spAutoFit/>
-          </a:bodyPr>
-          <a:lstStyle/>
-          <a:p>
-            <a:pPr algn="l"/>
-            <a:r>
-              <a:rPr sz="4000" b="1">
+          <p:cNvPr id="2" name="Text 0"/>
+          <p:cNvSpPr/>
+          <p:nvPr/>
+        </p:nvSpPr>
+        <p:spPr>
+          <a:xfrm>
+            <a:off x="548640" y="274320"/>
+            <a:ext cx="8046720" cy="777240"/>
+          </a:xfrm>
+          <a:prstGeom prst="rect">
+            <a:avLst/>
+          </a:prstGeom>
+          <a:noFill/>
+          <a:ln/>
+        </p:spPr>
+        <p:txBody>
+          <a:bodyPr wrap="square" lIns="0" tIns="0" rIns="0" bIns="0" rtlCol="0" anchor="ctr"/>
+          <a:lstStyle/>
+          <a:p>
+            <a:pPr indent="0" marL="0">
+              <a:buNone/>
+            </a:pPr>
+            <a:r>
+              <a:rPr lang="en-US" sz="3600" b="1" dirty="0">
                 <a:solidFill>
                   <a:srgbClr val="111111"/>
                 </a:solidFill>
-                <a:latin typeface="Noto Sans CJK KR"/>
-              </a:rPr>
-              <a:t>4. TDMA 통신 시연</a:t>
-            </a:r>
-          </a:p>
-        </p:txBody>
-      </p:sp>
-      <p:sp>
-        <p:nvSpPr>
-          <p:cNvPr id="3" name="TextBox 2"/>
-          <p:cNvSpPr txBox="1"/>
+                <a:latin typeface="Noto Sans CJK KR" pitchFamily="34" charset="0"/>
+                <a:ea typeface="Noto Sans CJK KR" pitchFamily="34" charset="-122"/>
+                <a:cs typeface="Noto Sans CJK KR" pitchFamily="34" charset="-120"/>
+              </a:rPr>
+              <a:t>Slave의 고장 처리</a:t>
+            </a:r>
+            <a:endParaRPr lang="en-US" sz="3600" dirty="0"/>
+          </a:p>
+        </p:txBody>
+      </p:sp>
+      <p:sp>
+        <p:nvSpPr>
+          <p:cNvPr id="3" name="Text 1"/>
+          <p:cNvSpPr/>
+          <p:nvPr/>
+        </p:nvSpPr>
+        <p:spPr>
+          <a:xfrm>
+            <a:off x="548640" y="1234440"/>
+            <a:ext cx="8046720" cy="2971800"/>
+          </a:xfrm>
+          <a:prstGeom prst="rect">
+            <a:avLst/>
+          </a:prstGeom>
+          <a:noFill/>
+          <a:ln/>
+        </p:spPr>
+        <p:txBody>
+          <a:bodyPr wrap="square" rtlCol="0" anchor="t"/>
+          <a:lstStyle/>
+          <a:p>
+            <a:pPr marL="342900" indent="-342900">
+              <a:spcAft>
+                <a:spcPts val="1200"/>
+              </a:spcAft>
+              <a:buSzPct val="100000"/>
+              <a:buChar char="•"/>
+            </a:pPr>
+            <a:r>
+              <a:rPr lang="en-US" sz="2000" dirty="0">
+                <a:solidFill>
+                  <a:srgbClr val="222222"/>
+                </a:solidFill>
+                <a:latin typeface="Noto Sans CJK KR" pitchFamily="34" charset="0"/>
+                <a:ea typeface="Noto Sans CJK KR" pitchFamily="34" charset="-122"/>
+                <a:cs typeface="Noto Sans CJK KR" pitchFamily="34" charset="-120"/>
+              </a:rPr>
+              <a:t>Master broadcast 프레임의 halt_cmd(halt_mask) 필드를 수신하면 해당 슬롯은 송신 중단</a:t>
+            </a:r>
+            <a:endParaRPr lang="en-US" sz="2000" dirty="0"/>
+          </a:p>
+          <a:p>
+            <a:pPr marL="342900" indent="-342900">
+              <a:spcAft>
+                <a:spcPts val="1200"/>
+              </a:spcAft>
+              <a:buSzPct val="100000"/>
+              <a:buChar char="•"/>
+            </a:pPr>
+            <a:r>
+              <a:rPr lang="en-US" sz="2000" dirty="0">
+                <a:solidFill>
+                  <a:srgbClr val="222222"/>
+                </a:solidFill>
+                <a:latin typeface="Noto Sans CJK KR" pitchFamily="34" charset="0"/>
+                <a:ea typeface="Noto Sans CJK KR" pitchFamily="34" charset="-122"/>
+                <a:cs typeface="Noto Sans CJK KR" pitchFamily="34" charset="-120"/>
+              </a:rPr>
+              <a:t>Master가 다음 broadcast에서 해당 비트를 0으로 보내면 다음 사이클부터 자동으로 재개</a:t>
+            </a:r>
+            <a:endParaRPr lang="en-US" sz="2000" dirty="0"/>
+          </a:p>
+          <a:p>
+            <a:pPr marL="342900" indent="-342900">
+              <a:spcAft>
+                <a:spcPts val="1200"/>
+              </a:spcAft>
+              <a:buSzPct val="100000"/>
+              <a:buChar char="•"/>
+            </a:pPr>
+            <a:r>
+              <a:rPr lang="en-US" sz="2000" dirty="0">
+                <a:solidFill>
+                  <a:srgbClr val="222222"/>
+                </a:solidFill>
+                <a:latin typeface="Noto Sans CJK KR" pitchFamily="34" charset="0"/>
+                <a:ea typeface="Noto Sans CJK KR" pitchFamily="34" charset="-122"/>
+                <a:cs typeface="Noto Sans CJK KR" pitchFamily="34" charset="-120"/>
+              </a:rPr>
+              <a:t>Slave 자체 감지 고장(tx_overlap, slot_timing_invalid, pl_payload6/7_invalid, rx_ham_2bit)은 플래그로 누적되어 인터럽트 신호만 발생, 별도 조치는 없음</a:t>
+            </a:r>
+            <a:endParaRPr lang="en-US" sz="2000" dirty="0"/>
+          </a:p>
+        </p:txBody>
+      </p:sp>
+      <p:sp>
+        <p:nvSpPr>
+          <p:cNvPr id="4" name="Text 2"/>
+          <p:cNvSpPr/>
           <p:nvPr/>
         </p:nvSpPr>
         <p:spPr>
@@ -6357,23 +6561,27 @@
             <a:avLst/>
           </a:prstGeom>
           <a:noFill/>
-        </p:spPr>
-        <p:txBody>
-          <a:bodyPr wrap="none">
-            <a:spAutoFit/>
-          </a:bodyPr>
-          <a:lstStyle/>
-          <a:p>
-            <a:pPr algn="r"/>
-            <a:r>
-              <a:rPr sz="1200">
+          <a:ln/>
+        </p:spPr>
+        <p:txBody>
+          <a:bodyPr wrap="square" rtlCol="0" anchor="ctr"/>
+          <a:lstStyle/>
+          <a:p>
+            <a:pPr algn="r" indent="0" marL="0">
+              <a:buNone/>
+            </a:pPr>
+            <a:r>
+              <a:rPr lang="en-US" sz="1200" dirty="0">
                 <a:solidFill>
                   <a:srgbClr val="999999"/>
                 </a:solidFill>
-                <a:latin typeface="Noto Sans CJK KR"/>
+                <a:latin typeface="Noto Sans CJK KR" pitchFamily="34" charset="0"/>
+                <a:ea typeface="Noto Sans CJK KR" pitchFamily="34" charset="-122"/>
+                <a:cs typeface="Noto Sans CJK KR" pitchFamily="34" charset="-120"/>
               </a:rPr>
               <a:t>28</a:t>
             </a:r>
+            <a:endParaRPr lang="en-US" sz="1200" dirty="0"/>
           </a:p>
         </p:txBody>
       </p:sp>
@@ -6433,7 +6641,7 @@
                 </a:solidFill>
                 <a:latin typeface="Noto Sans CJK KR"/>
               </a:rPr>
-              <a:t>5. 마무리</a:t>
+              <a:t>4. TDMA 통신 시연</a:t>
             </a:r>
           </a:p>
         </p:txBody>
@@ -6694,9 +6902,105 @@
                 <a:ea typeface="Noto Sans CJK KR" pitchFamily="34" charset="-122"/>
                 <a:cs typeface="Noto Sans CJK KR" pitchFamily="34" charset="-120"/>
               </a:rPr>
-              <a:t>3</a:t>
+              <a:t>4</a:t>
             </a:r>
             <a:endParaRPr lang="en-US" sz="1200" dirty="0"/>
+          </a:p>
+        </p:txBody>
+      </p:sp>
+    </p:spTree>
+  </p:cSld>
+  <p:clrMapOvr>
+    <a:masterClrMapping/>
+  </p:clrMapOvr>
+</p:sld>
+</file>
+
+<file path=ppt/slides/slide30.xml><?xml version="1.0" encoding="utf-8"?>
+<p:sld xmlns:a="http://schemas.openxmlformats.org/drawingml/2006/main" xmlns:p="http://schemas.openxmlformats.org/presentationml/2006/main" xmlns:r="http://schemas.openxmlformats.org/officeDocument/2006/relationships">
+  <p:cSld>
+    <p:bg>
+      <p:bgPr>
+        <a:solidFill>
+          <a:srgbClr val="F2F2F2"/>
+        </a:solidFill>
+        <a:effectLst/>
+      </p:bgPr>
+    </p:bg>
+    <p:spTree>
+      <p:nvGrpSpPr>
+        <p:cNvPr id="1" name=""/>
+        <p:cNvGrpSpPr/>
+        <p:nvPr/>
+      </p:nvGrpSpPr>
+      <p:grpSpPr/>
+      <p:sp>
+        <p:nvSpPr>
+          <p:cNvPr id="2" name="TextBox 1"/>
+          <p:cNvSpPr txBox="1"/>
+          <p:nvPr/>
+        </p:nvSpPr>
+        <p:spPr>
+          <a:xfrm>
+            <a:off x="548640" y="1828800"/>
+            <a:ext cx="8046720" cy="1371600"/>
+          </a:xfrm>
+          <a:prstGeom prst="rect">
+            <a:avLst/>
+          </a:prstGeom>
+          <a:noFill/>
+        </p:spPr>
+        <p:txBody>
+          <a:bodyPr wrap="square">
+            <a:spAutoFit/>
+          </a:bodyPr>
+          <a:lstStyle/>
+          <a:p>
+            <a:pPr algn="l"/>
+            <a:r>
+              <a:rPr sz="4000" b="1">
+                <a:solidFill>
+                  <a:srgbClr val="111111"/>
+                </a:solidFill>
+                <a:latin typeface="Noto Sans CJK KR"/>
+              </a:rPr>
+              <a:t>5. 마무리</a:t>
+            </a:r>
+          </a:p>
+        </p:txBody>
+      </p:sp>
+      <p:sp>
+        <p:nvSpPr>
+          <p:cNvPr id="3" name="TextBox 2"/>
+          <p:cNvSpPr txBox="1"/>
+          <p:nvPr/>
+        </p:nvSpPr>
+        <p:spPr>
+          <a:xfrm>
+            <a:off x="8503920" y="4754880"/>
+            <a:ext cx="457200" cy="274320"/>
+          </a:xfrm>
+          <a:prstGeom prst="rect">
+            <a:avLst/>
+          </a:prstGeom>
+          <a:noFill/>
+        </p:spPr>
+        <p:txBody>
+          <a:bodyPr wrap="none">
+            <a:spAutoFit/>
+          </a:bodyPr>
+          <a:lstStyle/>
+          <a:p>
+            <a:pPr algn="r"/>
+            <a:r>
+              <a:rPr sz="1200">
+                <a:solidFill>
+                  <a:srgbClr val="999999"/>
+                </a:solidFill>
+                <a:latin typeface="Noto Sans CJK KR"/>
+              </a:rPr>
+              <a:t>30</a:t>
+            </a:r>
           </a:p>
         </p:txBody>
       </p:sp>
@@ -6900,7 +7204,7 @@
                 <a:ea typeface="Noto Sans CJK KR" pitchFamily="34" charset="-122"/>
                 <a:cs typeface="Noto Sans CJK KR" pitchFamily="34" charset="-120"/>
               </a:rPr>
-              <a:t>4</a:t>
+              <a:t>5</a:t>
             </a:r>
             <a:endParaRPr lang="en-US" sz="1200" dirty="0"/>
           </a:p>
@@ -6915,6 +7219,196 @@
 </file>
 
 <file path=ppt/slides/slide5.xml><?xml version="1.0" encoding="utf-8"?>
+<p:sld xmlns:a="http://schemas.openxmlformats.org/drawingml/2006/main" xmlns:p="http://schemas.openxmlformats.org/presentationml/2006/main" xmlns:r="http://schemas.openxmlformats.org/officeDocument/2006/relationships">
+  <p:cSld>
+    <p:spTree>
+      <p:nvGrpSpPr>
+        <p:cNvPr id="1" name=""/>
+        <p:cNvGrpSpPr/>
+        <p:nvPr/>
+      </p:nvGrpSpPr>
+      <p:grpSpPr/>
+      <p:sp>
+        <p:nvSpPr>
+          <p:cNvPr id="2" name="TextBox 1"/>
+          <p:cNvSpPr txBox="1"/>
+          <p:nvPr/>
+        </p:nvSpPr>
+        <p:spPr>
+          <a:xfrm>
+            <a:off x="548640" y="457200"/>
+            <a:ext cx="8046720" cy="774192"/>
+          </a:xfrm>
+          <a:prstGeom prst="rect">
+            <a:avLst/>
+          </a:prstGeom>
+          <a:noFill/>
+        </p:spPr>
+        <p:txBody>
+          <a:bodyPr wrap="none">
+            <a:spAutoFit/>
+          </a:bodyPr>
+          <a:lstStyle/>
+          <a:p>
+            <a:r>
+              <a:rPr sz="3600" b="1">
+                <a:solidFill>
+                  <a:srgbClr val="111111"/>
+                </a:solidFill>
+                <a:latin typeface="Noto Sans CJK KR"/>
+              </a:rPr>
+              <a:t>Contents</a:t>
+            </a:r>
+          </a:p>
+        </p:txBody>
+      </p:sp>
+      <p:sp>
+        <p:nvSpPr>
+          <p:cNvPr id="3" name="TextBox 2"/>
+          <p:cNvSpPr txBox="1"/>
+          <p:nvPr/>
+        </p:nvSpPr>
+        <p:spPr>
+          <a:xfrm>
+            <a:off x="548640" y="1645920"/>
+            <a:ext cx="8046720" cy="3200400"/>
+          </a:xfrm>
+          <a:prstGeom prst="rect">
+            <a:avLst/>
+          </a:prstGeom>
+          <a:noFill/>
+        </p:spPr>
+        <p:txBody>
+          <a:bodyPr wrap="square">
+            <a:spAutoFit/>
+          </a:bodyPr>
+          <a:lstStyle/>
+          <a:p>
+            <a:pPr>
+              <a:spcAft>
+                <a:spcPts val="2000"/>
+              </a:spcAft>
+            </a:pPr>
+            <a:r>
+              <a:rPr sz="2400">
+                <a:solidFill>
+                  <a:srgbClr val="222222"/>
+                </a:solidFill>
+                <a:latin typeface="Noto Sans CJK KR"/>
+              </a:rPr>
+              <a:t>1.  프로젝트 개요</a:t>
+            </a:r>
+          </a:p>
+          <a:p>
+            <a:pPr>
+              <a:spcAft>
+                <a:spcPts val="2000"/>
+              </a:spcAft>
+            </a:pPr>
+            <a:r>
+              <a:rPr sz="2400">
+                <a:solidFill>
+                  <a:srgbClr val="222222"/>
+                </a:solidFill>
+                <a:latin typeface="Noto Sans CJK KR"/>
+              </a:rPr>
+              <a:t>2.  TDMA PHY · Datalink · 프로토콜 정의</a:t>
+            </a:r>
+          </a:p>
+          <a:p>
+            <a:pPr>
+              <a:spcAft>
+                <a:spcPts val="2000"/>
+              </a:spcAft>
+            </a:pPr>
+            <a:r>
+              <a:rPr sz="2400">
+                <a:solidFill>
+                  <a:srgbClr val="222222"/>
+                </a:solidFill>
+                <a:latin typeface="Noto Sans CJK KR"/>
+              </a:rPr>
+              <a:t>3.  Master / Slave 구현 사항</a:t>
+            </a:r>
+          </a:p>
+          <a:p>
+            <a:pPr>
+              <a:spcAft>
+                <a:spcPts val="2000"/>
+              </a:spcAft>
+            </a:pPr>
+            <a:r>
+              <a:rPr sz="2400">
+                <a:solidFill>
+                  <a:srgbClr val="222222"/>
+                </a:solidFill>
+                <a:latin typeface="Noto Sans CJK KR"/>
+              </a:rPr>
+              <a:t>4.  TDMA 통신 시연</a:t>
+            </a:r>
+          </a:p>
+          <a:p>
+            <a:pPr>
+              <a:spcAft>
+                <a:spcPts val="2000"/>
+              </a:spcAft>
+            </a:pPr>
+            <a:r>
+              <a:rPr sz="2400">
+                <a:solidFill>
+                  <a:srgbClr val="222222"/>
+                </a:solidFill>
+                <a:latin typeface="Noto Sans CJK KR"/>
+              </a:rPr>
+              <a:t>5.  마무리</a:t>
+            </a:r>
+          </a:p>
+        </p:txBody>
+      </p:sp>
+      <p:sp>
+        <p:nvSpPr>
+          <p:cNvPr id="4" name="TextBox 3"/>
+          <p:cNvSpPr txBox="1"/>
+          <p:nvPr/>
+        </p:nvSpPr>
+        <p:spPr>
+          <a:xfrm>
+            <a:off x="8503920" y="4754880"/>
+            <a:ext cx="457200" cy="274320"/>
+          </a:xfrm>
+          <a:prstGeom prst="rect">
+            <a:avLst/>
+          </a:prstGeom>
+          <a:noFill/>
+        </p:spPr>
+        <p:txBody>
+          <a:bodyPr wrap="none">
+            <a:spAutoFit/>
+          </a:bodyPr>
+          <a:lstStyle/>
+          <a:p>
+            <a:pPr algn="r"/>
+            <a:r>
+              <a:rPr sz="1200">
+                <a:solidFill>
+                  <a:srgbClr val="999999"/>
+                </a:solidFill>
+                <a:latin typeface="Noto Sans CJK KR"/>
+              </a:rPr>
+              <a:t>2</a:t>
+            </a:r>
+          </a:p>
+        </p:txBody>
+      </p:sp>
+    </p:spTree>
+  </p:cSld>
+  <p:clrMapOvr>
+    <a:masterClrMapping/>
+  </p:clrMapOvr>
+</p:sld>
+</file>
+
+<file path=ppt/slides/slide6.xml><?xml version="1.0" encoding="utf-8"?>
 <p:sld xmlns:a="http://schemas.openxmlformats.org/drawingml/2006/main" xmlns:p="http://schemas.openxmlformats.org/presentationml/2006/main" xmlns:r="http://schemas.openxmlformats.org/officeDocument/2006/relationships">
   <p:cSld>
     <p:bg>
@@ -7004,226 +7498,6 @@
                 <a:cs typeface="Noto Sans CJK KR" pitchFamily="34" charset="-120"/>
               </a:rPr>
               <a:t>OSI 7계층을 단축한 TDMA 자체 계층 구조</a:t>
-            </a:r>
-            <a:endParaRPr lang="en-US" sz="2000" dirty="0"/>
-          </a:p>
-        </p:txBody>
-      </p:sp>
-      <p:sp>
-        <p:nvSpPr>
-          <p:cNvPr id="4" name="Text 2"/>
-          <p:cNvSpPr/>
-          <p:nvPr/>
-        </p:nvSpPr>
-        <p:spPr>
-          <a:xfrm>
-            <a:off x="8503920" y="4754880"/>
-            <a:ext cx="457200" cy="274320"/>
-          </a:xfrm>
-          <a:prstGeom prst="rect">
-            <a:avLst/>
-          </a:prstGeom>
-          <a:noFill/>
-          <a:ln/>
-        </p:spPr>
-        <p:txBody>
-          <a:bodyPr wrap="square" rtlCol="0" anchor="ctr"/>
-          <a:lstStyle/>
-          <a:p>
-            <a:pPr algn="r" indent="0" marL="0">
-              <a:buNone/>
-            </a:pPr>
-            <a:r>
-              <a:rPr lang="en-US" sz="1200" dirty="0">
-                <a:solidFill>
-                  <a:srgbClr val="999999"/>
-                </a:solidFill>
-                <a:latin typeface="Noto Sans CJK KR" pitchFamily="34" charset="0"/>
-                <a:ea typeface="Noto Sans CJK KR" pitchFamily="34" charset="-122"/>
-                <a:cs typeface="Noto Sans CJK KR" pitchFamily="34" charset="-120"/>
-              </a:rPr>
-              <a:t>5</a:t>
-            </a:r>
-            <a:endParaRPr lang="en-US" sz="1200" dirty="0"/>
-          </a:p>
-        </p:txBody>
-      </p:sp>
-    </p:spTree>
-  </p:cSld>
-  <p:clrMapOvr>
-    <a:masterClrMapping/>
-  </p:clrMapOvr>
-</p:sld>
-</file>
-
-<file path=ppt/slides/slide6.xml><?xml version="1.0" encoding="utf-8"?>
-<p:sld xmlns:a="http://schemas.openxmlformats.org/drawingml/2006/main" xmlns:p="http://schemas.openxmlformats.org/presentationml/2006/main" xmlns:r="http://schemas.openxmlformats.org/officeDocument/2006/relationships">
-  <p:cSld>
-    <p:spTree>
-      <p:nvGrpSpPr>
-        <p:cNvPr id="1" name=""/>
-        <p:cNvGrpSpPr/>
-        <p:nvPr/>
-      </p:nvGrpSpPr>
-      <p:grpSpPr/>
-      <p:sp>
-        <p:nvSpPr>
-          <p:cNvPr id="2" name="Text 0"/>
-          <p:cNvSpPr/>
-          <p:nvPr/>
-        </p:nvSpPr>
-        <p:spPr>
-          <a:xfrm>
-            <a:off x="548640" y="274320"/>
-            <a:ext cx="8046720" cy="777240"/>
-          </a:xfrm>
-          <a:prstGeom prst="rect">
-            <a:avLst/>
-          </a:prstGeom>
-          <a:noFill/>
-          <a:ln/>
-        </p:spPr>
-        <p:txBody>
-          <a:bodyPr wrap="square" lIns="0" tIns="0" rIns="0" bIns="0" rtlCol="0" anchor="ctr"/>
-          <a:lstStyle/>
-          <a:p>
-            <a:pPr indent="0" marL="0">
-              <a:buNone/>
-            </a:pPr>
-            <a:r>
-              <a:rPr lang="en-US" sz="3600" b="1" dirty="0">
-                <a:solidFill>
-                  <a:srgbClr val="111111"/>
-                </a:solidFill>
-                <a:latin typeface="Noto Sans CJK KR" pitchFamily="34" charset="0"/>
-                <a:ea typeface="Noto Sans CJK KR" pitchFamily="34" charset="-122"/>
-                <a:cs typeface="Noto Sans CJK KR" pitchFamily="34" charset="-120"/>
-              </a:rPr>
-              <a:t>TDMA는 PHY와 DLL만 직접 정의한다</a:t>
-            </a:r>
-            <a:endParaRPr lang="en-US" sz="3600" dirty="0"/>
-          </a:p>
-        </p:txBody>
-      </p:sp>
-      <p:sp>
-        <p:nvSpPr>
-          <p:cNvPr id="3" name="Text 1"/>
-          <p:cNvSpPr/>
-          <p:nvPr/>
-        </p:nvSpPr>
-        <p:spPr>
-          <a:xfrm>
-            <a:off x="548640" y="1234440"/>
-            <a:ext cx="8046720" cy="2971800"/>
-          </a:xfrm>
-          <a:prstGeom prst="rect">
-            <a:avLst/>
-          </a:prstGeom>
-          <a:noFill/>
-          <a:ln/>
-        </p:spPr>
-        <p:txBody>
-          <a:bodyPr wrap="square" rtlCol="0" anchor="t"/>
-          <a:lstStyle/>
-          <a:p>
-            <a:pPr marL="342900" indent="-342900">
-              <a:spcAft>
-                <a:spcPts val="1200"/>
-              </a:spcAft>
-              <a:buSzPct val="100000"/>
-              <a:buChar char="•"/>
-            </a:pPr>
-            <a:r>
-              <a:rPr lang="en-US" sz="2000" dirty="0">
-                <a:solidFill>
-                  <a:srgbClr val="222222"/>
-                </a:solidFill>
-                <a:latin typeface="Noto Sans CJK KR" pitchFamily="34" charset="0"/>
-                <a:ea typeface="Noto Sans CJK KR" pitchFamily="34" charset="-122"/>
-                <a:cs typeface="Noto Sans CJK KR" pitchFamily="34" charset="-120"/>
-              </a:rPr>
-              <a:t>OSI 7계층 풀스택의 한계</a:t>
-            </a:r>
-            <a:endParaRPr lang="en-US" sz="2000" dirty="0"/>
-          </a:p>
-          <a:p>
-            <a:pPr lvl="1" marL="685800" indent="-342900">
-              <a:spcAft>
-                <a:spcPts val="800"/>
-              </a:spcAft>
-              <a:buSzPct val="100000"/>
-              <a:buChar char="•"/>
-            </a:pPr>
-            <a:r>
-              <a:rPr lang="en-US" sz="1700" dirty="0">
-                <a:solidFill>
-                  <a:srgbClr val="444444"/>
-                </a:solidFill>
-                <a:latin typeface="Noto Sans CJK KR" pitchFamily="34" charset="0"/>
-                <a:ea typeface="Noto Sans CJK KR" pitchFamily="34" charset="-122"/>
-                <a:cs typeface="Noto Sans CJK KR" pitchFamily="34" charset="-120"/>
-              </a:rPr>
-              <a:t>필드 디바이스(센서·액추에이터) 레벨에서는 과도한 지연·오버헤드 유발</a:t>
-            </a:r>
-            <a:endParaRPr lang="en-US" sz="2000" dirty="0"/>
-          </a:p>
-          <a:p>
-            <a:pPr marL="342900" indent="-342900">
-              <a:spcAft>
-                <a:spcPts val="1200"/>
-              </a:spcAft>
-              <a:buSzPct val="100000"/>
-              <a:buChar char="•"/>
-            </a:pPr>
-            <a:r>
-              <a:rPr lang="en-US" sz="2000" dirty="0">
-                <a:solidFill>
-                  <a:srgbClr val="222222"/>
-                </a:solidFill>
-                <a:latin typeface="Noto Sans CJK KR" pitchFamily="34" charset="0"/>
-                <a:ea typeface="Noto Sans CJK KR" pitchFamily="34" charset="-122"/>
-                <a:cs typeface="Noto Sans CJK KR" pitchFamily="34" charset="-120"/>
-              </a:rPr>
-              <a:t>TDMA의 계층 단축</a:t>
-            </a:r>
-            <a:endParaRPr lang="en-US" sz="2000" dirty="0"/>
-          </a:p>
-          <a:p>
-            <a:pPr lvl="1" marL="685800" indent="-342900">
-              <a:spcAft>
-                <a:spcPts val="800"/>
-              </a:spcAft>
-              <a:buSzPct val="100000"/>
-              <a:buChar char="•"/>
-            </a:pPr>
-            <a:r>
-              <a:rPr lang="en-US" sz="1700" dirty="0">
-                <a:solidFill>
-                  <a:srgbClr val="444444"/>
-                </a:solidFill>
-                <a:latin typeface="Noto Sans CJK KR" pitchFamily="34" charset="0"/>
-                <a:ea typeface="Noto Sans CJK KR" pitchFamily="34" charset="-122"/>
-                <a:cs typeface="Noto Sans CJK KR" pitchFamily="34" charset="-120"/>
-              </a:rPr>
-              <a:t>Application이 Data Link Layer에 직접 접근 → PHY, DLL 두 계층만 직접 정의</a:t>
-            </a:r>
-            <a:endParaRPr lang="en-US" sz="2000" dirty="0"/>
-          </a:p>
-          <a:p>
-            <a:pPr marL="342900" indent="-342900">
-              <a:buSzPct val="100000"/>
-              <a:buChar char="•"/>
-            </a:pPr>
-            <a:r>
-              <a:rPr lang="en-US" sz="2000" dirty="0">
-                <a:solidFill>
-                  <a:srgbClr val="222222"/>
-                </a:solidFill>
-                <a:latin typeface="Noto Sans CJK KR" pitchFamily="34" charset="0"/>
-                <a:ea typeface="Noto Sans CJK KR" pitchFamily="34" charset="-122"/>
-                <a:cs typeface="Noto Sans CJK KR" pitchFamily="34" charset="-120"/>
-              </a:rPr>
-              <a:t>이후 PHY → DLL(프레임/MAC/Flow Control) 순으로 차례로 짚어나간다</a:t>
             </a:r>
             <a:endParaRPr lang="en-US" sz="2000" dirty="0"/>
           </a:p>
@@ -7319,7 +7593,7 @@
                 <a:ea typeface="Noto Sans CJK KR" pitchFamily="34" charset="-122"/>
                 <a:cs typeface="Noto Sans CJK KR" pitchFamily="34" charset="-120"/>
               </a:rPr>
-              <a:t>PHY 정의</a:t>
+              <a:t>TDMA는 PHY와 DLL만 직접 정의한다</a:t>
             </a:r>
             <a:endParaRPr lang="en-US" sz="3600" dirty="0"/>
           </a:p>
@@ -7334,7 +7608,7 @@
         <p:spPr>
           <a:xfrm>
             <a:off x="548640" y="1234440"/>
-            <a:ext cx="3931920" cy="2971800"/>
+            <a:ext cx="8046720" cy="2971800"/>
           </a:xfrm>
           <a:prstGeom prst="rect">
             <a:avLst/>
@@ -7348,13 +7622,13 @@
           <a:p>
             <a:pPr marL="342900" indent="-342900">
               <a:spcAft>
-                <a:spcPts val="1000"/>
+                <a:spcPts val="1200"/>
               </a:spcAft>
               <a:buSzPct val="100000"/>
               <a:buChar char="•"/>
             </a:pPr>
             <a:r>
-              <a:rPr lang="en-US" sz="1900" dirty="0">
+              <a:rPr lang="en-US" sz="2000" dirty="0">
                 <a:solidFill>
                   <a:srgbClr val="222222"/>
                 </a:solidFill>
@@ -7362,20 +7636,20 @@
                 <a:ea typeface="Noto Sans CJK KR" pitchFamily="34" charset="-122"/>
                 <a:cs typeface="Noto Sans CJK KR" pitchFamily="34" charset="-120"/>
               </a:rPr>
-              <a:t>연결 구조</a:t>
-            </a:r>
-            <a:endParaRPr lang="en-US" sz="1900" dirty="0"/>
+              <a:t>OSI 7계층 풀스택의 한계</a:t>
+            </a:r>
+            <a:endParaRPr lang="en-US" sz="2000" dirty="0"/>
           </a:p>
           <a:p>
             <a:pPr lvl="1" marL="685800" indent="-342900">
               <a:spcAft>
-                <a:spcPts val="600"/>
+                <a:spcPts val="800"/>
               </a:spcAft>
               <a:buSzPct val="100000"/>
               <a:buChar char="•"/>
             </a:pPr>
             <a:r>
-              <a:rPr lang="en-US" sz="1600" dirty="0">
+              <a:rPr lang="en-US" sz="1700" dirty="0">
                 <a:solidFill>
                   <a:srgbClr val="444444"/>
                 </a:solidFill>
@@ -7383,20 +7657,20 @@
                 <a:ea typeface="Noto Sans CJK KR" pitchFamily="34" charset="-122"/>
                 <a:cs typeface="Noto Sans CJK KR" pitchFamily="34" charset="-120"/>
               </a:rPr>
-              <a:t>GPIO 단자 기반 공유 버스, Master 1 : Slave N (NODE_CNT)</a:t>
-            </a:r>
-            <a:endParaRPr lang="en-US" sz="1900" dirty="0"/>
+              <a:t>필드 디바이스(센서·액추에이터) 레벨에서는 과도한 지연·오버헤드 유발</a:t>
+            </a:r>
+            <a:endParaRPr lang="en-US" sz="2000" dirty="0"/>
           </a:p>
           <a:p>
             <a:pPr marL="342900" indent="-342900">
               <a:spcAft>
-                <a:spcPts val="1000"/>
+                <a:spcPts val="1200"/>
               </a:spcAft>
               <a:buSzPct val="100000"/>
               <a:buChar char="•"/>
             </a:pPr>
             <a:r>
-              <a:rPr lang="en-US" sz="1900" dirty="0">
+              <a:rPr lang="en-US" sz="2000" dirty="0">
                 <a:solidFill>
                   <a:srgbClr val="222222"/>
                 </a:solidFill>
@@ -7404,20 +7678,20 @@
                 <a:ea typeface="Noto Sans CJK KR" pitchFamily="34" charset="-122"/>
                 <a:cs typeface="Noto Sans CJK KR" pitchFamily="34" charset="-120"/>
               </a:rPr>
-              <a:t>라인 코딩</a:t>
-            </a:r>
-            <a:endParaRPr lang="en-US" sz="1900" dirty="0"/>
+              <a:t>TDMA의 계층 단축</a:t>
+            </a:r>
+            <a:endParaRPr lang="en-US" sz="2000" dirty="0"/>
           </a:p>
           <a:p>
             <a:pPr lvl="1" marL="685800" indent="-342900">
               <a:spcAft>
-                <a:spcPts val="600"/>
+                <a:spcPts val="800"/>
               </a:spcAft>
               <a:buSzPct val="100000"/>
               <a:buChar char="•"/>
             </a:pPr>
             <a:r>
-              <a:rPr lang="en-US" sz="1600" dirty="0">
+              <a:rPr lang="en-US" sz="1700" dirty="0">
                 <a:solidFill>
                   <a:srgbClr val="444444"/>
                 </a:solidFill>
@@ -7425,20 +7699,17 @@
                 <a:ea typeface="Noto Sans CJK KR" pitchFamily="34" charset="-122"/>
                 <a:cs typeface="Noto Sans CJK KR" pitchFamily="34" charset="-120"/>
               </a:rPr>
-              <a:t>NRZ (Non-Return-to-Zero)</a:t>
-            </a:r>
-            <a:endParaRPr lang="en-US" sz="1900" dirty="0"/>
+              <a:t>Application이 Data Link Layer에 직접 접근 → PHY, DLL 두 계층만 직접 정의</a:t>
+            </a:r>
+            <a:endParaRPr lang="en-US" sz="2000" dirty="0"/>
           </a:p>
           <a:p>
             <a:pPr marL="342900" indent="-342900">
-              <a:spcAft>
-                <a:spcPts val="1000"/>
-              </a:spcAft>
               <a:buSzPct val="100000"/>
               <a:buChar char="•"/>
             </a:pPr>
             <a:r>
-              <a:rPr lang="en-US" sz="1900" dirty="0">
+              <a:rPr lang="en-US" sz="2000" dirty="0">
                 <a:solidFill>
                   <a:srgbClr val="222222"/>
                 </a:solidFill>
@@ -7446,95 +7717,15 @@
                 <a:ea typeface="Noto Sans CJK KR" pitchFamily="34" charset="-122"/>
                 <a:cs typeface="Noto Sans CJK KR" pitchFamily="34" charset="-120"/>
               </a:rPr>
-              <a:t>배선</a:t>
-            </a:r>
-            <a:endParaRPr lang="en-US" sz="1900" dirty="0"/>
-          </a:p>
-          <a:p>
-            <a:pPr lvl="1" marL="685800" indent="-342900">
-              <a:buSzPct val="100000"/>
-              <a:buChar char="•"/>
-            </a:pPr>
-            <a:r>
-              <a:rPr lang="en-US" sz="1600" dirty="0">
-                <a:solidFill>
-                  <a:srgbClr val="444444"/>
-                </a:solidFill>
-                <a:latin typeface="Noto Sans CJK KR" pitchFamily="34" charset="0"/>
-                <a:ea typeface="Noto Sans CJK KR" pitchFamily="34" charset="-122"/>
-                <a:cs typeface="Noto Sans CJK KR" pitchFamily="34" charset="-120"/>
-              </a:rPr>
-              <a:t>TX 1선 + RX 1선 + 공통 GND = 3선 — 슬레이브는 자신의 슬롯에만 TX 구동</a:t>
-            </a:r>
-            <a:endParaRPr lang="en-US" sz="1900" dirty="0"/>
-          </a:p>
-        </p:txBody>
-      </p:sp>
-      <p:pic>
-        <p:nvPicPr>
-          <p:cNvPr id="4" name="Image 0" descr="/home/user/SoC_Design_and_Programming/diagrams/phy_wiring.png">    </p:cNvPr>
-          <p:cNvPicPr>
-            <a:picLocks noChangeAspect="1"/>
-          </p:cNvPicPr>
-          <p:nvPr/>
-        </p:nvPicPr>
-        <p:blipFill>
-          <a:blip r:embed="rId2"/>
-          <a:srcRect l="0" r="0" t="0" b="0"/>
-          <a:stretch/>
-        </p:blipFill>
-        <p:spPr>
-          <a:xfrm>
-            <a:off x="4663440" y="1280160"/>
-            <a:ext cx="3931920" cy="3291281"/>
-          </a:xfrm>
-          <a:prstGeom prst="rect">
-            <a:avLst/>
-          </a:prstGeom>
-        </p:spPr>
-      </p:pic>
-      <p:sp>
-        <p:nvSpPr>
-          <p:cNvPr id="5" name="Text 2"/>
-          <p:cNvSpPr/>
-          <p:nvPr/>
-        </p:nvSpPr>
-        <p:spPr>
-          <a:xfrm>
-            <a:off x="4663440" y="4644593"/>
-            <a:ext cx="3931920" cy="274320"/>
-          </a:xfrm>
-          <a:prstGeom prst="rect">
-            <a:avLst/>
-          </a:prstGeom>
-          <a:noFill/>
-          <a:ln/>
-        </p:spPr>
-        <p:txBody>
-          <a:bodyPr wrap="square" rtlCol="0" anchor="ctr"/>
-          <a:lstStyle/>
-          <a:p>
-            <a:pPr algn="ctr" indent="0" marL="0">
-              <a:buNone/>
-            </a:pPr>
-            <a:r>
-              <a:rPr lang="en-US" sz="900" dirty="0">
-                <a:solidFill>
-                  <a:srgbClr val="999999"/>
-                </a:solidFill>
-                <a:latin typeface="Noto Sans CJK KR" pitchFamily="34" charset="0"/>
-                <a:ea typeface="Noto Sans CJK KR" pitchFamily="34" charset="-122"/>
-                <a:cs typeface="Noto Sans CJK KR" pitchFamily="34" charset="-120"/>
-              </a:rPr>
-              <a:t>Master ↔ Slave 1..N 공유 버스 배선 구조</a:t>
-            </a:r>
-            <a:endParaRPr lang="en-US" sz="900" dirty="0"/>
-          </a:p>
-        </p:txBody>
-      </p:sp>
-      <p:sp>
-        <p:nvSpPr>
-          <p:cNvPr id="6" name="Text 3"/>
+              <a:t>이후 PHY → DLL(프레임/MAC/Flow Control) 순으로 차례로 짚어나간다</a:t>
+            </a:r>
+            <a:endParaRPr lang="en-US" sz="2000" dirty="0"/>
+          </a:p>
+        </p:txBody>
+      </p:sp>
+      <p:sp>
+        <p:nvSpPr>
+          <p:cNvPr id="4" name="Text 2"/>
           <p:cNvSpPr/>
           <p:nvPr/>
         </p:nvSpPr>
@@ -7622,7 +7813,7 @@
                 <a:ea typeface="Noto Sans CJK KR" pitchFamily="34" charset="-122"/>
                 <a:cs typeface="Noto Sans CJK KR" pitchFamily="34" charset="-120"/>
               </a:rPr>
-              <a:t>DLL - Slave 프레임 구조</a:t>
+              <a:t>PHY 정의</a:t>
             </a:r>
             <a:endParaRPr lang="en-US" sz="3600" dirty="0"/>
           </a:p>
@@ -7637,7 +7828,7 @@
         <p:spPr>
           <a:xfrm>
             <a:off x="548640" y="1234440"/>
-            <a:ext cx="8046720" cy="1874520"/>
+            <a:ext cx="3931920" cy="2971800"/>
           </a:xfrm>
           <a:prstGeom prst="rect">
             <a:avLst/>
@@ -7651,7 +7842,7 @@
           <a:p>
             <a:pPr marL="342900" indent="-342900">
               <a:spcAft>
-                <a:spcPts val="800"/>
+                <a:spcPts val="1000"/>
               </a:spcAft>
               <a:buSzPct val="100000"/>
               <a:buChar char="•"/>
@@ -7665,7 +7856,7 @@
                 <a:ea typeface="Noto Sans CJK KR" pitchFamily="34" charset="-122"/>
                 <a:cs typeface="Noto Sans CJK KR" pitchFamily="34" charset="-120"/>
               </a:rPr>
-              <a:t>필드 구성 (총 50비트)</a:t>
+              <a:t>연결 구조</a:t>
             </a:r>
             <a:endParaRPr lang="en-US" sz="1900" dirty="0"/>
           </a:p>
@@ -7686,14 +7877,14 @@
                 <a:ea typeface="Noto Sans CJK KR" pitchFamily="34" charset="-122"/>
                 <a:cs typeface="Noto Sans CJK KR" pitchFamily="34" charset="-120"/>
               </a:rPr>
-              <a:t>preamble(8, 0xAA) + slot_id(3) + payload(32) + hamming parity(7)</a:t>
+              <a:t>GPIO 단자 기반 공유 버스, Master 1 : Slave N (NODE_CNT)</a:t>
             </a:r>
             <a:endParaRPr lang="en-US" sz="1900" dirty="0"/>
           </a:p>
           <a:p>
             <a:pPr marL="342900" indent="-342900">
               <a:spcAft>
-                <a:spcPts val="800"/>
+                <a:spcPts val="1000"/>
               </a:spcAft>
               <a:buSzPct val="100000"/>
               <a:buChar char="•"/>
@@ -7707,7 +7898,7 @@
                 <a:ea typeface="Noto Sans CJK KR" pitchFamily="34" charset="-122"/>
                 <a:cs typeface="Noto Sans CJK KR" pitchFamily="34" charset="-120"/>
               </a:rPr>
-              <a:t>에러 검출/정정</a:t>
+              <a:t>라인 코딩</a:t>
             </a:r>
             <a:endParaRPr lang="en-US" sz="1900" dirty="0"/>
           </a:p>
@@ -7728,14 +7919,14 @@
                 <a:ea typeface="Noto Sans CJK KR" pitchFamily="34" charset="-122"/>
                 <a:cs typeface="Noto Sans CJK KR" pitchFamily="34" charset="-120"/>
               </a:rPr>
-              <a:t>SEC-DED 방식 — 1비트 에러는 검출 후 정정, 2비트 에러는 검출만 가능</a:t>
+              <a:t>NRZ (Non-Return-to-Zero)</a:t>
             </a:r>
             <a:endParaRPr lang="en-US" sz="1900" dirty="0"/>
           </a:p>
           <a:p>
             <a:pPr marL="342900" indent="-342900">
               <a:spcAft>
-                <a:spcPts val="800"/>
+                <a:spcPts val="1000"/>
               </a:spcAft>
               <a:buSzPct val="100000"/>
               <a:buChar char="•"/>
@@ -7749,7 +7940,7 @@
                 <a:ea typeface="Noto Sans CJK KR" pitchFamily="34" charset="-122"/>
                 <a:cs typeface="Noto Sans CJK KR" pitchFamily="34" charset="-120"/>
               </a:rPr>
-              <a:t>slot_id의 의미</a:t>
+              <a:t>배선</a:t>
             </a:r>
             <a:endParaRPr lang="en-US" sz="1900" dirty="0"/>
           </a:p>
@@ -7767,7 +7958,7 @@
                 <a:ea typeface="Noto Sans CJK KR" pitchFamily="34" charset="-122"/>
                 <a:cs typeface="Noto Sans CJK KR" pitchFamily="34" charset="-120"/>
               </a:rPr>
-              <a:t>슬레이브 고유 식별자가 아니라 TDMA 슬롯 번호로 운용됨</a:t>
+              <a:t>TX 1선 + RX 1선 + 공통 GND = 3선 — 슬레이브는 자신의 슬롯에만 TX 구동</a:t>
             </a:r>
             <a:endParaRPr lang="en-US" sz="1900" dirty="0"/>
           </a:p>
@@ -7775,7 +7966,7 @@
       </p:sp>
       <p:pic>
         <p:nvPicPr>
-          <p:cNvPr id="4" name="Image 0" descr="/home/user/SoC_Design_and_Programming/diagrams/slave_frame.png">    </p:cNvPr>
+          <p:cNvPr id="4" name="Image 0" descr="/home/user/SoC_Design_and_Programming/diagrams/phy_wiring.png">    </p:cNvPr>
           <p:cNvPicPr>
             <a:picLocks noChangeAspect="1"/>
           </p:cNvPicPr>
@@ -7788,8 +7979,8 @@
         </p:blipFill>
         <p:spPr>
           <a:xfrm>
-            <a:off x="548640" y="3246120"/>
-            <a:ext cx="8046720" cy="563270"/>
+            <a:off x="4663440" y="1280160"/>
+            <a:ext cx="3931920" cy="3291281"/>
           </a:xfrm>
           <a:prstGeom prst="rect">
             <a:avLst/>
@@ -7804,8 +7995,8 @@
         </p:nvSpPr>
         <p:spPr>
           <a:xfrm>
-            <a:off x="548640" y="3900830"/>
-            <a:ext cx="8046720" cy="228600"/>
+            <a:off x="4663440" y="4644593"/>
+            <a:ext cx="3931920" cy="274320"/>
           </a:xfrm>
           <a:prstGeom prst="rect">
             <a:avLst/>
@@ -7829,7 +8020,7 @@
                 <a:ea typeface="Noto Sans CJK KR" pitchFamily="34" charset="-122"/>
                 <a:cs typeface="Noto Sans CJK KR" pitchFamily="34" charset="-120"/>
               </a:rPr>
-              <a:t>Slave 프레임 비트필드 (전송 순서: preamble → slot_id → payload → hamming)</a:t>
+              <a:t>Master ↔ Slave 1..N 공유 버스 배선 구조</a:t>
             </a:r>
             <a:endParaRPr lang="en-US" sz="900" dirty="0"/>
           </a:p>
@@ -7925,7 +8116,7 @@
                 <a:ea typeface="Noto Sans CJK KR" pitchFamily="34" charset="-122"/>
                 <a:cs typeface="Noto Sans CJK KR" pitchFamily="34" charset="-120"/>
               </a:rPr>
-              <a:t>DLL - Master 프레임 구조</a:t>
+              <a:t>DLL - Slave 프레임 구조</a:t>
             </a:r>
             <a:endParaRPr lang="en-US" sz="3600" dirty="0"/>
           </a:p>
@@ -7940,7 +8131,7 @@
         <p:spPr>
           <a:xfrm>
             <a:off x="548640" y="1234440"/>
-            <a:ext cx="8046720" cy="2057400"/>
+            <a:ext cx="8046720" cy="1874520"/>
           </a:xfrm>
           <a:prstGeom prst="rect">
             <a:avLst/>
@@ -7968,7 +8159,7 @@
                 <a:ea typeface="Noto Sans CJK KR" pitchFamily="34" charset="-122"/>
                 <a:cs typeface="Noto Sans CJK KR" pitchFamily="34" charset="-120"/>
               </a:rPr>
-              <a:t>필드 구성</a:t>
+              <a:t>필드 구성 (총 50비트)</a:t>
             </a:r>
             <a:endParaRPr lang="en-US" sz="1900" dirty="0"/>
           </a:p>
@@ -7989,7 +8180,7 @@
                 <a:ea typeface="Noto Sans CJK KR" pitchFamily="34" charset="-122"/>
                 <a:cs typeface="Noto Sans CJK KR" pitchFamily="34" charset="-120"/>
               </a:rPr>
-              <a:t>preamble(8) + halt_cmd(8) + guard_ticks(10) + reserved(17) + hamming parity(7)</a:t>
+              <a:t>preamble(8, 0xAA) + slot_id(3) + payload(32) + hamming parity(7)</a:t>
             </a:r>
             <a:endParaRPr lang="en-US" sz="1900" dirty="0"/>
           </a:p>
@@ -8010,7 +8201,7 @@
                 <a:ea typeface="Noto Sans CJK KR" pitchFamily="34" charset="-122"/>
                 <a:cs typeface="Noto Sans CJK KR" pitchFamily="34" charset="-120"/>
               </a:rPr>
-              <a:t>halt_cmd</a:t>
+              <a:t>에러 검출/정정</a:t>
             </a:r>
             <a:endParaRPr lang="en-US" sz="1900" dirty="0"/>
           </a:p>
@@ -8031,7 +8222,7 @@
                 <a:ea typeface="Noto Sans CJK KR" pitchFamily="34" charset="-122"/>
                 <a:cs typeface="Noto Sans CJK KR" pitchFamily="34" charset="-120"/>
               </a:rPr>
-              <a:t>슬레이브별 1비트 마스크 — err_cnt가 임계치(FAULT_TH) 초과 시 해당 비트 set, 고장 슬레이브 중단 명령</a:t>
+              <a:t>SEC-DED 방식 — 1비트 에러는 검출 후 정정, 2비트 에러는 검출만 가능</a:t>
             </a:r>
             <a:endParaRPr lang="en-US" sz="1900" dirty="0"/>
           </a:p>
@@ -8052,7 +8243,7 @@
                 <a:ea typeface="Noto Sans CJK KR" pitchFamily="34" charset="-122"/>
                 <a:cs typeface="Noto Sans CJK KR" pitchFamily="34" charset="-120"/>
               </a:rPr>
-              <a:t>에러 검출/정정</a:t>
+              <a:t>slot_id의 의미</a:t>
             </a:r>
             <a:endParaRPr lang="en-US" sz="1900" dirty="0"/>
           </a:p>
@@ -8070,7 +8261,7 @@
                 <a:ea typeface="Noto Sans CJK KR" pitchFamily="34" charset="-122"/>
                 <a:cs typeface="Noto Sans CJK KR" pitchFamily="34" charset="-120"/>
               </a:rPr>
-              <a:t>Slave 프레임과 동일한 SEC-DED 방식 적용</a:t>
+              <a:t>슬레이브 고유 식별자가 아니라 TDMA 슬롯 번호로 운용됨</a:t>
             </a:r>
             <a:endParaRPr lang="en-US" sz="1900" dirty="0"/>
           </a:p>
@@ -8078,7 +8269,7 @@
       </p:sp>
       <p:pic>
         <p:nvPicPr>
-          <p:cNvPr id="4" name="Image 0" descr="/home/user/SoC_Design_and_Programming/diagrams/master_frame.png">    </p:cNvPr>
+          <p:cNvPr id="4" name="Image 0" descr="/home/user/SoC_Design_and_Programming/diagrams/slave_frame.png">    </p:cNvPr>
           <p:cNvPicPr>
             <a:picLocks noChangeAspect="1"/>
           </p:cNvPicPr>
@@ -8091,7 +8282,7 @@
         </p:blipFill>
         <p:spPr>
           <a:xfrm>
-            <a:off x="548640" y="3383280"/>
+            <a:off x="548640" y="3246120"/>
             <a:ext cx="8046720" cy="563270"/>
           </a:xfrm>
           <a:prstGeom prst="rect">
@@ -8107,7 +8298,7 @@
         </p:nvSpPr>
         <p:spPr>
           <a:xfrm>
-            <a:off x="548640" y="4037990"/>
+            <a:off x="548640" y="3900830"/>
             <a:ext cx="8046720" cy="228600"/>
           </a:xfrm>
           <a:prstGeom prst="rect">
@@ -8132,7 +8323,7 @@
                 <a:ea typeface="Noto Sans CJK KR" pitchFamily="34" charset="-122"/>
                 <a:cs typeface="Noto Sans CJK KR" pitchFamily="34" charset="-120"/>
               </a:rPr>
-              <a:t>Master 프레임 비트필드 (전송 순서: preamble → halt_cmd → guard_ticks → reserved → hamming)</a:t>
+              <a:t>Slave 프레임 비트필드 (전송 순서: preamble → slot_id → payload → hamming)</a:t>
             </a:r>
             <a:endParaRPr lang="en-US" sz="900" dirty="0"/>
           </a:p>

</xml_diff>

<commit_message>
Add section 1 divider slide and rename it in the TOC
Section 1 had no divider slide like the others; add one ("1. 프로젝트
소개") right after Contents, and update the TOC entry to match, so
every section now follows TOC -> divider -> content -> divider...

Co-Authored-By: Claude Sonnet 4.6 <noreply@anthropic.com>
Claude-Session: https://claude.ai/code/session_01UcZX9gdfC56CAidpRSm7mN
</commit_message>
<xml_diff>
--- a/presentation_full.pptx
+++ b/presentation_full.pptx
@@ -10,10 +10,10 @@
   <p:sldIdLst>
     <p:sldId id="256" r:id="rId2"/>
     <p:sldId id="260" r:id="rId11"/>
+    <p:sldId id="261" r:id="rId12"/>
     <p:sldId id="257" r:id="rId3"/>
     <p:sldId id="258" r:id="rId4"/>
     <p:sldId id="259" r:id="rId5"/>
-    <p:sldId id="261" r:id="rId12"/>
     <p:sldId id="262" r:id="rId13"/>
     <p:sldId id="263" r:id="rId14"/>
     <p:sldId id="264" r:id="rId15"/>
@@ -38,6 +38,7 @@
     <p:sldId id="283" r:id="rId34"/>
     <p:sldId id="284" r:id="rId35"/>
     <p:sldId id="285" r:id="rId36"/>
+    <p:sldId id="286" r:id="rId37"/>
   </p:sldIdLst>
   <p:sldSz cx="9144000" cy="5143500" type="screen16x9"/>
   <p:notesSz cx="5143500" cy="9144000"/>
@@ -1257,7 +1258,7 @@
                 <a:ea typeface="Noto Sans CJK KR" pitchFamily="34" charset="-122"/>
                 <a:cs typeface="Noto Sans CJK KR" pitchFamily="34" charset="-120"/>
               </a:rPr>
-              <a:t>DLL - Master 프레임 구조</a:t>
+              <a:t>DLL - Slave 프레임 구조</a:t>
             </a:r>
             <a:endParaRPr lang="en-US" sz="3600" dirty="0"/>
           </a:p>
@@ -1272,7 +1273,7 @@
         <p:spPr>
           <a:xfrm>
             <a:off x="548640" y="1234440"/>
-            <a:ext cx="8046720" cy="2057400"/>
+            <a:ext cx="8046720" cy="1874520"/>
           </a:xfrm>
           <a:prstGeom prst="rect">
             <a:avLst/>
@@ -1300,7 +1301,7 @@
                 <a:ea typeface="Noto Sans CJK KR" pitchFamily="34" charset="-122"/>
                 <a:cs typeface="Noto Sans CJK KR" pitchFamily="34" charset="-120"/>
               </a:rPr>
-              <a:t>필드 구성</a:t>
+              <a:t>필드 구성 (총 50비트)</a:t>
             </a:r>
             <a:endParaRPr lang="en-US" sz="1900" dirty="0"/>
           </a:p>
@@ -1321,7 +1322,7 @@
                 <a:ea typeface="Noto Sans CJK KR" pitchFamily="34" charset="-122"/>
                 <a:cs typeface="Noto Sans CJK KR" pitchFamily="34" charset="-120"/>
               </a:rPr>
-              <a:t>preamble(8) + halt_cmd(8) + guard_ticks(10) + reserved(17) + hamming parity(7)</a:t>
+              <a:t>preamble(8, 0xAA) + slot_id(3) + payload(32) + hamming parity(7)</a:t>
             </a:r>
             <a:endParaRPr lang="en-US" sz="1900" dirty="0"/>
           </a:p>
@@ -1342,7 +1343,7 @@
                 <a:ea typeface="Noto Sans CJK KR" pitchFamily="34" charset="-122"/>
                 <a:cs typeface="Noto Sans CJK KR" pitchFamily="34" charset="-120"/>
               </a:rPr>
-              <a:t>halt_cmd</a:t>
+              <a:t>에러 검출/정정</a:t>
             </a:r>
             <a:endParaRPr lang="en-US" sz="1900" dirty="0"/>
           </a:p>
@@ -1363,7 +1364,7 @@
                 <a:ea typeface="Noto Sans CJK KR" pitchFamily="34" charset="-122"/>
                 <a:cs typeface="Noto Sans CJK KR" pitchFamily="34" charset="-120"/>
               </a:rPr>
-              <a:t>슬레이브별 1비트 마스크 — err_cnt가 임계치(FAULT_TH) 초과 시 해당 비트 set, 고장 슬레이브 중단 명령</a:t>
+              <a:t>SEC-DED 방식 — 1비트 에러는 검출 후 정정, 2비트 에러는 검출만 가능</a:t>
             </a:r>
             <a:endParaRPr lang="en-US" sz="1900" dirty="0"/>
           </a:p>
@@ -1384,7 +1385,7 @@
                 <a:ea typeface="Noto Sans CJK KR" pitchFamily="34" charset="-122"/>
                 <a:cs typeface="Noto Sans CJK KR" pitchFamily="34" charset="-120"/>
               </a:rPr>
-              <a:t>에러 검출/정정</a:t>
+              <a:t>slot_id의 의미</a:t>
             </a:r>
             <a:endParaRPr lang="en-US" sz="1900" dirty="0"/>
           </a:p>
@@ -1402,7 +1403,7 @@
                 <a:ea typeface="Noto Sans CJK KR" pitchFamily="34" charset="-122"/>
                 <a:cs typeface="Noto Sans CJK KR" pitchFamily="34" charset="-120"/>
               </a:rPr>
-              <a:t>Slave 프레임과 동일한 SEC-DED 방식 적용</a:t>
+              <a:t>슬레이브 고유 식별자가 아니라 TDMA 슬롯 번호로 운용됨</a:t>
             </a:r>
             <a:endParaRPr lang="en-US" sz="1900" dirty="0"/>
           </a:p>
@@ -1410,7 +1411,7 @@
       </p:sp>
       <p:pic>
         <p:nvPicPr>
-          <p:cNvPr id="4" name="Image 0" descr="/home/user/SoC_Design_and_Programming/diagrams/master_frame.png">    </p:cNvPr>
+          <p:cNvPr id="4" name="Image 0" descr="/home/user/SoC_Design_and_Programming/diagrams/slave_frame.png">    </p:cNvPr>
           <p:cNvPicPr>
             <a:picLocks noChangeAspect="1"/>
           </p:cNvPicPr>
@@ -1423,7 +1424,7 @@
         </p:blipFill>
         <p:spPr>
           <a:xfrm>
-            <a:off x="548640" y="3383280"/>
+            <a:off x="548640" y="3246120"/>
             <a:ext cx="8046720" cy="563270"/>
           </a:xfrm>
           <a:prstGeom prst="rect">
@@ -1439,7 +1440,7 @@
         </p:nvSpPr>
         <p:spPr>
           <a:xfrm>
-            <a:off x="548640" y="4037990"/>
+            <a:off x="548640" y="3900830"/>
             <a:ext cx="8046720" cy="228600"/>
           </a:xfrm>
           <a:prstGeom prst="rect">
@@ -1464,7 +1465,7 @@
                 <a:ea typeface="Noto Sans CJK KR" pitchFamily="34" charset="-122"/>
                 <a:cs typeface="Noto Sans CJK KR" pitchFamily="34" charset="-120"/>
               </a:rPr>
-              <a:t>Master 프레임 비트필드 (전송 순서: preamble → halt_cmd → guard_ticks → reserved → hamming)</a:t>
+              <a:t>Slave 프레임 비트필드 (전송 순서: preamble → slot_id → payload → hamming)</a:t>
             </a:r>
             <a:endParaRPr lang="en-US" sz="900" dirty="0"/>
           </a:p>
@@ -1560,7 +1561,7 @@
                 <a:ea typeface="Noto Sans CJK KR" pitchFamily="34" charset="-122"/>
                 <a:cs typeface="Noto Sans CJK KR" pitchFamily="34" charset="-120"/>
               </a:rPr>
-              <a:t>DLL - MAC: 동기화와 타임슬롯</a:t>
+              <a:t>DLL - Master 프레임 구조</a:t>
             </a:r>
             <a:endParaRPr lang="en-US" sz="3600" dirty="0"/>
           </a:p>
@@ -1575,7 +1576,7 @@
         <p:spPr>
           <a:xfrm>
             <a:off x="548640" y="1234440"/>
-            <a:ext cx="8046720" cy="1371600"/>
+            <a:ext cx="8046720" cy="2057400"/>
           </a:xfrm>
           <a:prstGeom prst="rect">
             <a:avLst/>
@@ -1588,6 +1589,27 @@
           <a:lstStyle/>
           <a:p>
             <a:pPr marL="342900" indent="-342900">
+              <a:spcAft>
+                <a:spcPts val="800"/>
+              </a:spcAft>
+              <a:buSzPct val="100000"/>
+              <a:buChar char="•"/>
+            </a:pPr>
+            <a:r>
+              <a:rPr lang="en-US" sz="1900" dirty="0">
+                <a:solidFill>
+                  <a:srgbClr val="222222"/>
+                </a:solidFill>
+                <a:latin typeface="Noto Sans CJK KR" pitchFamily="34" charset="0"/>
+                <a:ea typeface="Noto Sans CJK KR" pitchFamily="34" charset="-122"/>
+                <a:cs typeface="Noto Sans CJK KR" pitchFamily="34" charset="-120"/>
+              </a:rPr>
+              <a:t>필드 구성</a:t>
+            </a:r>
+            <a:endParaRPr lang="en-US" sz="1900" dirty="0"/>
+          </a:p>
+          <a:p>
+            <a:pPr lvl="1" marL="685800" indent="-342900">
               <a:spcAft>
                 <a:spcPts val="600"/>
               </a:spcAft>
@@ -1595,41 +1617,41 @@
               <a:buChar char="•"/>
             </a:pPr>
             <a:r>
-              <a:rPr lang="en-US" sz="1800" dirty="0">
-                <a:solidFill>
-                  <a:srgbClr val="222222"/>
-                </a:solidFill>
-                <a:latin typeface="Noto Sans CJK KR" pitchFamily="34" charset="0"/>
-                <a:ea typeface="Noto Sans CJK KR" pitchFamily="34" charset="-122"/>
-                <a:cs typeface="Noto Sans CJK KR" pitchFamily="34" charset="-120"/>
-              </a:rPr>
-              <a:t>Sync 기준점</a:t>
-            </a:r>
-            <a:endParaRPr lang="en-US" sz="1800" dirty="0"/>
-          </a:p>
-          <a:p>
-            <a:pPr lvl="1" marL="685800" indent="-342900">
+              <a:rPr lang="en-US" sz="1600" dirty="0">
+                <a:solidFill>
+                  <a:srgbClr val="444444"/>
+                </a:solidFill>
+                <a:latin typeface="Noto Sans CJK KR" pitchFamily="34" charset="0"/>
+                <a:ea typeface="Noto Sans CJK KR" pitchFamily="34" charset="-122"/>
+                <a:cs typeface="Noto Sans CJK KR" pitchFamily="34" charset="-120"/>
+              </a:rPr>
+              <a:t>preamble(8) + halt_cmd(8) + guard_ticks(10) + reserved(17) + hamming parity(7)</a:t>
+            </a:r>
+            <a:endParaRPr lang="en-US" sz="1900" dirty="0"/>
+          </a:p>
+          <a:p>
+            <a:pPr marL="342900" indent="-342900">
               <a:spcAft>
-                <a:spcPts val="400"/>
+                <a:spcPts val="800"/>
               </a:spcAft>
               <a:buSzPct val="100000"/>
               <a:buChar char="•"/>
             </a:pPr>
             <a:r>
-              <a:rPr lang="en-US" sz="1500" dirty="0">
-                <a:solidFill>
-                  <a:srgbClr val="444444"/>
-                </a:solidFill>
-                <a:latin typeface="Noto Sans CJK KR" pitchFamily="34" charset="0"/>
-                <a:ea typeface="Noto Sans CJK KR" pitchFamily="34" charset="-122"/>
-                <a:cs typeface="Noto Sans CJK KR" pitchFamily="34" charset="-120"/>
-              </a:rPr>
-              <a:t>Master가 매 사이클 마지막 슬롯에서 전송한 sync를 다음 사이클 슬롯 계산 기준점으로 사용</a:t>
-            </a:r>
-            <a:endParaRPr lang="en-US" sz="1800" dirty="0"/>
-          </a:p>
-          <a:p>
-            <a:pPr marL="342900" indent="-342900">
+              <a:rPr lang="en-US" sz="1900" dirty="0">
+                <a:solidFill>
+                  <a:srgbClr val="222222"/>
+                </a:solidFill>
+                <a:latin typeface="Noto Sans CJK KR" pitchFamily="34" charset="0"/>
+                <a:ea typeface="Noto Sans CJK KR" pitchFamily="34" charset="-122"/>
+                <a:cs typeface="Noto Sans CJK KR" pitchFamily="34" charset="-120"/>
+              </a:rPr>
+              <a:t>halt_cmd</a:t>
+            </a:r>
+            <a:endParaRPr lang="en-US" sz="1900" dirty="0"/>
+          </a:p>
+          <a:p>
+            <a:pPr lvl="1" marL="685800" indent="-342900">
               <a:spcAft>
                 <a:spcPts val="600"/>
               </a:spcAft>
@@ -1637,49 +1659,28 @@
               <a:buChar char="•"/>
             </a:pPr>
             <a:r>
-              <a:rPr lang="en-US" sz="1800" dirty="0">
-                <a:solidFill>
-                  <a:srgbClr val="222222"/>
-                </a:solidFill>
-                <a:latin typeface="Noto Sans CJK KR" pitchFamily="34" charset="0"/>
-                <a:ea typeface="Noto Sans CJK KR" pitchFamily="34" charset="-122"/>
-                <a:cs typeface="Noto Sans CJK KR" pitchFamily="34" charset="-120"/>
-              </a:rPr>
-              <a:t>슬롯 내부 구조</a:t>
-            </a:r>
-            <a:endParaRPr lang="en-US" sz="1800" dirty="0"/>
-          </a:p>
-          <a:p>
-            <a:pPr lvl="1" marL="685800" indent="-342900">
+              <a:rPr lang="en-US" sz="1600" dirty="0">
+                <a:solidFill>
+                  <a:srgbClr val="444444"/>
+                </a:solidFill>
+                <a:latin typeface="Noto Sans CJK KR" pitchFamily="34" charset="0"/>
+                <a:ea typeface="Noto Sans CJK KR" pitchFamily="34" charset="-122"/>
+                <a:cs typeface="Noto Sans CJK KR" pitchFamily="34" charset="-120"/>
+              </a:rPr>
+              <a:t>슬레이브별 1비트 마스크 — err_cnt가 임계치(FAULT_TH) 초과 시 해당 비트 set, 고장 슬레이브 중단 명령</a:t>
+            </a:r>
+            <a:endParaRPr lang="en-US" sz="1900" dirty="0"/>
+          </a:p>
+          <a:p>
+            <a:pPr marL="342900" indent="-342900">
               <a:spcAft>
-                <a:spcPts val="400"/>
+                <a:spcPts val="800"/>
               </a:spcAft>
               <a:buSzPct val="100000"/>
               <a:buChar char="•"/>
             </a:pPr>
             <a:r>
-              <a:rPr lang="en-US" sz="1500" dirty="0">
-                <a:solidFill>
-                  <a:srgbClr val="444444"/>
-                </a:solidFill>
-                <a:latin typeface="Noto Sans CJK KR" pitchFamily="34" charset="0"/>
-                <a:ea typeface="Noto Sans CJK KR" pitchFamily="34" charset="-122"/>
-                <a:cs typeface="Noto Sans CJK KR" pitchFamily="34" charset="-120"/>
-              </a:rPr>
-              <a:t>½ guard tick 대기 → 데이터 전송 → ½ guard tick 대기</a:t>
-            </a:r>
-            <a:endParaRPr lang="en-US" sz="1800" dirty="0"/>
-          </a:p>
-          <a:p>
-            <a:pPr marL="342900" indent="-342900">
-              <a:spcAft>
-                <a:spcPts val="600"/>
-              </a:spcAft>
-              <a:buSzPct val="100000"/>
-              <a:buChar char="•"/>
-            </a:pPr>
-            <a:r>
-              <a:rPr lang="en-US" sz="1800" dirty="0">
+              <a:rPr lang="en-US" sz="1900" dirty="0">
                 <a:solidFill>
                   <a:srgbClr val="222222"/>
                 </a:solidFill>
@@ -1687,9 +1688,9 @@
                 <a:ea typeface="Noto Sans CJK KR" pitchFamily="34" charset="-122"/>
                 <a:cs typeface="Noto Sans CJK KR" pitchFamily="34" charset="-120"/>
               </a:rPr>
-              <a:t>Guard Tick의 역할</a:t>
-            </a:r>
-            <a:endParaRPr lang="en-US" sz="1800" dirty="0"/>
+              <a:t>에러 검출/정정</a:t>
+            </a:r>
+            <a:endParaRPr lang="en-US" sz="1900" dirty="0"/>
           </a:p>
           <a:p>
             <a:pPr lvl="1" marL="685800" indent="-342900">
@@ -1697,7 +1698,7 @@
               <a:buChar char="•"/>
             </a:pPr>
             <a:r>
-              <a:rPr lang="en-US" sz="1500" dirty="0">
+              <a:rPr lang="en-US" sz="1600" dirty="0">
                 <a:solidFill>
                   <a:srgbClr val="444444"/>
                 </a:solidFill>
@@ -1705,15 +1706,15 @@
                 <a:ea typeface="Noto Sans CJK KR" pitchFamily="34" charset="-122"/>
                 <a:cs typeface="Noto Sans CJK KR" pitchFamily="34" charset="-120"/>
               </a:rPr>
-              <a:t>인접 슬롯의 절반씩이 경계에서 맞물려 슬롯 침범 방지</a:t>
-            </a:r>
-            <a:endParaRPr lang="en-US" sz="1800" dirty="0"/>
+              <a:t>Slave 프레임과 동일한 SEC-DED 방식 적용</a:t>
+            </a:r>
+            <a:endParaRPr lang="en-US" sz="1900" dirty="0"/>
           </a:p>
         </p:txBody>
       </p:sp>
       <p:pic>
         <p:nvPicPr>
-          <p:cNvPr id="4" name="Image 0" descr="/home/user/SoC_Design_and_Programming/diagrams/slot_timeline.png">    </p:cNvPr>
+          <p:cNvPr id="4" name="Image 0" descr="/home/user/SoC_Design_and_Programming/diagrams/master_frame.png">    </p:cNvPr>
           <p:cNvPicPr>
             <a:picLocks noChangeAspect="1"/>
           </p:cNvPicPr>
@@ -1726,8 +1727,8 @@
         </p:blipFill>
         <p:spPr>
           <a:xfrm>
-            <a:off x="1371600" y="2743200"/>
-            <a:ext cx="6400800" cy="2081893"/>
+            <a:off x="548640" y="3383280"/>
+            <a:ext cx="8046720" cy="563270"/>
           </a:xfrm>
           <a:prstGeom prst="rect">
             <a:avLst/>
@@ -1742,8 +1743,8 @@
         </p:nvSpPr>
         <p:spPr>
           <a:xfrm>
-            <a:off x="1371600" y="4916533"/>
-            <a:ext cx="6400800" cy="228600"/>
+            <a:off x="548640" y="4037990"/>
+            <a:ext cx="8046720" cy="228600"/>
           </a:xfrm>
           <a:prstGeom prst="rect">
             <a:avLst/>
@@ -1767,7 +1768,7 @@
                 <a:ea typeface="Noto Sans CJK KR" pitchFamily="34" charset="-122"/>
                 <a:cs typeface="Noto Sans CJK KR" pitchFamily="34" charset="-120"/>
               </a:rPr>
-              <a:t>Sync → [½G · 데이터 · ½G] × (Slot 0...N) → Sync</a:t>
+              <a:t>Master 프레임 비트필드 (전송 순서: preamble → halt_cmd → guard_ticks → reserved → hamming)</a:t>
             </a:r>
             <a:endParaRPr lang="en-US" sz="900" dirty="0"/>
           </a:p>
@@ -1863,7 +1864,7 @@
                 <a:ea typeface="Noto Sans CJK KR" pitchFamily="34" charset="-122"/>
                 <a:cs typeface="Noto Sans CJK KR" pitchFamily="34" charset="-120"/>
               </a:rPr>
-              <a:t>DLL - Flow Control</a:t>
+              <a:t>DLL - MAC: 동기화와 타임슬롯</a:t>
             </a:r>
             <a:endParaRPr lang="en-US" sz="3600" dirty="0"/>
           </a:p>
@@ -1878,7 +1879,7 @@
         <p:spPr>
           <a:xfrm>
             <a:off x="548640" y="1234440"/>
-            <a:ext cx="4023360" cy="2971800"/>
+            <a:ext cx="8046720" cy="1371600"/>
           </a:xfrm>
           <a:prstGeom prst="rect">
             <a:avLst/>
@@ -1892,13 +1893,13 @@
           <a:p>
             <a:pPr marL="342900" indent="-342900">
               <a:spcAft>
-                <a:spcPts val="1200"/>
+                <a:spcPts val="600"/>
               </a:spcAft>
               <a:buSzPct val="100000"/>
               <a:buChar char="•"/>
             </a:pPr>
             <a:r>
-              <a:rPr lang="en-US" sz="2000" dirty="0">
+              <a:rPr lang="en-US" sz="1800" dirty="0">
                 <a:solidFill>
                   <a:srgbClr val="222222"/>
                 </a:solidFill>
@@ -1906,20 +1907,20 @@
                 <a:ea typeface="Noto Sans CJK KR" pitchFamily="34" charset="-122"/>
                 <a:cs typeface="Noto Sans CJK KR" pitchFamily="34" charset="-120"/>
               </a:rPr>
-              <a:t>1비트 에러</a:t>
-            </a:r>
-            <a:endParaRPr lang="en-US" sz="2000" dirty="0"/>
+              <a:t>Sync 기준점</a:t>
+            </a:r>
+            <a:endParaRPr lang="en-US" sz="1800" dirty="0"/>
           </a:p>
           <a:p>
             <a:pPr lvl="1" marL="685800" indent="-342900">
               <a:spcAft>
-                <a:spcPts val="800"/>
+                <a:spcPts val="400"/>
               </a:spcAft>
               <a:buSzPct val="100000"/>
               <a:buChar char="•"/>
             </a:pPr>
             <a:r>
-              <a:rPr lang="en-US" sz="1700" dirty="0">
+              <a:rPr lang="en-US" sz="1500" dirty="0">
                 <a:solidFill>
                   <a:srgbClr val="444444"/>
                 </a:solidFill>
@@ -1927,20 +1928,20 @@
                 <a:ea typeface="Noto Sans CJK KR" pitchFamily="34" charset="-122"/>
                 <a:cs typeface="Noto Sans CJK KR" pitchFamily="34" charset="-120"/>
               </a:rPr>
-              <a:t>Hamming으로 정정하여 정상 데이터로 사용</a:t>
-            </a:r>
-            <a:endParaRPr lang="en-US" sz="2000" dirty="0"/>
+              <a:t>Master가 매 사이클 마지막 슬롯에서 전송한 sync를 다음 사이클 슬롯 계산 기준점으로 사용</a:t>
+            </a:r>
+            <a:endParaRPr lang="en-US" sz="1800" dirty="0"/>
           </a:p>
           <a:p>
             <a:pPr marL="342900" indent="-342900">
               <a:spcAft>
-                <a:spcPts val="1200"/>
+                <a:spcPts val="600"/>
               </a:spcAft>
               <a:buSzPct val="100000"/>
               <a:buChar char="•"/>
             </a:pPr>
             <a:r>
-              <a:rPr lang="en-US" sz="2000" dirty="0">
+              <a:rPr lang="en-US" sz="1800" dirty="0">
                 <a:solidFill>
                   <a:srgbClr val="222222"/>
                 </a:solidFill>
@@ -1948,20 +1949,20 @@
                 <a:ea typeface="Noto Sans CJK KR" pitchFamily="34" charset="-122"/>
                 <a:cs typeface="Noto Sans CJK KR" pitchFamily="34" charset="-120"/>
               </a:rPr>
-              <a:t>2비트 에러 (정정 불가)</a:t>
-            </a:r>
-            <a:endParaRPr lang="en-US" sz="2000" dirty="0"/>
+              <a:t>슬롯 내부 구조</a:t>
+            </a:r>
+            <a:endParaRPr lang="en-US" sz="1800" dirty="0"/>
           </a:p>
           <a:p>
             <a:pPr lvl="1" marL="685800" indent="-342900">
               <a:spcAft>
-                <a:spcPts val="800"/>
+                <a:spcPts val="400"/>
               </a:spcAft>
               <a:buSzPct val="100000"/>
               <a:buChar char="•"/>
             </a:pPr>
             <a:r>
-              <a:rPr lang="en-US" sz="1700" dirty="0">
+              <a:rPr lang="en-US" sz="1500" dirty="0">
                 <a:solidFill>
                   <a:srgbClr val="444444"/>
                 </a:solidFill>
@@ -1969,20 +1970,20 @@
                 <a:ea typeface="Noto Sans CJK KR" pitchFamily="34" charset="-122"/>
                 <a:cs typeface="Noto Sans CJK KR" pitchFamily="34" charset="-120"/>
               </a:rPr>
-              <a:t>해당 프레임을 무효 처리하고 폐기, 이전 값 유지</a:t>
-            </a:r>
-            <a:endParaRPr lang="en-US" sz="2000" dirty="0"/>
+              <a:t>½ guard tick 대기 → 데이터 전송 → ½ guard tick 대기</a:t>
+            </a:r>
+            <a:endParaRPr lang="en-US" sz="1800" dirty="0"/>
           </a:p>
           <a:p>
             <a:pPr marL="342900" indent="-342900">
               <a:spcAft>
-                <a:spcPts val="1200"/>
+                <a:spcPts val="600"/>
               </a:spcAft>
               <a:buSzPct val="100000"/>
               <a:buChar char="•"/>
             </a:pPr>
             <a:r>
-              <a:rPr lang="en-US" sz="2000" dirty="0">
+              <a:rPr lang="en-US" sz="1800" dirty="0">
                 <a:solidFill>
                   <a:srgbClr val="222222"/>
                 </a:solidFill>
@@ -1990,9 +1991,9 @@
                 <a:ea typeface="Noto Sans CJK KR" pitchFamily="34" charset="-122"/>
                 <a:cs typeface="Noto Sans CJK KR" pitchFamily="34" charset="-120"/>
               </a:rPr>
-              <a:t>Implicit Flow Control</a:t>
-            </a:r>
-            <a:endParaRPr lang="en-US" sz="2000" dirty="0"/>
+              <a:t>Guard Tick의 역할</a:t>
+            </a:r>
+            <a:endParaRPr lang="en-US" sz="1800" dirty="0"/>
           </a:p>
           <a:p>
             <a:pPr lvl="1" marL="685800" indent="-342900">
@@ -2000,7 +2001,7 @@
               <a:buChar char="•"/>
             </a:pPr>
             <a:r>
-              <a:rPr lang="en-US" sz="1700" dirty="0">
+              <a:rPr lang="en-US" sz="1500" dirty="0">
                 <a:solidFill>
                   <a:srgbClr val="444444"/>
                 </a:solidFill>
@@ -2008,15 +2009,15 @@
                 <a:ea typeface="Noto Sans CJK KR" pitchFamily="34" charset="-122"/>
                 <a:cs typeface="Noto Sans CJK KR" pitchFamily="34" charset="-120"/>
               </a:rPr>
-              <a:t>명시적 재전송 요청(ARQ/NACK) 없음 — 다음 TDMA 사이클의 갱신 데이터를 기다림</a:t>
-            </a:r>
-            <a:endParaRPr lang="en-US" sz="2000" dirty="0"/>
+              <a:t>인접 슬롯의 절반씩이 경계에서 맞물려 슬롯 침범 방지</a:t>
+            </a:r>
+            <a:endParaRPr lang="en-US" sz="1800" dirty="0"/>
           </a:p>
         </p:txBody>
       </p:sp>
       <p:pic>
         <p:nvPicPr>
-          <p:cNvPr id="4" name="Image 0" descr="/home/user/SoC_Design_and_Programming/diagrams/flow_control.png">    </p:cNvPr>
+          <p:cNvPr id="4" name="Image 0" descr="/home/user/SoC_Design_and_Programming/diagrams/slot_timeline.png">    </p:cNvPr>
           <p:cNvPicPr>
             <a:picLocks noChangeAspect="1"/>
           </p:cNvPicPr>
@@ -2029,8 +2030,8 @@
         </p:blipFill>
         <p:spPr>
           <a:xfrm>
-            <a:off x="5029200" y="1371600"/>
-            <a:ext cx="3200400" cy="2319606"/>
+            <a:off x="1371600" y="2743200"/>
+            <a:ext cx="6400800" cy="2081893"/>
           </a:xfrm>
           <a:prstGeom prst="rect">
             <a:avLst/>
@@ -2040,6 +2041,45 @@
       <p:sp>
         <p:nvSpPr>
           <p:cNvPr id="5" name="Text 2"/>
+          <p:cNvSpPr/>
+          <p:nvPr/>
+        </p:nvSpPr>
+        <p:spPr>
+          <a:xfrm>
+            <a:off x="1371600" y="4916533"/>
+            <a:ext cx="6400800" cy="228600"/>
+          </a:xfrm>
+          <a:prstGeom prst="rect">
+            <a:avLst/>
+          </a:prstGeom>
+          <a:noFill/>
+          <a:ln/>
+        </p:spPr>
+        <p:txBody>
+          <a:bodyPr wrap="square" rtlCol="0" anchor="ctr"/>
+          <a:lstStyle/>
+          <a:p>
+            <a:pPr algn="ctr" indent="0" marL="0">
+              <a:buNone/>
+            </a:pPr>
+            <a:r>
+              <a:rPr lang="en-US" sz="900" dirty="0">
+                <a:solidFill>
+                  <a:srgbClr val="999999"/>
+                </a:solidFill>
+                <a:latin typeface="Noto Sans CJK KR" pitchFamily="34" charset="0"/>
+                <a:ea typeface="Noto Sans CJK KR" pitchFamily="34" charset="-122"/>
+                <a:cs typeface="Noto Sans CJK KR" pitchFamily="34" charset="-120"/>
+              </a:rPr>
+              <a:t>Sync → [½G · 데이터 · ½G] × (Slot 0...N) → Sync</a:t>
+            </a:r>
+            <a:endParaRPr lang="en-US" sz="900" dirty="0"/>
+          </a:p>
+        </p:txBody>
+      </p:sp>
+      <p:sp>
+        <p:nvSpPr>
+          <p:cNvPr id="6" name="Text 3"/>
           <p:cNvSpPr/>
           <p:nvPr/>
         </p:nvSpPr>
@@ -2085,6 +2125,270 @@
 </file>
 
 <file path=ppt/slides/slide13.xml><?xml version="1.0" encoding="utf-8"?>
+<p:sld xmlns:a="http://schemas.openxmlformats.org/drawingml/2006/main" xmlns:p="http://schemas.openxmlformats.org/presentationml/2006/main" xmlns:r="http://schemas.openxmlformats.org/officeDocument/2006/relationships">
+  <p:cSld>
+    <p:spTree>
+      <p:nvGrpSpPr>
+        <p:cNvPr id="1" name=""/>
+        <p:cNvGrpSpPr/>
+        <p:nvPr/>
+      </p:nvGrpSpPr>
+      <p:grpSpPr/>
+      <p:sp>
+        <p:nvSpPr>
+          <p:cNvPr id="2" name="Text 0"/>
+          <p:cNvSpPr/>
+          <p:nvPr/>
+        </p:nvSpPr>
+        <p:spPr>
+          <a:xfrm>
+            <a:off x="548640" y="274320"/>
+            <a:ext cx="8046720" cy="777240"/>
+          </a:xfrm>
+          <a:prstGeom prst="rect">
+            <a:avLst/>
+          </a:prstGeom>
+          <a:noFill/>
+          <a:ln/>
+        </p:spPr>
+        <p:txBody>
+          <a:bodyPr wrap="square" lIns="0" tIns="0" rIns="0" bIns="0" rtlCol="0" anchor="ctr"/>
+          <a:lstStyle/>
+          <a:p>
+            <a:pPr indent="0" marL="0">
+              <a:buNone/>
+            </a:pPr>
+            <a:r>
+              <a:rPr lang="en-US" sz="3600" b="1" dirty="0">
+                <a:solidFill>
+                  <a:srgbClr val="111111"/>
+                </a:solidFill>
+                <a:latin typeface="Noto Sans CJK KR" pitchFamily="34" charset="0"/>
+                <a:ea typeface="Noto Sans CJK KR" pitchFamily="34" charset="-122"/>
+                <a:cs typeface="Noto Sans CJK KR" pitchFamily="34" charset="-120"/>
+              </a:rPr>
+              <a:t>DLL - Flow Control</a:t>
+            </a:r>
+            <a:endParaRPr lang="en-US" sz="3600" dirty="0"/>
+          </a:p>
+        </p:txBody>
+      </p:sp>
+      <p:sp>
+        <p:nvSpPr>
+          <p:cNvPr id="3" name="Text 1"/>
+          <p:cNvSpPr/>
+          <p:nvPr/>
+        </p:nvSpPr>
+        <p:spPr>
+          <a:xfrm>
+            <a:off x="548640" y="1234440"/>
+            <a:ext cx="4023360" cy="2971800"/>
+          </a:xfrm>
+          <a:prstGeom prst="rect">
+            <a:avLst/>
+          </a:prstGeom>
+          <a:noFill/>
+          <a:ln/>
+        </p:spPr>
+        <p:txBody>
+          <a:bodyPr wrap="square" rtlCol="0" anchor="t"/>
+          <a:lstStyle/>
+          <a:p>
+            <a:pPr marL="342900" indent="-342900">
+              <a:spcAft>
+                <a:spcPts val="1200"/>
+              </a:spcAft>
+              <a:buSzPct val="100000"/>
+              <a:buChar char="•"/>
+            </a:pPr>
+            <a:r>
+              <a:rPr lang="en-US" sz="2000" dirty="0">
+                <a:solidFill>
+                  <a:srgbClr val="222222"/>
+                </a:solidFill>
+                <a:latin typeface="Noto Sans CJK KR" pitchFamily="34" charset="0"/>
+                <a:ea typeface="Noto Sans CJK KR" pitchFamily="34" charset="-122"/>
+                <a:cs typeface="Noto Sans CJK KR" pitchFamily="34" charset="-120"/>
+              </a:rPr>
+              <a:t>1비트 에러</a:t>
+            </a:r>
+            <a:endParaRPr lang="en-US" sz="2000" dirty="0"/>
+          </a:p>
+          <a:p>
+            <a:pPr lvl="1" marL="685800" indent="-342900">
+              <a:spcAft>
+                <a:spcPts val="800"/>
+              </a:spcAft>
+              <a:buSzPct val="100000"/>
+              <a:buChar char="•"/>
+            </a:pPr>
+            <a:r>
+              <a:rPr lang="en-US" sz="1700" dirty="0">
+                <a:solidFill>
+                  <a:srgbClr val="444444"/>
+                </a:solidFill>
+                <a:latin typeface="Noto Sans CJK KR" pitchFamily="34" charset="0"/>
+                <a:ea typeface="Noto Sans CJK KR" pitchFamily="34" charset="-122"/>
+                <a:cs typeface="Noto Sans CJK KR" pitchFamily="34" charset="-120"/>
+              </a:rPr>
+              <a:t>Hamming으로 정정하여 정상 데이터로 사용</a:t>
+            </a:r>
+            <a:endParaRPr lang="en-US" sz="2000" dirty="0"/>
+          </a:p>
+          <a:p>
+            <a:pPr marL="342900" indent="-342900">
+              <a:spcAft>
+                <a:spcPts val="1200"/>
+              </a:spcAft>
+              <a:buSzPct val="100000"/>
+              <a:buChar char="•"/>
+            </a:pPr>
+            <a:r>
+              <a:rPr lang="en-US" sz="2000" dirty="0">
+                <a:solidFill>
+                  <a:srgbClr val="222222"/>
+                </a:solidFill>
+                <a:latin typeface="Noto Sans CJK KR" pitchFamily="34" charset="0"/>
+                <a:ea typeface="Noto Sans CJK KR" pitchFamily="34" charset="-122"/>
+                <a:cs typeface="Noto Sans CJK KR" pitchFamily="34" charset="-120"/>
+              </a:rPr>
+              <a:t>2비트 에러 (정정 불가)</a:t>
+            </a:r>
+            <a:endParaRPr lang="en-US" sz="2000" dirty="0"/>
+          </a:p>
+          <a:p>
+            <a:pPr lvl="1" marL="685800" indent="-342900">
+              <a:spcAft>
+                <a:spcPts val="800"/>
+              </a:spcAft>
+              <a:buSzPct val="100000"/>
+              <a:buChar char="•"/>
+            </a:pPr>
+            <a:r>
+              <a:rPr lang="en-US" sz="1700" dirty="0">
+                <a:solidFill>
+                  <a:srgbClr val="444444"/>
+                </a:solidFill>
+                <a:latin typeface="Noto Sans CJK KR" pitchFamily="34" charset="0"/>
+                <a:ea typeface="Noto Sans CJK KR" pitchFamily="34" charset="-122"/>
+                <a:cs typeface="Noto Sans CJK KR" pitchFamily="34" charset="-120"/>
+              </a:rPr>
+              <a:t>해당 프레임을 무효 처리하고 폐기, 이전 값 유지</a:t>
+            </a:r>
+            <a:endParaRPr lang="en-US" sz="2000" dirty="0"/>
+          </a:p>
+          <a:p>
+            <a:pPr marL="342900" indent="-342900">
+              <a:spcAft>
+                <a:spcPts val="1200"/>
+              </a:spcAft>
+              <a:buSzPct val="100000"/>
+              <a:buChar char="•"/>
+            </a:pPr>
+            <a:r>
+              <a:rPr lang="en-US" sz="2000" dirty="0">
+                <a:solidFill>
+                  <a:srgbClr val="222222"/>
+                </a:solidFill>
+                <a:latin typeface="Noto Sans CJK KR" pitchFamily="34" charset="0"/>
+                <a:ea typeface="Noto Sans CJK KR" pitchFamily="34" charset="-122"/>
+                <a:cs typeface="Noto Sans CJK KR" pitchFamily="34" charset="-120"/>
+              </a:rPr>
+              <a:t>Implicit Flow Control</a:t>
+            </a:r>
+            <a:endParaRPr lang="en-US" sz="2000" dirty="0"/>
+          </a:p>
+          <a:p>
+            <a:pPr lvl="1" marL="685800" indent="-342900">
+              <a:buSzPct val="100000"/>
+              <a:buChar char="•"/>
+            </a:pPr>
+            <a:r>
+              <a:rPr lang="en-US" sz="1700" dirty="0">
+                <a:solidFill>
+                  <a:srgbClr val="444444"/>
+                </a:solidFill>
+                <a:latin typeface="Noto Sans CJK KR" pitchFamily="34" charset="0"/>
+                <a:ea typeface="Noto Sans CJK KR" pitchFamily="34" charset="-122"/>
+                <a:cs typeface="Noto Sans CJK KR" pitchFamily="34" charset="-120"/>
+              </a:rPr>
+              <a:t>명시적 재전송 요청(ARQ/NACK) 없음 — 다음 TDMA 사이클의 갱신 데이터를 기다림</a:t>
+            </a:r>
+            <a:endParaRPr lang="en-US" sz="2000" dirty="0"/>
+          </a:p>
+        </p:txBody>
+      </p:sp>
+      <p:pic>
+        <p:nvPicPr>
+          <p:cNvPr id="4" name="Image 0" descr="/home/user/SoC_Design_and_Programming/diagrams/flow_control.png">    </p:cNvPr>
+          <p:cNvPicPr>
+            <a:picLocks noChangeAspect="1"/>
+          </p:cNvPicPr>
+          <p:nvPr/>
+        </p:nvPicPr>
+        <p:blipFill>
+          <a:blip r:embed="rId2"/>
+          <a:srcRect l="0" r="0" t="0" b="0"/>
+          <a:stretch/>
+        </p:blipFill>
+        <p:spPr>
+          <a:xfrm>
+            <a:off x="5029200" y="1371600"/>
+            <a:ext cx="3200400" cy="2319606"/>
+          </a:xfrm>
+          <a:prstGeom prst="rect">
+            <a:avLst/>
+          </a:prstGeom>
+        </p:spPr>
+      </p:pic>
+      <p:sp>
+        <p:nvSpPr>
+          <p:cNvPr id="5" name="Text 2"/>
+          <p:cNvSpPr/>
+          <p:nvPr/>
+        </p:nvSpPr>
+        <p:spPr>
+          <a:xfrm>
+            <a:off x="8503920" y="4754880"/>
+            <a:ext cx="457200" cy="274320"/>
+          </a:xfrm>
+          <a:prstGeom prst="rect">
+            <a:avLst/>
+          </a:prstGeom>
+          <a:noFill/>
+          <a:ln/>
+        </p:spPr>
+        <p:txBody>
+          <a:bodyPr wrap="square" rtlCol="0" anchor="ctr"/>
+          <a:lstStyle/>
+          <a:p>
+            <a:pPr algn="r" indent="0" marL="0">
+              <a:buNone/>
+            </a:pPr>
+            <a:r>
+              <a:rPr lang="en-US" sz="1200" dirty="0">
+                <a:solidFill>
+                  <a:srgbClr val="999999"/>
+                </a:solidFill>
+                <a:latin typeface="Noto Sans CJK KR" pitchFamily="34" charset="0"/>
+                <a:ea typeface="Noto Sans CJK KR" pitchFamily="34" charset="-122"/>
+                <a:cs typeface="Noto Sans CJK KR" pitchFamily="34" charset="-120"/>
+              </a:rPr>
+              <a:t>13</a:t>
+            </a:r>
+            <a:endParaRPr lang="en-US" sz="1200" dirty="0"/>
+          </a:p>
+        </p:txBody>
+      </p:sp>
+    </p:spTree>
+  </p:cSld>
+  <p:clrMapOvr>
+    <a:masterClrMapping/>
+  </p:clrMapOvr>
+</p:sld>
+</file>
+
+<file path=ppt/slides/slide14.xml><?xml version="1.0" encoding="utf-8"?>
 <p:sld xmlns:a="http://schemas.openxmlformats.org/drawingml/2006/main" xmlns:p="http://schemas.openxmlformats.org/presentationml/2006/main" xmlns:r="http://schemas.openxmlformats.org/officeDocument/2006/relationships">
   <p:cSld>
     <p:bg>
@@ -2182,189 +2486,6 @@
       <p:sp>
         <p:nvSpPr>
           <p:cNvPr id="4" name="Text 2"/>
-          <p:cNvSpPr/>
-          <p:nvPr/>
-        </p:nvSpPr>
-        <p:spPr>
-          <a:xfrm>
-            <a:off x="8503920" y="4754880"/>
-            <a:ext cx="457200" cy="274320"/>
-          </a:xfrm>
-          <a:prstGeom prst="rect">
-            <a:avLst/>
-          </a:prstGeom>
-          <a:noFill/>
-          <a:ln/>
-        </p:spPr>
-        <p:txBody>
-          <a:bodyPr wrap="square" rtlCol="0" anchor="ctr"/>
-          <a:lstStyle/>
-          <a:p>
-            <a:pPr algn="r" indent="0" marL="0">
-              <a:buNone/>
-            </a:pPr>
-            <a:r>
-              <a:rPr lang="en-US" sz="1200" dirty="0">
-                <a:solidFill>
-                  <a:srgbClr val="999999"/>
-                </a:solidFill>
-                <a:latin typeface="Noto Sans CJK KR" pitchFamily="34" charset="0"/>
-                <a:ea typeface="Noto Sans CJK KR" pitchFamily="34" charset="-122"/>
-                <a:cs typeface="Noto Sans CJK KR" pitchFamily="34" charset="-120"/>
-              </a:rPr>
-              <a:t>13</a:t>
-            </a:r>
-            <a:endParaRPr lang="en-US" sz="1200" dirty="0"/>
-          </a:p>
-        </p:txBody>
-      </p:sp>
-    </p:spTree>
-  </p:cSld>
-  <p:clrMapOvr>
-    <a:masterClrMapping/>
-  </p:clrMapOvr>
-</p:sld>
-</file>
-
-<file path=ppt/slides/slide14.xml><?xml version="1.0" encoding="utf-8"?>
-<p:sld xmlns:a="http://schemas.openxmlformats.org/drawingml/2006/main" xmlns:p="http://schemas.openxmlformats.org/presentationml/2006/main" xmlns:r="http://schemas.openxmlformats.org/officeDocument/2006/relationships">
-  <p:cSld>
-    <p:spTree>
-      <p:nvGrpSpPr>
-        <p:cNvPr id="1" name=""/>
-        <p:cNvGrpSpPr/>
-        <p:nvPr/>
-      </p:nvGrpSpPr>
-      <p:grpSpPr/>
-      <p:sp>
-        <p:nvSpPr>
-          <p:cNvPr id="2" name="Text 0"/>
-          <p:cNvSpPr/>
-          <p:nvPr/>
-        </p:nvSpPr>
-        <p:spPr>
-          <a:xfrm>
-            <a:off x="548640" y="274320"/>
-            <a:ext cx="8046720" cy="777240"/>
-          </a:xfrm>
-          <a:prstGeom prst="rect">
-            <a:avLst/>
-          </a:prstGeom>
-          <a:noFill/>
-          <a:ln/>
-        </p:spPr>
-        <p:txBody>
-          <a:bodyPr wrap="square" lIns="0" tIns="0" rIns="0" bIns="0" rtlCol="0" anchor="ctr"/>
-          <a:lstStyle/>
-          <a:p>
-            <a:pPr indent="0" marL="0">
-              <a:buNone/>
-            </a:pPr>
-            <a:r>
-              <a:rPr lang="en-US" sz="3600" b="1" dirty="0">
-                <a:solidFill>
-                  <a:srgbClr val="111111"/>
-                </a:solidFill>
-                <a:latin typeface="Noto Sans CJK KR" pitchFamily="34" charset="0"/>
-                <a:ea typeface="Noto Sans CJK KR" pitchFamily="34" charset="-122"/>
-                <a:cs typeface="Noto Sans CJK KR" pitchFamily="34" charset="-120"/>
-              </a:rPr>
-              <a:t>Master 전체 구조</a:t>
-            </a:r>
-            <a:endParaRPr lang="en-US" sz="3600" dirty="0"/>
-          </a:p>
-        </p:txBody>
-      </p:sp>
-      <p:sp>
-        <p:nvSpPr>
-          <p:cNvPr id="3" name="Text 1"/>
-          <p:cNvSpPr/>
-          <p:nvPr/>
-        </p:nvSpPr>
-        <p:spPr>
-          <a:xfrm>
-            <a:off x="548640" y="1188720"/>
-            <a:ext cx="8046720" cy="594360"/>
-          </a:xfrm>
-          <a:prstGeom prst="rect">
-            <a:avLst/>
-          </a:prstGeom>
-          <a:noFill/>
-          <a:ln/>
-        </p:spPr>
-        <p:txBody>
-          <a:bodyPr wrap="square" rtlCol="0" anchor="t"/>
-          <a:lstStyle/>
-          <a:p>
-            <a:pPr marL="342900" indent="-342900">
-              <a:spcAft>
-                <a:spcPts val="600"/>
-              </a:spcAft>
-              <a:buSzPct val="100000"/>
-              <a:buChar char="•"/>
-            </a:pPr>
-            <a:r>
-              <a:rPr lang="en-US" sz="1700" dirty="0">
-                <a:solidFill>
-                  <a:srgbClr val="222222"/>
-                </a:solidFill>
-                <a:latin typeface="Noto Sans CJK KR" pitchFamily="34" charset="0"/>
-                <a:ea typeface="Noto Sans CJK KR" pitchFamily="34" charset="-122"/>
-                <a:cs typeface="Noto Sans CJK KR" pitchFamily="34" charset="-120"/>
-              </a:rPr>
-              <a:t>테스트 장치 · PS · PL(Master IP 포함) · GPIO 네 영역으로 구성</a:t>
-            </a:r>
-            <a:endParaRPr lang="en-US" sz="1700" dirty="0"/>
-          </a:p>
-          <a:p>
-            <a:pPr marL="342900" indent="-342900">
-              <a:spcAft>
-                <a:spcPts val="600"/>
-              </a:spcAft>
-              <a:buSzPct val="100000"/>
-              <a:buChar char="•"/>
-            </a:pPr>
-            <a:r>
-              <a:rPr lang="en-US" sz="1700" dirty="0">
-                <a:solidFill>
-                  <a:srgbClr val="222222"/>
-                </a:solidFill>
-                <a:latin typeface="Noto Sans CJK KR" pitchFamily="34" charset="0"/>
-                <a:ea typeface="Noto Sans CJK KR" pitchFamily="34" charset="-122"/>
-                <a:cs typeface="Noto Sans CJK KR" pitchFamily="34" charset="-120"/>
-              </a:rPr>
-              <a:t>GPIO를 통해 Slave와 TX/RX 시리얼로 연결 — 이후 슬라이드에서 블록을 하나씩 확대</a:t>
-            </a:r>
-            <a:endParaRPr lang="en-US" sz="1700" dirty="0"/>
-          </a:p>
-        </p:txBody>
-      </p:sp>
-      <p:pic>
-        <p:nvPicPr>
-          <p:cNvPr id="4" name="Image 0" descr="/home/user/SoC_Design_and_Programming/diagrams/section3/zoom/master_overview.png">    </p:cNvPr>
-          <p:cNvPicPr>
-            <a:picLocks noChangeAspect="1"/>
-          </p:cNvPicPr>
-          <p:nvPr/>
-        </p:nvPicPr>
-        <p:blipFill>
-          <a:blip r:embed="rId2"/>
-          <a:srcRect l="0" r="0" t="0" b="0"/>
-          <a:stretch/>
-        </p:blipFill>
-        <p:spPr>
-          <a:xfrm>
-            <a:off x="548640" y="2061599"/>
-            <a:ext cx="8046720" cy="2186162"/>
-          </a:xfrm>
-          <a:prstGeom prst="rect">
-            <a:avLst/>
-          </a:prstGeom>
-        </p:spPr>
-      </p:pic>
-      <p:sp>
-        <p:nvSpPr>
-          <p:cNvPr id="5" name="Text 2"/>
           <p:cNvSpPr/>
           <p:nvPr/>
         </p:nvSpPr>
@@ -2452,7 +2573,7 @@
                 <a:ea typeface="Noto Sans CJK KR" pitchFamily="34" charset="-122"/>
                 <a:cs typeface="Noto Sans CJK KR" pitchFamily="34" charset="-120"/>
               </a:rPr>
-              <a:t>Master - GPIO 확대</a:t>
+              <a:t>Master 전체 구조</a:t>
             </a:r>
             <a:endParaRPr lang="en-US" sz="3600" dirty="0"/>
           </a:p>
@@ -2466,8 +2587,8 @@
         </p:nvSpPr>
         <p:spPr>
           <a:xfrm>
-            <a:off x="548640" y="1234440"/>
-            <a:ext cx="4023360" cy="2971800"/>
+            <a:off x="548640" y="1188720"/>
+            <a:ext cx="8046720" cy="594360"/>
           </a:xfrm>
           <a:prstGeom prst="rect">
             <a:avLst/>
@@ -2481,13 +2602,13 @@
           <a:p>
             <a:pPr marL="342900" indent="-342900">
               <a:spcAft>
-                <a:spcPts val="1000"/>
+                <a:spcPts val="600"/>
               </a:spcAft>
               <a:buSzPct val="100000"/>
               <a:buChar char="•"/>
             </a:pPr>
             <a:r>
-              <a:rPr lang="en-US" sz="1800" dirty="0">
+              <a:rPr lang="en-US" sz="1700" dirty="0">
                 <a:solidFill>
                   <a:srgbClr val="222222"/>
                 </a:solidFill>
@@ -2495,20 +2616,20 @@
                 <a:ea typeface="Noto Sans CJK KR" pitchFamily="34" charset="-122"/>
                 <a:cs typeface="Noto Sans CJK KR" pitchFamily="34" charset="-120"/>
               </a:rPr>
-              <a:t>GND / RX 포트 / TX 포트로 구성</a:t>
-            </a:r>
-            <a:endParaRPr lang="en-US" sz="1800" dirty="0"/>
+              <a:t>테스트 장치 · PS · PL(Master IP 포함) · GPIO 네 영역으로 구성</a:t>
+            </a:r>
+            <a:endParaRPr lang="en-US" sz="1700" dirty="0"/>
           </a:p>
           <a:p>
             <a:pPr marL="342900" indent="-342900">
               <a:spcAft>
-                <a:spcPts val="1000"/>
+                <a:spcPts val="600"/>
               </a:spcAft>
               <a:buSzPct val="100000"/>
               <a:buChar char="•"/>
             </a:pPr>
             <a:r>
-              <a:rPr lang="en-US" sz="1800" dirty="0">
+              <a:rPr lang="en-US" sz="1700" dirty="0">
                 <a:solidFill>
                   <a:srgbClr val="222222"/>
                 </a:solidFill>
@@ -2516,15 +2637,15 @@
                 <a:ea typeface="Noto Sans CJK KR" pitchFamily="34" charset="-122"/>
                 <a:cs typeface="Noto Sans CJK KR" pitchFamily="34" charset="-120"/>
               </a:rPr>
-              <a:t>TX·RX는 PL(Master IP)과 Slave 사이를 잇는 물리 연결 — 외부 장치-PS-PL 경로와는 분리된 통신 채널</a:t>
-            </a:r>
-            <a:endParaRPr lang="en-US" sz="1800" dirty="0"/>
+              <a:t>GPIO를 통해 Slave와 TX/RX 시리얼로 연결 — 이후 슬라이드에서 블록을 하나씩 확대</a:t>
+            </a:r>
+            <a:endParaRPr lang="en-US" sz="1700" dirty="0"/>
           </a:p>
         </p:txBody>
       </p:sp>
       <p:pic>
         <p:nvPicPr>
-          <p:cNvPr id="4" name="Image 0" descr="/home/user/SoC_Design_and_Programming/diagrams/section3/zoom/m_gpio.png">    </p:cNvPr>
+          <p:cNvPr id="4" name="Image 0" descr="/home/user/SoC_Design_and_Programming/diagrams/section3/zoom/master_overview.png">    </p:cNvPr>
           <p:cNvPicPr>
             <a:picLocks noChangeAspect="1"/>
           </p:cNvPicPr>
@@ -2537,8 +2658,8 @@
         </p:blipFill>
         <p:spPr>
           <a:xfrm>
-            <a:off x="4846320" y="1916974"/>
-            <a:ext cx="3749040" cy="1606731"/>
+            <a:off x="548640" y="2061599"/>
+            <a:ext cx="8046720" cy="2186162"/>
           </a:xfrm>
           <a:prstGeom prst="rect">
             <a:avLst/>
@@ -2635,7 +2756,7 @@
                 <a:ea typeface="Noto Sans CJK KR" pitchFamily="34" charset="-122"/>
                 <a:cs typeface="Noto Sans CJK KR" pitchFamily="34" charset="-120"/>
               </a:rPr>
-              <a:t>Master - PS 확대</a:t>
+              <a:t>Master - GPIO 확대</a:t>
             </a:r>
             <a:endParaRPr lang="en-US" sz="3600" dirty="0"/>
           </a:p>
@@ -2649,8 +2770,8 @@
         </p:nvSpPr>
         <p:spPr>
           <a:xfrm>
-            <a:off x="548640" y="1188720"/>
-            <a:ext cx="8046720" cy="594360"/>
+            <a:off x="548640" y="1234440"/>
+            <a:ext cx="4023360" cy="2971800"/>
           </a:xfrm>
           <a:prstGeom prst="rect">
             <a:avLst/>
@@ -2664,13 +2785,13 @@
           <a:p>
             <a:pPr marL="342900" indent="-342900">
               <a:spcAft>
-                <a:spcPts val="600"/>
+                <a:spcPts val="1000"/>
               </a:spcAft>
               <a:buSzPct val="100000"/>
               <a:buChar char="•"/>
             </a:pPr>
             <a:r>
-              <a:rPr lang="en-US" sz="1700" dirty="0">
+              <a:rPr lang="en-US" sz="1800" dirty="0">
                 <a:solidFill>
                   <a:srgbClr val="222222"/>
                 </a:solidFill>
@@ -2678,20 +2799,20 @@
                 <a:ea typeface="Noto Sans CJK KR" pitchFamily="34" charset="-122"/>
                 <a:cs typeface="Noto Sans CJK KR" pitchFamily="34" charset="-120"/>
               </a:rPr>
-              <a:t>외부 테스트 장치에서 초깃값을 입력받아 Master를 초기 구동</a:t>
-            </a:r>
-            <a:endParaRPr lang="en-US" sz="1700" dirty="0"/>
+              <a:t>GND / RX 포트 / TX 포트로 구성</a:t>
+            </a:r>
+            <a:endParaRPr lang="en-US" sz="1800" dirty="0"/>
           </a:p>
           <a:p>
             <a:pPr marL="342900" indent="-342900">
               <a:spcAft>
-                <a:spcPts val="600"/>
+                <a:spcPts val="1000"/>
               </a:spcAft>
               <a:buSzPct val="100000"/>
               <a:buChar char="•"/>
             </a:pPr>
             <a:r>
-              <a:rPr lang="en-US" sz="1700" dirty="0">
+              <a:rPr lang="en-US" sz="1800" dirty="0">
                 <a:solidFill>
                   <a:srgbClr val="222222"/>
                 </a:solidFill>
@@ -2699,15 +2820,15 @@
                 <a:ea typeface="Noto Sans CJK KR" pitchFamily="34" charset="-122"/>
                 <a:cs typeface="Noto Sans CJK KR" pitchFamily="34" charset="-120"/>
               </a:rPr>
-              <a:t>구동 중인 Master 값을 주기적으로 읽고, Master가 발생시키는 인터럽트를 수신</a:t>
-            </a:r>
-            <a:endParaRPr lang="en-US" sz="1700" dirty="0"/>
+              <a:t>TX·RX는 PL(Master IP)과 Slave 사이를 잇는 물리 연결 — 외부 장치-PS-PL 경로와는 분리된 통신 채널</a:t>
+            </a:r>
+            <a:endParaRPr lang="en-US" sz="1800" dirty="0"/>
           </a:p>
         </p:txBody>
       </p:sp>
       <p:pic>
         <p:nvPicPr>
-          <p:cNvPr id="4" name="Image 0" descr="/home/user/SoC_Design_and_Programming/diagrams/section3/zoom/m_ps.png">    </p:cNvPr>
+          <p:cNvPr id="4" name="Image 0" descr="/home/user/SoC_Design_and_Programming/diagrams/section3/zoom/m_gpio.png">    </p:cNvPr>
           <p:cNvPicPr>
             <a:picLocks noChangeAspect="1"/>
           </p:cNvPicPr>
@@ -2720,8 +2841,8 @@
         </p:blipFill>
         <p:spPr>
           <a:xfrm>
-            <a:off x="745187" y="1783080"/>
-            <a:ext cx="7653626" cy="2743200"/>
+            <a:off x="4846320" y="1916974"/>
+            <a:ext cx="3749040" cy="1606731"/>
           </a:xfrm>
           <a:prstGeom prst="rect">
             <a:avLst/>
@@ -2818,7 +2939,7 @@
                 <a:ea typeface="Noto Sans CJK KR" pitchFamily="34" charset="-122"/>
                 <a:cs typeface="Noto Sans CJK KR" pitchFamily="34" charset="-120"/>
               </a:rPr>
-              <a:t>Master - PL 확대</a:t>
+              <a:t>Master - PS 확대</a:t>
             </a:r>
             <a:endParaRPr lang="en-US" sz="3600" dirty="0"/>
           </a:p>
@@ -2832,8 +2953,8 @@
         </p:nvSpPr>
         <p:spPr>
           <a:xfrm>
-            <a:off x="548640" y="1234440"/>
-            <a:ext cx="4023360" cy="2971800"/>
+            <a:off x="548640" y="1188720"/>
+            <a:ext cx="8046720" cy="594360"/>
           </a:xfrm>
           <a:prstGeom prst="rect">
             <a:avLst/>
@@ -2847,13 +2968,13 @@
           <a:p>
             <a:pPr marL="342900" indent="-342900">
               <a:spcAft>
-                <a:spcPts val="1000"/>
+                <a:spcPts val="600"/>
               </a:spcAft>
               <a:buSzPct val="100000"/>
               <a:buChar char="•"/>
             </a:pPr>
             <a:r>
-              <a:rPr lang="en-US" sz="1800" dirty="0">
+              <a:rPr lang="en-US" sz="1700" dirty="0">
                 <a:solidFill>
                   <a:srgbClr val="222222"/>
                 </a:solidFill>
@@ -2861,20 +2982,20 @@
                 <a:ea typeface="Noto Sans CJK KR" pitchFamily="34" charset="-122"/>
                 <a:cs typeface="Noto Sans CJK KR" pitchFamily="34" charset="-120"/>
               </a:rPr>
-              <a:t>LED · 푸시버튼 · DIP 스위치 · 7-seg와 Master IP로 보드 자체의 입출력 구성</a:t>
-            </a:r>
-            <a:endParaRPr lang="en-US" sz="1800" dirty="0"/>
+              <a:t>외부 테스트 장치에서 초깃값을 입력받아 Master를 초기 구동</a:t>
+            </a:r>
+            <a:endParaRPr lang="en-US" sz="1700" dirty="0"/>
           </a:p>
           <a:p>
             <a:pPr marL="342900" indent="-342900">
               <a:spcAft>
-                <a:spcPts val="1000"/>
+                <a:spcPts val="600"/>
               </a:spcAft>
               <a:buSzPct val="100000"/>
               <a:buChar char="•"/>
             </a:pPr>
             <a:r>
-              <a:rPr lang="en-US" sz="1800" dirty="0">
+              <a:rPr lang="en-US" sz="1700" dirty="0">
                 <a:solidFill>
                   <a:srgbClr val="222222"/>
                 </a:solidFill>
@@ -2882,36 +3003,15 @@
                 <a:ea typeface="Noto Sans CJK KR" pitchFamily="34" charset="-122"/>
                 <a:cs typeface="Noto Sans CJK KR" pitchFamily="34" charset="-120"/>
               </a:rPr>
-              <a:t>LED는 RX/TX 이진 신호를 그대로 받아 통신 상태를 표시</a:t>
-            </a:r>
-            <a:endParaRPr lang="en-US" sz="1800" dirty="0"/>
-          </a:p>
-          <a:p>
-            <a:pPr marL="342900" indent="-342900">
-              <a:spcAft>
-                <a:spcPts val="1000"/>
-              </a:spcAft>
-              <a:buSzPct val="100000"/>
-              <a:buChar char="•"/>
-            </a:pPr>
-            <a:r>
-              <a:rPr lang="en-US" sz="1800" dirty="0">
-                <a:solidFill>
-                  <a:srgbClr val="222222"/>
-                </a:solidFill>
-                <a:latin typeface="Noto Sans CJK KR" pitchFamily="34" charset="0"/>
-                <a:ea typeface="Noto Sans CJK KR" pitchFamily="34" charset="-122"/>
-                <a:cs typeface="Noto Sans CJK KR" pitchFamily="34" charset="-120"/>
-              </a:rPr>
-              <a:t>DIP 스위치·7-seg는 슬롯별 통신 상태와 수신 데이터를 출력 — Master IP가 이들을 조율</a:t>
-            </a:r>
-            <a:endParaRPr lang="en-US" sz="1800" dirty="0"/>
+              <a:t>구동 중인 Master 값을 주기적으로 읽고, Master가 발생시키는 인터럽트를 수신</a:t>
+            </a:r>
+            <a:endParaRPr lang="en-US" sz="1700" dirty="0"/>
           </a:p>
         </p:txBody>
       </p:sp>
       <p:pic>
         <p:nvPicPr>
-          <p:cNvPr id="4" name="Image 0" descr="/home/user/SoC_Design_and_Programming/diagrams/section3/zoom/m_pl.png">    </p:cNvPr>
+          <p:cNvPr id="4" name="Image 0" descr="/home/user/SoC_Design_and_Programming/diagrams/section3/zoom/m_ps.png">    </p:cNvPr>
           <p:cNvPicPr>
             <a:picLocks noChangeAspect="1"/>
           </p:cNvPicPr>
@@ -2924,8 +3024,8 @@
         </p:blipFill>
         <p:spPr>
           <a:xfrm>
-            <a:off x="4846320" y="1653968"/>
-            <a:ext cx="3749040" cy="2132745"/>
+            <a:off x="745187" y="1783080"/>
+            <a:ext cx="7653626" cy="2743200"/>
           </a:xfrm>
           <a:prstGeom prst="rect">
             <a:avLst/>
@@ -3022,7 +3122,7 @@
                 <a:ea typeface="Noto Sans CJK KR" pitchFamily="34" charset="-122"/>
                 <a:cs typeface="Noto Sans CJK KR" pitchFamily="34" charset="-120"/>
               </a:rPr>
-              <a:t>Master - Master IP 확대</a:t>
+              <a:t>Master - PL 확대</a:t>
             </a:r>
             <a:endParaRPr lang="en-US" sz="3600" dirty="0"/>
           </a:p>
@@ -3036,8 +3136,8 @@
         </p:nvSpPr>
         <p:spPr>
           <a:xfrm>
-            <a:off x="548640" y="1188720"/>
-            <a:ext cx="8046720" cy="594360"/>
+            <a:off x="548640" y="1234440"/>
+            <a:ext cx="4023360" cy="2971800"/>
           </a:xfrm>
           <a:prstGeom prst="rect">
             <a:avLst/>
@@ -3051,13 +3151,13 @@
           <a:p>
             <a:pPr marL="342900" indent="-342900">
               <a:spcAft>
-                <a:spcPts val="600"/>
+                <a:spcPts val="1000"/>
               </a:spcAft>
               <a:buSzPct val="100000"/>
               <a:buChar char="•"/>
             </a:pPr>
             <a:r>
-              <a:rPr lang="en-US" sz="1700" dirty="0">
+              <a:rPr lang="en-US" sz="1800" dirty="0">
                 <a:solidFill>
                   <a:srgbClr val="222222"/>
                 </a:solidFill>
@@ -3065,20 +3165,20 @@
                 <a:ea typeface="Noto Sans CJK KR" pitchFamily="34" charset="-122"/>
                 <a:cs typeface="Noto Sans CJK KR" pitchFamily="34" charset="-120"/>
               </a:rPr>
-              <a:t>PS에서 설정값을 받아 동기 메시지를 송신, 각 Slave의 응답을 수신</a:t>
-            </a:r>
-            <a:endParaRPr lang="en-US" sz="1700" dirty="0"/>
+              <a:t>LED · 푸시버튼 · DIP 스위치 · 7-seg와 Master IP로 보드 자체의 입출력 구성</a:t>
+            </a:r>
+            <a:endParaRPr lang="en-US" sz="1800" dirty="0"/>
           </a:p>
           <a:p>
             <a:pPr marL="342900" indent="-342900">
               <a:spcAft>
-                <a:spcPts val="600"/>
+                <a:spcPts val="1000"/>
               </a:spcAft>
               <a:buSzPct val="100000"/>
               <a:buChar char="•"/>
             </a:pPr>
             <a:r>
-              <a:rPr lang="en-US" sz="1700" dirty="0">
+              <a:rPr lang="en-US" sz="1800" dirty="0">
                 <a:solidFill>
                   <a:srgbClr val="222222"/>
                 </a:solidFill>
@@ -3086,15 +3186,36 @@
                 <a:ea typeface="Noto Sans CJK KR" pitchFamily="34" charset="-122"/>
                 <a:cs typeface="Noto Sans CJK KR" pitchFamily="34" charset="-120"/>
               </a:rPr>
-              <a:t>에러·데이터 전송 여부·형식·슬롯 침범 여부를 확인해 내부에서 고장 처리 후 PS에 보고</a:t>
-            </a:r>
-            <a:endParaRPr lang="en-US" sz="1700" dirty="0"/>
+              <a:t>LED는 RX/TX 이진 신호를 그대로 받아 통신 상태를 표시</a:t>
+            </a:r>
+            <a:endParaRPr lang="en-US" sz="1800" dirty="0"/>
+          </a:p>
+          <a:p>
+            <a:pPr marL="342900" indent="-342900">
+              <a:spcAft>
+                <a:spcPts val="1000"/>
+              </a:spcAft>
+              <a:buSzPct val="100000"/>
+              <a:buChar char="•"/>
+            </a:pPr>
+            <a:r>
+              <a:rPr lang="en-US" sz="1800" dirty="0">
+                <a:solidFill>
+                  <a:srgbClr val="222222"/>
+                </a:solidFill>
+                <a:latin typeface="Noto Sans CJK KR" pitchFamily="34" charset="0"/>
+                <a:ea typeface="Noto Sans CJK KR" pitchFamily="34" charset="-122"/>
+                <a:cs typeface="Noto Sans CJK KR" pitchFamily="34" charset="-120"/>
+              </a:rPr>
+              <a:t>DIP 스위치·7-seg는 슬롯별 통신 상태와 수신 데이터를 출력 — Master IP가 이들을 조율</a:t>
+            </a:r>
+            <a:endParaRPr lang="en-US" sz="1800" dirty="0"/>
           </a:p>
         </p:txBody>
       </p:sp>
       <p:pic>
         <p:nvPicPr>
-          <p:cNvPr id="4" name="Image 0" descr="/home/user/SoC_Design_and_Programming/diagrams/section3/zoom/m_masterip.png">    </p:cNvPr>
+          <p:cNvPr id="4" name="Image 0" descr="/home/user/SoC_Design_and_Programming/diagrams/section3/zoom/m_pl.png">    </p:cNvPr>
           <p:cNvPicPr>
             <a:picLocks noChangeAspect="1"/>
           </p:cNvPicPr>
@@ -3107,8 +3228,8 @@
         </p:blipFill>
         <p:spPr>
           <a:xfrm>
-            <a:off x="548640" y="2087258"/>
-            <a:ext cx="8046720" cy="2134844"/>
+            <a:off x="4846320" y="1653968"/>
+            <a:ext cx="3749040" cy="2132745"/>
           </a:xfrm>
           <a:prstGeom prst="rect">
             <a:avLst/>
@@ -3205,7 +3326,7 @@
                 <a:ea typeface="Noto Sans CJK KR" pitchFamily="34" charset="-122"/>
                 <a:cs typeface="Noto Sans CJK KR" pitchFamily="34" charset="-120"/>
               </a:rPr>
-              <a:t>Slave 전체 구조</a:t>
+              <a:t>Master - Master IP 확대</a:t>
             </a:r>
             <a:endParaRPr lang="en-US" sz="3600" dirty="0"/>
           </a:p>
@@ -3248,7 +3369,7 @@
                 <a:ea typeface="Noto Sans CJK KR" pitchFamily="34" charset="-122"/>
                 <a:cs typeface="Noto Sans CJK KR" pitchFamily="34" charset="-120"/>
               </a:rPr>
-              <a:t>GPIO · PL(Slave IP 포함) 두 영역으로 구성</a:t>
+              <a:t>PS에서 설정값을 받아 동기 메시지를 송신, 각 Slave의 응답을 수신</a:t>
             </a:r>
             <a:endParaRPr lang="en-US" sz="1700" dirty="0"/>
           </a:p>
@@ -3269,7 +3390,7 @@
                 <a:ea typeface="Noto Sans CJK KR" pitchFamily="34" charset="-122"/>
                 <a:cs typeface="Noto Sans CJK KR" pitchFamily="34" charset="-120"/>
               </a:rPr>
-              <a:t>GPIO를 통해 Master와 TX/RX 시리얼로 연결</a:t>
+              <a:t>에러·데이터 전송 여부·형식·슬롯 침범 여부를 확인해 내부에서 고장 처리 후 PS에 보고</a:t>
             </a:r>
             <a:endParaRPr lang="en-US" sz="1700" dirty="0"/>
           </a:p>
@@ -3277,7 +3398,7 @@
       </p:sp>
       <p:pic>
         <p:nvPicPr>
-          <p:cNvPr id="4" name="Image 0" descr="/home/user/SoC_Design_and_Programming/diagrams/section3/zoom/slave_overview.png">    </p:cNvPr>
+          <p:cNvPr id="4" name="Image 0" descr="/home/user/SoC_Design_and_Programming/diagrams/section3/zoom/m_masterip.png">    </p:cNvPr>
           <p:cNvPicPr>
             <a:picLocks noChangeAspect="1"/>
           </p:cNvPicPr>
@@ -3290,8 +3411,8 @@
         </p:blipFill>
         <p:spPr>
           <a:xfrm>
-            <a:off x="636404" y="1783080"/>
-            <a:ext cx="7871192" cy="2743200"/>
+            <a:off x="548640" y="2087258"/>
+            <a:ext cx="8046720" cy="2134844"/>
           </a:xfrm>
           <a:prstGeom prst="rect">
             <a:avLst/>
@@ -3623,7 +3744,7 @@
                 <a:ea typeface="Noto Sans CJK KR" pitchFamily="34" charset="-122"/>
                 <a:cs typeface="Noto Sans CJK KR" pitchFamily="34" charset="-120"/>
               </a:rPr>
-              <a:t>3</a:t>
+              <a:t>4</a:t>
             </a:r>
             <a:endParaRPr lang="en-US" sz="1200" dirty="0"/>
           </a:p>
@@ -3680,7 +3801,7 @@
                 <a:ea typeface="Noto Sans CJK KR" pitchFamily="34" charset="-122"/>
                 <a:cs typeface="Noto Sans CJK KR" pitchFamily="34" charset="-120"/>
               </a:rPr>
-              <a:t>Slave - GPIO 확대</a:t>
+              <a:t>Slave 전체 구조</a:t>
             </a:r>
             <a:endParaRPr lang="en-US" sz="3600" dirty="0"/>
           </a:p>
@@ -3694,8 +3815,8 @@
         </p:nvSpPr>
         <p:spPr>
           <a:xfrm>
-            <a:off x="548640" y="1234440"/>
-            <a:ext cx="4023360" cy="2971800"/>
+            <a:off x="548640" y="1188720"/>
+            <a:ext cx="8046720" cy="594360"/>
           </a:xfrm>
           <a:prstGeom prst="rect">
             <a:avLst/>
@@ -3709,13 +3830,13 @@
           <a:p>
             <a:pPr marL="342900" indent="-342900">
               <a:spcAft>
-                <a:spcPts val="1000"/>
+                <a:spcPts val="600"/>
               </a:spcAft>
               <a:buSzPct val="100000"/>
               <a:buChar char="•"/>
             </a:pPr>
             <a:r>
-              <a:rPr lang="en-US" sz="1800" dirty="0">
+              <a:rPr lang="en-US" sz="1700" dirty="0">
                 <a:solidFill>
                   <a:srgbClr val="222222"/>
                 </a:solidFill>
@@ -3723,20 +3844,20 @@
                 <a:ea typeface="Noto Sans CJK KR" pitchFamily="34" charset="-122"/>
                 <a:cs typeface="Noto Sans CJK KR" pitchFamily="34" charset="-120"/>
               </a:rPr>
-              <a:t>GND / RX 포트 / TX 포트로 구성</a:t>
-            </a:r>
-            <a:endParaRPr lang="en-US" sz="1800" dirty="0"/>
+              <a:t>GPIO · PL(Slave IP 포함) 두 영역으로 구성</a:t>
+            </a:r>
+            <a:endParaRPr lang="en-US" sz="1700" dirty="0"/>
           </a:p>
           <a:p>
             <a:pPr marL="342900" indent="-342900">
               <a:spcAft>
-                <a:spcPts val="1000"/>
+                <a:spcPts val="600"/>
               </a:spcAft>
               <a:buSzPct val="100000"/>
               <a:buChar char="•"/>
             </a:pPr>
             <a:r>
-              <a:rPr lang="en-US" sz="1800" dirty="0">
+              <a:rPr lang="en-US" sz="1700" dirty="0">
                 <a:solidFill>
                   <a:srgbClr val="222222"/>
                 </a:solidFill>
@@ -3744,15 +3865,15 @@
                 <a:ea typeface="Noto Sans CJK KR" pitchFamily="34" charset="-122"/>
                 <a:cs typeface="Noto Sans CJK KR" pitchFamily="34" charset="-120"/>
               </a:rPr>
-              <a:t>RX·TX는 LED에 직결되어 통신 상태를 표시 (Master와 표현 통일)</a:t>
-            </a:r>
-            <a:endParaRPr lang="en-US" sz="1800" dirty="0"/>
+              <a:t>GPIO를 통해 Master와 TX/RX 시리얼로 연결</a:t>
+            </a:r>
+            <a:endParaRPr lang="en-US" sz="1700" dirty="0"/>
           </a:p>
         </p:txBody>
       </p:sp>
       <p:pic>
         <p:nvPicPr>
-          <p:cNvPr id="4" name="Image 0" descr="/home/user/SoC_Design_and_Programming/diagrams/section3/zoom/s_gpio.png">    </p:cNvPr>
+          <p:cNvPr id="4" name="Image 0" descr="/home/user/SoC_Design_and_Programming/diagrams/section3/zoom/slave_overview.png">    </p:cNvPr>
           <p:cNvPicPr>
             <a:picLocks noChangeAspect="1"/>
           </p:cNvPicPr>
@@ -3765,8 +3886,8 @@
         </p:blipFill>
         <p:spPr>
           <a:xfrm>
-            <a:off x="4846320" y="1618103"/>
-            <a:ext cx="3749040" cy="2204474"/>
+            <a:off x="636404" y="1783080"/>
+            <a:ext cx="7871192" cy="2743200"/>
           </a:xfrm>
           <a:prstGeom prst="rect">
             <a:avLst/>
@@ -3863,7 +3984,7 @@
                 <a:ea typeface="Noto Sans CJK KR" pitchFamily="34" charset="-122"/>
                 <a:cs typeface="Noto Sans CJK KR" pitchFamily="34" charset="-120"/>
               </a:rPr>
-              <a:t>Slave - PL 확대</a:t>
+              <a:t>Slave - GPIO 확대</a:t>
             </a:r>
             <a:endParaRPr lang="en-US" sz="3600" dirty="0"/>
           </a:p>
@@ -3906,7 +4027,7 @@
                 <a:ea typeface="Noto Sans CJK KR" pitchFamily="34" charset="-122"/>
                 <a:cs typeface="Noto Sans CJK KR" pitchFamily="34" charset="-120"/>
               </a:rPr>
-              <a:t>LED와 Slave IP로 구성</a:t>
+              <a:t>GND / RX 포트 / TX 포트로 구성</a:t>
             </a:r>
             <a:endParaRPr lang="en-US" sz="1800" dirty="0"/>
           </a:p>
@@ -3927,7 +4048,7 @@
                 <a:ea typeface="Noto Sans CJK KR" pitchFamily="34" charset="-122"/>
                 <a:cs typeface="Noto Sans CJK KR" pitchFamily="34" charset="-120"/>
               </a:rPr>
-              <a:t>구조는 단순하지만 일관성을 위해 동일하게 확대해서 표시</a:t>
+              <a:t>RX·TX는 LED에 직결되어 통신 상태를 표시 (Master와 표현 통일)</a:t>
             </a:r>
             <a:endParaRPr lang="en-US" sz="1800" dirty="0"/>
           </a:p>
@@ -3935,7 +4056,7 @@
       </p:sp>
       <p:pic>
         <p:nvPicPr>
-          <p:cNvPr id="4" name="Image 0" descr="/home/user/SoC_Design_and_Programming/diagrams/section3/zoom/s_pl.png">    </p:cNvPr>
+          <p:cNvPr id="4" name="Image 0" descr="/home/user/SoC_Design_and_Programming/diagrams/section3/zoom/s_gpio.png">    </p:cNvPr>
           <p:cNvPicPr>
             <a:picLocks noChangeAspect="1"/>
           </p:cNvPicPr>
@@ -3948,8 +4069,8 @@
         </p:blipFill>
         <p:spPr>
           <a:xfrm>
-            <a:off x="4846320" y="1484484"/>
-            <a:ext cx="3749040" cy="2471712"/>
+            <a:off x="4846320" y="1618103"/>
+            <a:ext cx="3749040" cy="2204474"/>
           </a:xfrm>
           <a:prstGeom prst="rect">
             <a:avLst/>
@@ -4046,7 +4167,7 @@
                 <a:ea typeface="Noto Sans CJK KR" pitchFamily="34" charset="-122"/>
                 <a:cs typeface="Noto Sans CJK KR" pitchFamily="34" charset="-120"/>
               </a:rPr>
-              <a:t>Slave - Slave IP 확대</a:t>
+              <a:t>Slave - PL 확대</a:t>
             </a:r>
             <a:endParaRPr lang="en-US" sz="3600" dirty="0"/>
           </a:p>
@@ -4060,8 +4181,8 @@
         </p:nvSpPr>
         <p:spPr>
           <a:xfrm>
-            <a:off x="548640" y="1188720"/>
-            <a:ext cx="8046720" cy="594360"/>
+            <a:off x="548640" y="1234440"/>
+            <a:ext cx="4023360" cy="2971800"/>
           </a:xfrm>
           <a:prstGeom prst="rect">
             <a:avLst/>
@@ -4075,13 +4196,13 @@
           <a:p>
             <a:pPr marL="342900" indent="-342900">
               <a:spcAft>
-                <a:spcPts val="600"/>
+                <a:spcPts val="1000"/>
               </a:spcAft>
               <a:buSzPct val="100000"/>
               <a:buChar char="•"/>
             </a:pPr>
             <a:r>
-              <a:rPr lang="en-US" sz="1700" dirty="0">
+              <a:rPr lang="en-US" sz="1800" dirty="0">
                 <a:solidFill>
                   <a:srgbClr val="222222"/>
                 </a:solidFill>
@@ -4089,20 +4210,20 @@
                 <a:ea typeface="Noto Sans CJK KR" pitchFamily="34" charset="-122"/>
                 <a:cs typeface="Noto Sans CJK KR" pitchFamily="34" charset="-120"/>
               </a:rPr>
-              <a:t>Master의 동기 메시지를 받으면 자신의 슬롯 시간대를 계산해 적시에 메시지를 전송</a:t>
-            </a:r>
-            <a:endParaRPr lang="en-US" sz="1700" dirty="0"/>
+              <a:t>LED와 Slave IP로 구성</a:t>
+            </a:r>
+            <a:endParaRPr lang="en-US" sz="1800" dirty="0"/>
           </a:p>
           <a:p>
             <a:pPr marL="342900" indent="-342900">
               <a:spcAft>
-                <a:spcPts val="600"/>
+                <a:spcPts val="1000"/>
               </a:spcAft>
               <a:buSzPct val="100000"/>
               <a:buChar char="•"/>
             </a:pPr>
             <a:r>
-              <a:rPr lang="en-US" sz="1700" dirty="0">
+              <a:rPr lang="en-US" sz="1800" dirty="0">
                 <a:solidFill>
                   <a:srgbClr val="222222"/>
                 </a:solidFill>
@@ -4110,15 +4231,15 @@
                 <a:ea typeface="Noto Sans CJK KR" pitchFamily="34" charset="-122"/>
                 <a:cs typeface="Noto Sans CJK KR" pitchFamily="34" charset="-120"/>
               </a:rPr>
-              <a:t>Master가 송신 중단을 명령하면 송신을 중지하는 등 고장 처리를 수행</a:t>
-            </a:r>
-            <a:endParaRPr lang="en-US" sz="1700" dirty="0"/>
+              <a:t>구조는 단순하지만 일관성을 위해 동일하게 확대해서 표시</a:t>
+            </a:r>
+            <a:endParaRPr lang="en-US" sz="1800" dirty="0"/>
           </a:p>
         </p:txBody>
       </p:sp>
       <p:pic>
         <p:nvPicPr>
-          <p:cNvPr id="4" name="Image 0" descr="/home/user/SoC_Design_and_Programming/diagrams/section3/zoom/s_slaveip.png">    </p:cNvPr>
+          <p:cNvPr id="4" name="Image 0" descr="/home/user/SoC_Design_and_Programming/diagrams/section3/zoom/s_pl.png">    </p:cNvPr>
           <p:cNvPicPr>
             <a:picLocks noChangeAspect="1"/>
           </p:cNvPicPr>
@@ -4131,8 +4252,8 @@
         </p:blipFill>
         <p:spPr>
           <a:xfrm>
-            <a:off x="745187" y="1783080"/>
-            <a:ext cx="7653626" cy="2743200"/>
+            <a:off x="4846320" y="1484484"/>
+            <a:ext cx="3749040" cy="2471712"/>
           </a:xfrm>
           <a:prstGeom prst="rect">
             <a:avLst/>
@@ -4229,7 +4350,7 @@
                 <a:ea typeface="Noto Sans CJK KR" pitchFamily="34" charset="-122"/>
                 <a:cs typeface="Noto Sans CJK KR" pitchFamily="34" charset="-120"/>
               </a:rPr>
-              <a:t>Slave의 멀티 슬롯 시뮬레이션</a:t>
+              <a:t>Slave - Slave IP 확대</a:t>
             </a:r>
             <a:endParaRPr lang="en-US" sz="3600" dirty="0"/>
           </a:p>
@@ -4243,8 +4364,8 @@
         </p:nvSpPr>
         <p:spPr>
           <a:xfrm>
-            <a:off x="548640" y="1234440"/>
-            <a:ext cx="8046720" cy="2971800"/>
+            <a:off x="548640" y="1188720"/>
+            <a:ext cx="8046720" cy="594360"/>
           </a:xfrm>
           <a:prstGeom prst="rect">
             <a:avLst/>
@@ -4258,13 +4379,13 @@
           <a:p>
             <a:pPr marL="342900" indent="-342900">
               <a:spcAft>
-                <a:spcPts val="1200"/>
+                <a:spcPts val="600"/>
               </a:spcAft>
               <a:buSzPct val="100000"/>
               <a:buChar char="•"/>
             </a:pPr>
             <a:r>
-              <a:rPr lang="en-US" sz="2000" dirty="0">
+              <a:rPr lang="en-US" sz="1700" dirty="0">
                 <a:solidFill>
                   <a:srgbClr val="222222"/>
                 </a:solidFill>
@@ -4272,20 +4393,20 @@
                 <a:ea typeface="Noto Sans CJK KR" pitchFamily="34" charset="-122"/>
                 <a:cs typeface="Noto Sans CJK KR" pitchFamily="34" charset="-120"/>
               </a:rPr>
-              <a:t>통신 시연에서는 하나의 물리 시퀀서가 8개의 슬롯(슬롯 인덱스 0~7)을 순차 처리 — 슬롯 위치가 식별자 역할을 함</a:t>
-            </a:r>
-            <a:endParaRPr lang="en-US" sz="2000" dirty="0"/>
+              <a:t>Master의 동기 메시지를 받으면 자신의 슬롯 시간대를 계산해 적시에 메시지를 전송</a:t>
+            </a:r>
+            <a:endParaRPr lang="en-US" sz="1700" dirty="0"/>
           </a:p>
           <a:p>
             <a:pPr marL="342900" indent="-342900">
               <a:spcAft>
-                <a:spcPts val="1200"/>
+                <a:spcPts val="600"/>
               </a:spcAft>
               <a:buSzPct val="100000"/>
               <a:buChar char="•"/>
             </a:pPr>
             <a:r>
-              <a:rPr lang="en-US" sz="2000" dirty="0">
+              <a:rPr lang="en-US" sz="1700" dirty="0">
                 <a:solidFill>
                   <a:srgbClr val="222222"/>
                 </a:solidFill>
@@ -4293,57 +4414,38 @@
                 <a:ea typeface="Noto Sans CJK KR" pitchFamily="34" charset="-122"/>
                 <a:cs typeface="Noto Sans CJK KR" pitchFamily="34" charset="-120"/>
               </a:rPr>
-              <a:t>각 슬롯은 자신의 타임슬롯에서 자신의 payload를 전송 (슬롯별 절대 타겟 틱을 기준으로 순회)</a:t>
-            </a:r>
-            <a:endParaRPr lang="en-US" sz="2000" dirty="0"/>
-          </a:p>
-          <a:p>
-            <a:pPr marL="342900" indent="-342900">
-              <a:spcAft>
-                <a:spcPts val="1200"/>
-              </a:spcAft>
-              <a:buSzPct val="100000"/>
-              <a:buChar char="•"/>
-            </a:pPr>
-            <a:r>
-              <a:rPr lang="en-US" sz="2000" dirty="0">
-                <a:solidFill>
-                  <a:srgbClr val="222222"/>
-                </a:solidFill>
-                <a:latin typeface="Noto Sans CJK KR" pitchFamily="34" charset="0"/>
-                <a:ea typeface="Noto Sans CJK KR" pitchFamily="34" charset="-122"/>
-                <a:cs typeface="Noto Sans CJK KR" pitchFamily="34" charset="-120"/>
-              </a:rPr>
-              <a:t>슬롯 0~5는 AXI 레지스터, 슬롯 6~7은 외부 PL 버스에서 payload를 가져옴</a:t>
-            </a:r>
-            <a:endParaRPr lang="en-US" sz="2000" dirty="0"/>
-          </a:p>
-          <a:p>
-            <a:pPr marL="342900" indent="-342900">
-              <a:spcAft>
-                <a:spcPts val="1200"/>
-              </a:spcAft>
-              <a:buSzPct val="100000"/>
-              <a:buChar char="•"/>
-            </a:pPr>
-            <a:r>
-              <a:rPr lang="en-US" sz="2000" dirty="0">
-                <a:solidFill>
-                  <a:srgbClr val="222222"/>
-                </a:solidFill>
-                <a:latin typeface="Noto Sans CJK KR" pitchFamily="34" charset="0"/>
-                <a:ea typeface="Noto Sans CJK KR" pitchFamily="34" charset="-122"/>
-                <a:cs typeface="Noto Sans CJK KR" pitchFamily="34" charset="-120"/>
-              </a:rPr>
-              <a:t>시연에서는 버튼으로 payload 값을 바꾸고, 변경된 값이 Master에서 정확히 수신되는지 확인</a:t>
-            </a:r>
-            <a:endParaRPr lang="en-US" sz="2000" dirty="0"/>
-          </a:p>
-        </p:txBody>
-      </p:sp>
-      <p:sp>
-        <p:nvSpPr>
-          <p:cNvPr id="4" name="Text 2"/>
+              <a:t>Master가 송신 중단을 명령하면 송신을 중지하는 등 고장 처리를 수행</a:t>
+            </a:r>
+            <a:endParaRPr lang="en-US" sz="1700" dirty="0"/>
+          </a:p>
+        </p:txBody>
+      </p:sp>
+      <p:pic>
+        <p:nvPicPr>
+          <p:cNvPr id="4" name="Image 0" descr="/home/user/SoC_Design_and_Programming/diagrams/section3/zoom/s_slaveip.png">    </p:cNvPr>
+          <p:cNvPicPr>
+            <a:picLocks noChangeAspect="1"/>
+          </p:cNvPicPr>
+          <p:nvPr/>
+        </p:nvPicPr>
+        <p:blipFill>
+          <a:blip r:embed="rId2"/>
+          <a:srcRect l="0" r="0" t="0" b="0"/>
+          <a:stretch/>
+        </p:blipFill>
+        <p:spPr>
+          <a:xfrm>
+            <a:off x="745187" y="1783080"/>
+            <a:ext cx="7653626" cy="2743200"/>
+          </a:xfrm>
+          <a:prstGeom prst="rect">
+            <a:avLst/>
+          </a:prstGeom>
+        </p:spPr>
+      </p:pic>
+      <p:sp>
+        <p:nvSpPr>
+          <p:cNvPr id="5" name="Text 2"/>
           <p:cNvSpPr/>
           <p:nvPr/>
         </p:nvSpPr>
@@ -4389,6 +4491,208 @@
 </file>
 
 <file path=ppt/slides/slide24.xml><?xml version="1.0" encoding="utf-8"?>
+<p:sld xmlns:a="http://schemas.openxmlformats.org/drawingml/2006/main" xmlns:p="http://schemas.openxmlformats.org/presentationml/2006/main" xmlns:r="http://schemas.openxmlformats.org/officeDocument/2006/relationships">
+  <p:cSld>
+    <p:spTree>
+      <p:nvGrpSpPr>
+        <p:cNvPr id="1" name=""/>
+        <p:cNvGrpSpPr/>
+        <p:nvPr/>
+      </p:nvGrpSpPr>
+      <p:grpSpPr/>
+      <p:sp>
+        <p:nvSpPr>
+          <p:cNvPr id="2" name="Text 0"/>
+          <p:cNvSpPr/>
+          <p:nvPr/>
+        </p:nvSpPr>
+        <p:spPr>
+          <a:xfrm>
+            <a:off x="548640" y="274320"/>
+            <a:ext cx="8046720" cy="777240"/>
+          </a:xfrm>
+          <a:prstGeom prst="rect">
+            <a:avLst/>
+          </a:prstGeom>
+          <a:noFill/>
+          <a:ln/>
+        </p:spPr>
+        <p:txBody>
+          <a:bodyPr wrap="square" lIns="0" tIns="0" rIns="0" bIns="0" rtlCol="0" anchor="ctr"/>
+          <a:lstStyle/>
+          <a:p>
+            <a:pPr indent="0" marL="0">
+              <a:buNone/>
+            </a:pPr>
+            <a:r>
+              <a:rPr lang="en-US" sz="3600" b="1" dirty="0">
+                <a:solidFill>
+                  <a:srgbClr val="111111"/>
+                </a:solidFill>
+                <a:latin typeface="Noto Sans CJK KR" pitchFamily="34" charset="0"/>
+                <a:ea typeface="Noto Sans CJK KR" pitchFamily="34" charset="-122"/>
+                <a:cs typeface="Noto Sans CJK KR" pitchFamily="34" charset="-120"/>
+              </a:rPr>
+              <a:t>Slave의 멀티 슬롯 시뮬레이션</a:t>
+            </a:r>
+            <a:endParaRPr lang="en-US" sz="3600" dirty="0"/>
+          </a:p>
+        </p:txBody>
+      </p:sp>
+      <p:sp>
+        <p:nvSpPr>
+          <p:cNvPr id="3" name="Text 1"/>
+          <p:cNvSpPr/>
+          <p:nvPr/>
+        </p:nvSpPr>
+        <p:spPr>
+          <a:xfrm>
+            <a:off x="548640" y="1234440"/>
+            <a:ext cx="8046720" cy="2971800"/>
+          </a:xfrm>
+          <a:prstGeom prst="rect">
+            <a:avLst/>
+          </a:prstGeom>
+          <a:noFill/>
+          <a:ln/>
+        </p:spPr>
+        <p:txBody>
+          <a:bodyPr wrap="square" rtlCol="0" anchor="t"/>
+          <a:lstStyle/>
+          <a:p>
+            <a:pPr marL="342900" indent="-342900">
+              <a:spcAft>
+                <a:spcPts val="1200"/>
+              </a:spcAft>
+              <a:buSzPct val="100000"/>
+              <a:buChar char="•"/>
+            </a:pPr>
+            <a:r>
+              <a:rPr lang="en-US" sz="2000" dirty="0">
+                <a:solidFill>
+                  <a:srgbClr val="222222"/>
+                </a:solidFill>
+                <a:latin typeface="Noto Sans CJK KR" pitchFamily="34" charset="0"/>
+                <a:ea typeface="Noto Sans CJK KR" pitchFamily="34" charset="-122"/>
+                <a:cs typeface="Noto Sans CJK KR" pitchFamily="34" charset="-120"/>
+              </a:rPr>
+              <a:t>통신 시연에서는 하나의 물리 시퀀서가 8개의 슬롯(슬롯 인덱스 0~7)을 순차 처리 — 슬롯 위치가 식별자 역할을 함</a:t>
+            </a:r>
+            <a:endParaRPr lang="en-US" sz="2000" dirty="0"/>
+          </a:p>
+          <a:p>
+            <a:pPr marL="342900" indent="-342900">
+              <a:spcAft>
+                <a:spcPts val="1200"/>
+              </a:spcAft>
+              <a:buSzPct val="100000"/>
+              <a:buChar char="•"/>
+            </a:pPr>
+            <a:r>
+              <a:rPr lang="en-US" sz="2000" dirty="0">
+                <a:solidFill>
+                  <a:srgbClr val="222222"/>
+                </a:solidFill>
+                <a:latin typeface="Noto Sans CJK KR" pitchFamily="34" charset="0"/>
+                <a:ea typeface="Noto Sans CJK KR" pitchFamily="34" charset="-122"/>
+                <a:cs typeface="Noto Sans CJK KR" pitchFamily="34" charset="-120"/>
+              </a:rPr>
+              <a:t>각 슬롯은 자신의 타임슬롯에서 자신의 payload를 전송 (슬롯별 절대 타겟 틱을 기준으로 순회)</a:t>
+            </a:r>
+            <a:endParaRPr lang="en-US" sz="2000" dirty="0"/>
+          </a:p>
+          <a:p>
+            <a:pPr marL="342900" indent="-342900">
+              <a:spcAft>
+                <a:spcPts val="1200"/>
+              </a:spcAft>
+              <a:buSzPct val="100000"/>
+              <a:buChar char="•"/>
+            </a:pPr>
+            <a:r>
+              <a:rPr lang="en-US" sz="2000" dirty="0">
+                <a:solidFill>
+                  <a:srgbClr val="222222"/>
+                </a:solidFill>
+                <a:latin typeface="Noto Sans CJK KR" pitchFamily="34" charset="0"/>
+                <a:ea typeface="Noto Sans CJK KR" pitchFamily="34" charset="-122"/>
+                <a:cs typeface="Noto Sans CJK KR" pitchFamily="34" charset="-120"/>
+              </a:rPr>
+              <a:t>슬롯 0~5는 AXI 레지스터, 슬롯 6~7은 외부 PL 버스에서 payload를 가져옴</a:t>
+            </a:r>
+            <a:endParaRPr lang="en-US" sz="2000" dirty="0"/>
+          </a:p>
+          <a:p>
+            <a:pPr marL="342900" indent="-342900">
+              <a:spcAft>
+                <a:spcPts val="1200"/>
+              </a:spcAft>
+              <a:buSzPct val="100000"/>
+              <a:buChar char="•"/>
+            </a:pPr>
+            <a:r>
+              <a:rPr lang="en-US" sz="2000" dirty="0">
+                <a:solidFill>
+                  <a:srgbClr val="222222"/>
+                </a:solidFill>
+                <a:latin typeface="Noto Sans CJK KR" pitchFamily="34" charset="0"/>
+                <a:ea typeface="Noto Sans CJK KR" pitchFamily="34" charset="-122"/>
+                <a:cs typeface="Noto Sans CJK KR" pitchFamily="34" charset="-120"/>
+              </a:rPr>
+              <a:t>시연에서는 버튼으로 payload 값을 바꾸고, 변경된 값이 Master에서 정확히 수신되는지 확인</a:t>
+            </a:r>
+            <a:endParaRPr lang="en-US" sz="2000" dirty="0"/>
+          </a:p>
+        </p:txBody>
+      </p:sp>
+      <p:sp>
+        <p:nvSpPr>
+          <p:cNvPr id="4" name="Text 2"/>
+          <p:cNvSpPr/>
+          <p:nvPr/>
+        </p:nvSpPr>
+        <p:spPr>
+          <a:xfrm>
+            <a:off x="8503920" y="4754880"/>
+            <a:ext cx="457200" cy="274320"/>
+          </a:xfrm>
+          <a:prstGeom prst="rect">
+            <a:avLst/>
+          </a:prstGeom>
+          <a:noFill/>
+          <a:ln/>
+        </p:spPr>
+        <p:txBody>
+          <a:bodyPr wrap="square" rtlCol="0" anchor="ctr"/>
+          <a:lstStyle/>
+          <a:p>
+            <a:pPr algn="r" indent="0" marL="0">
+              <a:buNone/>
+            </a:pPr>
+            <a:r>
+              <a:rPr lang="en-US" sz="1200" dirty="0">
+                <a:solidFill>
+                  <a:srgbClr val="999999"/>
+                </a:solidFill>
+                <a:latin typeface="Noto Sans CJK KR" pitchFamily="34" charset="0"/>
+                <a:ea typeface="Noto Sans CJK KR" pitchFamily="34" charset="-122"/>
+                <a:cs typeface="Noto Sans CJK KR" pitchFamily="34" charset="-120"/>
+              </a:rPr>
+              <a:t>24</a:t>
+            </a:r>
+            <a:endParaRPr lang="en-US" sz="1200" dirty="0"/>
+          </a:p>
+        </p:txBody>
+      </p:sp>
+    </p:spTree>
+  </p:cSld>
+  <p:clrMapOvr>
+    <a:masterClrMapping/>
+  </p:clrMapOvr>
+</p:sld>
+</file>
+
+<file path=ppt/slides/slide25.xml><?xml version="1.0" encoding="utf-8"?>
 <p:sld xmlns:a="http://schemas.openxmlformats.org/drawingml/2006/main" xmlns:p="http://schemas.openxmlformats.org/presentationml/2006/main" xmlns:r="http://schemas.openxmlformats.org/officeDocument/2006/relationships">
   <p:cSld>
     <p:spTree>
@@ -5769,208 +6073,6 @@
                 <a:ea typeface="Noto Sans CJK KR" pitchFamily="34" charset="-122"/>
                 <a:cs typeface="Noto Sans CJK KR" pitchFamily="34" charset="-120"/>
               </a:rPr>
-              <a:t>24</a:t>
-            </a:r>
-            <a:endParaRPr lang="en-US" sz="1200" dirty="0"/>
-          </a:p>
-        </p:txBody>
-      </p:sp>
-    </p:spTree>
-  </p:cSld>
-  <p:clrMapOvr>
-    <a:masterClrMapping/>
-  </p:clrMapOvr>
-</p:sld>
-</file>
-
-<file path=ppt/slides/slide25.xml><?xml version="1.0" encoding="utf-8"?>
-<p:sld xmlns:a="http://schemas.openxmlformats.org/drawingml/2006/main" xmlns:p="http://schemas.openxmlformats.org/presentationml/2006/main" xmlns:r="http://schemas.openxmlformats.org/officeDocument/2006/relationships">
-  <p:cSld>
-    <p:spTree>
-      <p:nvGrpSpPr>
-        <p:cNvPr id="1" name=""/>
-        <p:cNvGrpSpPr/>
-        <p:nvPr/>
-      </p:nvGrpSpPr>
-      <p:grpSpPr/>
-      <p:sp>
-        <p:nvSpPr>
-          <p:cNvPr id="2" name="Text 0"/>
-          <p:cNvSpPr/>
-          <p:nvPr/>
-        </p:nvSpPr>
-        <p:spPr>
-          <a:xfrm>
-            <a:off x="548640" y="274320"/>
-            <a:ext cx="8046720" cy="777240"/>
-          </a:xfrm>
-          <a:prstGeom prst="rect">
-            <a:avLst/>
-          </a:prstGeom>
-          <a:noFill/>
-          <a:ln/>
-        </p:spPr>
-        <p:txBody>
-          <a:bodyPr wrap="square" lIns="0" tIns="0" rIns="0" bIns="0" rtlCol="0" anchor="ctr"/>
-          <a:lstStyle/>
-          <a:p>
-            <a:pPr indent="0" marL="0">
-              <a:buNone/>
-            </a:pPr>
-            <a:r>
-              <a:rPr lang="en-US" sz="3600" b="1" dirty="0">
-                <a:solidFill>
-                  <a:srgbClr val="111111"/>
-                </a:solidFill>
-                <a:latin typeface="Noto Sans CJK KR" pitchFamily="34" charset="0"/>
-                <a:ea typeface="Noto Sans CJK KR" pitchFamily="34" charset="-122"/>
-                <a:cs typeface="Noto Sans CJK KR" pitchFamily="34" charset="-120"/>
-              </a:rPr>
-              <a:t>클럭 동기의 어려움</a:t>
-            </a:r>
-            <a:endParaRPr lang="en-US" sz="3600" dirty="0"/>
-          </a:p>
-        </p:txBody>
-      </p:sp>
-      <p:sp>
-        <p:nvSpPr>
-          <p:cNvPr id="3" name="Text 1"/>
-          <p:cNvSpPr/>
-          <p:nvPr/>
-        </p:nvSpPr>
-        <p:spPr>
-          <a:xfrm>
-            <a:off x="548640" y="1234440"/>
-            <a:ext cx="8046720" cy="2971800"/>
-          </a:xfrm>
-          <a:prstGeom prst="rect">
-            <a:avLst/>
-          </a:prstGeom>
-          <a:noFill/>
-          <a:ln/>
-        </p:spPr>
-        <p:txBody>
-          <a:bodyPr wrap="square" rtlCol="0" anchor="t"/>
-          <a:lstStyle/>
-          <a:p>
-            <a:pPr marL="342900" indent="-342900">
-              <a:spcAft>
-                <a:spcPts val="1200"/>
-              </a:spcAft>
-              <a:buSzPct val="100000"/>
-              <a:buChar char="•"/>
-            </a:pPr>
-            <a:r>
-              <a:rPr lang="en-US" sz="2000" dirty="0">
-                <a:solidFill>
-                  <a:srgbClr val="222222"/>
-                </a:solidFill>
-                <a:latin typeface="Noto Sans CJK KR" pitchFamily="34" charset="0"/>
-                <a:ea typeface="Noto Sans CJK KR" pitchFamily="34" charset="-122"/>
-                <a:cs typeface="Noto Sans CJK KR" pitchFamily="34" charset="-120"/>
-              </a:rPr>
-              <a:t>Master·Slave는 클럭을 공유하지 않음 — 클럭 오차가 통신에 치명적인 방해 요인</a:t>
-            </a:r>
-            <a:endParaRPr lang="en-US" sz="2000" dirty="0"/>
-          </a:p>
-          <a:p>
-            <a:pPr marL="342900" indent="-342900">
-              <a:spcAft>
-                <a:spcPts val="1200"/>
-              </a:spcAft>
-              <a:buSzPct val="100000"/>
-              <a:buChar char="•"/>
-            </a:pPr>
-            <a:r>
-              <a:rPr lang="en-US" sz="2000" dirty="0">
-                <a:solidFill>
-                  <a:srgbClr val="222222"/>
-                </a:solidFill>
-                <a:latin typeface="Noto Sans CJK KR" pitchFamily="34" charset="0"/>
-                <a:ea typeface="Noto Sans CJK KR" pitchFamily="34" charset="-122"/>
-                <a:cs typeface="Noto Sans CJK KR" pitchFamily="34" charset="-120"/>
-              </a:rPr>
-              <a:t>DIV 값을 AXI 레지스터로 설정해 클럭을 분주, Master·Slave 양쪽에 동일한 DIV 값을 쓴다고 가정</a:t>
-            </a:r>
-            <a:endParaRPr lang="en-US" sz="2000" dirty="0"/>
-          </a:p>
-          <a:p>
-            <a:pPr marL="342900" indent="-342900">
-              <a:spcAft>
-                <a:spcPts val="1200"/>
-              </a:spcAft>
-              <a:buSzPct val="100000"/>
-              <a:buChar char="•"/>
-            </a:pPr>
-            <a:r>
-              <a:rPr lang="en-US" sz="2000" dirty="0">
-                <a:solidFill>
-                  <a:srgbClr val="222222"/>
-                </a:solidFill>
-                <a:latin typeface="Noto Sans CJK KR" pitchFamily="34" charset="0"/>
-                <a:ea typeface="Noto Sans CJK KR" pitchFamily="34" charset="-122"/>
-                <a:cs typeface="Noto Sans CJK KR" pitchFamily="34" charset="-120"/>
-              </a:rPr>
-              <a:t>분주 클럭은 메인 클럭 / (DIV + 1)</a:t>
-            </a:r>
-            <a:endParaRPr lang="en-US" sz="2000" dirty="0"/>
-          </a:p>
-          <a:p>
-            <a:pPr marL="342900" indent="-342900">
-              <a:spcAft>
-                <a:spcPts val="1200"/>
-              </a:spcAft>
-              <a:buSzPct val="100000"/>
-              <a:buChar char="•"/>
-            </a:pPr>
-            <a:r>
-              <a:rPr lang="en-US" sz="2000" dirty="0">
-                <a:solidFill>
-                  <a:srgbClr val="222222"/>
-                </a:solidFill>
-                <a:latin typeface="Noto Sans CJK KR" pitchFamily="34" charset="0"/>
-                <a:ea typeface="Noto Sans CJK KR" pitchFamily="34" charset="-122"/>
-                <a:cs typeface="Noto Sans CJK KR" pitchFamily="34" charset="-120"/>
-              </a:rPr>
-              <a:t>수신 샘플링은 비트 구간의 중간 지점에서 1회만 수행</a:t>
-            </a:r>
-            <a:endParaRPr lang="en-US" sz="2000" dirty="0"/>
-          </a:p>
-        </p:txBody>
-      </p:sp>
-      <p:sp>
-        <p:nvSpPr>
-          <p:cNvPr id="4" name="Text 2"/>
-          <p:cNvSpPr/>
-          <p:nvPr/>
-        </p:nvSpPr>
-        <p:spPr>
-          <a:xfrm>
-            <a:off x="8503920" y="4754880"/>
-            <a:ext cx="457200" cy="274320"/>
-          </a:xfrm>
-          <a:prstGeom prst="rect">
-            <a:avLst/>
-          </a:prstGeom>
-          <a:noFill/>
-          <a:ln/>
-        </p:spPr>
-        <p:txBody>
-          <a:bodyPr wrap="square" rtlCol="0" anchor="ctr"/>
-          <a:lstStyle/>
-          <a:p>
-            <a:pPr algn="r" indent="0" marL="0">
-              <a:buNone/>
-            </a:pPr>
-            <a:r>
-              <a:rPr lang="en-US" sz="1200" dirty="0">
-                <a:solidFill>
-                  <a:srgbClr val="999999"/>
-                </a:solidFill>
-                <a:latin typeface="Noto Sans CJK KR" pitchFamily="34" charset="0"/>
-                <a:ea typeface="Noto Sans CJK KR" pitchFamily="34" charset="-122"/>
-                <a:cs typeface="Noto Sans CJK KR" pitchFamily="34" charset="-120"/>
-              </a:rPr>
               <a:t>25</a:t>
             </a:r>
             <a:endParaRPr lang="en-US" sz="1200" dirty="0"/>
@@ -6028,7 +6130,7 @@
                 <a:ea typeface="Noto Sans CJK KR" pitchFamily="34" charset="-122"/>
                 <a:cs typeface="Noto Sans CJK KR" pitchFamily="34" charset="-120"/>
               </a:rPr>
-              <a:t>Master의 고장 처리</a:t>
+              <a:t>클럭 동기의 어려움</a:t>
             </a:r>
             <a:endParaRPr lang="en-US" sz="3600" dirty="0"/>
           </a:p>
@@ -6071,7 +6173,7 @@
                 <a:ea typeface="Noto Sans CJK KR" pitchFamily="34" charset="-122"/>
                 <a:cs typeface="Noto Sans CJK KR" pitchFamily="34" charset="-120"/>
               </a:rPr>
-              <a:t>슬롯별 4가지 카운터(preamble_err_cnt, slot_timeout_cnt, hamming_err_cnt, silent_cnt)로 임계치 기반 고장 판정</a:t>
+              <a:t>Master·Slave는 클럭을 공유하지 않음 — 클럭 오차가 통신에 치명적인 방해 요인</a:t>
             </a:r>
             <a:endParaRPr lang="en-US" sz="2000" dirty="0"/>
           </a:p>
@@ -6092,7 +6194,7 @@
                 <a:ea typeface="Noto Sans CJK KR" pitchFamily="34" charset="-122"/>
                 <a:cs typeface="Noto Sans CJK KR" pitchFamily="34" charset="-120"/>
               </a:rPr>
-              <a:t>slot_timeout_cnt는 심각한 타이밍/주소 불일치 시 즉시 255로 saturate, 약한 가드 경계 오류 시 +6</a:t>
+              <a:t>DIV 값을 AXI 레지스터로 설정해 클럭을 분주, Master·Slave 양쪽에 동일한 DIV 값을 쓴다고 가정</a:t>
             </a:r>
             <a:endParaRPr lang="en-US" sz="2000" dirty="0"/>
           </a:p>
@@ -6113,7 +6215,7 @@
                 <a:ea typeface="Noto Sans CJK KR" pitchFamily="34" charset="-122"/>
                 <a:cs typeface="Noto Sans CJK KR" pitchFamily="34" charset="-120"/>
               </a:rPr>
-              <a:t>판정 임곗값(FAULT_TH, SILENT_TH)은 PS가 AXI 레지스터로 설정</a:t>
+              <a:t>분주 클럭은 메인 클럭 / (DIV + 1)</a:t>
             </a:r>
             <a:endParaRPr lang="en-US" sz="2000" dirty="0"/>
           </a:p>
@@ -6134,7 +6236,7 @@
                 <a:ea typeface="Noto Sans CJK KR" pitchFamily="34" charset="-122"/>
                 <a:cs typeface="Noto Sans CJK KR" pitchFamily="34" charset="-120"/>
               </a:rPr>
-              <a:t>(preamble_err_cnt + slot_timeout_cnt + hamming_err_cnt) &gt; FAULT_TH 이면 halt_cmd=1 → 동기 프레임에 실어 전송 (silent_cnt는 표시용으로 합산에서 제외)</a:t>
+              <a:t>수신 샘플링은 비트 구간의 중간 지점에서 1회만 수행</a:t>
             </a:r>
             <a:endParaRPr lang="en-US" sz="2000" dirty="0"/>
           </a:p>
@@ -6230,7 +6332,7 @@
                 <a:ea typeface="Noto Sans CJK KR" pitchFamily="34" charset="-122"/>
                 <a:cs typeface="Noto Sans CJK KR" pitchFamily="34" charset="-120"/>
               </a:rPr>
-              <a:t>Master 고장 처리 흐름도</a:t>
+              <a:t>Master의 고장 처리</a:t>
             </a:r>
             <a:endParaRPr lang="en-US" sz="3600" dirty="0"/>
           </a:p>
@@ -6244,8 +6346,8 @@
         </p:nvSpPr>
         <p:spPr>
           <a:xfrm>
-            <a:off x="548640" y="1188720"/>
-            <a:ext cx="8046720" cy="685800"/>
+            <a:off x="548640" y="1234440"/>
+            <a:ext cx="8046720" cy="2971800"/>
           </a:xfrm>
           <a:prstGeom prst="rect">
             <a:avLst/>
@@ -6259,13 +6361,13 @@
           <a:p>
             <a:pPr marL="342900" indent="-342900">
               <a:spcAft>
-                <a:spcPts val="600"/>
+                <a:spcPts val="1200"/>
               </a:spcAft>
               <a:buSzPct val="100000"/>
               <a:buChar char="•"/>
             </a:pPr>
             <a:r>
-              <a:rPr lang="en-US" sz="1600" dirty="0">
+              <a:rPr lang="en-US" sz="2000" dirty="0">
                 <a:solidFill>
                   <a:srgbClr val="222222"/>
                 </a:solidFill>
@@ -6273,20 +6375,20 @@
                 <a:ea typeface="Noto Sans CJK KR" pitchFamily="34" charset="-122"/>
                 <a:cs typeface="Noto Sans CJK KR" pitchFamily="34" charset="-120"/>
               </a:rPr>
-              <a:t>슬롯마다 프리앰블 → 타이밍 → Hamming 순으로 검사</a:t>
-            </a:r>
-            <a:endParaRPr lang="en-US" sz="1600" dirty="0"/>
+              <a:t>슬롯별 4가지 카운터(preamble_err_cnt, slot_timeout_cnt, hamming_err_cnt, silent_cnt)로 임계치 기반 고장 판정</a:t>
+            </a:r>
+            <a:endParaRPr lang="en-US" sz="2000" dirty="0"/>
           </a:p>
           <a:p>
             <a:pPr marL="342900" indent="-342900">
               <a:spcAft>
-                <a:spcPts val="600"/>
+                <a:spcPts val="1200"/>
               </a:spcAft>
               <a:buSzPct val="100000"/>
               <a:buChar char="•"/>
             </a:pPr>
             <a:r>
-              <a:rPr lang="en-US" sz="1600" dirty="0">
+              <a:rPr lang="en-US" sz="2000" dirty="0">
                 <a:solidFill>
                   <a:srgbClr val="222222"/>
                 </a:solidFill>
@@ -6294,20 +6396,20 @@
                 <a:ea typeface="Noto Sans CJK KR" pitchFamily="34" charset="-122"/>
                 <a:cs typeface="Noto Sans CJK KR" pitchFamily="34" charset="-120"/>
               </a:rPr>
-              <a:t>각 단계의 오류는 해당 카운터를 증가시킴</a:t>
-            </a:r>
-            <a:endParaRPr lang="en-US" sz="1600" dirty="0"/>
+              <a:t>slot_timeout_cnt는 심각한 타이밍/주소 불일치 시 즉시 255로 saturate, 약한 가드 경계 오류 시 +6</a:t>
+            </a:r>
+            <a:endParaRPr lang="en-US" sz="2000" dirty="0"/>
           </a:p>
           <a:p>
             <a:pPr marL="342900" indent="-342900">
               <a:spcAft>
-                <a:spcPts val="600"/>
+                <a:spcPts val="1200"/>
               </a:spcAft>
               <a:buSzPct val="100000"/>
               <a:buChar char="•"/>
             </a:pPr>
             <a:r>
-              <a:rPr lang="en-US" sz="1600" dirty="0">
+              <a:rPr lang="en-US" sz="2000" dirty="0">
                 <a:solidFill>
                   <a:srgbClr val="222222"/>
                 </a:solidFill>
@@ -6315,20 +6417,20 @@
                 <a:ea typeface="Noto Sans CJK KR" pitchFamily="34" charset="-122"/>
                 <a:cs typeface="Noto Sans CJK KR" pitchFamily="34" charset="-120"/>
               </a:rPr>
-              <a:t>누적합이 FAULT_TH를 넘으면 halt_cmd=1, 이후 카운터는 동결됨</a:t>
-            </a:r>
-            <a:endParaRPr lang="en-US" sz="1600" dirty="0"/>
+              <a:t>판정 임곗값(FAULT_TH, SILENT_TH)은 PS가 AXI 레지스터로 설정</a:t>
+            </a:r>
+            <a:endParaRPr lang="en-US" sz="2000" dirty="0"/>
           </a:p>
           <a:p>
             <a:pPr marL="342900" indent="-342900">
               <a:spcAft>
-                <a:spcPts val="600"/>
+                <a:spcPts val="1200"/>
               </a:spcAft>
               <a:buSzPct val="100000"/>
               <a:buChar char="•"/>
             </a:pPr>
             <a:r>
-              <a:rPr lang="en-US" sz="1600" dirty="0">
+              <a:rPr lang="en-US" sz="2000" dirty="0">
                 <a:solidFill>
                   <a:srgbClr val="222222"/>
                 </a:solidFill>
@@ -6336,38 +6438,15 @@
                 <a:ea typeface="Noto Sans CJK KR" pitchFamily="34" charset="-122"/>
                 <a:cs typeface="Noto Sans CJK KR" pitchFamily="34" charset="-120"/>
               </a:rPr>
-              <a:t>halt_cmd는 리셋 전까지 유지되며, 취소 경로는 없음</a:t>
-            </a:r>
-            <a:endParaRPr lang="en-US" sz="1600" dirty="0"/>
-          </a:p>
-        </p:txBody>
-      </p:sp>
-      <p:pic>
-        <p:nvPicPr>
-          <p:cNvPr id="4" name="Image 0" descr="/home/user/SoC_Design_and_Programming/diagrams/section3/zoom/master_fault_flow.png">    </p:cNvPr>
-          <p:cNvPicPr>
-            <a:picLocks noChangeAspect="1"/>
-          </p:cNvPicPr>
-          <p:nvPr/>
-        </p:nvPicPr>
-        <p:blipFill>
-          <a:blip r:embed="rId2"/>
-          <a:srcRect l="0" r="0" t="0" b="0"/>
-          <a:stretch/>
-        </p:blipFill>
-        <p:spPr>
-          <a:xfrm>
-            <a:off x="548640" y="2404499"/>
-            <a:ext cx="8046720" cy="1683242"/>
-          </a:xfrm>
-          <a:prstGeom prst="rect">
-            <a:avLst/>
-          </a:prstGeom>
-        </p:spPr>
-      </p:pic>
-      <p:sp>
-        <p:nvSpPr>
-          <p:cNvPr id="5" name="Text 2"/>
+              <a:t>(preamble_err_cnt + slot_timeout_cnt + hamming_err_cnt) &gt; FAULT_TH 이면 halt_cmd=1 → 동기 프레임에 실어 전송 (silent_cnt는 표시용으로 합산에서 제외)</a:t>
+            </a:r>
+            <a:endParaRPr lang="en-US" sz="2000" dirty="0"/>
+          </a:p>
+        </p:txBody>
+      </p:sp>
+      <p:sp>
+        <p:nvSpPr>
+          <p:cNvPr id="4" name="Text 2"/>
           <p:cNvSpPr/>
           <p:nvPr/>
         </p:nvSpPr>
@@ -6455,7 +6534,7 @@
                 <a:ea typeface="Noto Sans CJK KR" pitchFamily="34" charset="-122"/>
                 <a:cs typeface="Noto Sans CJK KR" pitchFamily="34" charset="-120"/>
               </a:rPr>
-              <a:t>Slave의 고장 처리</a:t>
+              <a:t>Master 고장 처리 흐름도</a:t>
             </a:r>
             <a:endParaRPr lang="en-US" sz="3600" dirty="0"/>
           </a:p>
@@ -6469,8 +6548,8 @@
         </p:nvSpPr>
         <p:spPr>
           <a:xfrm>
-            <a:off x="548640" y="1234440"/>
-            <a:ext cx="8046720" cy="2971800"/>
+            <a:off x="548640" y="1188720"/>
+            <a:ext cx="8046720" cy="685800"/>
           </a:xfrm>
           <a:prstGeom prst="rect">
             <a:avLst/>
@@ -6484,13 +6563,13 @@
           <a:p>
             <a:pPr marL="342900" indent="-342900">
               <a:spcAft>
-                <a:spcPts val="1200"/>
+                <a:spcPts val="600"/>
               </a:spcAft>
               <a:buSzPct val="100000"/>
               <a:buChar char="•"/>
             </a:pPr>
             <a:r>
-              <a:rPr lang="en-US" sz="2000" dirty="0">
+              <a:rPr lang="en-US" sz="1600" dirty="0">
                 <a:solidFill>
                   <a:srgbClr val="222222"/>
                 </a:solidFill>
@@ -6498,20 +6577,20 @@
                 <a:ea typeface="Noto Sans CJK KR" pitchFamily="34" charset="-122"/>
                 <a:cs typeface="Noto Sans CJK KR" pitchFamily="34" charset="-120"/>
               </a:rPr>
-              <a:t>Master broadcast 프레임의 halt_cmd(halt_mask) 필드를 수신하면 해당 슬롯은 송신 중단</a:t>
-            </a:r>
-            <a:endParaRPr lang="en-US" sz="2000" dirty="0"/>
+              <a:t>슬롯마다 프리앰블 → 타이밍 → Hamming 순으로 검사</a:t>
+            </a:r>
+            <a:endParaRPr lang="en-US" sz="1600" dirty="0"/>
           </a:p>
           <a:p>
             <a:pPr marL="342900" indent="-342900">
               <a:spcAft>
-                <a:spcPts val="1200"/>
+                <a:spcPts val="600"/>
               </a:spcAft>
               <a:buSzPct val="100000"/>
               <a:buChar char="•"/>
             </a:pPr>
             <a:r>
-              <a:rPr lang="en-US" sz="2000" dirty="0">
+              <a:rPr lang="en-US" sz="1600" dirty="0">
                 <a:solidFill>
                   <a:srgbClr val="222222"/>
                 </a:solidFill>
@@ -6519,20 +6598,20 @@
                 <a:ea typeface="Noto Sans CJK KR" pitchFamily="34" charset="-122"/>
                 <a:cs typeface="Noto Sans CJK KR" pitchFamily="34" charset="-120"/>
               </a:rPr>
-              <a:t>Master가 다음 broadcast에서 해당 비트를 0으로 보내면 다음 사이클부터 자동으로 재개</a:t>
-            </a:r>
-            <a:endParaRPr lang="en-US" sz="2000" dirty="0"/>
+              <a:t>각 단계의 오류는 해당 카운터를 증가시킴</a:t>
+            </a:r>
+            <a:endParaRPr lang="en-US" sz="1600" dirty="0"/>
           </a:p>
           <a:p>
             <a:pPr marL="342900" indent="-342900">
               <a:spcAft>
-                <a:spcPts val="1200"/>
+                <a:spcPts val="600"/>
               </a:spcAft>
               <a:buSzPct val="100000"/>
               <a:buChar char="•"/>
             </a:pPr>
             <a:r>
-              <a:rPr lang="en-US" sz="2000" dirty="0">
+              <a:rPr lang="en-US" sz="1600" dirty="0">
                 <a:solidFill>
                   <a:srgbClr val="222222"/>
                 </a:solidFill>
@@ -6540,15 +6619,59 @@
                 <a:ea typeface="Noto Sans CJK KR" pitchFamily="34" charset="-122"/>
                 <a:cs typeface="Noto Sans CJK KR" pitchFamily="34" charset="-120"/>
               </a:rPr>
-              <a:t>Slave 자체 감지 고장(tx_overlap, slot_timing_invalid, pl_payload6/7_invalid, rx_ham_2bit)은 플래그로 누적되어 인터럽트 신호만 발생, 별도 조치는 없음</a:t>
-            </a:r>
-            <a:endParaRPr lang="en-US" sz="2000" dirty="0"/>
-          </a:p>
-        </p:txBody>
-      </p:sp>
-      <p:sp>
-        <p:nvSpPr>
-          <p:cNvPr id="4" name="Text 2"/>
+              <a:t>누적합이 FAULT_TH를 넘으면 halt_cmd=1, 이후 카운터는 동결됨</a:t>
+            </a:r>
+            <a:endParaRPr lang="en-US" sz="1600" dirty="0"/>
+          </a:p>
+          <a:p>
+            <a:pPr marL="342900" indent="-342900">
+              <a:spcAft>
+                <a:spcPts val="600"/>
+              </a:spcAft>
+              <a:buSzPct val="100000"/>
+              <a:buChar char="•"/>
+            </a:pPr>
+            <a:r>
+              <a:rPr lang="en-US" sz="1600" dirty="0">
+                <a:solidFill>
+                  <a:srgbClr val="222222"/>
+                </a:solidFill>
+                <a:latin typeface="Noto Sans CJK KR" pitchFamily="34" charset="0"/>
+                <a:ea typeface="Noto Sans CJK KR" pitchFamily="34" charset="-122"/>
+                <a:cs typeface="Noto Sans CJK KR" pitchFamily="34" charset="-120"/>
+              </a:rPr>
+              <a:t>halt_cmd는 리셋 전까지 유지되며, 취소 경로는 없음</a:t>
+            </a:r>
+            <a:endParaRPr lang="en-US" sz="1600" dirty="0"/>
+          </a:p>
+        </p:txBody>
+      </p:sp>
+      <p:pic>
+        <p:nvPicPr>
+          <p:cNvPr id="4" name="Image 0" descr="/home/user/SoC_Design_and_Programming/diagrams/section3/zoom/master_fault_flow.png">    </p:cNvPr>
+          <p:cNvPicPr>
+            <a:picLocks noChangeAspect="1"/>
+          </p:cNvPicPr>
+          <p:nvPr/>
+        </p:nvPicPr>
+        <p:blipFill>
+          <a:blip r:embed="rId2"/>
+          <a:srcRect l="0" r="0" t="0" b="0"/>
+          <a:stretch/>
+        </p:blipFill>
+        <p:spPr>
+          <a:xfrm>
+            <a:off x="548640" y="2404499"/>
+            <a:ext cx="8046720" cy="1683242"/>
+          </a:xfrm>
+          <a:prstGeom prst="rect">
+            <a:avLst/>
+          </a:prstGeom>
+        </p:spPr>
+      </p:pic>
+      <p:sp>
+        <p:nvSpPr>
+          <p:cNvPr id="5" name="Text 2"/>
           <p:cNvSpPr/>
           <p:nvPr/>
         </p:nvSpPr>
@@ -6596,14 +6719,6 @@
 <file path=ppt/slides/slide29.xml><?xml version="1.0" encoding="utf-8"?>
 <p:sld xmlns:a="http://schemas.openxmlformats.org/drawingml/2006/main" xmlns:p="http://schemas.openxmlformats.org/presentationml/2006/main" xmlns:r="http://schemas.openxmlformats.org/officeDocument/2006/relationships">
   <p:cSld>
-    <p:bg>
-      <p:bgPr>
-        <a:solidFill>
-          <a:srgbClr val="F2F2F2"/>
-        </a:solidFill>
-        <a:effectLst/>
-      </p:bgPr>
-    </p:bg>
     <p:spTree>
       <p:nvGrpSpPr>
         <p:cNvPr id="1" name=""/>
@@ -6613,43 +6728,132 @@
       <p:grpSpPr/>
       <p:sp>
         <p:nvSpPr>
-          <p:cNvPr id="2" name="TextBox 1"/>
-          <p:cNvSpPr txBox="1"/>
-          <p:nvPr/>
-        </p:nvSpPr>
-        <p:spPr>
-          <a:xfrm>
-            <a:off x="548640" y="1828800"/>
-            <a:ext cx="8046720" cy="1371600"/>
-          </a:xfrm>
-          <a:prstGeom prst="rect">
-            <a:avLst/>
-          </a:prstGeom>
-          <a:noFill/>
-        </p:spPr>
-        <p:txBody>
-          <a:bodyPr wrap="square">
-            <a:spAutoFit/>
-          </a:bodyPr>
-          <a:lstStyle/>
-          <a:p>
-            <a:pPr algn="l"/>
-            <a:r>
-              <a:rPr sz="4000" b="1">
+          <p:cNvPr id="2" name="Text 0"/>
+          <p:cNvSpPr/>
+          <p:nvPr/>
+        </p:nvSpPr>
+        <p:spPr>
+          <a:xfrm>
+            <a:off x="548640" y="274320"/>
+            <a:ext cx="8046720" cy="777240"/>
+          </a:xfrm>
+          <a:prstGeom prst="rect">
+            <a:avLst/>
+          </a:prstGeom>
+          <a:noFill/>
+          <a:ln/>
+        </p:spPr>
+        <p:txBody>
+          <a:bodyPr wrap="square" lIns="0" tIns="0" rIns="0" bIns="0" rtlCol="0" anchor="ctr"/>
+          <a:lstStyle/>
+          <a:p>
+            <a:pPr indent="0" marL="0">
+              <a:buNone/>
+            </a:pPr>
+            <a:r>
+              <a:rPr lang="en-US" sz="3600" b="1" dirty="0">
                 <a:solidFill>
                   <a:srgbClr val="111111"/>
                 </a:solidFill>
-                <a:latin typeface="Noto Sans CJK KR"/>
-              </a:rPr>
-              <a:t>4. TDMA 통신 시연</a:t>
-            </a:r>
-          </a:p>
-        </p:txBody>
-      </p:sp>
-      <p:sp>
-        <p:nvSpPr>
-          <p:cNvPr id="3" name="TextBox 2"/>
-          <p:cNvSpPr txBox="1"/>
+                <a:latin typeface="Noto Sans CJK KR" pitchFamily="34" charset="0"/>
+                <a:ea typeface="Noto Sans CJK KR" pitchFamily="34" charset="-122"/>
+                <a:cs typeface="Noto Sans CJK KR" pitchFamily="34" charset="-120"/>
+              </a:rPr>
+              <a:t>Slave의 고장 처리</a:t>
+            </a:r>
+            <a:endParaRPr lang="en-US" sz="3600" dirty="0"/>
+          </a:p>
+        </p:txBody>
+      </p:sp>
+      <p:sp>
+        <p:nvSpPr>
+          <p:cNvPr id="3" name="Text 1"/>
+          <p:cNvSpPr/>
+          <p:nvPr/>
+        </p:nvSpPr>
+        <p:spPr>
+          <a:xfrm>
+            <a:off x="548640" y="1234440"/>
+            <a:ext cx="8046720" cy="2971800"/>
+          </a:xfrm>
+          <a:prstGeom prst="rect">
+            <a:avLst/>
+          </a:prstGeom>
+          <a:noFill/>
+          <a:ln/>
+        </p:spPr>
+        <p:txBody>
+          <a:bodyPr wrap="square" rtlCol="0" anchor="t"/>
+          <a:lstStyle/>
+          <a:p>
+            <a:pPr marL="342900" indent="-342900">
+              <a:spcAft>
+                <a:spcPts val="1200"/>
+              </a:spcAft>
+              <a:buSzPct val="100000"/>
+              <a:buChar char="•"/>
+            </a:pPr>
+            <a:r>
+              <a:rPr lang="en-US" sz="2000" dirty="0">
+                <a:solidFill>
+                  <a:srgbClr val="222222"/>
+                </a:solidFill>
+                <a:latin typeface="Noto Sans CJK KR" pitchFamily="34" charset="0"/>
+                <a:ea typeface="Noto Sans CJK KR" pitchFamily="34" charset="-122"/>
+                <a:cs typeface="Noto Sans CJK KR" pitchFamily="34" charset="-120"/>
+              </a:rPr>
+              <a:t>Master broadcast 프레임의 halt_cmd(halt_mask) 필드를 수신하면 해당 슬롯은 송신 중단</a:t>
+            </a:r>
+            <a:endParaRPr lang="en-US" sz="2000" dirty="0"/>
+          </a:p>
+          <a:p>
+            <a:pPr marL="342900" indent="-342900">
+              <a:spcAft>
+                <a:spcPts val="1200"/>
+              </a:spcAft>
+              <a:buSzPct val="100000"/>
+              <a:buChar char="•"/>
+            </a:pPr>
+            <a:r>
+              <a:rPr lang="en-US" sz="2000" dirty="0">
+                <a:solidFill>
+                  <a:srgbClr val="222222"/>
+                </a:solidFill>
+                <a:latin typeface="Noto Sans CJK KR" pitchFamily="34" charset="0"/>
+                <a:ea typeface="Noto Sans CJK KR" pitchFamily="34" charset="-122"/>
+                <a:cs typeface="Noto Sans CJK KR" pitchFamily="34" charset="-120"/>
+              </a:rPr>
+              <a:t>Master가 다음 broadcast에서 해당 비트를 0으로 보내면 다음 사이클부터 자동으로 재개</a:t>
+            </a:r>
+            <a:endParaRPr lang="en-US" sz="2000" dirty="0"/>
+          </a:p>
+          <a:p>
+            <a:pPr marL="342900" indent="-342900">
+              <a:spcAft>
+                <a:spcPts val="1200"/>
+              </a:spcAft>
+              <a:buSzPct val="100000"/>
+              <a:buChar char="•"/>
+            </a:pPr>
+            <a:r>
+              <a:rPr lang="en-US" sz="2000" dirty="0">
+                <a:solidFill>
+                  <a:srgbClr val="222222"/>
+                </a:solidFill>
+                <a:latin typeface="Noto Sans CJK KR" pitchFamily="34" charset="0"/>
+                <a:ea typeface="Noto Sans CJK KR" pitchFamily="34" charset="-122"/>
+                <a:cs typeface="Noto Sans CJK KR" pitchFamily="34" charset="-120"/>
+              </a:rPr>
+              <a:t>Slave 자체 감지 고장(tx_overlap, slot_timing_invalid, pl_payload6/7_invalid, rx_ham_2bit)은 플래그로 누적되어 인터럽트 신호만 발생, 별도 조치는 없음</a:t>
+            </a:r>
+            <a:endParaRPr lang="en-US" sz="2000" dirty="0"/>
+          </a:p>
+        </p:txBody>
+      </p:sp>
+      <p:sp>
+        <p:nvSpPr>
+          <p:cNvPr id="4" name="Text 2"/>
+          <p:cNvSpPr/>
           <p:nvPr/>
         </p:nvSpPr>
         <p:spPr>
@@ -6661,23 +6865,27 @@
             <a:avLst/>
           </a:prstGeom>
           <a:noFill/>
-        </p:spPr>
-        <p:txBody>
-          <a:bodyPr wrap="none">
-            <a:spAutoFit/>
-          </a:bodyPr>
-          <a:lstStyle/>
-          <a:p>
-            <a:pPr algn="r"/>
-            <a:r>
-              <a:rPr sz="1200">
+          <a:ln/>
+        </p:spPr>
+        <p:txBody>
+          <a:bodyPr wrap="square" rtlCol="0" anchor="ctr"/>
+          <a:lstStyle/>
+          <a:p>
+            <a:pPr algn="r" indent="0" marL="0">
+              <a:buNone/>
+            </a:pPr>
+            <a:r>
+              <a:rPr lang="en-US" sz="1200" dirty="0">
                 <a:solidFill>
                   <a:srgbClr val="999999"/>
                 </a:solidFill>
-                <a:latin typeface="Noto Sans CJK KR"/>
+                <a:latin typeface="Noto Sans CJK KR" pitchFamily="34" charset="0"/>
+                <a:ea typeface="Noto Sans CJK KR" pitchFamily="34" charset="-122"/>
+                <a:cs typeface="Noto Sans CJK KR" pitchFamily="34" charset="-120"/>
               </a:rPr>
               <a:t>29</a:t>
             </a:r>
+            <a:endParaRPr lang="en-US" sz="1200" dirty="0"/>
           </a:p>
         </p:txBody>
       </p:sp>
@@ -6902,7 +7110,7 @@
                 <a:ea typeface="Noto Sans CJK KR" pitchFamily="34" charset="-122"/>
                 <a:cs typeface="Noto Sans CJK KR" pitchFamily="34" charset="-120"/>
               </a:rPr>
-              <a:t>4</a:t>
+              <a:t>5</a:t>
             </a:r>
             <a:endParaRPr lang="en-US" sz="1200" dirty="0"/>
           </a:p>
@@ -6964,7 +7172,7 @@
                 </a:solidFill>
                 <a:latin typeface="Noto Sans CJK KR"/>
               </a:rPr>
-              <a:t>5. 마무리</a:t>
+              <a:t>4. TDMA 통신 시연</a:t>
             </a:r>
           </a:p>
         </p:txBody>
@@ -7000,6 +7208,102 @@
                 <a:latin typeface="Noto Sans CJK KR"/>
               </a:rPr>
               <a:t>30</a:t>
+            </a:r>
+          </a:p>
+        </p:txBody>
+      </p:sp>
+    </p:spTree>
+  </p:cSld>
+  <p:clrMapOvr>
+    <a:masterClrMapping/>
+  </p:clrMapOvr>
+</p:sld>
+</file>
+
+<file path=ppt/slides/slide31.xml><?xml version="1.0" encoding="utf-8"?>
+<p:sld xmlns:a="http://schemas.openxmlformats.org/drawingml/2006/main" xmlns:p="http://schemas.openxmlformats.org/presentationml/2006/main" xmlns:r="http://schemas.openxmlformats.org/officeDocument/2006/relationships">
+  <p:cSld>
+    <p:bg>
+      <p:bgPr>
+        <a:solidFill>
+          <a:srgbClr val="F2F2F2"/>
+        </a:solidFill>
+        <a:effectLst/>
+      </p:bgPr>
+    </p:bg>
+    <p:spTree>
+      <p:nvGrpSpPr>
+        <p:cNvPr id="1" name=""/>
+        <p:cNvGrpSpPr/>
+        <p:nvPr/>
+      </p:nvGrpSpPr>
+      <p:grpSpPr/>
+      <p:sp>
+        <p:nvSpPr>
+          <p:cNvPr id="2" name="TextBox 1"/>
+          <p:cNvSpPr txBox="1"/>
+          <p:nvPr/>
+        </p:nvSpPr>
+        <p:spPr>
+          <a:xfrm>
+            <a:off x="548640" y="1828800"/>
+            <a:ext cx="8046720" cy="1371600"/>
+          </a:xfrm>
+          <a:prstGeom prst="rect">
+            <a:avLst/>
+          </a:prstGeom>
+          <a:noFill/>
+        </p:spPr>
+        <p:txBody>
+          <a:bodyPr wrap="square">
+            <a:spAutoFit/>
+          </a:bodyPr>
+          <a:lstStyle/>
+          <a:p>
+            <a:pPr algn="l"/>
+            <a:r>
+              <a:rPr sz="4000" b="1">
+                <a:solidFill>
+                  <a:srgbClr val="111111"/>
+                </a:solidFill>
+                <a:latin typeface="Noto Sans CJK KR"/>
+              </a:rPr>
+              <a:t>5. 마무리</a:t>
+            </a:r>
+          </a:p>
+        </p:txBody>
+      </p:sp>
+      <p:sp>
+        <p:nvSpPr>
+          <p:cNvPr id="3" name="TextBox 2"/>
+          <p:cNvSpPr txBox="1"/>
+          <p:nvPr/>
+        </p:nvSpPr>
+        <p:spPr>
+          <a:xfrm>
+            <a:off x="8503920" y="4754880"/>
+            <a:ext cx="457200" cy="274320"/>
+          </a:xfrm>
+          <a:prstGeom prst="rect">
+            <a:avLst/>
+          </a:prstGeom>
+          <a:noFill/>
+        </p:spPr>
+        <p:txBody>
+          <a:bodyPr wrap="none">
+            <a:spAutoFit/>
+          </a:bodyPr>
+          <a:lstStyle/>
+          <a:p>
+            <a:pPr algn="r"/>
+            <a:r>
+              <a:rPr sz="1200">
+                <a:solidFill>
+                  <a:srgbClr val="999999"/>
+                </a:solidFill>
+                <a:latin typeface="Noto Sans CJK KR"/>
+              </a:rPr>
+              <a:t>31</a:t>
             </a:r>
           </a:p>
         </p:txBody>
@@ -7204,7 +7508,7 @@
                 <a:ea typeface="Noto Sans CJK KR" pitchFamily="34" charset="-122"/>
                 <a:cs typeface="Noto Sans CJK KR" pitchFamily="34" charset="-120"/>
               </a:rPr>
-              <a:t>5</a:t>
+              <a:t>6</a:t>
             </a:r>
             <a:endParaRPr lang="en-US" sz="1200" dirty="0"/>
           </a:p>
@@ -7296,7 +7600,7 @@
                 </a:solidFill>
                 <a:latin typeface="Noto Sans CJK KR"/>
               </a:rPr>
-              <a:t>1.  프로젝트 개요</a:t>
+              <a:t>1.  프로젝트 소개</a:t>
             </a:r>
           </a:p>
           <a:p>
@@ -7416,6 +7720,7 @@
         <a:solidFill>
           <a:srgbClr val="F2F2F2"/>
         </a:solidFill>
+        <a:effectLst/>
       </p:bgPr>
     </p:bg>
     <p:spTree>
@@ -7427,8 +7732,8 @@
       <p:grpSpPr/>
       <p:sp>
         <p:nvSpPr>
-          <p:cNvPr id="2" name="Text 0"/>
-          <p:cNvSpPr/>
+          <p:cNvPr id="2" name="TextBox 1"/>
+          <p:cNvSpPr txBox="1"/>
           <p:nvPr/>
         </p:nvSpPr>
         <p:spPr>
@@ -7440,73 +7745,30 @@
             <a:avLst/>
           </a:prstGeom>
           <a:noFill/>
-          <a:ln/>
-        </p:spPr>
-        <p:txBody>
-          <a:bodyPr wrap="square" rtlCol="0" anchor="ctr"/>
-          <a:lstStyle/>
-          <a:p>
-            <a:pPr algn="l" indent="0" marL="0">
-              <a:buNone/>
-            </a:pPr>
-            <a:r>
-              <a:rPr lang="en-US" sz="4000" b="1" dirty="0">
+        </p:spPr>
+        <p:txBody>
+          <a:bodyPr wrap="square">
+            <a:spAutoFit/>
+          </a:bodyPr>
+          <a:lstStyle/>
+          <a:p>
+            <a:pPr algn="l"/>
+            <a:r>
+              <a:rPr sz="4000" b="1">
                 <a:solidFill>
                   <a:srgbClr val="111111"/>
                 </a:solidFill>
-                <a:latin typeface="Noto Sans CJK KR" pitchFamily="34" charset="0"/>
-                <a:ea typeface="Noto Sans CJK KR" pitchFamily="34" charset="-122"/>
-                <a:cs typeface="Noto Sans CJK KR" pitchFamily="34" charset="-120"/>
-              </a:rPr>
-              <a:t>2. TDMA PHY · Datalink · 프로토콜 정의</a:t>
-            </a:r>
-            <a:endParaRPr lang="en-US" sz="4000" dirty="0"/>
-          </a:p>
-        </p:txBody>
-      </p:sp>
-      <p:sp>
-        <p:nvSpPr>
-          <p:cNvPr id="3" name="Text 1"/>
-          <p:cNvSpPr/>
-          <p:nvPr/>
-        </p:nvSpPr>
-        <p:spPr>
-          <a:xfrm>
-            <a:off x="548640" y="3108960"/>
-            <a:ext cx="8046720" cy="457200"/>
-          </a:xfrm>
-          <a:prstGeom prst="rect">
-            <a:avLst/>
-          </a:prstGeom>
-          <a:noFill/>
-          <a:ln/>
-        </p:spPr>
-        <p:txBody>
-          <a:bodyPr wrap="square" rtlCol="0" anchor="ctr"/>
-          <a:lstStyle/>
-          <a:p>
-            <a:pPr algn="l" indent="0" marL="0">
-              <a:buNone/>
-            </a:pPr>
-            <a:r>
-              <a:rPr lang="en-US" sz="2000" dirty="0">
-                <a:solidFill>
-                  <a:srgbClr val="666666"/>
-                </a:solidFill>
-                <a:latin typeface="Noto Sans CJK KR" pitchFamily="34" charset="0"/>
-                <a:ea typeface="Noto Sans CJK KR" pitchFamily="34" charset="-122"/>
-                <a:cs typeface="Noto Sans CJK KR" pitchFamily="34" charset="-120"/>
-              </a:rPr>
-              <a:t>OSI 7계층을 단축한 TDMA 자체 계층 구조</a:t>
-            </a:r>
-            <a:endParaRPr lang="en-US" sz="2000" dirty="0"/>
-          </a:p>
-        </p:txBody>
-      </p:sp>
-      <p:sp>
-        <p:nvSpPr>
-          <p:cNvPr id="4" name="Text 2"/>
-          <p:cNvSpPr/>
+                <a:latin typeface="Noto Sans CJK KR"/>
+              </a:rPr>
+              <a:t>1. 프로젝트 소개</a:t>
+            </a:r>
+          </a:p>
+        </p:txBody>
+      </p:sp>
+      <p:sp>
+        <p:nvSpPr>
+          <p:cNvPr id="3" name="TextBox 2"/>
+          <p:cNvSpPr txBox="1"/>
           <p:nvPr/>
         </p:nvSpPr>
         <p:spPr>
@@ -7518,27 +7780,23 @@
             <a:avLst/>
           </a:prstGeom>
           <a:noFill/>
-          <a:ln/>
-        </p:spPr>
-        <p:txBody>
-          <a:bodyPr wrap="square" rtlCol="0" anchor="ctr"/>
-          <a:lstStyle/>
-          <a:p>
-            <a:pPr algn="r" indent="0" marL="0">
-              <a:buNone/>
-            </a:pPr>
-            <a:r>
-              <a:rPr lang="en-US" sz="1200" dirty="0">
+        </p:spPr>
+        <p:txBody>
+          <a:bodyPr wrap="none">
+            <a:spAutoFit/>
+          </a:bodyPr>
+          <a:lstStyle/>
+          <a:p>
+            <a:pPr algn="r"/>
+            <a:r>
+              <a:rPr sz="1200">
                 <a:solidFill>
                   <a:srgbClr val="999999"/>
                 </a:solidFill>
-                <a:latin typeface="Noto Sans CJK KR" pitchFamily="34" charset="0"/>
-                <a:ea typeface="Noto Sans CJK KR" pitchFamily="34" charset="-122"/>
-                <a:cs typeface="Noto Sans CJK KR" pitchFamily="34" charset="-120"/>
-              </a:rPr>
-              <a:t>6</a:t>
-            </a:r>
-            <a:endParaRPr lang="en-US" sz="1200" dirty="0"/>
+                <a:latin typeface="Noto Sans CJK KR"/>
+              </a:rPr>
+              <a:t>3</a:t>
+            </a:r>
           </a:p>
         </p:txBody>
       </p:sp>
@@ -7553,6 +7811,13 @@
 <file path=ppt/slides/slide7.xml><?xml version="1.0" encoding="utf-8"?>
 <p:sld xmlns:a="http://schemas.openxmlformats.org/drawingml/2006/main" xmlns:p="http://schemas.openxmlformats.org/presentationml/2006/main" xmlns:r="http://schemas.openxmlformats.org/officeDocument/2006/relationships">
   <p:cSld>
+    <p:bg>
+      <p:bgPr>
+        <a:solidFill>
+          <a:srgbClr val="F2F2F2"/>
+        </a:solidFill>
+      </p:bgPr>
+    </p:bg>
     <p:spTree>
       <p:nvGrpSpPr>
         <p:cNvPr id="1" name=""/>
@@ -7568,8 +7833,8 @@
         </p:nvSpPr>
         <p:spPr>
           <a:xfrm>
-            <a:off x="548640" y="274320"/>
-            <a:ext cx="8046720" cy="777240"/>
+            <a:off x="548640" y="1828800"/>
+            <a:ext cx="8046720" cy="1371600"/>
           </a:xfrm>
           <a:prstGeom prst="rect">
             <a:avLst/>
@@ -7578,14 +7843,14 @@
           <a:ln/>
         </p:spPr>
         <p:txBody>
-          <a:bodyPr wrap="square" lIns="0" tIns="0" rIns="0" bIns="0" rtlCol="0" anchor="ctr"/>
-          <a:lstStyle/>
-          <a:p>
-            <a:pPr indent="0" marL="0">
+          <a:bodyPr wrap="square" rtlCol="0" anchor="ctr"/>
+          <a:lstStyle/>
+          <a:p>
+            <a:pPr algn="l" indent="0" marL="0">
               <a:buNone/>
             </a:pPr>
             <a:r>
-              <a:rPr lang="en-US" sz="3600" b="1" dirty="0">
+              <a:rPr lang="en-US" sz="4000" b="1" dirty="0">
                 <a:solidFill>
                   <a:srgbClr val="111111"/>
                 </a:solidFill>
@@ -7593,9 +7858,9 @@
                 <a:ea typeface="Noto Sans CJK KR" pitchFamily="34" charset="-122"/>
                 <a:cs typeface="Noto Sans CJK KR" pitchFamily="34" charset="-120"/>
               </a:rPr>
-              <a:t>TDMA는 PHY와 DLL만 직접 정의한다</a:t>
-            </a:r>
-            <a:endParaRPr lang="en-US" sz="3600" dirty="0"/>
+              <a:t>2. TDMA PHY · Datalink · 프로토콜 정의</a:t>
+            </a:r>
+            <a:endParaRPr lang="en-US" sz="4000" dirty="0"/>
           </a:p>
         </p:txBody>
       </p:sp>
@@ -7607,8 +7872,8 @@
         </p:nvSpPr>
         <p:spPr>
           <a:xfrm>
-            <a:off x="548640" y="1234440"/>
-            <a:ext cx="8046720" cy="2971800"/>
+            <a:off x="548640" y="3108960"/>
+            <a:ext cx="8046720" cy="457200"/>
           </a:xfrm>
           <a:prstGeom prst="rect">
             <a:avLst/>
@@ -7617,107 +7882,22 @@
           <a:ln/>
         </p:spPr>
         <p:txBody>
-          <a:bodyPr wrap="square" rtlCol="0" anchor="t"/>
-          <a:lstStyle/>
-          <a:p>
-            <a:pPr marL="342900" indent="-342900">
-              <a:spcAft>
-                <a:spcPts val="1200"/>
-              </a:spcAft>
-              <a:buSzPct val="100000"/>
-              <a:buChar char="•"/>
+          <a:bodyPr wrap="square" rtlCol="0" anchor="ctr"/>
+          <a:lstStyle/>
+          <a:p>
+            <a:pPr algn="l" indent="0" marL="0">
+              <a:buNone/>
             </a:pPr>
             <a:r>
               <a:rPr lang="en-US" sz="2000" dirty="0">
                 <a:solidFill>
-                  <a:srgbClr val="222222"/>
-                </a:solidFill>
-                <a:latin typeface="Noto Sans CJK KR" pitchFamily="34" charset="0"/>
-                <a:ea typeface="Noto Sans CJK KR" pitchFamily="34" charset="-122"/>
-                <a:cs typeface="Noto Sans CJK KR" pitchFamily="34" charset="-120"/>
-              </a:rPr>
-              <a:t>OSI 7계층 풀스택의 한계</a:t>
-            </a:r>
-            <a:endParaRPr lang="en-US" sz="2000" dirty="0"/>
-          </a:p>
-          <a:p>
-            <a:pPr lvl="1" marL="685800" indent="-342900">
-              <a:spcAft>
-                <a:spcPts val="800"/>
-              </a:spcAft>
-              <a:buSzPct val="100000"/>
-              <a:buChar char="•"/>
-            </a:pPr>
-            <a:r>
-              <a:rPr lang="en-US" sz="1700" dirty="0">
-                <a:solidFill>
-                  <a:srgbClr val="444444"/>
-                </a:solidFill>
-                <a:latin typeface="Noto Sans CJK KR" pitchFamily="34" charset="0"/>
-                <a:ea typeface="Noto Sans CJK KR" pitchFamily="34" charset="-122"/>
-                <a:cs typeface="Noto Sans CJK KR" pitchFamily="34" charset="-120"/>
-              </a:rPr>
-              <a:t>필드 디바이스(센서·액추에이터) 레벨에서는 과도한 지연·오버헤드 유발</a:t>
-            </a:r>
-            <a:endParaRPr lang="en-US" sz="2000" dirty="0"/>
-          </a:p>
-          <a:p>
-            <a:pPr marL="342900" indent="-342900">
-              <a:spcAft>
-                <a:spcPts val="1200"/>
-              </a:spcAft>
-              <a:buSzPct val="100000"/>
-              <a:buChar char="•"/>
-            </a:pPr>
-            <a:r>
-              <a:rPr lang="en-US" sz="2000" dirty="0">
-                <a:solidFill>
-                  <a:srgbClr val="222222"/>
-                </a:solidFill>
-                <a:latin typeface="Noto Sans CJK KR" pitchFamily="34" charset="0"/>
-                <a:ea typeface="Noto Sans CJK KR" pitchFamily="34" charset="-122"/>
-                <a:cs typeface="Noto Sans CJK KR" pitchFamily="34" charset="-120"/>
-              </a:rPr>
-              <a:t>TDMA의 계층 단축</a:t>
-            </a:r>
-            <a:endParaRPr lang="en-US" sz="2000" dirty="0"/>
-          </a:p>
-          <a:p>
-            <a:pPr lvl="1" marL="685800" indent="-342900">
-              <a:spcAft>
-                <a:spcPts val="800"/>
-              </a:spcAft>
-              <a:buSzPct val="100000"/>
-              <a:buChar char="•"/>
-            </a:pPr>
-            <a:r>
-              <a:rPr lang="en-US" sz="1700" dirty="0">
-                <a:solidFill>
-                  <a:srgbClr val="444444"/>
-                </a:solidFill>
-                <a:latin typeface="Noto Sans CJK KR" pitchFamily="34" charset="0"/>
-                <a:ea typeface="Noto Sans CJK KR" pitchFamily="34" charset="-122"/>
-                <a:cs typeface="Noto Sans CJK KR" pitchFamily="34" charset="-120"/>
-              </a:rPr>
-              <a:t>Application이 Data Link Layer에 직접 접근 → PHY, DLL 두 계층만 직접 정의</a:t>
-            </a:r>
-            <a:endParaRPr lang="en-US" sz="2000" dirty="0"/>
-          </a:p>
-          <a:p>
-            <a:pPr marL="342900" indent="-342900">
-              <a:buSzPct val="100000"/>
-              <a:buChar char="•"/>
-            </a:pPr>
-            <a:r>
-              <a:rPr lang="en-US" sz="2000" dirty="0">
-                <a:solidFill>
-                  <a:srgbClr val="222222"/>
-                </a:solidFill>
-                <a:latin typeface="Noto Sans CJK KR" pitchFamily="34" charset="0"/>
-                <a:ea typeface="Noto Sans CJK KR" pitchFamily="34" charset="-122"/>
-                <a:cs typeface="Noto Sans CJK KR" pitchFamily="34" charset="-120"/>
-              </a:rPr>
-              <a:t>이후 PHY → DLL(프레임/MAC/Flow Control) 순으로 차례로 짚어나간다</a:t>
+                  <a:srgbClr val="666666"/>
+                </a:solidFill>
+                <a:latin typeface="Noto Sans CJK KR" pitchFamily="34" charset="0"/>
+                <a:ea typeface="Noto Sans CJK KR" pitchFamily="34" charset="-122"/>
+                <a:cs typeface="Noto Sans CJK KR" pitchFamily="34" charset="-120"/>
+              </a:rPr>
+              <a:t>OSI 7계층을 단축한 TDMA 자체 계층 구조</a:t>
             </a:r>
             <a:endParaRPr lang="en-US" sz="2000" dirty="0"/>
           </a:p>
@@ -7813,7 +7993,7 @@
                 <a:ea typeface="Noto Sans CJK KR" pitchFamily="34" charset="-122"/>
                 <a:cs typeface="Noto Sans CJK KR" pitchFamily="34" charset="-120"/>
               </a:rPr>
-              <a:t>PHY 정의</a:t>
+              <a:t>TDMA는 PHY와 DLL만 직접 정의한다</a:t>
             </a:r>
             <a:endParaRPr lang="en-US" sz="3600" dirty="0"/>
           </a:p>
@@ -7828,7 +8008,7 @@
         <p:spPr>
           <a:xfrm>
             <a:off x="548640" y="1234440"/>
-            <a:ext cx="3931920" cy="2971800"/>
+            <a:ext cx="8046720" cy="2971800"/>
           </a:xfrm>
           <a:prstGeom prst="rect">
             <a:avLst/>
@@ -7842,13 +8022,13 @@
           <a:p>
             <a:pPr marL="342900" indent="-342900">
               <a:spcAft>
-                <a:spcPts val="1000"/>
+                <a:spcPts val="1200"/>
               </a:spcAft>
               <a:buSzPct val="100000"/>
               <a:buChar char="•"/>
             </a:pPr>
             <a:r>
-              <a:rPr lang="en-US" sz="1900" dirty="0">
+              <a:rPr lang="en-US" sz="2000" dirty="0">
                 <a:solidFill>
                   <a:srgbClr val="222222"/>
                 </a:solidFill>
@@ -7856,20 +8036,20 @@
                 <a:ea typeface="Noto Sans CJK KR" pitchFamily="34" charset="-122"/>
                 <a:cs typeface="Noto Sans CJK KR" pitchFamily="34" charset="-120"/>
               </a:rPr>
-              <a:t>연결 구조</a:t>
-            </a:r>
-            <a:endParaRPr lang="en-US" sz="1900" dirty="0"/>
+              <a:t>OSI 7계층 풀스택의 한계</a:t>
+            </a:r>
+            <a:endParaRPr lang="en-US" sz="2000" dirty="0"/>
           </a:p>
           <a:p>
             <a:pPr lvl="1" marL="685800" indent="-342900">
               <a:spcAft>
-                <a:spcPts val="600"/>
+                <a:spcPts val="800"/>
               </a:spcAft>
               <a:buSzPct val="100000"/>
               <a:buChar char="•"/>
             </a:pPr>
             <a:r>
-              <a:rPr lang="en-US" sz="1600" dirty="0">
+              <a:rPr lang="en-US" sz="1700" dirty="0">
                 <a:solidFill>
                   <a:srgbClr val="444444"/>
                 </a:solidFill>
@@ -7877,20 +8057,20 @@
                 <a:ea typeface="Noto Sans CJK KR" pitchFamily="34" charset="-122"/>
                 <a:cs typeface="Noto Sans CJK KR" pitchFamily="34" charset="-120"/>
               </a:rPr>
-              <a:t>GPIO 단자 기반 공유 버스, Master 1 : Slave N (NODE_CNT)</a:t>
-            </a:r>
-            <a:endParaRPr lang="en-US" sz="1900" dirty="0"/>
+              <a:t>필드 디바이스(센서·액추에이터) 레벨에서는 과도한 지연·오버헤드 유발</a:t>
+            </a:r>
+            <a:endParaRPr lang="en-US" sz="2000" dirty="0"/>
           </a:p>
           <a:p>
             <a:pPr marL="342900" indent="-342900">
               <a:spcAft>
-                <a:spcPts val="1000"/>
+                <a:spcPts val="1200"/>
               </a:spcAft>
               <a:buSzPct val="100000"/>
               <a:buChar char="•"/>
             </a:pPr>
             <a:r>
-              <a:rPr lang="en-US" sz="1900" dirty="0">
+              <a:rPr lang="en-US" sz="2000" dirty="0">
                 <a:solidFill>
                   <a:srgbClr val="222222"/>
                 </a:solidFill>
@@ -7898,20 +8078,20 @@
                 <a:ea typeface="Noto Sans CJK KR" pitchFamily="34" charset="-122"/>
                 <a:cs typeface="Noto Sans CJK KR" pitchFamily="34" charset="-120"/>
               </a:rPr>
-              <a:t>라인 코딩</a:t>
-            </a:r>
-            <a:endParaRPr lang="en-US" sz="1900" dirty="0"/>
+              <a:t>TDMA의 계층 단축</a:t>
+            </a:r>
+            <a:endParaRPr lang="en-US" sz="2000" dirty="0"/>
           </a:p>
           <a:p>
             <a:pPr lvl="1" marL="685800" indent="-342900">
               <a:spcAft>
-                <a:spcPts val="600"/>
+                <a:spcPts val="800"/>
               </a:spcAft>
               <a:buSzPct val="100000"/>
               <a:buChar char="•"/>
             </a:pPr>
             <a:r>
-              <a:rPr lang="en-US" sz="1600" dirty="0">
+              <a:rPr lang="en-US" sz="1700" dirty="0">
                 <a:solidFill>
                   <a:srgbClr val="444444"/>
                 </a:solidFill>
@@ -7919,20 +8099,17 @@
                 <a:ea typeface="Noto Sans CJK KR" pitchFamily="34" charset="-122"/>
                 <a:cs typeface="Noto Sans CJK KR" pitchFamily="34" charset="-120"/>
               </a:rPr>
-              <a:t>NRZ (Non-Return-to-Zero)</a:t>
-            </a:r>
-            <a:endParaRPr lang="en-US" sz="1900" dirty="0"/>
+              <a:t>Application이 Data Link Layer에 직접 접근 → PHY, DLL 두 계층만 직접 정의</a:t>
+            </a:r>
+            <a:endParaRPr lang="en-US" sz="2000" dirty="0"/>
           </a:p>
           <a:p>
             <a:pPr marL="342900" indent="-342900">
-              <a:spcAft>
-                <a:spcPts val="1000"/>
-              </a:spcAft>
               <a:buSzPct val="100000"/>
               <a:buChar char="•"/>
             </a:pPr>
             <a:r>
-              <a:rPr lang="en-US" sz="1900" dirty="0">
+              <a:rPr lang="en-US" sz="2000" dirty="0">
                 <a:solidFill>
                   <a:srgbClr val="222222"/>
                 </a:solidFill>
@@ -7940,95 +8117,15 @@
                 <a:ea typeface="Noto Sans CJK KR" pitchFamily="34" charset="-122"/>
                 <a:cs typeface="Noto Sans CJK KR" pitchFamily="34" charset="-120"/>
               </a:rPr>
-              <a:t>배선</a:t>
-            </a:r>
-            <a:endParaRPr lang="en-US" sz="1900" dirty="0"/>
-          </a:p>
-          <a:p>
-            <a:pPr lvl="1" marL="685800" indent="-342900">
-              <a:buSzPct val="100000"/>
-              <a:buChar char="•"/>
-            </a:pPr>
-            <a:r>
-              <a:rPr lang="en-US" sz="1600" dirty="0">
-                <a:solidFill>
-                  <a:srgbClr val="444444"/>
-                </a:solidFill>
-                <a:latin typeface="Noto Sans CJK KR" pitchFamily="34" charset="0"/>
-                <a:ea typeface="Noto Sans CJK KR" pitchFamily="34" charset="-122"/>
-                <a:cs typeface="Noto Sans CJK KR" pitchFamily="34" charset="-120"/>
-              </a:rPr>
-              <a:t>TX 1선 + RX 1선 + 공통 GND = 3선 — 슬레이브는 자신의 슬롯에만 TX 구동</a:t>
-            </a:r>
-            <a:endParaRPr lang="en-US" sz="1900" dirty="0"/>
-          </a:p>
-        </p:txBody>
-      </p:sp>
-      <p:pic>
-        <p:nvPicPr>
-          <p:cNvPr id="4" name="Image 0" descr="/home/user/SoC_Design_and_Programming/diagrams/phy_wiring.png">    </p:cNvPr>
-          <p:cNvPicPr>
-            <a:picLocks noChangeAspect="1"/>
-          </p:cNvPicPr>
-          <p:nvPr/>
-        </p:nvPicPr>
-        <p:blipFill>
-          <a:blip r:embed="rId2"/>
-          <a:srcRect l="0" r="0" t="0" b="0"/>
-          <a:stretch/>
-        </p:blipFill>
-        <p:spPr>
-          <a:xfrm>
-            <a:off x="4663440" y="1280160"/>
-            <a:ext cx="3931920" cy="3291281"/>
-          </a:xfrm>
-          <a:prstGeom prst="rect">
-            <a:avLst/>
-          </a:prstGeom>
-        </p:spPr>
-      </p:pic>
-      <p:sp>
-        <p:nvSpPr>
-          <p:cNvPr id="5" name="Text 2"/>
-          <p:cNvSpPr/>
-          <p:nvPr/>
-        </p:nvSpPr>
-        <p:spPr>
-          <a:xfrm>
-            <a:off x="4663440" y="4644593"/>
-            <a:ext cx="3931920" cy="274320"/>
-          </a:xfrm>
-          <a:prstGeom prst="rect">
-            <a:avLst/>
-          </a:prstGeom>
-          <a:noFill/>
-          <a:ln/>
-        </p:spPr>
-        <p:txBody>
-          <a:bodyPr wrap="square" rtlCol="0" anchor="ctr"/>
-          <a:lstStyle/>
-          <a:p>
-            <a:pPr algn="ctr" indent="0" marL="0">
-              <a:buNone/>
-            </a:pPr>
-            <a:r>
-              <a:rPr lang="en-US" sz="900" dirty="0">
-                <a:solidFill>
-                  <a:srgbClr val="999999"/>
-                </a:solidFill>
-                <a:latin typeface="Noto Sans CJK KR" pitchFamily="34" charset="0"/>
-                <a:ea typeface="Noto Sans CJK KR" pitchFamily="34" charset="-122"/>
-                <a:cs typeface="Noto Sans CJK KR" pitchFamily="34" charset="-120"/>
-              </a:rPr>
-              <a:t>Master ↔ Slave 1..N 공유 버스 배선 구조</a:t>
-            </a:r>
-            <a:endParaRPr lang="en-US" sz="900" dirty="0"/>
-          </a:p>
-        </p:txBody>
-      </p:sp>
-      <p:sp>
-        <p:nvSpPr>
-          <p:cNvPr id="6" name="Text 3"/>
+              <a:t>이후 PHY → DLL(프레임/MAC/Flow Control) 순으로 차례로 짚어나간다</a:t>
+            </a:r>
+            <a:endParaRPr lang="en-US" sz="2000" dirty="0"/>
+          </a:p>
+        </p:txBody>
+      </p:sp>
+      <p:sp>
+        <p:nvSpPr>
+          <p:cNvPr id="4" name="Text 2"/>
           <p:cNvSpPr/>
           <p:nvPr/>
         </p:nvSpPr>
@@ -8116,7 +8213,7 @@
                 <a:ea typeface="Noto Sans CJK KR" pitchFamily="34" charset="-122"/>
                 <a:cs typeface="Noto Sans CJK KR" pitchFamily="34" charset="-120"/>
               </a:rPr>
-              <a:t>DLL - Slave 프레임 구조</a:t>
+              <a:t>PHY 정의</a:t>
             </a:r>
             <a:endParaRPr lang="en-US" sz="3600" dirty="0"/>
           </a:p>
@@ -8131,7 +8228,7 @@
         <p:spPr>
           <a:xfrm>
             <a:off x="548640" y="1234440"/>
-            <a:ext cx="8046720" cy="1874520"/>
+            <a:ext cx="3931920" cy="2971800"/>
           </a:xfrm>
           <a:prstGeom prst="rect">
             <a:avLst/>
@@ -8145,7 +8242,7 @@
           <a:p>
             <a:pPr marL="342900" indent="-342900">
               <a:spcAft>
-                <a:spcPts val="800"/>
+                <a:spcPts val="1000"/>
               </a:spcAft>
               <a:buSzPct val="100000"/>
               <a:buChar char="•"/>
@@ -8159,7 +8256,7 @@
                 <a:ea typeface="Noto Sans CJK KR" pitchFamily="34" charset="-122"/>
                 <a:cs typeface="Noto Sans CJK KR" pitchFamily="34" charset="-120"/>
               </a:rPr>
-              <a:t>필드 구성 (총 50비트)</a:t>
+              <a:t>연결 구조</a:t>
             </a:r>
             <a:endParaRPr lang="en-US" sz="1900" dirty="0"/>
           </a:p>
@@ -8180,14 +8277,14 @@
                 <a:ea typeface="Noto Sans CJK KR" pitchFamily="34" charset="-122"/>
                 <a:cs typeface="Noto Sans CJK KR" pitchFamily="34" charset="-120"/>
               </a:rPr>
-              <a:t>preamble(8, 0xAA) + slot_id(3) + payload(32) + hamming parity(7)</a:t>
+              <a:t>GPIO 단자 기반 공유 버스, Master 1 : Slave N (NODE_CNT)</a:t>
             </a:r>
             <a:endParaRPr lang="en-US" sz="1900" dirty="0"/>
           </a:p>
           <a:p>
             <a:pPr marL="342900" indent="-342900">
               <a:spcAft>
-                <a:spcPts val="800"/>
+                <a:spcPts val="1000"/>
               </a:spcAft>
               <a:buSzPct val="100000"/>
               <a:buChar char="•"/>
@@ -8201,7 +8298,7 @@
                 <a:ea typeface="Noto Sans CJK KR" pitchFamily="34" charset="-122"/>
                 <a:cs typeface="Noto Sans CJK KR" pitchFamily="34" charset="-120"/>
               </a:rPr>
-              <a:t>에러 검출/정정</a:t>
+              <a:t>라인 코딩</a:t>
             </a:r>
             <a:endParaRPr lang="en-US" sz="1900" dirty="0"/>
           </a:p>
@@ -8222,14 +8319,14 @@
                 <a:ea typeface="Noto Sans CJK KR" pitchFamily="34" charset="-122"/>
                 <a:cs typeface="Noto Sans CJK KR" pitchFamily="34" charset="-120"/>
               </a:rPr>
-              <a:t>SEC-DED 방식 — 1비트 에러는 검출 후 정정, 2비트 에러는 검출만 가능</a:t>
+              <a:t>NRZ (Non-Return-to-Zero)</a:t>
             </a:r>
             <a:endParaRPr lang="en-US" sz="1900" dirty="0"/>
           </a:p>
           <a:p>
             <a:pPr marL="342900" indent="-342900">
               <a:spcAft>
-                <a:spcPts val="800"/>
+                <a:spcPts val="1000"/>
               </a:spcAft>
               <a:buSzPct val="100000"/>
               <a:buChar char="•"/>
@@ -8243,7 +8340,7 @@
                 <a:ea typeface="Noto Sans CJK KR" pitchFamily="34" charset="-122"/>
                 <a:cs typeface="Noto Sans CJK KR" pitchFamily="34" charset="-120"/>
               </a:rPr>
-              <a:t>slot_id의 의미</a:t>
+              <a:t>배선</a:t>
             </a:r>
             <a:endParaRPr lang="en-US" sz="1900" dirty="0"/>
           </a:p>
@@ -8261,7 +8358,7 @@
                 <a:ea typeface="Noto Sans CJK KR" pitchFamily="34" charset="-122"/>
                 <a:cs typeface="Noto Sans CJK KR" pitchFamily="34" charset="-120"/>
               </a:rPr>
-              <a:t>슬레이브 고유 식별자가 아니라 TDMA 슬롯 번호로 운용됨</a:t>
+              <a:t>TX 1선 + RX 1선 + 공통 GND = 3선 — 슬레이브는 자신의 슬롯에만 TX 구동</a:t>
             </a:r>
             <a:endParaRPr lang="en-US" sz="1900" dirty="0"/>
           </a:p>
@@ -8269,7 +8366,7 @@
       </p:sp>
       <p:pic>
         <p:nvPicPr>
-          <p:cNvPr id="4" name="Image 0" descr="/home/user/SoC_Design_and_Programming/diagrams/slave_frame.png">    </p:cNvPr>
+          <p:cNvPr id="4" name="Image 0" descr="/home/user/SoC_Design_and_Programming/diagrams/phy_wiring.png">    </p:cNvPr>
           <p:cNvPicPr>
             <a:picLocks noChangeAspect="1"/>
           </p:cNvPicPr>
@@ -8282,8 +8379,8 @@
         </p:blipFill>
         <p:spPr>
           <a:xfrm>
-            <a:off x="548640" y="3246120"/>
-            <a:ext cx="8046720" cy="563270"/>
+            <a:off x="4663440" y="1280160"/>
+            <a:ext cx="3931920" cy="3291281"/>
           </a:xfrm>
           <a:prstGeom prst="rect">
             <a:avLst/>
@@ -8298,8 +8395,8 @@
         </p:nvSpPr>
         <p:spPr>
           <a:xfrm>
-            <a:off x="548640" y="3900830"/>
-            <a:ext cx="8046720" cy="228600"/>
+            <a:off x="4663440" y="4644593"/>
+            <a:ext cx="3931920" cy="274320"/>
           </a:xfrm>
           <a:prstGeom prst="rect">
             <a:avLst/>
@@ -8323,7 +8420,7 @@
                 <a:ea typeface="Noto Sans CJK KR" pitchFamily="34" charset="-122"/>
                 <a:cs typeface="Noto Sans CJK KR" pitchFamily="34" charset="-120"/>
               </a:rPr>
-              <a:t>Slave 프레임 비트필드 (전송 순서: preamble → slot_id → payload → hamming)</a:t>
+              <a:t>Master ↔ Slave 1..N 공유 버스 배선 구조</a:t>
             </a:r>
             <a:endParaRPr lang="en-US" sz="900" dirty="0"/>
           </a:p>

</xml_diff>

<commit_message>
Unify Slave terminology and halt_cmd naming across slides
- Replace Korean transliteration "슬레이브" with "Slave" in section 2 slides for consistency with section 3
- Add missing "의" particle to "Master의 고장 처리 흐름도" title to match sibling slide titles
- Drop the "(halt_mask)" alias and standardize on halt_cmd everywhere
</commit_message>
<xml_diff>
--- a/presentation_full.pptx
+++ b/presentation_full.pptx
@@ -1403,7 +1403,7 @@
                 <a:ea typeface="Noto Sans CJK KR" pitchFamily="34" charset="-122"/>
                 <a:cs typeface="Noto Sans CJK KR" pitchFamily="34" charset="-120"/>
               </a:rPr>
-              <a:t>슬레이브 고유 식별자가 아니라 TDMA 슬롯 번호로 운용됨</a:t>
+              <a:t>Slave 고유 식별자가 아니라 TDMA 슬롯 번호로 운용됨</a:t>
             </a:r>
             <a:endParaRPr lang="en-US" sz="1900" dirty="0"/>
           </a:p>
@@ -1667,7 +1667,7 @@
                 <a:ea typeface="Noto Sans CJK KR" pitchFamily="34" charset="-122"/>
                 <a:cs typeface="Noto Sans CJK KR" pitchFamily="34" charset="-120"/>
               </a:rPr>
-              <a:t>슬레이브별 1비트 마스크 — err_cnt가 임계치(FAULT_TH) 초과 시 해당 비트 set, 고장 슬레이브 중단 명령</a:t>
+              <a:t>Slave별 1비트 마스크 — err_cnt가 임계치(FAULT_TH) 초과 시 해당 비트 set, 고장 Slave 중단 명령</a:t>
             </a:r>
             <a:endParaRPr lang="en-US" sz="1900" dirty="0"/>
           </a:p>
@@ -6534,7 +6534,7 @@
                 <a:ea typeface="Noto Sans CJK KR" pitchFamily="34" charset="-122"/>
                 <a:cs typeface="Noto Sans CJK KR" pitchFamily="34" charset="-120"/>
               </a:rPr>
-              <a:t>Master 고장 처리 흐름도</a:t>
+              <a:t>Master의 고장 처리 흐름도</a:t>
             </a:r>
             <a:endParaRPr lang="en-US" sz="3600" dirty="0"/>
           </a:p>
@@ -6802,7 +6802,7 @@
                 <a:ea typeface="Noto Sans CJK KR" pitchFamily="34" charset="-122"/>
                 <a:cs typeface="Noto Sans CJK KR" pitchFamily="34" charset="-120"/>
               </a:rPr>
-              <a:t>Master broadcast 프레임의 halt_cmd(halt_mask) 필드를 수신하면 해당 슬롯은 송신 중단</a:t>
+              <a:t>Master broadcast 프레임의 halt_cmd 필드를 수신하면 해당 슬롯은 송신 중단</a:t>
             </a:r>
             <a:endParaRPr lang="en-US" sz="2000" dirty="0"/>
           </a:p>
@@ -8358,7 +8358,7 @@
                 <a:ea typeface="Noto Sans CJK KR" pitchFamily="34" charset="-122"/>
                 <a:cs typeface="Noto Sans CJK KR" pitchFamily="34" charset="-120"/>
               </a:rPr>
-              <a:t>TX 1선 + RX 1선 + 공통 GND = 3선 — 슬레이브는 자신의 슬롯에만 TX 구동</a:t>
+              <a:t>TX 1선 + RX 1선 + 공통 GND = 3선 — Slave는 자신의 슬롯에만 TX 구동</a:t>
             </a:r>
             <a:endParaRPr lang="en-US" sz="1900" dirty="0"/>
           </a:p>

</xml_diff>

<commit_message>
Add consistent subtitles to section dividers 1-4
Section 5 intentionally left without a subtitle as a closing slide.
</commit_message>
<xml_diff>
--- a/presentation_full.pptx
+++ b/presentation_full.pptx
@@ -2477,7 +2477,7 @@
                 <a:ea typeface="Noto Sans CJK KR" pitchFamily="34" charset="-122"/>
                 <a:cs typeface="Noto Sans CJK KR" pitchFamily="34" charset="-120"/>
               </a:rPr>
-              <a:t>시스템의 구현과 설계 특이사항을 다룬다</a:t>
+              <a:t>하드웨어 블록 구성부터 고장 처리 로직까지 구현 세부사항을 짚는다</a:t>
             </a:r>
             <a:endParaRPr lang="en-US" sz="2000" dirty="0"/>
           </a:p>
@@ -7185,6 +7185,40 @@
         </p:nvSpPr>
         <p:spPr>
           <a:xfrm>
+            <a:off x="548640" y="3111120"/>
+            <a:ext cx="8046720" cy="457200"/>
+          </a:xfrm>
+          <a:prstGeom prst="rect">
+            <a:avLst/>
+          </a:prstGeom>
+          <a:noFill/>
+        </p:spPr>
+        <p:txBody>
+          <a:bodyPr wrap="square">
+            <a:spAutoFit/>
+          </a:bodyPr>
+          <a:lstStyle/>
+          <a:p>
+            <a:r>
+              <a:rPr sz="1800">
+                <a:solidFill>
+                  <a:srgbClr val="666666"/>
+                </a:solidFill>
+                <a:latin typeface="Noto Sans CJK KR"/>
+              </a:rPr>
+              <a:t>실제 보드에서 TDMA 통신이 동작하는 과정을 시연한다</a:t>
+            </a:r>
+          </a:p>
+        </p:txBody>
+      </p:sp>
+      <p:sp>
+        <p:nvSpPr>
+          <p:cNvPr id="4" name="TextBox 3"/>
+          <p:cNvSpPr txBox="1"/>
+          <p:nvPr/>
+        </p:nvSpPr>
+        <p:spPr>
+          <a:xfrm>
             <a:off x="8503920" y="4754880"/>
             <a:ext cx="457200" cy="274320"/>
           </a:xfrm>
@@ -7773,6 +7807,40 @@
         </p:nvSpPr>
         <p:spPr>
           <a:xfrm>
+            <a:off x="548640" y="3111120"/>
+            <a:ext cx="8046720" cy="457200"/>
+          </a:xfrm>
+          <a:prstGeom prst="rect">
+            <a:avLst/>
+          </a:prstGeom>
+          <a:noFill/>
+        </p:spPr>
+        <p:txBody>
+          <a:bodyPr wrap="square">
+            <a:spAutoFit/>
+          </a:bodyPr>
+          <a:lstStyle/>
+          <a:p>
+            <a:r>
+              <a:rPr sz="1800">
+                <a:solidFill>
+                  <a:srgbClr val="666666"/>
+                </a:solidFill>
+                <a:latin typeface="Noto Sans CJK KR"/>
+              </a:rPr>
+              <a:t>왜 시간을 나누어 전송해야 하는지, 프로젝트의 목표를 짚는다</a:t>
+            </a:r>
+          </a:p>
+        </p:txBody>
+      </p:sp>
+      <p:sp>
+        <p:nvSpPr>
+          <p:cNvPr id="4" name="TextBox 3"/>
+          <p:cNvSpPr txBox="1"/>
+          <p:nvPr/>
+        </p:nvSpPr>
+        <p:spPr>
+          <a:xfrm>
             <a:off x="8503920" y="4754880"/>
             <a:ext cx="457200" cy="274320"/>
           </a:xfrm>
@@ -7897,7 +7965,7 @@
                 <a:ea typeface="Noto Sans CJK KR" pitchFamily="34" charset="-122"/>
                 <a:cs typeface="Noto Sans CJK KR" pitchFamily="34" charset="-120"/>
               </a:rPr>
-              <a:t>OSI 7계층을 단축한 TDMA 자체 계층 구조</a:t>
+              <a:t>프레임 구조부터 동기화, 흐름 제어까지 통신 규약을 설계한다</a:t>
             </a:r>
             <a:endParaRPr lang="en-US" sz="2000" dirty="0"/>
           </a:p>

</xml_diff>

<commit_message>
Move clock sync slide into section 2 right after MAC/timeslot slide
Clock sync was previously placed in section 3 between Slave detail
slides and fault handling, disconnected from the guard-tick rationale
it explains. Moved it to section 2 immediately after the MAC sync
slide and renamed it "DLL - 클럭 동기" to match sibling slide titles.
</commit_message>
<xml_diff>
--- a/presentation_full.pptx
+++ b/presentation_full.pptx
@@ -2167,7 +2167,7 @@
                 <a:ea typeface="Noto Sans CJK KR" pitchFamily="34" charset="-122"/>
                 <a:cs typeface="Noto Sans CJK KR" pitchFamily="34" charset="-120"/>
               </a:rPr>
-              <a:t>DLL - Flow Control</a:t>
+              <a:t>DLL - 클럭 동기</a:t>
             </a:r>
             <a:endParaRPr lang="en-US" sz="3600" dirty="0"/>
           </a:p>
@@ -2182,7 +2182,7 @@
         <p:spPr>
           <a:xfrm>
             <a:off x="548640" y="1234440"/>
-            <a:ext cx="4023360" cy="2971800"/>
+            <a:ext cx="8046720" cy="2971800"/>
           </a:xfrm>
           <a:prstGeom prst="rect">
             <a:avLst/>
@@ -2210,7 +2210,7 @@
                 <a:ea typeface="Noto Sans CJK KR" pitchFamily="34" charset="-122"/>
                 <a:cs typeface="Noto Sans CJK KR" pitchFamily="34" charset="-120"/>
               </a:rPr>
-              <a:t>1비트 에러</a:t>
+              <a:t>Master·Slave는 클럭을 공유하지 않음</a:t>
             </a:r>
             <a:endParaRPr lang="en-US" sz="2000" dirty="0"/>
           </a:p>
@@ -2231,7 +2231,7 @@
                 <a:ea typeface="Noto Sans CJK KR" pitchFamily="34" charset="-122"/>
                 <a:cs typeface="Noto Sans CJK KR" pitchFamily="34" charset="-120"/>
               </a:rPr>
-              <a:t>Hamming으로 정정하여 정상 데이터로 사용</a:t>
+              <a:t>클럭 오차가 통신에 치명적인 방해 요인 — guard tick만으로는 누적 오차를 막을 수 없음</a:t>
             </a:r>
             <a:endParaRPr lang="en-US" sz="2000" dirty="0"/>
           </a:p>
@@ -2252,7 +2252,7 @@
                 <a:ea typeface="Noto Sans CJK KR" pitchFamily="34" charset="-122"/>
                 <a:cs typeface="Noto Sans CJK KR" pitchFamily="34" charset="-120"/>
               </a:rPr>
-              <a:t>2비트 에러 (정정 불가)</a:t>
+              <a:t>분주 클럭으로 동일 타이밍 가정</a:t>
             </a:r>
             <a:endParaRPr lang="en-US" sz="2000" dirty="0"/>
           </a:p>
@@ -2273,7 +2273,7 @@
                 <a:ea typeface="Noto Sans CJK KR" pitchFamily="34" charset="-122"/>
                 <a:cs typeface="Noto Sans CJK KR" pitchFamily="34" charset="-120"/>
               </a:rPr>
-              <a:t>해당 프레임을 무효 처리하고 폐기, 이전 값 유지</a:t>
+              <a:t>DIV 값을 AXI 레지스터로 설정, Master·Slave 양쪽에 동일한 DIV 값을 쓴다고 가정 — 분주 클럭은 메인 클럭 / (DIV + 1)</a:t>
             </a:r>
             <a:endParaRPr lang="en-US" sz="2000" dirty="0"/>
           </a:p>
@@ -2294,7 +2294,7 @@
                 <a:ea typeface="Noto Sans CJK KR" pitchFamily="34" charset="-122"/>
                 <a:cs typeface="Noto Sans CJK KR" pitchFamily="34" charset="-120"/>
               </a:rPr>
-              <a:t>Implicit Flow Control</a:t>
+              <a:t>샘플링 방식</a:t>
             </a:r>
             <a:endParaRPr lang="en-US" sz="2000" dirty="0"/>
           </a:p>
@@ -2312,38 +2312,15 @@
                 <a:ea typeface="Noto Sans CJK KR" pitchFamily="34" charset="-122"/>
                 <a:cs typeface="Noto Sans CJK KR" pitchFamily="34" charset="-120"/>
               </a:rPr>
-              <a:t>명시적 재전송 요청(ARQ/NACK) 없음 — 다음 TDMA 사이클의 갱신 데이터를 기다림</a:t>
+              <a:t>수신 샘플링은 비트 구간의 중간 지점에서 1회만 수행</a:t>
             </a:r>
             <a:endParaRPr lang="en-US" sz="2000" dirty="0"/>
           </a:p>
         </p:txBody>
       </p:sp>
-      <p:pic>
-        <p:nvPicPr>
-          <p:cNvPr id="4" name="Image 0" descr="/home/user/SoC_Design_and_Programming/diagrams/flow_control.png">    </p:cNvPr>
-          <p:cNvPicPr>
-            <a:picLocks noChangeAspect="1"/>
-          </p:cNvPicPr>
-          <p:nvPr/>
-        </p:nvPicPr>
-        <p:blipFill>
-          <a:blip r:embed="rId2"/>
-          <a:srcRect l="0" r="0" t="0" b="0"/>
-          <a:stretch/>
-        </p:blipFill>
-        <p:spPr>
-          <a:xfrm>
-            <a:off x="5029200" y="1371600"/>
-            <a:ext cx="3200400" cy="2319606"/>
-          </a:xfrm>
-          <a:prstGeom prst="rect">
-            <a:avLst/>
-          </a:prstGeom>
-        </p:spPr>
-      </p:pic>
-      <p:sp>
-        <p:nvSpPr>
-          <p:cNvPr id="5" name="Text 2"/>
+      <p:sp>
+        <p:nvSpPr>
+          <p:cNvPr id="4" name="Text 2"/>
           <p:cNvSpPr/>
           <p:nvPr/>
         </p:nvSpPr>
@@ -2389,6 +2366,270 @@
 </file>
 
 <file path=ppt/slides/slide14.xml><?xml version="1.0" encoding="utf-8"?>
+<p:sld xmlns:a="http://schemas.openxmlformats.org/drawingml/2006/main" xmlns:p="http://schemas.openxmlformats.org/presentationml/2006/main" xmlns:r="http://schemas.openxmlformats.org/officeDocument/2006/relationships">
+  <p:cSld>
+    <p:spTree>
+      <p:nvGrpSpPr>
+        <p:cNvPr id="1" name=""/>
+        <p:cNvGrpSpPr/>
+        <p:nvPr/>
+      </p:nvGrpSpPr>
+      <p:grpSpPr/>
+      <p:sp>
+        <p:nvSpPr>
+          <p:cNvPr id="2" name="Text 0"/>
+          <p:cNvSpPr/>
+          <p:nvPr/>
+        </p:nvSpPr>
+        <p:spPr>
+          <a:xfrm>
+            <a:off x="548640" y="274320"/>
+            <a:ext cx="8046720" cy="777240"/>
+          </a:xfrm>
+          <a:prstGeom prst="rect">
+            <a:avLst/>
+          </a:prstGeom>
+          <a:noFill/>
+          <a:ln/>
+        </p:spPr>
+        <p:txBody>
+          <a:bodyPr wrap="square" lIns="0" tIns="0" rIns="0" bIns="0" rtlCol="0" anchor="ctr"/>
+          <a:lstStyle/>
+          <a:p>
+            <a:pPr indent="0" marL="0">
+              <a:buNone/>
+            </a:pPr>
+            <a:r>
+              <a:rPr lang="en-US" sz="3600" b="1" dirty="0">
+                <a:solidFill>
+                  <a:srgbClr val="111111"/>
+                </a:solidFill>
+                <a:latin typeface="Noto Sans CJK KR" pitchFamily="34" charset="0"/>
+                <a:ea typeface="Noto Sans CJK KR" pitchFamily="34" charset="-122"/>
+                <a:cs typeface="Noto Sans CJK KR" pitchFamily="34" charset="-120"/>
+              </a:rPr>
+              <a:t>DLL - Flow Control</a:t>
+            </a:r>
+            <a:endParaRPr lang="en-US" sz="3600" dirty="0"/>
+          </a:p>
+        </p:txBody>
+      </p:sp>
+      <p:sp>
+        <p:nvSpPr>
+          <p:cNvPr id="3" name="Text 1"/>
+          <p:cNvSpPr/>
+          <p:nvPr/>
+        </p:nvSpPr>
+        <p:spPr>
+          <a:xfrm>
+            <a:off x="548640" y="1234440"/>
+            <a:ext cx="4023360" cy="2971800"/>
+          </a:xfrm>
+          <a:prstGeom prst="rect">
+            <a:avLst/>
+          </a:prstGeom>
+          <a:noFill/>
+          <a:ln/>
+        </p:spPr>
+        <p:txBody>
+          <a:bodyPr wrap="square" rtlCol="0" anchor="t"/>
+          <a:lstStyle/>
+          <a:p>
+            <a:pPr marL="342900" indent="-342900">
+              <a:spcAft>
+                <a:spcPts val="1200"/>
+              </a:spcAft>
+              <a:buSzPct val="100000"/>
+              <a:buChar char="•"/>
+            </a:pPr>
+            <a:r>
+              <a:rPr lang="en-US" sz="2000" dirty="0">
+                <a:solidFill>
+                  <a:srgbClr val="222222"/>
+                </a:solidFill>
+                <a:latin typeface="Noto Sans CJK KR" pitchFamily="34" charset="0"/>
+                <a:ea typeface="Noto Sans CJK KR" pitchFamily="34" charset="-122"/>
+                <a:cs typeface="Noto Sans CJK KR" pitchFamily="34" charset="-120"/>
+              </a:rPr>
+              <a:t>1비트 에러</a:t>
+            </a:r>
+            <a:endParaRPr lang="en-US" sz="2000" dirty="0"/>
+          </a:p>
+          <a:p>
+            <a:pPr lvl="1" marL="685800" indent="-342900">
+              <a:spcAft>
+                <a:spcPts val="800"/>
+              </a:spcAft>
+              <a:buSzPct val="100000"/>
+              <a:buChar char="•"/>
+            </a:pPr>
+            <a:r>
+              <a:rPr lang="en-US" sz="1700" dirty="0">
+                <a:solidFill>
+                  <a:srgbClr val="444444"/>
+                </a:solidFill>
+                <a:latin typeface="Noto Sans CJK KR" pitchFamily="34" charset="0"/>
+                <a:ea typeface="Noto Sans CJK KR" pitchFamily="34" charset="-122"/>
+                <a:cs typeface="Noto Sans CJK KR" pitchFamily="34" charset="-120"/>
+              </a:rPr>
+              <a:t>Hamming으로 정정하여 정상 데이터로 사용</a:t>
+            </a:r>
+            <a:endParaRPr lang="en-US" sz="2000" dirty="0"/>
+          </a:p>
+          <a:p>
+            <a:pPr marL="342900" indent="-342900">
+              <a:spcAft>
+                <a:spcPts val="1200"/>
+              </a:spcAft>
+              <a:buSzPct val="100000"/>
+              <a:buChar char="•"/>
+            </a:pPr>
+            <a:r>
+              <a:rPr lang="en-US" sz="2000" dirty="0">
+                <a:solidFill>
+                  <a:srgbClr val="222222"/>
+                </a:solidFill>
+                <a:latin typeface="Noto Sans CJK KR" pitchFamily="34" charset="0"/>
+                <a:ea typeface="Noto Sans CJK KR" pitchFamily="34" charset="-122"/>
+                <a:cs typeface="Noto Sans CJK KR" pitchFamily="34" charset="-120"/>
+              </a:rPr>
+              <a:t>2비트 에러 (정정 불가)</a:t>
+            </a:r>
+            <a:endParaRPr lang="en-US" sz="2000" dirty="0"/>
+          </a:p>
+          <a:p>
+            <a:pPr lvl="1" marL="685800" indent="-342900">
+              <a:spcAft>
+                <a:spcPts val="800"/>
+              </a:spcAft>
+              <a:buSzPct val="100000"/>
+              <a:buChar char="•"/>
+            </a:pPr>
+            <a:r>
+              <a:rPr lang="en-US" sz="1700" dirty="0">
+                <a:solidFill>
+                  <a:srgbClr val="444444"/>
+                </a:solidFill>
+                <a:latin typeface="Noto Sans CJK KR" pitchFamily="34" charset="0"/>
+                <a:ea typeface="Noto Sans CJK KR" pitchFamily="34" charset="-122"/>
+                <a:cs typeface="Noto Sans CJK KR" pitchFamily="34" charset="-120"/>
+              </a:rPr>
+              <a:t>해당 프레임을 무효 처리하고 폐기, 이전 값 유지</a:t>
+            </a:r>
+            <a:endParaRPr lang="en-US" sz="2000" dirty="0"/>
+          </a:p>
+          <a:p>
+            <a:pPr marL="342900" indent="-342900">
+              <a:spcAft>
+                <a:spcPts val="1200"/>
+              </a:spcAft>
+              <a:buSzPct val="100000"/>
+              <a:buChar char="•"/>
+            </a:pPr>
+            <a:r>
+              <a:rPr lang="en-US" sz="2000" dirty="0">
+                <a:solidFill>
+                  <a:srgbClr val="222222"/>
+                </a:solidFill>
+                <a:latin typeface="Noto Sans CJK KR" pitchFamily="34" charset="0"/>
+                <a:ea typeface="Noto Sans CJK KR" pitchFamily="34" charset="-122"/>
+                <a:cs typeface="Noto Sans CJK KR" pitchFamily="34" charset="-120"/>
+              </a:rPr>
+              <a:t>Implicit Flow Control</a:t>
+            </a:r>
+            <a:endParaRPr lang="en-US" sz="2000" dirty="0"/>
+          </a:p>
+          <a:p>
+            <a:pPr lvl="1" marL="685800" indent="-342900">
+              <a:buSzPct val="100000"/>
+              <a:buChar char="•"/>
+            </a:pPr>
+            <a:r>
+              <a:rPr lang="en-US" sz="1700" dirty="0">
+                <a:solidFill>
+                  <a:srgbClr val="444444"/>
+                </a:solidFill>
+                <a:latin typeface="Noto Sans CJK KR" pitchFamily="34" charset="0"/>
+                <a:ea typeface="Noto Sans CJK KR" pitchFamily="34" charset="-122"/>
+                <a:cs typeface="Noto Sans CJK KR" pitchFamily="34" charset="-120"/>
+              </a:rPr>
+              <a:t>명시적 재전송 요청(ARQ/NACK) 없음 — 다음 TDMA 사이클의 갱신 데이터를 기다림</a:t>
+            </a:r>
+            <a:endParaRPr lang="en-US" sz="2000" dirty="0"/>
+          </a:p>
+        </p:txBody>
+      </p:sp>
+      <p:pic>
+        <p:nvPicPr>
+          <p:cNvPr id="4" name="Image 0" descr="/home/user/SoC_Design_and_Programming/diagrams/flow_control.png">    </p:cNvPr>
+          <p:cNvPicPr>
+            <a:picLocks noChangeAspect="1"/>
+          </p:cNvPicPr>
+          <p:nvPr/>
+        </p:nvPicPr>
+        <p:blipFill>
+          <a:blip r:embed="rId2"/>
+          <a:srcRect l="0" r="0" t="0" b="0"/>
+          <a:stretch/>
+        </p:blipFill>
+        <p:spPr>
+          <a:xfrm>
+            <a:off x="5029200" y="1371600"/>
+            <a:ext cx="3200400" cy="2319606"/>
+          </a:xfrm>
+          <a:prstGeom prst="rect">
+            <a:avLst/>
+          </a:prstGeom>
+        </p:spPr>
+      </p:pic>
+      <p:sp>
+        <p:nvSpPr>
+          <p:cNvPr id="5" name="Text 2"/>
+          <p:cNvSpPr/>
+          <p:nvPr/>
+        </p:nvSpPr>
+        <p:spPr>
+          <a:xfrm>
+            <a:off x="8503920" y="4754880"/>
+            <a:ext cx="457200" cy="274320"/>
+          </a:xfrm>
+          <a:prstGeom prst="rect">
+            <a:avLst/>
+          </a:prstGeom>
+          <a:noFill/>
+          <a:ln/>
+        </p:spPr>
+        <p:txBody>
+          <a:bodyPr wrap="square" rtlCol="0" anchor="ctr"/>
+          <a:lstStyle/>
+          <a:p>
+            <a:pPr algn="r" indent="0" marL="0">
+              <a:buNone/>
+            </a:pPr>
+            <a:r>
+              <a:rPr lang="en-US" sz="1200" dirty="0">
+                <a:solidFill>
+                  <a:srgbClr val="999999"/>
+                </a:solidFill>
+                <a:latin typeface="Noto Sans CJK KR" pitchFamily="34" charset="0"/>
+                <a:ea typeface="Noto Sans CJK KR" pitchFamily="34" charset="-122"/>
+                <a:cs typeface="Noto Sans CJK KR" pitchFamily="34" charset="-120"/>
+              </a:rPr>
+              <a:t>14</a:t>
+            </a:r>
+            <a:endParaRPr lang="en-US" sz="1200" dirty="0"/>
+          </a:p>
+        </p:txBody>
+      </p:sp>
+    </p:spTree>
+  </p:cSld>
+  <p:clrMapOvr>
+    <a:masterClrMapping/>
+  </p:clrMapOvr>
+</p:sld>
+</file>
+
+<file path=ppt/slides/slide15.xml><?xml version="1.0" encoding="utf-8"?>
 <p:sld xmlns:a="http://schemas.openxmlformats.org/drawingml/2006/main" xmlns:p="http://schemas.openxmlformats.org/presentationml/2006/main" xmlns:r="http://schemas.openxmlformats.org/officeDocument/2006/relationships">
   <p:cSld>
     <p:bg>
@@ -2486,189 +2727,6 @@
       <p:sp>
         <p:nvSpPr>
           <p:cNvPr id="4" name="Text 2"/>
-          <p:cNvSpPr/>
-          <p:nvPr/>
-        </p:nvSpPr>
-        <p:spPr>
-          <a:xfrm>
-            <a:off x="8503920" y="4754880"/>
-            <a:ext cx="457200" cy="274320"/>
-          </a:xfrm>
-          <a:prstGeom prst="rect">
-            <a:avLst/>
-          </a:prstGeom>
-          <a:noFill/>
-          <a:ln/>
-        </p:spPr>
-        <p:txBody>
-          <a:bodyPr wrap="square" rtlCol="0" anchor="ctr"/>
-          <a:lstStyle/>
-          <a:p>
-            <a:pPr algn="r" indent="0" marL="0">
-              <a:buNone/>
-            </a:pPr>
-            <a:r>
-              <a:rPr lang="en-US" sz="1200" dirty="0">
-                <a:solidFill>
-                  <a:srgbClr val="999999"/>
-                </a:solidFill>
-                <a:latin typeface="Noto Sans CJK KR" pitchFamily="34" charset="0"/>
-                <a:ea typeface="Noto Sans CJK KR" pitchFamily="34" charset="-122"/>
-                <a:cs typeface="Noto Sans CJK KR" pitchFamily="34" charset="-120"/>
-              </a:rPr>
-              <a:t>14</a:t>
-            </a:r>
-            <a:endParaRPr lang="en-US" sz="1200" dirty="0"/>
-          </a:p>
-        </p:txBody>
-      </p:sp>
-    </p:spTree>
-  </p:cSld>
-  <p:clrMapOvr>
-    <a:masterClrMapping/>
-  </p:clrMapOvr>
-</p:sld>
-</file>
-
-<file path=ppt/slides/slide15.xml><?xml version="1.0" encoding="utf-8"?>
-<p:sld xmlns:a="http://schemas.openxmlformats.org/drawingml/2006/main" xmlns:p="http://schemas.openxmlformats.org/presentationml/2006/main" xmlns:r="http://schemas.openxmlformats.org/officeDocument/2006/relationships">
-  <p:cSld>
-    <p:spTree>
-      <p:nvGrpSpPr>
-        <p:cNvPr id="1" name=""/>
-        <p:cNvGrpSpPr/>
-        <p:nvPr/>
-      </p:nvGrpSpPr>
-      <p:grpSpPr/>
-      <p:sp>
-        <p:nvSpPr>
-          <p:cNvPr id="2" name="Text 0"/>
-          <p:cNvSpPr/>
-          <p:nvPr/>
-        </p:nvSpPr>
-        <p:spPr>
-          <a:xfrm>
-            <a:off x="548640" y="274320"/>
-            <a:ext cx="8046720" cy="777240"/>
-          </a:xfrm>
-          <a:prstGeom prst="rect">
-            <a:avLst/>
-          </a:prstGeom>
-          <a:noFill/>
-          <a:ln/>
-        </p:spPr>
-        <p:txBody>
-          <a:bodyPr wrap="square" lIns="0" tIns="0" rIns="0" bIns="0" rtlCol="0" anchor="ctr"/>
-          <a:lstStyle/>
-          <a:p>
-            <a:pPr indent="0" marL="0">
-              <a:buNone/>
-            </a:pPr>
-            <a:r>
-              <a:rPr lang="en-US" sz="3600" b="1" dirty="0">
-                <a:solidFill>
-                  <a:srgbClr val="111111"/>
-                </a:solidFill>
-                <a:latin typeface="Noto Sans CJK KR" pitchFamily="34" charset="0"/>
-                <a:ea typeface="Noto Sans CJK KR" pitchFamily="34" charset="-122"/>
-                <a:cs typeface="Noto Sans CJK KR" pitchFamily="34" charset="-120"/>
-              </a:rPr>
-              <a:t>Master 전체 구조</a:t>
-            </a:r>
-            <a:endParaRPr lang="en-US" sz="3600" dirty="0"/>
-          </a:p>
-        </p:txBody>
-      </p:sp>
-      <p:sp>
-        <p:nvSpPr>
-          <p:cNvPr id="3" name="Text 1"/>
-          <p:cNvSpPr/>
-          <p:nvPr/>
-        </p:nvSpPr>
-        <p:spPr>
-          <a:xfrm>
-            <a:off x="548640" y="1188720"/>
-            <a:ext cx="8046720" cy="594360"/>
-          </a:xfrm>
-          <a:prstGeom prst="rect">
-            <a:avLst/>
-          </a:prstGeom>
-          <a:noFill/>
-          <a:ln/>
-        </p:spPr>
-        <p:txBody>
-          <a:bodyPr wrap="square" rtlCol="0" anchor="t"/>
-          <a:lstStyle/>
-          <a:p>
-            <a:pPr marL="342900" indent="-342900">
-              <a:spcAft>
-                <a:spcPts val="600"/>
-              </a:spcAft>
-              <a:buSzPct val="100000"/>
-              <a:buChar char="•"/>
-            </a:pPr>
-            <a:r>
-              <a:rPr lang="en-US" sz="1700" dirty="0">
-                <a:solidFill>
-                  <a:srgbClr val="222222"/>
-                </a:solidFill>
-                <a:latin typeface="Noto Sans CJK KR" pitchFamily="34" charset="0"/>
-                <a:ea typeface="Noto Sans CJK KR" pitchFamily="34" charset="-122"/>
-                <a:cs typeface="Noto Sans CJK KR" pitchFamily="34" charset="-120"/>
-              </a:rPr>
-              <a:t>테스트 장치 · PS · PL(Master IP 포함) · GPIO 네 영역으로 구성</a:t>
-            </a:r>
-            <a:endParaRPr lang="en-US" sz="1700" dirty="0"/>
-          </a:p>
-          <a:p>
-            <a:pPr marL="342900" indent="-342900">
-              <a:spcAft>
-                <a:spcPts val="600"/>
-              </a:spcAft>
-              <a:buSzPct val="100000"/>
-              <a:buChar char="•"/>
-            </a:pPr>
-            <a:r>
-              <a:rPr lang="en-US" sz="1700" dirty="0">
-                <a:solidFill>
-                  <a:srgbClr val="222222"/>
-                </a:solidFill>
-                <a:latin typeface="Noto Sans CJK KR" pitchFamily="34" charset="0"/>
-                <a:ea typeface="Noto Sans CJK KR" pitchFamily="34" charset="-122"/>
-                <a:cs typeface="Noto Sans CJK KR" pitchFamily="34" charset="-120"/>
-              </a:rPr>
-              <a:t>GPIO를 통해 Slave와 TX/RX 시리얼로 연결 — 이후 슬라이드에서 블록을 하나씩 확대</a:t>
-            </a:r>
-            <a:endParaRPr lang="en-US" sz="1700" dirty="0"/>
-          </a:p>
-        </p:txBody>
-      </p:sp>
-      <p:pic>
-        <p:nvPicPr>
-          <p:cNvPr id="4" name="Image 0" descr="/home/user/SoC_Design_and_Programming/diagrams/section3/zoom/master_overview.png">    </p:cNvPr>
-          <p:cNvPicPr>
-            <a:picLocks noChangeAspect="1"/>
-          </p:cNvPicPr>
-          <p:nvPr/>
-        </p:nvPicPr>
-        <p:blipFill>
-          <a:blip r:embed="rId2"/>
-          <a:srcRect l="0" r="0" t="0" b="0"/>
-          <a:stretch/>
-        </p:blipFill>
-        <p:spPr>
-          <a:xfrm>
-            <a:off x="548640" y="2061599"/>
-            <a:ext cx="8046720" cy="2186162"/>
-          </a:xfrm>
-          <a:prstGeom prst="rect">
-            <a:avLst/>
-          </a:prstGeom>
-        </p:spPr>
-      </p:pic>
-      <p:sp>
-        <p:nvSpPr>
-          <p:cNvPr id="5" name="Text 2"/>
           <p:cNvSpPr/>
           <p:nvPr/>
         </p:nvSpPr>
@@ -2756,7 +2814,7 @@
                 <a:ea typeface="Noto Sans CJK KR" pitchFamily="34" charset="-122"/>
                 <a:cs typeface="Noto Sans CJK KR" pitchFamily="34" charset="-120"/>
               </a:rPr>
-              <a:t>Master - GPIO 확대</a:t>
+              <a:t>Master 전체 구조</a:t>
             </a:r>
             <a:endParaRPr lang="en-US" sz="3600" dirty="0"/>
           </a:p>
@@ -2770,8 +2828,8 @@
         </p:nvSpPr>
         <p:spPr>
           <a:xfrm>
-            <a:off x="548640" y="1234440"/>
-            <a:ext cx="4023360" cy="2971800"/>
+            <a:off x="548640" y="1188720"/>
+            <a:ext cx="8046720" cy="594360"/>
           </a:xfrm>
           <a:prstGeom prst="rect">
             <a:avLst/>
@@ -2785,13 +2843,13 @@
           <a:p>
             <a:pPr marL="342900" indent="-342900">
               <a:spcAft>
-                <a:spcPts val="1000"/>
+                <a:spcPts val="600"/>
               </a:spcAft>
               <a:buSzPct val="100000"/>
               <a:buChar char="•"/>
             </a:pPr>
             <a:r>
-              <a:rPr lang="en-US" sz="1800" dirty="0">
+              <a:rPr lang="en-US" sz="1700" dirty="0">
                 <a:solidFill>
                   <a:srgbClr val="222222"/>
                 </a:solidFill>
@@ -2799,20 +2857,20 @@
                 <a:ea typeface="Noto Sans CJK KR" pitchFamily="34" charset="-122"/>
                 <a:cs typeface="Noto Sans CJK KR" pitchFamily="34" charset="-120"/>
               </a:rPr>
-              <a:t>GND / RX 포트 / TX 포트로 구성</a:t>
-            </a:r>
-            <a:endParaRPr lang="en-US" sz="1800" dirty="0"/>
+              <a:t>테스트 장치 · PS · PL(Master IP 포함) · GPIO 네 영역으로 구성</a:t>
+            </a:r>
+            <a:endParaRPr lang="en-US" sz="1700" dirty="0"/>
           </a:p>
           <a:p>
             <a:pPr marL="342900" indent="-342900">
               <a:spcAft>
-                <a:spcPts val="1000"/>
+                <a:spcPts val="600"/>
               </a:spcAft>
               <a:buSzPct val="100000"/>
               <a:buChar char="•"/>
             </a:pPr>
             <a:r>
-              <a:rPr lang="en-US" sz="1800" dirty="0">
+              <a:rPr lang="en-US" sz="1700" dirty="0">
                 <a:solidFill>
                   <a:srgbClr val="222222"/>
                 </a:solidFill>
@@ -2820,15 +2878,15 @@
                 <a:ea typeface="Noto Sans CJK KR" pitchFamily="34" charset="-122"/>
                 <a:cs typeface="Noto Sans CJK KR" pitchFamily="34" charset="-120"/>
               </a:rPr>
-              <a:t>TX·RX는 PL(Master IP)과 Slave 사이를 잇는 물리 연결 — 외부 장치-PS-PL 경로와는 분리된 통신 채널</a:t>
-            </a:r>
-            <a:endParaRPr lang="en-US" sz="1800" dirty="0"/>
+              <a:t>GPIO를 통해 Slave와 TX/RX 시리얼로 연결 — 이후 슬라이드에서 블록을 하나씩 확대</a:t>
+            </a:r>
+            <a:endParaRPr lang="en-US" sz="1700" dirty="0"/>
           </a:p>
         </p:txBody>
       </p:sp>
       <p:pic>
         <p:nvPicPr>
-          <p:cNvPr id="4" name="Image 0" descr="/home/user/SoC_Design_and_Programming/diagrams/section3/zoom/m_gpio.png">    </p:cNvPr>
+          <p:cNvPr id="4" name="Image 0" descr="/home/user/SoC_Design_and_Programming/diagrams/section3/zoom/master_overview.png">    </p:cNvPr>
           <p:cNvPicPr>
             <a:picLocks noChangeAspect="1"/>
           </p:cNvPicPr>
@@ -2841,8 +2899,8 @@
         </p:blipFill>
         <p:spPr>
           <a:xfrm>
-            <a:off x="4846320" y="1916974"/>
-            <a:ext cx="3749040" cy="1606731"/>
+            <a:off x="548640" y="2061599"/>
+            <a:ext cx="8046720" cy="2186162"/>
           </a:xfrm>
           <a:prstGeom prst="rect">
             <a:avLst/>
@@ -2939,7 +2997,7 @@
                 <a:ea typeface="Noto Sans CJK KR" pitchFamily="34" charset="-122"/>
                 <a:cs typeface="Noto Sans CJK KR" pitchFamily="34" charset="-120"/>
               </a:rPr>
-              <a:t>Master - PS 확대</a:t>
+              <a:t>Master - GPIO 확대</a:t>
             </a:r>
             <a:endParaRPr lang="en-US" sz="3600" dirty="0"/>
           </a:p>
@@ -2953,8 +3011,8 @@
         </p:nvSpPr>
         <p:spPr>
           <a:xfrm>
-            <a:off x="548640" y="1188720"/>
-            <a:ext cx="8046720" cy="594360"/>
+            <a:off x="548640" y="1234440"/>
+            <a:ext cx="4023360" cy="2971800"/>
           </a:xfrm>
           <a:prstGeom prst="rect">
             <a:avLst/>
@@ -2968,13 +3026,13 @@
           <a:p>
             <a:pPr marL="342900" indent="-342900">
               <a:spcAft>
-                <a:spcPts val="600"/>
+                <a:spcPts val="1000"/>
               </a:spcAft>
               <a:buSzPct val="100000"/>
               <a:buChar char="•"/>
             </a:pPr>
             <a:r>
-              <a:rPr lang="en-US" sz="1700" dirty="0">
+              <a:rPr lang="en-US" sz="1800" dirty="0">
                 <a:solidFill>
                   <a:srgbClr val="222222"/>
                 </a:solidFill>
@@ -2982,20 +3040,20 @@
                 <a:ea typeface="Noto Sans CJK KR" pitchFamily="34" charset="-122"/>
                 <a:cs typeface="Noto Sans CJK KR" pitchFamily="34" charset="-120"/>
               </a:rPr>
-              <a:t>외부 테스트 장치에서 초깃값을 입력받아 Master를 초기 구동</a:t>
-            </a:r>
-            <a:endParaRPr lang="en-US" sz="1700" dirty="0"/>
+              <a:t>GND / RX 포트 / TX 포트로 구성</a:t>
+            </a:r>
+            <a:endParaRPr lang="en-US" sz="1800" dirty="0"/>
           </a:p>
           <a:p>
             <a:pPr marL="342900" indent="-342900">
               <a:spcAft>
-                <a:spcPts val="600"/>
+                <a:spcPts val="1000"/>
               </a:spcAft>
               <a:buSzPct val="100000"/>
               <a:buChar char="•"/>
             </a:pPr>
             <a:r>
-              <a:rPr lang="en-US" sz="1700" dirty="0">
+              <a:rPr lang="en-US" sz="1800" dirty="0">
                 <a:solidFill>
                   <a:srgbClr val="222222"/>
                 </a:solidFill>
@@ -3003,15 +3061,15 @@
                 <a:ea typeface="Noto Sans CJK KR" pitchFamily="34" charset="-122"/>
                 <a:cs typeface="Noto Sans CJK KR" pitchFamily="34" charset="-120"/>
               </a:rPr>
-              <a:t>구동 중인 Master 값을 주기적으로 읽고, Master가 발생시키는 인터럽트를 수신</a:t>
-            </a:r>
-            <a:endParaRPr lang="en-US" sz="1700" dirty="0"/>
+              <a:t>TX·RX는 PL(Master IP)과 Slave 사이를 잇는 물리 연결 — 외부 장치-PS-PL 경로와는 분리된 통신 채널</a:t>
+            </a:r>
+            <a:endParaRPr lang="en-US" sz="1800" dirty="0"/>
           </a:p>
         </p:txBody>
       </p:sp>
       <p:pic>
         <p:nvPicPr>
-          <p:cNvPr id="4" name="Image 0" descr="/home/user/SoC_Design_and_Programming/diagrams/section3/zoom/m_ps.png">    </p:cNvPr>
+          <p:cNvPr id="4" name="Image 0" descr="/home/user/SoC_Design_and_Programming/diagrams/section3/zoom/m_gpio.png">    </p:cNvPr>
           <p:cNvPicPr>
             <a:picLocks noChangeAspect="1"/>
           </p:cNvPicPr>
@@ -3024,8 +3082,8 @@
         </p:blipFill>
         <p:spPr>
           <a:xfrm>
-            <a:off x="745187" y="1783080"/>
-            <a:ext cx="7653626" cy="2743200"/>
+            <a:off x="4846320" y="1916974"/>
+            <a:ext cx="3749040" cy="1606731"/>
           </a:xfrm>
           <a:prstGeom prst="rect">
             <a:avLst/>
@@ -3122,7 +3180,7 @@
                 <a:ea typeface="Noto Sans CJK KR" pitchFamily="34" charset="-122"/>
                 <a:cs typeface="Noto Sans CJK KR" pitchFamily="34" charset="-120"/>
               </a:rPr>
-              <a:t>Master - PL 확대</a:t>
+              <a:t>Master - PS 확대</a:t>
             </a:r>
             <a:endParaRPr lang="en-US" sz="3600" dirty="0"/>
           </a:p>
@@ -3136,8 +3194,8 @@
         </p:nvSpPr>
         <p:spPr>
           <a:xfrm>
-            <a:off x="548640" y="1234440"/>
-            <a:ext cx="4023360" cy="2971800"/>
+            <a:off x="548640" y="1188720"/>
+            <a:ext cx="8046720" cy="594360"/>
           </a:xfrm>
           <a:prstGeom prst="rect">
             <a:avLst/>
@@ -3151,13 +3209,13 @@
           <a:p>
             <a:pPr marL="342900" indent="-342900">
               <a:spcAft>
-                <a:spcPts val="1000"/>
+                <a:spcPts val="600"/>
               </a:spcAft>
               <a:buSzPct val="100000"/>
               <a:buChar char="•"/>
             </a:pPr>
             <a:r>
-              <a:rPr lang="en-US" sz="1800" dirty="0">
+              <a:rPr lang="en-US" sz="1700" dirty="0">
                 <a:solidFill>
                   <a:srgbClr val="222222"/>
                 </a:solidFill>
@@ -3165,20 +3223,20 @@
                 <a:ea typeface="Noto Sans CJK KR" pitchFamily="34" charset="-122"/>
                 <a:cs typeface="Noto Sans CJK KR" pitchFamily="34" charset="-120"/>
               </a:rPr>
-              <a:t>LED · 푸시버튼 · DIP 스위치 · 7-seg와 Master IP로 보드 자체의 입출력 구성</a:t>
-            </a:r>
-            <a:endParaRPr lang="en-US" sz="1800" dirty="0"/>
+              <a:t>외부 테스트 장치에서 초깃값을 입력받아 Master를 초기 구동</a:t>
+            </a:r>
+            <a:endParaRPr lang="en-US" sz="1700" dirty="0"/>
           </a:p>
           <a:p>
             <a:pPr marL="342900" indent="-342900">
               <a:spcAft>
-                <a:spcPts val="1000"/>
+                <a:spcPts val="600"/>
               </a:spcAft>
               <a:buSzPct val="100000"/>
               <a:buChar char="•"/>
             </a:pPr>
             <a:r>
-              <a:rPr lang="en-US" sz="1800" dirty="0">
+              <a:rPr lang="en-US" sz="1700" dirty="0">
                 <a:solidFill>
                   <a:srgbClr val="222222"/>
                 </a:solidFill>
@@ -3186,36 +3244,15 @@
                 <a:ea typeface="Noto Sans CJK KR" pitchFamily="34" charset="-122"/>
                 <a:cs typeface="Noto Sans CJK KR" pitchFamily="34" charset="-120"/>
               </a:rPr>
-              <a:t>LED는 RX/TX 이진 신호를 그대로 받아 통신 상태를 표시</a:t>
-            </a:r>
-            <a:endParaRPr lang="en-US" sz="1800" dirty="0"/>
-          </a:p>
-          <a:p>
-            <a:pPr marL="342900" indent="-342900">
-              <a:spcAft>
-                <a:spcPts val="1000"/>
-              </a:spcAft>
-              <a:buSzPct val="100000"/>
-              <a:buChar char="•"/>
-            </a:pPr>
-            <a:r>
-              <a:rPr lang="en-US" sz="1800" dirty="0">
-                <a:solidFill>
-                  <a:srgbClr val="222222"/>
-                </a:solidFill>
-                <a:latin typeface="Noto Sans CJK KR" pitchFamily="34" charset="0"/>
-                <a:ea typeface="Noto Sans CJK KR" pitchFamily="34" charset="-122"/>
-                <a:cs typeface="Noto Sans CJK KR" pitchFamily="34" charset="-120"/>
-              </a:rPr>
-              <a:t>DIP 스위치·7-seg는 슬롯별 통신 상태와 수신 데이터를 출력 — Master IP가 이들을 조율</a:t>
-            </a:r>
-            <a:endParaRPr lang="en-US" sz="1800" dirty="0"/>
+              <a:t>구동 중인 Master 값을 주기적으로 읽고, Master가 발생시키는 인터럽트를 수신</a:t>
+            </a:r>
+            <a:endParaRPr lang="en-US" sz="1700" dirty="0"/>
           </a:p>
         </p:txBody>
       </p:sp>
       <p:pic>
         <p:nvPicPr>
-          <p:cNvPr id="4" name="Image 0" descr="/home/user/SoC_Design_and_Programming/diagrams/section3/zoom/m_pl.png">    </p:cNvPr>
+          <p:cNvPr id="4" name="Image 0" descr="/home/user/SoC_Design_and_Programming/diagrams/section3/zoom/m_ps.png">    </p:cNvPr>
           <p:cNvPicPr>
             <a:picLocks noChangeAspect="1"/>
           </p:cNvPicPr>
@@ -3228,8 +3265,8 @@
         </p:blipFill>
         <p:spPr>
           <a:xfrm>
-            <a:off x="4846320" y="1653968"/>
-            <a:ext cx="3749040" cy="2132745"/>
+            <a:off x="745187" y="1783080"/>
+            <a:ext cx="7653626" cy="2743200"/>
           </a:xfrm>
           <a:prstGeom prst="rect">
             <a:avLst/>
@@ -3326,7 +3363,7 @@
                 <a:ea typeface="Noto Sans CJK KR" pitchFamily="34" charset="-122"/>
                 <a:cs typeface="Noto Sans CJK KR" pitchFamily="34" charset="-120"/>
               </a:rPr>
-              <a:t>Master - Master IP 확대</a:t>
+              <a:t>Master - PL 확대</a:t>
             </a:r>
             <a:endParaRPr lang="en-US" sz="3600" dirty="0"/>
           </a:p>
@@ -3340,8 +3377,8 @@
         </p:nvSpPr>
         <p:spPr>
           <a:xfrm>
-            <a:off x="548640" y="1188720"/>
-            <a:ext cx="8046720" cy="594360"/>
+            <a:off x="548640" y="1234440"/>
+            <a:ext cx="4023360" cy="2971800"/>
           </a:xfrm>
           <a:prstGeom prst="rect">
             <a:avLst/>
@@ -3355,13 +3392,13 @@
           <a:p>
             <a:pPr marL="342900" indent="-342900">
               <a:spcAft>
-                <a:spcPts val="600"/>
+                <a:spcPts val="1000"/>
               </a:spcAft>
               <a:buSzPct val="100000"/>
               <a:buChar char="•"/>
             </a:pPr>
             <a:r>
-              <a:rPr lang="en-US" sz="1700" dirty="0">
+              <a:rPr lang="en-US" sz="1800" dirty="0">
                 <a:solidFill>
                   <a:srgbClr val="222222"/>
                 </a:solidFill>
@@ -3369,20 +3406,20 @@
                 <a:ea typeface="Noto Sans CJK KR" pitchFamily="34" charset="-122"/>
                 <a:cs typeface="Noto Sans CJK KR" pitchFamily="34" charset="-120"/>
               </a:rPr>
-              <a:t>PS에서 설정값을 받아 동기 메시지를 송신, 각 Slave의 응답을 수신</a:t>
-            </a:r>
-            <a:endParaRPr lang="en-US" sz="1700" dirty="0"/>
+              <a:t>LED · 푸시버튼 · DIP 스위치 · 7-seg와 Master IP로 보드 자체의 입출력 구성</a:t>
+            </a:r>
+            <a:endParaRPr lang="en-US" sz="1800" dirty="0"/>
           </a:p>
           <a:p>
             <a:pPr marL="342900" indent="-342900">
               <a:spcAft>
-                <a:spcPts val="600"/>
+                <a:spcPts val="1000"/>
               </a:spcAft>
               <a:buSzPct val="100000"/>
               <a:buChar char="•"/>
             </a:pPr>
             <a:r>
-              <a:rPr lang="en-US" sz="1700" dirty="0">
+              <a:rPr lang="en-US" sz="1800" dirty="0">
                 <a:solidFill>
                   <a:srgbClr val="222222"/>
                 </a:solidFill>
@@ -3390,15 +3427,36 @@
                 <a:ea typeface="Noto Sans CJK KR" pitchFamily="34" charset="-122"/>
                 <a:cs typeface="Noto Sans CJK KR" pitchFamily="34" charset="-120"/>
               </a:rPr>
-              <a:t>에러·데이터 전송 여부·형식·슬롯 침범 여부를 확인해 내부에서 고장 처리 후 PS에 보고</a:t>
-            </a:r>
-            <a:endParaRPr lang="en-US" sz="1700" dirty="0"/>
+              <a:t>LED는 RX/TX 이진 신호를 그대로 받아 통신 상태를 표시</a:t>
+            </a:r>
+            <a:endParaRPr lang="en-US" sz="1800" dirty="0"/>
+          </a:p>
+          <a:p>
+            <a:pPr marL="342900" indent="-342900">
+              <a:spcAft>
+                <a:spcPts val="1000"/>
+              </a:spcAft>
+              <a:buSzPct val="100000"/>
+              <a:buChar char="•"/>
+            </a:pPr>
+            <a:r>
+              <a:rPr lang="en-US" sz="1800" dirty="0">
+                <a:solidFill>
+                  <a:srgbClr val="222222"/>
+                </a:solidFill>
+                <a:latin typeface="Noto Sans CJK KR" pitchFamily="34" charset="0"/>
+                <a:ea typeface="Noto Sans CJK KR" pitchFamily="34" charset="-122"/>
+                <a:cs typeface="Noto Sans CJK KR" pitchFamily="34" charset="-120"/>
+              </a:rPr>
+              <a:t>DIP 스위치·7-seg는 슬롯별 통신 상태와 수신 데이터를 출력 — Master IP가 이들을 조율</a:t>
+            </a:r>
+            <a:endParaRPr lang="en-US" sz="1800" dirty="0"/>
           </a:p>
         </p:txBody>
       </p:sp>
       <p:pic>
         <p:nvPicPr>
-          <p:cNvPr id="4" name="Image 0" descr="/home/user/SoC_Design_and_Programming/diagrams/section3/zoom/m_masterip.png">    </p:cNvPr>
+          <p:cNvPr id="4" name="Image 0" descr="/home/user/SoC_Design_and_Programming/diagrams/section3/zoom/m_pl.png">    </p:cNvPr>
           <p:cNvPicPr>
             <a:picLocks noChangeAspect="1"/>
           </p:cNvPicPr>
@@ -3411,8 +3469,8 @@
         </p:blipFill>
         <p:spPr>
           <a:xfrm>
-            <a:off x="548640" y="2087258"/>
-            <a:ext cx="8046720" cy="2134844"/>
+            <a:off x="4846320" y="1653968"/>
+            <a:ext cx="3749040" cy="2132745"/>
           </a:xfrm>
           <a:prstGeom prst="rect">
             <a:avLst/>
@@ -3801,7 +3859,7 @@
                 <a:ea typeface="Noto Sans CJK KR" pitchFamily="34" charset="-122"/>
                 <a:cs typeface="Noto Sans CJK KR" pitchFamily="34" charset="-120"/>
               </a:rPr>
-              <a:t>Slave 전체 구조</a:t>
+              <a:t>Master - Master IP 확대</a:t>
             </a:r>
             <a:endParaRPr lang="en-US" sz="3600" dirty="0"/>
           </a:p>
@@ -3844,7 +3902,7 @@
                 <a:ea typeface="Noto Sans CJK KR" pitchFamily="34" charset="-122"/>
                 <a:cs typeface="Noto Sans CJK KR" pitchFamily="34" charset="-120"/>
               </a:rPr>
-              <a:t>GPIO · PL(Slave IP 포함) 두 영역으로 구성</a:t>
+              <a:t>PS에서 설정값을 받아 동기 메시지를 송신, 각 Slave의 응답을 수신</a:t>
             </a:r>
             <a:endParaRPr lang="en-US" sz="1700" dirty="0"/>
           </a:p>
@@ -3865,7 +3923,7 @@
                 <a:ea typeface="Noto Sans CJK KR" pitchFamily="34" charset="-122"/>
                 <a:cs typeface="Noto Sans CJK KR" pitchFamily="34" charset="-120"/>
               </a:rPr>
-              <a:t>GPIO를 통해 Master와 TX/RX 시리얼로 연결</a:t>
+              <a:t>에러·데이터 전송 여부·형식·슬롯 침범 여부를 확인해 내부에서 고장 처리 후 PS에 보고</a:t>
             </a:r>
             <a:endParaRPr lang="en-US" sz="1700" dirty="0"/>
           </a:p>
@@ -3873,7 +3931,7 @@
       </p:sp>
       <p:pic>
         <p:nvPicPr>
-          <p:cNvPr id="4" name="Image 0" descr="/home/user/SoC_Design_and_Programming/diagrams/section3/zoom/slave_overview.png">    </p:cNvPr>
+          <p:cNvPr id="4" name="Image 0" descr="/home/user/SoC_Design_and_Programming/diagrams/section3/zoom/m_masterip.png">    </p:cNvPr>
           <p:cNvPicPr>
             <a:picLocks noChangeAspect="1"/>
           </p:cNvPicPr>
@@ -3886,8 +3944,8 @@
         </p:blipFill>
         <p:spPr>
           <a:xfrm>
-            <a:off x="636404" y="1783080"/>
-            <a:ext cx="7871192" cy="2743200"/>
+            <a:off x="548640" y="2087258"/>
+            <a:ext cx="8046720" cy="2134844"/>
           </a:xfrm>
           <a:prstGeom prst="rect">
             <a:avLst/>
@@ -3984,7 +4042,7 @@
                 <a:ea typeface="Noto Sans CJK KR" pitchFamily="34" charset="-122"/>
                 <a:cs typeface="Noto Sans CJK KR" pitchFamily="34" charset="-120"/>
               </a:rPr>
-              <a:t>Slave - GPIO 확대</a:t>
+              <a:t>Slave 전체 구조</a:t>
             </a:r>
             <a:endParaRPr lang="en-US" sz="3600" dirty="0"/>
           </a:p>
@@ -3998,8 +4056,8 @@
         </p:nvSpPr>
         <p:spPr>
           <a:xfrm>
-            <a:off x="548640" y="1234440"/>
-            <a:ext cx="4023360" cy="2971800"/>
+            <a:off x="548640" y="1188720"/>
+            <a:ext cx="8046720" cy="594360"/>
           </a:xfrm>
           <a:prstGeom prst="rect">
             <a:avLst/>
@@ -4013,13 +4071,13 @@
           <a:p>
             <a:pPr marL="342900" indent="-342900">
               <a:spcAft>
-                <a:spcPts val="1000"/>
+                <a:spcPts val="600"/>
               </a:spcAft>
               <a:buSzPct val="100000"/>
               <a:buChar char="•"/>
             </a:pPr>
             <a:r>
-              <a:rPr lang="en-US" sz="1800" dirty="0">
+              <a:rPr lang="en-US" sz="1700" dirty="0">
                 <a:solidFill>
                   <a:srgbClr val="222222"/>
                 </a:solidFill>
@@ -4027,20 +4085,20 @@
                 <a:ea typeface="Noto Sans CJK KR" pitchFamily="34" charset="-122"/>
                 <a:cs typeface="Noto Sans CJK KR" pitchFamily="34" charset="-120"/>
               </a:rPr>
-              <a:t>GND / RX 포트 / TX 포트로 구성</a:t>
-            </a:r>
-            <a:endParaRPr lang="en-US" sz="1800" dirty="0"/>
+              <a:t>GPIO · PL(Slave IP 포함) 두 영역으로 구성</a:t>
+            </a:r>
+            <a:endParaRPr lang="en-US" sz="1700" dirty="0"/>
           </a:p>
           <a:p>
             <a:pPr marL="342900" indent="-342900">
               <a:spcAft>
-                <a:spcPts val="1000"/>
+                <a:spcPts val="600"/>
               </a:spcAft>
               <a:buSzPct val="100000"/>
               <a:buChar char="•"/>
             </a:pPr>
             <a:r>
-              <a:rPr lang="en-US" sz="1800" dirty="0">
+              <a:rPr lang="en-US" sz="1700" dirty="0">
                 <a:solidFill>
                   <a:srgbClr val="222222"/>
                 </a:solidFill>
@@ -4048,15 +4106,15 @@
                 <a:ea typeface="Noto Sans CJK KR" pitchFamily="34" charset="-122"/>
                 <a:cs typeface="Noto Sans CJK KR" pitchFamily="34" charset="-120"/>
               </a:rPr>
-              <a:t>RX·TX는 LED에 직결되어 통신 상태를 표시 (Master와 표현 통일)</a:t>
-            </a:r>
-            <a:endParaRPr lang="en-US" sz="1800" dirty="0"/>
+              <a:t>GPIO를 통해 Master와 TX/RX 시리얼로 연결</a:t>
+            </a:r>
+            <a:endParaRPr lang="en-US" sz="1700" dirty="0"/>
           </a:p>
         </p:txBody>
       </p:sp>
       <p:pic>
         <p:nvPicPr>
-          <p:cNvPr id="4" name="Image 0" descr="/home/user/SoC_Design_and_Programming/diagrams/section3/zoom/s_gpio.png">    </p:cNvPr>
+          <p:cNvPr id="4" name="Image 0" descr="/home/user/SoC_Design_and_Programming/diagrams/section3/zoom/slave_overview.png">    </p:cNvPr>
           <p:cNvPicPr>
             <a:picLocks noChangeAspect="1"/>
           </p:cNvPicPr>
@@ -4069,8 +4127,8 @@
         </p:blipFill>
         <p:spPr>
           <a:xfrm>
-            <a:off x="4846320" y="1618103"/>
-            <a:ext cx="3749040" cy="2204474"/>
+            <a:off x="636404" y="1783080"/>
+            <a:ext cx="7871192" cy="2743200"/>
           </a:xfrm>
           <a:prstGeom prst="rect">
             <a:avLst/>
@@ -4167,7 +4225,7 @@
                 <a:ea typeface="Noto Sans CJK KR" pitchFamily="34" charset="-122"/>
                 <a:cs typeface="Noto Sans CJK KR" pitchFamily="34" charset="-120"/>
               </a:rPr>
-              <a:t>Slave - PL 확대</a:t>
+              <a:t>Slave - GPIO 확대</a:t>
             </a:r>
             <a:endParaRPr lang="en-US" sz="3600" dirty="0"/>
           </a:p>
@@ -4210,7 +4268,7 @@
                 <a:ea typeface="Noto Sans CJK KR" pitchFamily="34" charset="-122"/>
                 <a:cs typeface="Noto Sans CJK KR" pitchFamily="34" charset="-120"/>
               </a:rPr>
-              <a:t>LED와 Slave IP로 구성</a:t>
+              <a:t>GND / RX 포트 / TX 포트로 구성</a:t>
             </a:r>
             <a:endParaRPr lang="en-US" sz="1800" dirty="0"/>
           </a:p>
@@ -4231,7 +4289,7 @@
                 <a:ea typeface="Noto Sans CJK KR" pitchFamily="34" charset="-122"/>
                 <a:cs typeface="Noto Sans CJK KR" pitchFamily="34" charset="-120"/>
               </a:rPr>
-              <a:t>구조는 단순하지만 일관성을 위해 동일하게 확대해서 표시</a:t>
+              <a:t>RX·TX는 LED에 직결되어 통신 상태를 표시 (Master와 표현 통일)</a:t>
             </a:r>
             <a:endParaRPr lang="en-US" sz="1800" dirty="0"/>
           </a:p>
@@ -4239,7 +4297,7 @@
       </p:sp>
       <p:pic>
         <p:nvPicPr>
-          <p:cNvPr id="4" name="Image 0" descr="/home/user/SoC_Design_and_Programming/diagrams/section3/zoom/s_pl.png">    </p:cNvPr>
+          <p:cNvPr id="4" name="Image 0" descr="/home/user/SoC_Design_and_Programming/diagrams/section3/zoom/s_gpio.png">    </p:cNvPr>
           <p:cNvPicPr>
             <a:picLocks noChangeAspect="1"/>
           </p:cNvPicPr>
@@ -4252,8 +4310,8 @@
         </p:blipFill>
         <p:spPr>
           <a:xfrm>
-            <a:off x="4846320" y="1484484"/>
-            <a:ext cx="3749040" cy="2471712"/>
+            <a:off x="4846320" y="1618103"/>
+            <a:ext cx="3749040" cy="2204474"/>
           </a:xfrm>
           <a:prstGeom prst="rect">
             <a:avLst/>
@@ -4350,7 +4408,7 @@
                 <a:ea typeface="Noto Sans CJK KR" pitchFamily="34" charset="-122"/>
                 <a:cs typeface="Noto Sans CJK KR" pitchFamily="34" charset="-120"/>
               </a:rPr>
-              <a:t>Slave - Slave IP 확대</a:t>
+              <a:t>Slave - PL 확대</a:t>
             </a:r>
             <a:endParaRPr lang="en-US" sz="3600" dirty="0"/>
           </a:p>
@@ -4364,8 +4422,8 @@
         </p:nvSpPr>
         <p:spPr>
           <a:xfrm>
-            <a:off x="548640" y="1188720"/>
-            <a:ext cx="8046720" cy="594360"/>
+            <a:off x="548640" y="1234440"/>
+            <a:ext cx="4023360" cy="2971800"/>
           </a:xfrm>
           <a:prstGeom prst="rect">
             <a:avLst/>
@@ -4379,13 +4437,13 @@
           <a:p>
             <a:pPr marL="342900" indent="-342900">
               <a:spcAft>
-                <a:spcPts val="600"/>
+                <a:spcPts val="1000"/>
               </a:spcAft>
               <a:buSzPct val="100000"/>
               <a:buChar char="•"/>
             </a:pPr>
             <a:r>
-              <a:rPr lang="en-US" sz="1700" dirty="0">
+              <a:rPr lang="en-US" sz="1800" dirty="0">
                 <a:solidFill>
                   <a:srgbClr val="222222"/>
                 </a:solidFill>
@@ -4393,20 +4451,20 @@
                 <a:ea typeface="Noto Sans CJK KR" pitchFamily="34" charset="-122"/>
                 <a:cs typeface="Noto Sans CJK KR" pitchFamily="34" charset="-120"/>
               </a:rPr>
-              <a:t>Master의 동기 메시지를 받으면 자신의 슬롯 시간대를 계산해 적시에 메시지를 전송</a:t>
-            </a:r>
-            <a:endParaRPr lang="en-US" sz="1700" dirty="0"/>
+              <a:t>LED와 Slave IP로 구성</a:t>
+            </a:r>
+            <a:endParaRPr lang="en-US" sz="1800" dirty="0"/>
           </a:p>
           <a:p>
             <a:pPr marL="342900" indent="-342900">
               <a:spcAft>
-                <a:spcPts val="600"/>
+                <a:spcPts val="1000"/>
               </a:spcAft>
               <a:buSzPct val="100000"/>
               <a:buChar char="•"/>
             </a:pPr>
             <a:r>
-              <a:rPr lang="en-US" sz="1700" dirty="0">
+              <a:rPr lang="en-US" sz="1800" dirty="0">
                 <a:solidFill>
                   <a:srgbClr val="222222"/>
                 </a:solidFill>
@@ -4414,15 +4472,15 @@
                 <a:ea typeface="Noto Sans CJK KR" pitchFamily="34" charset="-122"/>
                 <a:cs typeface="Noto Sans CJK KR" pitchFamily="34" charset="-120"/>
               </a:rPr>
-              <a:t>Master가 송신 중단을 명령하면 송신을 중지하는 등 고장 처리를 수행</a:t>
-            </a:r>
-            <a:endParaRPr lang="en-US" sz="1700" dirty="0"/>
+              <a:t>구조는 단순하지만 일관성을 위해 동일하게 확대해서 표시</a:t>
+            </a:r>
+            <a:endParaRPr lang="en-US" sz="1800" dirty="0"/>
           </a:p>
         </p:txBody>
       </p:sp>
       <p:pic>
         <p:nvPicPr>
-          <p:cNvPr id="4" name="Image 0" descr="/home/user/SoC_Design_and_Programming/diagrams/section3/zoom/s_slaveip.png">    </p:cNvPr>
+          <p:cNvPr id="4" name="Image 0" descr="/home/user/SoC_Design_and_Programming/diagrams/section3/zoom/s_pl.png">    </p:cNvPr>
           <p:cNvPicPr>
             <a:picLocks noChangeAspect="1"/>
           </p:cNvPicPr>
@@ -4435,8 +4493,8 @@
         </p:blipFill>
         <p:spPr>
           <a:xfrm>
-            <a:off x="745187" y="1783080"/>
-            <a:ext cx="7653626" cy="2743200"/>
+            <a:off x="4846320" y="1484484"/>
+            <a:ext cx="3749040" cy="2471712"/>
           </a:xfrm>
           <a:prstGeom prst="rect">
             <a:avLst/>
@@ -4533,7 +4591,7 @@
                 <a:ea typeface="Noto Sans CJK KR" pitchFamily="34" charset="-122"/>
                 <a:cs typeface="Noto Sans CJK KR" pitchFamily="34" charset="-120"/>
               </a:rPr>
-              <a:t>Slave의 멀티 슬롯 시뮬레이션</a:t>
+              <a:t>Slave - Slave IP 확대</a:t>
             </a:r>
             <a:endParaRPr lang="en-US" sz="3600" dirty="0"/>
           </a:p>
@@ -4547,8 +4605,8 @@
         </p:nvSpPr>
         <p:spPr>
           <a:xfrm>
-            <a:off x="548640" y="1234440"/>
-            <a:ext cx="8046720" cy="2971800"/>
+            <a:off x="548640" y="1188720"/>
+            <a:ext cx="8046720" cy="594360"/>
           </a:xfrm>
           <a:prstGeom prst="rect">
             <a:avLst/>
@@ -4562,13 +4620,13 @@
           <a:p>
             <a:pPr marL="342900" indent="-342900">
               <a:spcAft>
-                <a:spcPts val="1200"/>
+                <a:spcPts val="600"/>
               </a:spcAft>
               <a:buSzPct val="100000"/>
               <a:buChar char="•"/>
             </a:pPr>
             <a:r>
-              <a:rPr lang="en-US" sz="2000" dirty="0">
+              <a:rPr lang="en-US" sz="1700" dirty="0">
                 <a:solidFill>
                   <a:srgbClr val="222222"/>
                 </a:solidFill>
@@ -4576,20 +4634,20 @@
                 <a:ea typeface="Noto Sans CJK KR" pitchFamily="34" charset="-122"/>
                 <a:cs typeface="Noto Sans CJK KR" pitchFamily="34" charset="-120"/>
               </a:rPr>
-              <a:t>통신 시연에서는 하나의 물리 시퀀서가 8개의 슬롯(슬롯 인덱스 0~7)을 순차 처리 — 슬롯 위치가 식별자 역할을 함</a:t>
-            </a:r>
-            <a:endParaRPr lang="en-US" sz="2000" dirty="0"/>
+              <a:t>Master의 동기 메시지를 받으면 자신의 슬롯 시간대를 계산해 적시에 메시지를 전송</a:t>
+            </a:r>
+            <a:endParaRPr lang="en-US" sz="1700" dirty="0"/>
           </a:p>
           <a:p>
             <a:pPr marL="342900" indent="-342900">
               <a:spcAft>
-                <a:spcPts val="1200"/>
+                <a:spcPts val="600"/>
               </a:spcAft>
               <a:buSzPct val="100000"/>
               <a:buChar char="•"/>
             </a:pPr>
             <a:r>
-              <a:rPr lang="en-US" sz="2000" dirty="0">
+              <a:rPr lang="en-US" sz="1700" dirty="0">
                 <a:solidFill>
                   <a:srgbClr val="222222"/>
                 </a:solidFill>
@@ -4597,57 +4655,38 @@
                 <a:ea typeface="Noto Sans CJK KR" pitchFamily="34" charset="-122"/>
                 <a:cs typeface="Noto Sans CJK KR" pitchFamily="34" charset="-120"/>
               </a:rPr>
-              <a:t>각 슬롯은 자신의 타임슬롯에서 자신의 payload를 전송 (슬롯별 절대 타겟 틱을 기준으로 순회)</a:t>
-            </a:r>
-            <a:endParaRPr lang="en-US" sz="2000" dirty="0"/>
-          </a:p>
-          <a:p>
-            <a:pPr marL="342900" indent="-342900">
-              <a:spcAft>
-                <a:spcPts val="1200"/>
-              </a:spcAft>
-              <a:buSzPct val="100000"/>
-              <a:buChar char="•"/>
-            </a:pPr>
-            <a:r>
-              <a:rPr lang="en-US" sz="2000" dirty="0">
-                <a:solidFill>
-                  <a:srgbClr val="222222"/>
-                </a:solidFill>
-                <a:latin typeface="Noto Sans CJK KR" pitchFamily="34" charset="0"/>
-                <a:ea typeface="Noto Sans CJK KR" pitchFamily="34" charset="-122"/>
-                <a:cs typeface="Noto Sans CJK KR" pitchFamily="34" charset="-120"/>
-              </a:rPr>
-              <a:t>슬롯 0~5는 AXI 레지스터, 슬롯 6~7은 외부 PL 버스에서 payload를 가져옴</a:t>
-            </a:r>
-            <a:endParaRPr lang="en-US" sz="2000" dirty="0"/>
-          </a:p>
-          <a:p>
-            <a:pPr marL="342900" indent="-342900">
-              <a:spcAft>
-                <a:spcPts val="1200"/>
-              </a:spcAft>
-              <a:buSzPct val="100000"/>
-              <a:buChar char="•"/>
-            </a:pPr>
-            <a:r>
-              <a:rPr lang="en-US" sz="2000" dirty="0">
-                <a:solidFill>
-                  <a:srgbClr val="222222"/>
-                </a:solidFill>
-                <a:latin typeface="Noto Sans CJK KR" pitchFamily="34" charset="0"/>
-                <a:ea typeface="Noto Sans CJK KR" pitchFamily="34" charset="-122"/>
-                <a:cs typeface="Noto Sans CJK KR" pitchFamily="34" charset="-120"/>
-              </a:rPr>
-              <a:t>시연에서는 버튼으로 payload 값을 바꾸고, 변경된 값이 Master에서 정확히 수신되는지 확인</a:t>
-            </a:r>
-            <a:endParaRPr lang="en-US" sz="2000" dirty="0"/>
-          </a:p>
-        </p:txBody>
-      </p:sp>
-      <p:sp>
-        <p:nvSpPr>
-          <p:cNvPr id="4" name="Text 2"/>
+              <a:t>Master가 송신 중단을 명령하면 송신을 중지하는 등 고장 처리를 수행</a:t>
+            </a:r>
+            <a:endParaRPr lang="en-US" sz="1700" dirty="0"/>
+          </a:p>
+        </p:txBody>
+      </p:sp>
+      <p:pic>
+        <p:nvPicPr>
+          <p:cNvPr id="4" name="Image 0" descr="/home/user/SoC_Design_and_Programming/diagrams/section3/zoom/s_slaveip.png">    </p:cNvPr>
+          <p:cNvPicPr>
+            <a:picLocks noChangeAspect="1"/>
+          </p:cNvPicPr>
+          <p:nvPr/>
+        </p:nvPicPr>
+        <p:blipFill>
+          <a:blip r:embed="rId2"/>
+          <a:srcRect l="0" r="0" t="0" b="0"/>
+          <a:stretch/>
+        </p:blipFill>
+        <p:spPr>
+          <a:xfrm>
+            <a:off x="745187" y="1783080"/>
+            <a:ext cx="7653626" cy="2743200"/>
+          </a:xfrm>
+          <a:prstGeom prst="rect">
+            <a:avLst/>
+          </a:prstGeom>
+        </p:spPr>
+      </p:pic>
+      <p:sp>
+        <p:nvSpPr>
+          <p:cNvPr id="5" name="Text 2"/>
           <p:cNvSpPr/>
           <p:nvPr/>
         </p:nvSpPr>
@@ -4693,6 +4732,208 @@
 </file>
 
 <file path=ppt/slides/slide25.xml><?xml version="1.0" encoding="utf-8"?>
+<p:sld xmlns:a="http://schemas.openxmlformats.org/drawingml/2006/main" xmlns:p="http://schemas.openxmlformats.org/presentationml/2006/main" xmlns:r="http://schemas.openxmlformats.org/officeDocument/2006/relationships">
+  <p:cSld>
+    <p:spTree>
+      <p:nvGrpSpPr>
+        <p:cNvPr id="1" name=""/>
+        <p:cNvGrpSpPr/>
+        <p:nvPr/>
+      </p:nvGrpSpPr>
+      <p:grpSpPr/>
+      <p:sp>
+        <p:nvSpPr>
+          <p:cNvPr id="2" name="Text 0"/>
+          <p:cNvSpPr/>
+          <p:nvPr/>
+        </p:nvSpPr>
+        <p:spPr>
+          <a:xfrm>
+            <a:off x="548640" y="274320"/>
+            <a:ext cx="8046720" cy="777240"/>
+          </a:xfrm>
+          <a:prstGeom prst="rect">
+            <a:avLst/>
+          </a:prstGeom>
+          <a:noFill/>
+          <a:ln/>
+        </p:spPr>
+        <p:txBody>
+          <a:bodyPr wrap="square" lIns="0" tIns="0" rIns="0" bIns="0" rtlCol="0" anchor="ctr"/>
+          <a:lstStyle/>
+          <a:p>
+            <a:pPr indent="0" marL="0">
+              <a:buNone/>
+            </a:pPr>
+            <a:r>
+              <a:rPr lang="en-US" sz="3600" b="1" dirty="0">
+                <a:solidFill>
+                  <a:srgbClr val="111111"/>
+                </a:solidFill>
+                <a:latin typeface="Noto Sans CJK KR" pitchFamily="34" charset="0"/>
+                <a:ea typeface="Noto Sans CJK KR" pitchFamily="34" charset="-122"/>
+                <a:cs typeface="Noto Sans CJK KR" pitchFamily="34" charset="-120"/>
+              </a:rPr>
+              <a:t>Slave의 멀티 슬롯 시뮬레이션</a:t>
+            </a:r>
+            <a:endParaRPr lang="en-US" sz="3600" dirty="0"/>
+          </a:p>
+        </p:txBody>
+      </p:sp>
+      <p:sp>
+        <p:nvSpPr>
+          <p:cNvPr id="3" name="Text 1"/>
+          <p:cNvSpPr/>
+          <p:nvPr/>
+        </p:nvSpPr>
+        <p:spPr>
+          <a:xfrm>
+            <a:off x="548640" y="1234440"/>
+            <a:ext cx="8046720" cy="2971800"/>
+          </a:xfrm>
+          <a:prstGeom prst="rect">
+            <a:avLst/>
+          </a:prstGeom>
+          <a:noFill/>
+          <a:ln/>
+        </p:spPr>
+        <p:txBody>
+          <a:bodyPr wrap="square" rtlCol="0" anchor="t"/>
+          <a:lstStyle/>
+          <a:p>
+            <a:pPr marL="342900" indent="-342900">
+              <a:spcAft>
+                <a:spcPts val="1200"/>
+              </a:spcAft>
+              <a:buSzPct val="100000"/>
+              <a:buChar char="•"/>
+            </a:pPr>
+            <a:r>
+              <a:rPr lang="en-US" sz="2000" dirty="0">
+                <a:solidFill>
+                  <a:srgbClr val="222222"/>
+                </a:solidFill>
+                <a:latin typeface="Noto Sans CJK KR" pitchFamily="34" charset="0"/>
+                <a:ea typeface="Noto Sans CJK KR" pitchFamily="34" charset="-122"/>
+                <a:cs typeface="Noto Sans CJK KR" pitchFamily="34" charset="-120"/>
+              </a:rPr>
+              <a:t>통신 시연에서는 하나의 물리 시퀀서가 8개의 슬롯(슬롯 인덱스 0~7)을 순차 처리 — 슬롯 위치가 식별자 역할을 함</a:t>
+            </a:r>
+            <a:endParaRPr lang="en-US" sz="2000" dirty="0"/>
+          </a:p>
+          <a:p>
+            <a:pPr marL="342900" indent="-342900">
+              <a:spcAft>
+                <a:spcPts val="1200"/>
+              </a:spcAft>
+              <a:buSzPct val="100000"/>
+              <a:buChar char="•"/>
+            </a:pPr>
+            <a:r>
+              <a:rPr lang="en-US" sz="2000" dirty="0">
+                <a:solidFill>
+                  <a:srgbClr val="222222"/>
+                </a:solidFill>
+                <a:latin typeface="Noto Sans CJK KR" pitchFamily="34" charset="0"/>
+                <a:ea typeface="Noto Sans CJK KR" pitchFamily="34" charset="-122"/>
+                <a:cs typeface="Noto Sans CJK KR" pitchFamily="34" charset="-120"/>
+              </a:rPr>
+              <a:t>각 슬롯은 자신의 타임슬롯에서 자신의 payload를 전송 (슬롯별 절대 타겟 틱을 기준으로 순회)</a:t>
+            </a:r>
+            <a:endParaRPr lang="en-US" sz="2000" dirty="0"/>
+          </a:p>
+          <a:p>
+            <a:pPr marL="342900" indent="-342900">
+              <a:spcAft>
+                <a:spcPts val="1200"/>
+              </a:spcAft>
+              <a:buSzPct val="100000"/>
+              <a:buChar char="•"/>
+            </a:pPr>
+            <a:r>
+              <a:rPr lang="en-US" sz="2000" dirty="0">
+                <a:solidFill>
+                  <a:srgbClr val="222222"/>
+                </a:solidFill>
+                <a:latin typeface="Noto Sans CJK KR" pitchFamily="34" charset="0"/>
+                <a:ea typeface="Noto Sans CJK KR" pitchFamily="34" charset="-122"/>
+                <a:cs typeface="Noto Sans CJK KR" pitchFamily="34" charset="-120"/>
+              </a:rPr>
+              <a:t>슬롯 0~5는 AXI 레지스터, 슬롯 6~7은 외부 PL 버스에서 payload를 가져옴</a:t>
+            </a:r>
+            <a:endParaRPr lang="en-US" sz="2000" dirty="0"/>
+          </a:p>
+          <a:p>
+            <a:pPr marL="342900" indent="-342900">
+              <a:spcAft>
+                <a:spcPts val="1200"/>
+              </a:spcAft>
+              <a:buSzPct val="100000"/>
+              <a:buChar char="•"/>
+            </a:pPr>
+            <a:r>
+              <a:rPr lang="en-US" sz="2000" dirty="0">
+                <a:solidFill>
+                  <a:srgbClr val="222222"/>
+                </a:solidFill>
+                <a:latin typeface="Noto Sans CJK KR" pitchFamily="34" charset="0"/>
+                <a:ea typeface="Noto Sans CJK KR" pitchFamily="34" charset="-122"/>
+                <a:cs typeface="Noto Sans CJK KR" pitchFamily="34" charset="-120"/>
+              </a:rPr>
+              <a:t>시연에서는 버튼으로 payload 값을 바꾸고, 변경된 값이 Master에서 정확히 수신되는지 확인</a:t>
+            </a:r>
+            <a:endParaRPr lang="en-US" sz="2000" dirty="0"/>
+          </a:p>
+        </p:txBody>
+      </p:sp>
+      <p:sp>
+        <p:nvSpPr>
+          <p:cNvPr id="4" name="Text 2"/>
+          <p:cNvSpPr/>
+          <p:nvPr/>
+        </p:nvSpPr>
+        <p:spPr>
+          <a:xfrm>
+            <a:off x="8503920" y="4754880"/>
+            <a:ext cx="457200" cy="274320"/>
+          </a:xfrm>
+          <a:prstGeom prst="rect">
+            <a:avLst/>
+          </a:prstGeom>
+          <a:noFill/>
+          <a:ln/>
+        </p:spPr>
+        <p:txBody>
+          <a:bodyPr wrap="square" rtlCol="0" anchor="ctr"/>
+          <a:lstStyle/>
+          <a:p>
+            <a:pPr algn="r" indent="0" marL="0">
+              <a:buNone/>
+            </a:pPr>
+            <a:r>
+              <a:rPr lang="en-US" sz="1200" dirty="0">
+                <a:solidFill>
+                  <a:srgbClr val="999999"/>
+                </a:solidFill>
+                <a:latin typeface="Noto Sans CJK KR" pitchFamily="34" charset="0"/>
+                <a:ea typeface="Noto Sans CJK KR" pitchFamily="34" charset="-122"/>
+                <a:cs typeface="Noto Sans CJK KR" pitchFamily="34" charset="-120"/>
+              </a:rPr>
+              <a:t>25</a:t>
+            </a:r>
+            <a:endParaRPr lang="en-US" sz="1200" dirty="0"/>
+          </a:p>
+        </p:txBody>
+      </p:sp>
+    </p:spTree>
+  </p:cSld>
+  <p:clrMapOvr>
+    <a:masterClrMapping/>
+  </p:clrMapOvr>
+</p:sld>
+</file>
+
+<file path=ppt/slides/slide26.xml><?xml version="1.0" encoding="utf-8"?>
 <p:sld xmlns:a="http://schemas.openxmlformats.org/drawingml/2006/main" xmlns:p="http://schemas.openxmlformats.org/presentationml/2006/main" xmlns:r="http://schemas.openxmlformats.org/officeDocument/2006/relationships">
   <p:cSld>
     <p:spTree>
@@ -6073,208 +6314,6 @@
                 <a:ea typeface="Noto Sans CJK KR" pitchFamily="34" charset="-122"/>
                 <a:cs typeface="Noto Sans CJK KR" pitchFamily="34" charset="-120"/>
               </a:rPr>
-              <a:t>25</a:t>
-            </a:r>
-            <a:endParaRPr lang="en-US" sz="1200" dirty="0"/>
-          </a:p>
-        </p:txBody>
-      </p:sp>
-    </p:spTree>
-  </p:cSld>
-  <p:clrMapOvr>
-    <a:masterClrMapping/>
-  </p:clrMapOvr>
-</p:sld>
-</file>
-
-<file path=ppt/slides/slide26.xml><?xml version="1.0" encoding="utf-8"?>
-<p:sld xmlns:a="http://schemas.openxmlformats.org/drawingml/2006/main" xmlns:p="http://schemas.openxmlformats.org/presentationml/2006/main" xmlns:r="http://schemas.openxmlformats.org/officeDocument/2006/relationships">
-  <p:cSld>
-    <p:spTree>
-      <p:nvGrpSpPr>
-        <p:cNvPr id="1" name=""/>
-        <p:cNvGrpSpPr/>
-        <p:nvPr/>
-      </p:nvGrpSpPr>
-      <p:grpSpPr/>
-      <p:sp>
-        <p:nvSpPr>
-          <p:cNvPr id="2" name="Text 0"/>
-          <p:cNvSpPr/>
-          <p:nvPr/>
-        </p:nvSpPr>
-        <p:spPr>
-          <a:xfrm>
-            <a:off x="548640" y="274320"/>
-            <a:ext cx="8046720" cy="777240"/>
-          </a:xfrm>
-          <a:prstGeom prst="rect">
-            <a:avLst/>
-          </a:prstGeom>
-          <a:noFill/>
-          <a:ln/>
-        </p:spPr>
-        <p:txBody>
-          <a:bodyPr wrap="square" lIns="0" tIns="0" rIns="0" bIns="0" rtlCol="0" anchor="ctr"/>
-          <a:lstStyle/>
-          <a:p>
-            <a:pPr indent="0" marL="0">
-              <a:buNone/>
-            </a:pPr>
-            <a:r>
-              <a:rPr lang="en-US" sz="3600" b="1" dirty="0">
-                <a:solidFill>
-                  <a:srgbClr val="111111"/>
-                </a:solidFill>
-                <a:latin typeface="Noto Sans CJK KR" pitchFamily="34" charset="0"/>
-                <a:ea typeface="Noto Sans CJK KR" pitchFamily="34" charset="-122"/>
-                <a:cs typeface="Noto Sans CJK KR" pitchFamily="34" charset="-120"/>
-              </a:rPr>
-              <a:t>클럭 동기의 어려움</a:t>
-            </a:r>
-            <a:endParaRPr lang="en-US" sz="3600" dirty="0"/>
-          </a:p>
-        </p:txBody>
-      </p:sp>
-      <p:sp>
-        <p:nvSpPr>
-          <p:cNvPr id="3" name="Text 1"/>
-          <p:cNvSpPr/>
-          <p:nvPr/>
-        </p:nvSpPr>
-        <p:spPr>
-          <a:xfrm>
-            <a:off x="548640" y="1234440"/>
-            <a:ext cx="8046720" cy="2971800"/>
-          </a:xfrm>
-          <a:prstGeom prst="rect">
-            <a:avLst/>
-          </a:prstGeom>
-          <a:noFill/>
-          <a:ln/>
-        </p:spPr>
-        <p:txBody>
-          <a:bodyPr wrap="square" rtlCol="0" anchor="t"/>
-          <a:lstStyle/>
-          <a:p>
-            <a:pPr marL="342900" indent="-342900">
-              <a:spcAft>
-                <a:spcPts val="1200"/>
-              </a:spcAft>
-              <a:buSzPct val="100000"/>
-              <a:buChar char="•"/>
-            </a:pPr>
-            <a:r>
-              <a:rPr lang="en-US" sz="2000" dirty="0">
-                <a:solidFill>
-                  <a:srgbClr val="222222"/>
-                </a:solidFill>
-                <a:latin typeface="Noto Sans CJK KR" pitchFamily="34" charset="0"/>
-                <a:ea typeface="Noto Sans CJK KR" pitchFamily="34" charset="-122"/>
-                <a:cs typeface="Noto Sans CJK KR" pitchFamily="34" charset="-120"/>
-              </a:rPr>
-              <a:t>Master·Slave는 클럭을 공유하지 않음 — 클럭 오차가 통신에 치명적인 방해 요인</a:t>
-            </a:r>
-            <a:endParaRPr lang="en-US" sz="2000" dirty="0"/>
-          </a:p>
-          <a:p>
-            <a:pPr marL="342900" indent="-342900">
-              <a:spcAft>
-                <a:spcPts val="1200"/>
-              </a:spcAft>
-              <a:buSzPct val="100000"/>
-              <a:buChar char="•"/>
-            </a:pPr>
-            <a:r>
-              <a:rPr lang="en-US" sz="2000" dirty="0">
-                <a:solidFill>
-                  <a:srgbClr val="222222"/>
-                </a:solidFill>
-                <a:latin typeface="Noto Sans CJK KR" pitchFamily="34" charset="0"/>
-                <a:ea typeface="Noto Sans CJK KR" pitchFamily="34" charset="-122"/>
-                <a:cs typeface="Noto Sans CJK KR" pitchFamily="34" charset="-120"/>
-              </a:rPr>
-              <a:t>DIV 값을 AXI 레지스터로 설정해 클럭을 분주, Master·Slave 양쪽에 동일한 DIV 값을 쓴다고 가정</a:t>
-            </a:r>
-            <a:endParaRPr lang="en-US" sz="2000" dirty="0"/>
-          </a:p>
-          <a:p>
-            <a:pPr marL="342900" indent="-342900">
-              <a:spcAft>
-                <a:spcPts val="1200"/>
-              </a:spcAft>
-              <a:buSzPct val="100000"/>
-              <a:buChar char="•"/>
-            </a:pPr>
-            <a:r>
-              <a:rPr lang="en-US" sz="2000" dirty="0">
-                <a:solidFill>
-                  <a:srgbClr val="222222"/>
-                </a:solidFill>
-                <a:latin typeface="Noto Sans CJK KR" pitchFamily="34" charset="0"/>
-                <a:ea typeface="Noto Sans CJK KR" pitchFamily="34" charset="-122"/>
-                <a:cs typeface="Noto Sans CJK KR" pitchFamily="34" charset="-120"/>
-              </a:rPr>
-              <a:t>분주 클럭은 메인 클럭 / (DIV + 1)</a:t>
-            </a:r>
-            <a:endParaRPr lang="en-US" sz="2000" dirty="0"/>
-          </a:p>
-          <a:p>
-            <a:pPr marL="342900" indent="-342900">
-              <a:spcAft>
-                <a:spcPts val="1200"/>
-              </a:spcAft>
-              <a:buSzPct val="100000"/>
-              <a:buChar char="•"/>
-            </a:pPr>
-            <a:r>
-              <a:rPr lang="en-US" sz="2000" dirty="0">
-                <a:solidFill>
-                  <a:srgbClr val="222222"/>
-                </a:solidFill>
-                <a:latin typeface="Noto Sans CJK KR" pitchFamily="34" charset="0"/>
-                <a:ea typeface="Noto Sans CJK KR" pitchFamily="34" charset="-122"/>
-                <a:cs typeface="Noto Sans CJK KR" pitchFamily="34" charset="-120"/>
-              </a:rPr>
-              <a:t>수신 샘플링은 비트 구간의 중간 지점에서 1회만 수행</a:t>
-            </a:r>
-            <a:endParaRPr lang="en-US" sz="2000" dirty="0"/>
-          </a:p>
-        </p:txBody>
-      </p:sp>
-      <p:sp>
-        <p:nvSpPr>
-          <p:cNvPr id="4" name="Text 2"/>
-          <p:cNvSpPr/>
-          <p:nvPr/>
-        </p:nvSpPr>
-        <p:spPr>
-          <a:xfrm>
-            <a:off x="8503920" y="4754880"/>
-            <a:ext cx="457200" cy="274320"/>
-          </a:xfrm>
-          <a:prstGeom prst="rect">
-            <a:avLst/>
-          </a:prstGeom>
-          <a:noFill/>
-          <a:ln/>
-        </p:spPr>
-        <p:txBody>
-          <a:bodyPr wrap="square" rtlCol="0" anchor="ctr"/>
-          <a:lstStyle/>
-          <a:p>
-            <a:pPr algn="r" indent="0" marL="0">
-              <a:buNone/>
-            </a:pPr>
-            <a:r>
-              <a:rPr lang="en-US" sz="1200" dirty="0">
-                <a:solidFill>
-                  <a:srgbClr val="999999"/>
-                </a:solidFill>
-                <a:latin typeface="Noto Sans CJK KR" pitchFamily="34" charset="0"/>
-                <a:ea typeface="Noto Sans CJK KR" pitchFamily="34" charset="-122"/>
-                <a:cs typeface="Noto Sans CJK KR" pitchFamily="34" charset="-120"/>
-              </a:rPr>
               <a:t>26</a:t>
             </a:r>
             <a:endParaRPr lang="en-US" sz="1200" dirty="0"/>

</xml_diff>

<commit_message>
Remove intermediate per-section pptx byproducts, keep build scripts and final deck
Added build_section1.js so section1_intro.pptx is reproducible like
section2/3 (previously had no source script). Removed the now-redundant
intermediate decks and the stale master_presentation.pdf — only
build_section*.js, build_full_presentation.py, diagrams/, and the final
presentation_full.pptx remain. Master/Slave/button RTL sources untouched.
</commit_message>
<xml_diff>
--- a/presentation_full.pptx
+++ b/presentation_full.pptx
@@ -4,9 +4,6 @@
   <p:sldMasterIdLst>
     <p:sldMasterId id="2147483648" r:id="rId1"/>
   </p:sldMasterIdLst>
-  <p:notesMasterIdLst>
-    <p:notesMasterId r:id="rId6"/>
-  </p:notesMasterIdLst>
   <p:sldIdLst>
     <p:sldId id="256" r:id="rId2"/>
     <p:sldId id="260" r:id="rId11"/>
@@ -40,7 +37,10 @@
     <p:sldId id="285" r:id="rId36"/>
     <p:sldId id="286" r:id="rId37"/>
   </p:sldIdLst>
-  <p:sldSz cx="9144000" cy="5143500" type="screen16x9"/>
+  <p:notesMasterIdLst>
+    <p:notesMasterId r:id="rId6"/>
+  </p:notesMasterIdLst>
+  <p:sldSz cx="9144000" cy="5143500"/>
   <p:notesSz cx="5143500" cy="9144000"/>
   <p:defaultTextStyle>
     <a:lvl1pPr marL="0" algn="l" defTabSz="914400" rtl="0" eaLnBrk="1" latinLnBrk="0" hangingPunct="1">
@@ -134,11 +134,6 @@
       </a:defRPr>
     </a:lvl9pPr>
   </p:defaultTextStyle>
-  <p:extLst>
-    <p:ext uri="{EFAFB233-063F-42B5-8137-9DF3F51BA10A}">
-      <p15:sldGuideLst xmlns:p15="http://schemas.microsoft.com/office/powerpoint/2012/main"/>
-    </p:ext>
-  </p:extLst>
 </p:presentation>
 </file>
 
@@ -164,16 +159,240 @@
           <a:chExt cx="0" cy="0"/>
         </a:xfrm>
       </p:grpSpPr>
+      <p:sp>
+        <p:nvSpPr>
+          <p:cNvPr id="2" name="Header Placeholder 1"/>
+          <p:cNvSpPr>
+            <a:spLocks noGrp="1"/>
+          </p:cNvSpPr>
+          <p:nvPr>
+            <p:ph type="hdr" sz="quarter"/>
+          </p:nvPr>
+        </p:nvSpPr>
+        <p:spPr>
+          <a:xfrm>
+            <a:off x="0" y="0"/>
+            <a:ext cx="2971800" cy="458788"/>
+          </a:xfrm>
+          <a:prstGeom prst="rect">
+            <a:avLst/>
+          </a:prstGeom>
+        </p:spPr>
+        <p:txBody>
+          <a:bodyPr vert="horz" lIns="91440" tIns="45720" rIns="91440" bIns="45720" rtlCol="0"/>
+          <a:lstStyle>
+            <a:lvl1pPr algn="l">
+              <a:defRPr sz="1200"/>
+            </a:lvl1pPr>
+          </a:lstStyle>
+          <a:p>
+            <a:endParaRPr lang="en-US"/>
+          </a:p>
+        </p:txBody>
+      </p:sp>
+      <p:sp>
+        <p:nvSpPr>
+          <p:cNvPr id="3" name="Date Placeholder 2"/>
+          <p:cNvSpPr>
+            <a:spLocks noGrp="1"/>
+          </p:cNvSpPr>
+          <p:nvPr>
+            <p:ph type="dt" idx="1"/>
+          </p:nvPr>
+        </p:nvSpPr>
+        <p:spPr>
+          <a:xfrm>
+            <a:off x="3884613" y="0"/>
+            <a:ext cx="2971800" cy="458788"/>
+          </a:xfrm>
+          <a:prstGeom prst="rect">
+            <a:avLst/>
+          </a:prstGeom>
+        </p:spPr>
+        <p:txBody>
+          <a:bodyPr vert="horz" lIns="91440" tIns="45720" rIns="91440" bIns="45720" rtlCol="0"/>
+          <a:lstStyle>
+            <a:lvl1pPr algn="r">
+              <a:defRPr sz="1200"/>
+            </a:lvl1pPr>
+          </a:lstStyle>
+          <a:p>
+            <a:fld id="{5282F153-3F37-0F45-9E97-73ACFA13230C}" type="datetimeFigureOut">
+              <a:rPr lang="en-US"/>
+              <a:t>7/23/19</a:t>
+            </a:fld>
+            <a:endParaRPr lang="en-US"/>
+          </a:p>
+        </p:txBody>
+      </p:sp>
+      <p:sp>
+        <p:nvSpPr>
+          <p:cNvPr id="4" name="Slide Image Placeholder 3"/>
+          <p:cNvSpPr>
+            <a:spLocks noGrp="1" noRot="1" noChangeAspect="1"/>
+          </p:cNvSpPr>
+          <p:nvPr>
+            <p:ph type="sldImg" idx="2"/>
+          </p:nvPr>
+        </p:nvSpPr>
+        <p:spPr>
+          <a:xfrm>
+            <a:off x="685800" y="1143000"/>
+            <a:ext cx="5486400" cy="3086100"/>
+          </a:xfrm>
+          <a:prstGeom prst="rect">
+            <a:avLst/>
+          </a:prstGeom>
+          <a:noFill/>
+          <a:ln w="12700">
+            <a:solidFill>
+              <a:prstClr val="black"/>
+            </a:solidFill>
+          </a:ln>
+        </p:spPr>
+        <p:txBody>
+          <a:bodyPr vert="horz" lIns="91440" tIns="45720" rIns="91440" bIns="45720" rtlCol="0" anchor="ctr"/>
+          <a:lstStyle/>
+          <a:p>
+            <a:endParaRPr lang="en-US"/>
+          </a:p>
+        </p:txBody>
+      </p:sp>
+      <p:sp>
+        <p:nvSpPr>
+          <p:cNvPr id="5" name="Notes Placeholder 4"/>
+          <p:cNvSpPr>
+            <a:spLocks noGrp="1"/>
+          </p:cNvSpPr>
+          <p:nvPr>
+            <p:ph type="body" sz="quarter" idx="3"/>
+          </p:nvPr>
+        </p:nvSpPr>
+        <p:spPr>
+          <a:xfrm>
+            <a:off x="685800" y="4400550"/>
+            <a:ext cx="5486400" cy="3600450"/>
+          </a:xfrm>
+          <a:prstGeom prst="rect">
+            <a:avLst/>
+          </a:prstGeom>
+        </p:spPr>
+        <p:txBody>
+          <a:bodyPr vert="horz" lIns="91440" tIns="45720" rIns="91440" bIns="45720" rtlCol="0"/>
+          <a:lstStyle/>
+          <a:p>
+            <a:pPr lvl="0"/>
+            <a:r>
+              <a:rPr lang="en-US"/>
+              <a:t>Click to edit Master text styles</a:t>
+            </a:r>
+          </a:p>
+          <a:p>
+            <a:pPr lvl="1"/>
+            <a:r>
+              <a:rPr lang="en-US"/>
+              <a:t>Second level</a:t>
+            </a:r>
+          </a:p>
+          <a:p>
+            <a:pPr lvl="2"/>
+            <a:r>
+              <a:rPr lang="en-US"/>
+              <a:t>Third level</a:t>
+            </a:r>
+          </a:p>
+          <a:p>
+            <a:pPr lvl="3"/>
+            <a:r>
+              <a:rPr lang="en-US"/>
+              <a:t>Fourth level</a:t>
+            </a:r>
+          </a:p>
+          <a:p>
+            <a:pPr lvl="4"/>
+            <a:r>
+              <a:rPr lang="en-US"/>
+              <a:t>Fifth level</a:t>
+            </a:r>
+          </a:p>
+        </p:txBody>
+      </p:sp>
+      <p:sp>
+        <p:nvSpPr>
+          <p:cNvPr id="6" name="Footer Placeholder 5"/>
+          <p:cNvSpPr>
+            <a:spLocks noGrp="1"/>
+          </p:cNvSpPr>
+          <p:nvPr>
+            <p:ph type="ftr" sz="quarter" idx="4"/>
+          </p:nvPr>
+        </p:nvSpPr>
+        <p:spPr>
+          <a:xfrm>
+            <a:off x="0" y="8685213"/>
+            <a:ext cx="2971800" cy="458787"/>
+          </a:xfrm>
+          <a:prstGeom prst="rect">
+            <a:avLst/>
+          </a:prstGeom>
+        </p:spPr>
+        <p:txBody>
+          <a:bodyPr vert="horz" lIns="91440" tIns="45720" rIns="91440" bIns="45720" rtlCol="0" anchor="b"/>
+          <a:lstStyle>
+            <a:lvl1pPr algn="l">
+              <a:defRPr sz="1200"/>
+            </a:lvl1pPr>
+          </a:lstStyle>
+          <a:p>
+            <a:endParaRPr lang="en-US"/>
+          </a:p>
+        </p:txBody>
+      </p:sp>
+      <p:sp>
+        <p:nvSpPr>
+          <p:cNvPr id="7" name="Slide Number Placeholder 6"/>
+          <p:cNvSpPr>
+            <a:spLocks noGrp="1"/>
+          </p:cNvSpPr>
+          <p:nvPr>
+            <p:ph type="sldNum" sz="quarter" idx="5"/>
+          </p:nvPr>
+        </p:nvSpPr>
+        <p:spPr>
+          <a:xfrm>
+            <a:off x="3884613" y="8685213"/>
+            <a:ext cx="2971800" cy="458787"/>
+          </a:xfrm>
+          <a:prstGeom prst="rect">
+            <a:avLst/>
+          </a:prstGeom>
+        </p:spPr>
+        <p:txBody>
+          <a:bodyPr vert="horz" lIns="91440" tIns="45720" rIns="91440" bIns="45720" rtlCol="0" anchor="b"/>
+          <a:lstStyle>
+            <a:lvl1pPr algn="r">
+              <a:defRPr sz="1200"/>
+            </a:lvl1pPr>
+          </a:lstStyle>
+          <a:p>
+            <a:fld id="{CE5E9CC1-C706-0F49-92D6-E571CC5EEA8F}" type="slidenum">
+              <a:rPr lang="en-US"/>
+              <a:t>‹#›</a:t>
+            </a:fld>
+            <a:endParaRPr lang="en-US"/>
+          </a:p>
+        </p:txBody>
+      </p:sp>
     </p:spTree>
     <p:extLst>
       <p:ext uri="{BB962C8B-B14F-4D97-AF65-F5344CB8AC3E}">
-        <p14:creationId xmlns:p14="http://schemas.microsoft.com/office/powerpoint/2010/main" val="2966718711"/>
+        <p14:creationId xmlns:p14="http://schemas.microsoft.com/office/powerpoint/2010/main" val="1024086991"/>
       </p:ext>
     </p:extLst>
   </p:cSld>
   <p:clrMap bg1="lt1" tx1="dk1" bg2="lt2" tx2="dk2" accent1="accent1" accent2="accent2" accent3="accent3" accent4="accent4" accent5="accent5" accent6="accent6" hlink="hlink" folHlink="folHlink"/>
   <p:notesStyle>
-    <a:lvl1pPr marL="0" algn="l" defTabSz="914400" rtl="0" eaLnBrk="1" latinLnBrk="1" hangingPunct="1">
+    <a:lvl1pPr marL="0" algn="l" defTabSz="914400" rtl="0" eaLnBrk="1" latinLnBrk="0" hangingPunct="1">
       <a:defRPr sz="1200" kern="1200">
         <a:solidFill>
           <a:schemeClr val="tx1"/>
@@ -183,7 +402,7 @@
         <a:cs typeface="+mn-cs"/>
       </a:defRPr>
     </a:lvl1pPr>
-    <a:lvl2pPr marL="457200" algn="l" defTabSz="914400" rtl="0" eaLnBrk="1" latinLnBrk="1" hangingPunct="1">
+    <a:lvl2pPr marL="457200" algn="l" defTabSz="914400" rtl="0" eaLnBrk="1" latinLnBrk="0" hangingPunct="1">
       <a:defRPr sz="1200" kern="1200">
         <a:solidFill>
           <a:schemeClr val="tx1"/>
@@ -193,7 +412,7 @@
         <a:cs typeface="+mn-cs"/>
       </a:defRPr>
     </a:lvl2pPr>
-    <a:lvl3pPr marL="914400" algn="l" defTabSz="914400" rtl="0" eaLnBrk="1" latinLnBrk="1" hangingPunct="1">
+    <a:lvl3pPr marL="914400" algn="l" defTabSz="914400" rtl="0" eaLnBrk="1" latinLnBrk="0" hangingPunct="1">
       <a:defRPr sz="1200" kern="1200">
         <a:solidFill>
           <a:schemeClr val="tx1"/>
@@ -203,7 +422,7 @@
         <a:cs typeface="+mn-cs"/>
       </a:defRPr>
     </a:lvl3pPr>
-    <a:lvl4pPr marL="1371600" algn="l" defTabSz="914400" rtl="0" eaLnBrk="1" latinLnBrk="1" hangingPunct="1">
+    <a:lvl4pPr marL="1371600" algn="l" defTabSz="914400" rtl="0" eaLnBrk="1" latinLnBrk="0" hangingPunct="1">
       <a:defRPr sz="1200" kern="1200">
         <a:solidFill>
           <a:schemeClr val="tx1"/>
@@ -213,7 +432,7 @@
         <a:cs typeface="+mn-cs"/>
       </a:defRPr>
     </a:lvl4pPr>
-    <a:lvl5pPr marL="1828800" algn="l" defTabSz="914400" rtl="0" eaLnBrk="1" latinLnBrk="1" hangingPunct="1">
+    <a:lvl5pPr marL="1828800" algn="l" defTabSz="914400" rtl="0" eaLnBrk="1" latinLnBrk="0" hangingPunct="1">
       <a:defRPr sz="1200" kern="1200">
         <a:solidFill>
           <a:schemeClr val="tx1"/>
@@ -223,7 +442,7 @@
         <a:cs typeface="+mn-cs"/>
       </a:defRPr>
     </a:lvl5pPr>
-    <a:lvl6pPr marL="2286000" algn="l" defTabSz="914400" rtl="0" eaLnBrk="1" latinLnBrk="1" hangingPunct="1">
+    <a:lvl6pPr marL="2286000" algn="l" defTabSz="914400" rtl="0" eaLnBrk="1" latinLnBrk="0" hangingPunct="1">
       <a:defRPr sz="1200" kern="1200">
         <a:solidFill>
           <a:schemeClr val="tx1"/>
@@ -233,7 +452,7 @@
         <a:cs typeface="+mn-cs"/>
       </a:defRPr>
     </a:lvl6pPr>
-    <a:lvl7pPr marL="2743200" algn="l" defTabSz="914400" rtl="0" eaLnBrk="1" latinLnBrk="1" hangingPunct="1">
+    <a:lvl7pPr marL="2743200" algn="l" defTabSz="914400" rtl="0" eaLnBrk="1" latinLnBrk="0" hangingPunct="1">
       <a:defRPr sz="1200" kern="1200">
         <a:solidFill>
           <a:schemeClr val="tx1"/>
@@ -243,7 +462,7 @@
         <a:cs typeface="+mn-cs"/>
       </a:defRPr>
     </a:lvl7pPr>
-    <a:lvl8pPr marL="3200400" algn="l" defTabSz="914400" rtl="0" eaLnBrk="1" latinLnBrk="1" hangingPunct="1">
+    <a:lvl8pPr marL="3200400" algn="l" defTabSz="914400" rtl="0" eaLnBrk="1" latinLnBrk="0" hangingPunct="1">
       <a:defRPr sz="1200" kern="1200">
         <a:solidFill>
           <a:schemeClr val="tx1"/>
@@ -253,7 +472,7 @@
         <a:cs typeface="+mn-cs"/>
       </a:defRPr>
     </a:lvl8pPr>
-    <a:lvl9pPr marL="3657600" algn="l" defTabSz="914400" rtl="0" eaLnBrk="1" latinLnBrk="1" hangingPunct="1">
+    <a:lvl9pPr marL="3657600" algn="l" defTabSz="914400" rtl="0" eaLnBrk="1" latinLnBrk="0" hangingPunct="1">
       <a:defRPr sz="1200" kern="1200">
         <a:solidFill>
           <a:schemeClr val="tx1"/>
@@ -311,6 +530,10 @@
           <a:bodyPr/>
           <a:lstStyle/>
           <a:p>
+            <a:r>
+              <a:rPr lang="en-US" dirty="0"/>
+              <a:t/>
+            </a:r>
             <a:endParaRPr lang="en-US" dirty="0"/>
           </a:p>
         </p:txBody>
@@ -395,6 +618,10 @@
           <a:bodyPr/>
           <a:lstStyle/>
           <a:p>
+            <a:r>
+              <a:rPr lang="en-US" dirty="0"/>
+              <a:t/>
+            </a:r>
             <a:endParaRPr lang="en-US" dirty="0"/>
           </a:p>
         </p:txBody>
@@ -479,6 +706,10 @@
           <a:bodyPr/>
           <a:lstStyle/>
           <a:p>
+            <a:r>
+              <a:rPr lang="en-US" dirty="0"/>
+              <a:t/>
+            </a:r>
             <a:endParaRPr lang="en-US" dirty="0"/>
           </a:p>
         </p:txBody>
@@ -563,6 +794,10 @@
           <a:bodyPr/>
           <a:lstStyle/>
           <a:p>
+            <a:r>
+              <a:rPr lang="en-US" dirty="0"/>
+              <a:t/>
+            </a:r>
             <a:endParaRPr lang="en-US" dirty="0"/>
           </a:p>
         </p:txBody>
@@ -636,11 +871,6 @@
 <file path=ppt/slideMasters/slideMaster1.xml><?xml version="1.0" encoding="utf-8"?>
 <p:sldMaster xmlns:a="http://schemas.openxmlformats.org/drawingml/2006/main" xmlns:r="http://schemas.openxmlformats.org/officeDocument/2006/relationships" xmlns:p="http://schemas.openxmlformats.org/presentationml/2006/main">
   <p:cSld>
-    <p:bg>
-      <p:bgRef idx="1001">
-        <a:schemeClr val="bg1"/>
-      </p:bgRef>
-    </p:bg>
     <p:spTree>
       <p:nvGrpSpPr>
         <p:cNvPr id="1" name=""/>
@@ -950,10 +1180,10 @@
           <a:ln/>
         </p:spPr>
         <p:txBody>
-          <a:bodyPr wrap="square" rtlCol="0" anchor="ctr"/>
-          <a:lstStyle/>
-          <a:p>
-            <a:pPr marL="0" indent="0" algn="l">
+          <a:bodyPr wrap="square" rtlCol="0" anchor="t"/>
+          <a:lstStyle/>
+          <a:p>
+            <a:pPr algn="l" indent="0" marL="0">
               <a:buNone/>
             </a:pPr>
             <a:r>
@@ -992,7 +1222,7 @@
           <a:bodyPr wrap="square" rtlCol="0" anchor="ctr"/>
           <a:lstStyle/>
           <a:p>
-            <a:pPr marL="0" indent="0" algn="l">
+            <a:pPr algn="l" indent="0" marL="0">
               <a:buNone/>
             </a:pPr>
             <a:r>
@@ -1004,49 +1234,9 @@
                 <a:ea typeface="Noto Sans CJK KR" pitchFamily="34" charset="-122"/>
                 <a:cs typeface="Noto Sans CJK KR" pitchFamily="34" charset="-120"/>
               </a:rPr>
-              <a:t>Safety-Critical 통신을 위한 결정론적 시간 </a:t>
-            </a:r>
-            <a:r>
-              <a:rPr lang="en-US" sz="2000" dirty="0" err="1">
-                <a:solidFill>
-                  <a:srgbClr val="666666"/>
-                </a:solidFill>
-                <a:latin typeface="Noto Sans CJK KR" pitchFamily="34" charset="0"/>
-                <a:ea typeface="Noto Sans CJK KR" pitchFamily="34" charset="-122"/>
-                <a:cs typeface="Noto Sans CJK KR" pitchFamily="34" charset="-120"/>
-              </a:rPr>
-              <a:t>분할</a:t>
-            </a:r>
-            <a:r>
-              <a:rPr lang="en-US" sz="2000" dirty="0">
-                <a:solidFill>
-                  <a:srgbClr val="666666"/>
-                </a:solidFill>
-                <a:latin typeface="Noto Sans CJK KR" pitchFamily="34" charset="0"/>
-                <a:ea typeface="Noto Sans CJK KR" pitchFamily="34" charset="-122"/>
-                <a:cs typeface="Noto Sans CJK KR" pitchFamily="34" charset="-120"/>
-              </a:rPr>
-              <a:t> </a:t>
-            </a:r>
-            <a:r>
-              <a:rPr lang="en-US" sz="2000" dirty="0" err="1">
-                <a:solidFill>
-                  <a:srgbClr val="666666"/>
-                </a:solidFill>
-                <a:latin typeface="Noto Sans CJK KR" pitchFamily="34" charset="0"/>
-                <a:ea typeface="Noto Sans CJK KR" pitchFamily="34" charset="-122"/>
-                <a:cs typeface="Noto Sans CJK KR" pitchFamily="34" charset="-120"/>
-              </a:rPr>
-              <a:t>접근</a:t>
-            </a:r>
-            <a:endParaRPr lang="en-US" sz="2000" dirty="0">
-              <a:solidFill>
-                <a:srgbClr val="666666"/>
-              </a:solidFill>
-              <a:latin typeface="Noto Sans CJK KR" pitchFamily="34" charset="0"/>
-              <a:ea typeface="Noto Sans CJK KR" pitchFamily="34" charset="-122"/>
-              <a:cs typeface="Noto Sans CJK KR" pitchFamily="34" charset="-120"/>
-            </a:endParaRPr>
+              <a:t>Safety-Critical 통신을 위한 결정론적 시간 분할 접근</a:t>
+            </a:r>
+            <a:endParaRPr lang="en-US" sz="2000" dirty="0"/>
           </a:p>
         </p:txBody>
       </p:sp>
@@ -1058,6 +1248,45 @@
         </p:nvSpPr>
         <p:spPr>
           <a:xfrm>
+            <a:off x="548640" y="3721608"/>
+            <a:ext cx="8046720" cy="594360"/>
+          </a:xfrm>
+          <a:prstGeom prst="rect">
+            <a:avLst/>
+          </a:prstGeom>
+          <a:noFill/>
+          <a:ln/>
+        </p:spPr>
+        <p:txBody>
+          <a:bodyPr wrap="square" rtlCol="0" anchor="ctr"/>
+          <a:lstStyle/>
+          <a:p>
+            <a:pPr algn="l" indent="0" marL="0">
+              <a:buNone/>
+            </a:pPr>
+            <a:r>
+              <a:rPr lang="en-US" sz="2000" dirty="0">
+                <a:solidFill>
+                  <a:srgbClr val="666666"/>
+                </a:solidFill>
+                <a:latin typeface="Noto Sans CJK KR" pitchFamily="34" charset="0"/>
+                <a:ea typeface="Noto Sans CJK KR" pitchFamily="34" charset="-122"/>
+                <a:cs typeface="Noto Sans CJK KR" pitchFamily="34" charset="-120"/>
+              </a:rPr>
+              <a:t>9조 (정신수, 우동엽)</a:t>
+            </a:r>
+            <a:endParaRPr lang="en-US" sz="2000" dirty="0"/>
+          </a:p>
+        </p:txBody>
+      </p:sp>
+      <p:sp>
+        <p:nvSpPr>
+          <p:cNvPr id="5" name="Text 3"/>
+          <p:cNvSpPr/>
+          <p:nvPr/>
+        </p:nvSpPr>
+        <p:spPr>
+          <a:xfrm>
             <a:off x="8503920" y="4754880"/>
             <a:ext cx="457200" cy="274320"/>
           </a:xfrm>
@@ -1071,7 +1300,7 @@
           <a:bodyPr wrap="square" rtlCol="0" anchor="ctr"/>
           <a:lstStyle/>
           <a:p>
-            <a:pPr marL="0" indent="0" algn="r">
+            <a:pPr algn="r" indent="0" marL="0">
               <a:buNone/>
             </a:pPr>
             <a:r>
@@ -1086,124 +1315,6 @@
               <a:t>1</a:t>
             </a:r>
             <a:endParaRPr lang="en-US" sz="1200" dirty="0"/>
-          </a:p>
-        </p:txBody>
-      </p:sp>
-      <p:sp>
-        <p:nvSpPr>
-          <p:cNvPr id="5" name="Text 1">
-            <a:extLst>
-              <a:ext uri="{FF2B5EF4-FFF2-40B4-BE49-F238E27FC236}">
-                <a16:creationId xmlns:a16="http://schemas.microsoft.com/office/drawing/2014/main" id="{B33BE6BC-3DD7-4F12-A357-5154787D8F69}"/>
-              </a:ext>
-            </a:extLst>
-          </p:cNvPr>
-          <p:cNvSpPr/>
-          <p:nvPr/>
-        </p:nvSpPr>
-        <p:spPr>
-          <a:xfrm>
-            <a:off x="548640" y="3718346"/>
-            <a:ext cx="8046720" cy="594360"/>
-          </a:xfrm>
-          <a:prstGeom prst="rect">
-            <a:avLst/>
-          </a:prstGeom>
-          <a:noFill/>
-          <a:ln/>
-        </p:spPr>
-        <p:txBody>
-          <a:bodyPr wrap="square" rtlCol="0" anchor="ctr"/>
-          <a:lstStyle/>
-          <a:p>
-            <a:pPr marL="0" indent="0" algn="l">
-              <a:buNone/>
-            </a:pPr>
-            <a:r>
-              <a:rPr lang="en-US" sz="2000" dirty="0">
-                <a:solidFill>
-                  <a:srgbClr val="666666"/>
-                </a:solidFill>
-                <a:latin typeface="Noto Sans CJK KR" pitchFamily="34" charset="0"/>
-                <a:ea typeface="Noto Sans CJK KR" pitchFamily="34" charset="-122"/>
-                <a:cs typeface="Noto Sans CJK KR" pitchFamily="34" charset="-120"/>
-              </a:rPr>
-              <a:t>9</a:t>
-            </a:r>
-            <a:r>
-              <a:rPr lang="ko-KR" altLang="en-US" sz="2000" dirty="0">
-                <a:solidFill>
-                  <a:srgbClr val="666666"/>
-                </a:solidFill>
-                <a:latin typeface="Noto Sans CJK KR" pitchFamily="34" charset="0"/>
-                <a:ea typeface="Noto Sans CJK KR" pitchFamily="34" charset="-122"/>
-                <a:cs typeface="Noto Sans CJK KR" pitchFamily="34" charset="-120"/>
-              </a:rPr>
-              <a:t>조 </a:t>
-            </a:r>
-            <a:r>
-              <a:rPr lang="en-US" altLang="ko-KR" sz="2000" dirty="0">
-                <a:solidFill>
-                  <a:srgbClr val="666666"/>
-                </a:solidFill>
-                <a:latin typeface="Noto Sans CJK KR" pitchFamily="34" charset="0"/>
-                <a:ea typeface="Noto Sans CJK KR" pitchFamily="34" charset="-122"/>
-                <a:cs typeface="Noto Sans CJK KR" pitchFamily="34" charset="-120"/>
-              </a:rPr>
-              <a:t>(</a:t>
-            </a:r>
-            <a:r>
-              <a:rPr lang="ko-KR" altLang="en-US" sz="2000" dirty="0" err="1">
-                <a:solidFill>
-                  <a:srgbClr val="666666"/>
-                </a:solidFill>
-                <a:latin typeface="Noto Sans CJK KR" pitchFamily="34" charset="0"/>
-                <a:ea typeface="Noto Sans CJK KR" pitchFamily="34" charset="-122"/>
-                <a:cs typeface="Noto Sans CJK KR" pitchFamily="34" charset="-120"/>
-              </a:rPr>
-              <a:t>정신수</a:t>
-            </a:r>
-            <a:r>
-              <a:rPr lang="en-US" altLang="ko-KR" sz="2000" dirty="0">
-                <a:solidFill>
-                  <a:srgbClr val="666666"/>
-                </a:solidFill>
-                <a:latin typeface="Noto Sans CJK KR" pitchFamily="34" charset="0"/>
-                <a:ea typeface="Noto Sans CJK KR" pitchFamily="34" charset="-122"/>
-                <a:cs typeface="Noto Sans CJK KR" pitchFamily="34" charset="-120"/>
-              </a:rPr>
-              <a:t>, </a:t>
-            </a:r>
-            <a:r>
-              <a:rPr lang="ko-KR" altLang="en-US" sz="2000" dirty="0" err="1">
-                <a:solidFill>
-                  <a:srgbClr val="666666"/>
-                </a:solidFill>
-                <a:latin typeface="Noto Sans CJK KR" pitchFamily="34" charset="0"/>
-                <a:ea typeface="Noto Sans CJK KR" pitchFamily="34" charset="-122"/>
-                <a:cs typeface="Noto Sans CJK KR" pitchFamily="34" charset="-120"/>
-              </a:rPr>
-              <a:t>우동엽</a:t>
-            </a:r>
-            <a:r>
-              <a:rPr lang="en-US" altLang="ko-KR" sz="2000" dirty="0">
-                <a:solidFill>
-                  <a:srgbClr val="666666"/>
-                </a:solidFill>
-                <a:latin typeface="Noto Sans CJK KR" pitchFamily="34" charset="0"/>
-                <a:ea typeface="Noto Sans CJK KR" pitchFamily="34" charset="-122"/>
-                <a:cs typeface="Noto Sans CJK KR" pitchFamily="34" charset="-120"/>
-              </a:rPr>
-              <a:t>)</a:t>
-            </a:r>
-            <a:endParaRPr lang="en-US" sz="2000" dirty="0">
-              <a:solidFill>
-                <a:srgbClr val="666666"/>
-              </a:solidFill>
-              <a:latin typeface="Noto Sans CJK KR" pitchFamily="34" charset="0"/>
-              <a:ea typeface="Noto Sans CJK KR" pitchFamily="34" charset="-122"/>
-              <a:cs typeface="Noto Sans CJK KR" pitchFamily="34" charset="-120"/>
-            </a:endParaRPr>
           </a:p>
         </p:txBody>
       </p:sp>
@@ -3562,7 +3673,7 @@
           <a:bodyPr wrap="square" lIns="0" tIns="0" rIns="0" bIns="0" rtlCol="0" anchor="ctr"/>
           <a:lstStyle/>
           <a:p>
-            <a:pPr marL="0" indent="0">
+            <a:pPr indent="0" marL="0">
               <a:buNone/>
             </a:pPr>
             <a:r>
@@ -3609,7 +3720,7 @@
               <a:buChar char="•"/>
             </a:pPr>
             <a:r>
-              <a:rPr lang="en-US" sz="2000" dirty="0" err="1">
+              <a:rPr lang="en-US" sz="2000" dirty="0">
                 <a:solidFill>
                   <a:srgbClr val="222222"/>
                 </a:solidFill>
@@ -3617,56 +3728,12 @@
                 <a:ea typeface="Noto Sans CJK KR" pitchFamily="34" charset="-122"/>
                 <a:cs typeface="Noto Sans CJK KR" pitchFamily="34" charset="-120"/>
               </a:rPr>
-              <a:t>RT·안전-critical</a:t>
-            </a:r>
-            <a:r>
-              <a:rPr lang="en-US" sz="2000" dirty="0">
-                <a:solidFill>
-                  <a:srgbClr val="222222"/>
-                </a:solidFill>
-                <a:latin typeface="Noto Sans CJK KR" pitchFamily="34" charset="0"/>
-                <a:ea typeface="Noto Sans CJK KR" pitchFamily="34" charset="-122"/>
-                <a:cs typeface="Noto Sans CJK KR" pitchFamily="34" charset="-120"/>
-              </a:rPr>
-              <a:t> </a:t>
-            </a:r>
-            <a:r>
-              <a:rPr lang="ko-KR" altLang="en-US" sz="2000" dirty="0">
-                <a:solidFill>
-                  <a:srgbClr val="222222"/>
-                </a:solidFill>
-                <a:latin typeface="Noto Sans CJK KR" pitchFamily="34" charset="0"/>
-                <a:ea typeface="Noto Sans CJK KR" pitchFamily="34" charset="-122"/>
-                <a:cs typeface="Noto Sans CJK KR" pitchFamily="34" charset="-120"/>
-              </a:rPr>
-              <a:t>통신 </a:t>
-            </a:r>
-            <a:r>
-              <a:rPr lang="en-US" sz="2000" dirty="0" err="1">
-                <a:solidFill>
-                  <a:srgbClr val="222222"/>
-                </a:solidFill>
-                <a:latin typeface="Noto Sans CJK KR" pitchFamily="34" charset="0"/>
-                <a:ea typeface="Noto Sans CJK KR" pitchFamily="34" charset="-122"/>
-                <a:cs typeface="Noto Sans CJK KR" pitchFamily="34" charset="-120"/>
-              </a:rPr>
-              <a:t>시스템의</a:t>
-            </a:r>
-            <a:r>
-              <a:rPr lang="en-US" sz="2000" dirty="0">
-                <a:solidFill>
-                  <a:srgbClr val="222222"/>
-                </a:solidFill>
-                <a:latin typeface="Noto Sans CJK KR" pitchFamily="34" charset="0"/>
-                <a:ea typeface="Noto Sans CJK KR" pitchFamily="34" charset="-122"/>
-                <a:cs typeface="Noto Sans CJK KR" pitchFamily="34" charset="-120"/>
-              </a:rPr>
-              <a:t> 요구사항</a:t>
+              <a:t>RT·안전-critical 통신 시스템의 요구사항</a:t>
             </a:r>
             <a:endParaRPr lang="en-US" sz="2000" dirty="0"/>
           </a:p>
           <a:p>
-            <a:pPr marL="685800" lvl="1" indent="-342900">
+            <a:pPr lvl="1" marL="685800" indent="-342900">
               <a:spcAft>
                 <a:spcPts val="800"/>
               </a:spcAft>
@@ -3687,7 +3754,7 @@
             <a:endParaRPr lang="en-US" sz="2000" dirty="0"/>
           </a:p>
           <a:p>
-            <a:pPr marL="685800" lvl="1" indent="-342900">
+            <a:pPr lvl="1" marL="685800" indent="-342900">
               <a:spcAft>
                 <a:spcPts val="800"/>
               </a:spcAft>
@@ -3729,7 +3796,7 @@
             <a:endParaRPr lang="en-US" sz="2000" dirty="0"/>
           </a:p>
           <a:p>
-            <a:pPr marL="685800" lvl="1" indent="-342900">
+            <a:pPr lvl="1" marL="685800" indent="-342900">
               <a:spcAft>
                 <a:spcPts val="800"/>
               </a:spcAft>
@@ -3750,7 +3817,10 @@
             <a:endParaRPr lang="en-US" sz="2000" dirty="0"/>
           </a:p>
           <a:p>
-            <a:pPr marL="342900" indent="-342900">
+            <a:pPr lvl="1" marL="685800" indent="-342900">
+              <a:spcAft>
+                <a:spcPts val="800"/>
+              </a:spcAft>
               <a:buSzPct val="100000"/>
               <a:buChar char="•"/>
             </a:pPr>
@@ -3790,7 +3860,7 @@
           <a:bodyPr wrap="square" rtlCol="0" anchor="ctr"/>
           <a:lstStyle/>
           <a:p>
-            <a:pPr marL="0" indent="0" algn="r">
+            <a:pPr algn="r" indent="0" marL="0">
               <a:buNone/>
             </a:pPr>
             <a:r>
@@ -6974,7 +7044,7 @@
           <a:bodyPr wrap="square" lIns="0" tIns="0" rIns="0" bIns="0" rtlCol="0" anchor="ctr"/>
           <a:lstStyle/>
           <a:p>
-            <a:pPr marL="0" indent="0">
+            <a:pPr indent="0" marL="0">
               <a:buNone/>
             </a:pPr>
             <a:r>
@@ -7034,7 +7104,7 @@
             <a:endParaRPr lang="en-US" sz="2000" dirty="0"/>
           </a:p>
           <a:p>
-            <a:pPr marL="685800" lvl="1" indent="-342900">
+            <a:pPr lvl="1" marL="685800" indent="-342900">
               <a:spcAft>
                 <a:spcPts val="800"/>
               </a:spcAft>
@@ -7055,7 +7125,7 @@
             <a:endParaRPr lang="en-US" sz="2000" dirty="0"/>
           </a:p>
           <a:p>
-            <a:pPr marL="685800" lvl="1" indent="-342900">
+            <a:pPr lvl="1" marL="685800" indent="-342900">
               <a:spcAft>
                 <a:spcPts val="800"/>
               </a:spcAft>
@@ -7097,7 +7167,10 @@
             <a:endParaRPr lang="en-US" sz="2000" dirty="0"/>
           </a:p>
           <a:p>
-            <a:pPr marL="342900" indent="-342900">
+            <a:pPr lvl="1" marL="685800" indent="-342900">
+              <a:spcAft>
+                <a:spcPts val="800"/>
+              </a:spcAft>
               <a:buSzPct val="100000"/>
               <a:buChar char="•"/>
             </a:pPr>
@@ -7137,7 +7210,7 @@
           <a:bodyPr wrap="square" rtlCol="0" anchor="ctr"/>
           <a:lstStyle/>
           <a:p>
-            <a:pPr marL="0" indent="0" algn="r">
+            <a:pPr algn="r" indent="0" marL="0">
               <a:buNone/>
             </a:pPr>
             <a:r>
@@ -7427,7 +7500,7 @@
           <a:bodyPr wrap="square" lIns="0" tIns="0" rIns="0" bIns="0" rtlCol="0" anchor="ctr"/>
           <a:lstStyle/>
           <a:p>
-            <a:pPr marL="0" indent="0">
+            <a:pPr indent="0" marL="0">
               <a:buNone/>
             </a:pPr>
             <a:r>
@@ -7487,7 +7560,7 @@
             <a:endParaRPr lang="en-US" sz="2000" dirty="0"/>
           </a:p>
           <a:p>
-            <a:pPr marL="685800" lvl="1" indent="-342900">
+            <a:pPr lvl="1" marL="685800" indent="-342900">
               <a:spcAft>
                 <a:spcPts val="800"/>
               </a:spcAft>
@@ -7529,7 +7602,10 @@
             <a:endParaRPr lang="en-US" sz="2000" dirty="0"/>
           </a:p>
           <a:p>
-            <a:pPr marL="342900" indent="-342900">
+            <a:pPr lvl="1" marL="685800" indent="-342900">
+              <a:spcAft>
+                <a:spcPts val="800"/>
+              </a:spcAft>
               <a:buSzPct val="100000"/>
               <a:buChar char="•"/>
             </a:pPr>
@@ -7569,7 +7645,7 @@
           <a:bodyPr wrap="square" rtlCol="0" anchor="ctr"/>
           <a:lstStyle/>
           <a:p>
-            <a:pPr marL="0" indent="0" algn="r">
+            <a:pPr algn="r" indent="0" marL="0">
               <a:buNone/>
             </a:pPr>
             <a:r>
@@ -8873,319 +8949,4 @@
     </a:ext>
   </a:extLst>
 </a:theme>
-</file>
-
-<file path=ppt/theme/theme2.xml><?xml version="1.0" encoding="utf-8"?>
-<a:theme xmlns:a="http://schemas.openxmlformats.org/drawingml/2006/main" name="Office 테마">
-  <a:themeElements>
-    <a:clrScheme name="Office">
-      <a:dk1>
-        <a:sysClr val="windowText" lastClr="000000"/>
-      </a:dk1>
-      <a:lt1>
-        <a:sysClr val="window" lastClr="FFFFFF"/>
-      </a:lt1>
-      <a:dk2>
-        <a:srgbClr val="0E2841"/>
-      </a:dk2>
-      <a:lt2>
-        <a:srgbClr val="E8E8E8"/>
-      </a:lt2>
-      <a:accent1>
-        <a:srgbClr val="156082"/>
-      </a:accent1>
-      <a:accent2>
-        <a:srgbClr val="E97132"/>
-      </a:accent2>
-      <a:accent3>
-        <a:srgbClr val="196B24"/>
-      </a:accent3>
-      <a:accent4>
-        <a:srgbClr val="0F9ED5"/>
-      </a:accent4>
-      <a:accent5>
-        <a:srgbClr val="A02B93"/>
-      </a:accent5>
-      <a:accent6>
-        <a:srgbClr val="4EA72E"/>
-      </a:accent6>
-      <a:hlink>
-        <a:srgbClr val="467886"/>
-      </a:hlink>
-      <a:folHlink>
-        <a:srgbClr val="96607D"/>
-      </a:folHlink>
-    </a:clrScheme>
-    <a:fontScheme name="Office">
-      <a:majorFont>
-        <a:latin typeface="맑은 고딕" panose="02110004020202020204"/>
-        <a:ea typeface=""/>
-        <a:cs typeface=""/>
-        <a:font script="Jpan" typeface="游ゴシック Light"/>
-        <a:font script="Hang" typeface="맑은 고딕"/>
-        <a:font script="Hans" typeface="等线 Light"/>
-        <a:font script="Hant" typeface="新細明體"/>
-        <a:font script="Arab" typeface="Times New Roman"/>
-        <a:font script="Hebr" typeface="Times New Roman"/>
-        <a:font script="Thai" typeface="Angsana New"/>
-        <a:font script="Ethi" typeface="Nyala"/>
-        <a:font script="Beng" typeface="Vrinda"/>
-        <a:font script="Gujr" typeface="Shruti"/>
-        <a:font script="Khmr" typeface="MoolBoran"/>
-        <a:font script="Knda" typeface="Tunga"/>
-        <a:font script="Guru" typeface="Raavi"/>
-        <a:font script="Cans" typeface="Euphemia"/>
-        <a:font script="Cher" typeface="Plantagenet Cherokee"/>
-        <a:font script="Yiii" typeface="Microsoft Yi Baiti"/>
-        <a:font script="Tibt" typeface="Microsoft Himalaya"/>
-        <a:font script="Thaa" typeface="MV Boli"/>
-        <a:font script="Deva" typeface="Mangal"/>
-        <a:font script="Telu" typeface="Gautami"/>
-        <a:font script="Taml" typeface="Latha"/>
-        <a:font script="Syrc" typeface="Estrangelo Edessa"/>
-        <a:font script="Orya" typeface="Kalinga"/>
-        <a:font script="Mlym" typeface="Kartika"/>
-        <a:font script="Laoo" typeface="DokChampa"/>
-        <a:font script="Sinh" typeface="Iskoola Pota"/>
-        <a:font script="Mong" typeface="Mongolian Baiti"/>
-        <a:font script="Viet" typeface="Times New Roman"/>
-        <a:font script="Uigh" typeface="Microsoft Uighur"/>
-        <a:font script="Geor" typeface="Sylfaen"/>
-        <a:font script="Armn" typeface="Arial"/>
-        <a:font script="Bugi" typeface="Leelawadee UI"/>
-        <a:font script="Bopo" typeface="Microsoft JhengHei"/>
-        <a:font script="Java" typeface="Javanese Text"/>
-        <a:font script="Lisu" typeface="Segoe UI"/>
-        <a:font script="Mymr" typeface="Myanmar Text"/>
-        <a:font script="Nkoo" typeface="Ebrima"/>
-        <a:font script="Olck" typeface="Nirmala UI"/>
-        <a:font script="Osma" typeface="Ebrima"/>
-        <a:font script="Phag" typeface="Phagspa"/>
-        <a:font script="Syrn" typeface="Estrangelo Edessa"/>
-        <a:font script="Syrj" typeface="Estrangelo Edessa"/>
-        <a:font script="Syre" typeface="Estrangelo Edessa"/>
-        <a:font script="Sora" typeface="Nirmala UI"/>
-        <a:font script="Tale" typeface="Microsoft Tai Le"/>
-        <a:font script="Talu" typeface="Microsoft New Tai Lue"/>
-        <a:font script="Tfng" typeface="Ebrima"/>
-      </a:majorFont>
-      <a:minorFont>
-        <a:latin typeface="맑은 고딕" panose="02110004020202020204"/>
-        <a:ea typeface=""/>
-        <a:cs typeface=""/>
-        <a:font script="Jpan" typeface="游ゴシック"/>
-        <a:font script="Hang" typeface="맑은 고딕"/>
-        <a:font script="Hans" typeface="等线"/>
-        <a:font script="Hant" typeface="新細明體"/>
-        <a:font script="Arab" typeface="Arial"/>
-        <a:font script="Hebr" typeface="Arial"/>
-        <a:font script="Thai" typeface="Cordia New"/>
-        <a:font script="Ethi" typeface="Nyala"/>
-        <a:font script="Beng" typeface="Vrinda"/>
-        <a:font script="Gujr" typeface="Shruti"/>
-        <a:font script="Khmr" typeface="DaunPenh"/>
-        <a:font script="Knda" typeface="Tunga"/>
-        <a:font script="Guru" typeface="Raavi"/>
-        <a:font script="Cans" typeface="Euphemia"/>
-        <a:font script="Cher" typeface="Plantagenet Cherokee"/>
-        <a:font script="Yiii" typeface="Microsoft Yi Baiti"/>
-        <a:font script="Tibt" typeface="Microsoft Himalaya"/>
-        <a:font script="Thaa" typeface="MV Boli"/>
-        <a:font script="Deva" typeface="Mangal"/>
-        <a:font script="Telu" typeface="Gautami"/>
-        <a:font script="Taml" typeface="Latha"/>
-        <a:font script="Syrc" typeface="Estrangelo Edessa"/>
-        <a:font script="Orya" typeface="Kalinga"/>
-        <a:font script="Mlym" typeface="Kartika"/>
-        <a:font script="Laoo" typeface="DokChampa"/>
-        <a:font script="Sinh" typeface="Iskoola Pota"/>
-        <a:font script="Mong" typeface="Mongolian Baiti"/>
-        <a:font script="Viet" typeface="Arial"/>
-        <a:font script="Uigh" typeface="Microsoft Uighur"/>
-        <a:font script="Geor" typeface="Sylfaen"/>
-        <a:font script="Armn" typeface="Arial"/>
-        <a:font script="Bugi" typeface="Leelawadee UI"/>
-        <a:font script="Bopo" typeface="Microsoft JhengHei"/>
-        <a:font script="Java" typeface="Javanese Text"/>
-        <a:font script="Lisu" typeface="Segoe UI"/>
-        <a:font script="Mymr" typeface="Myanmar Text"/>
-        <a:font script="Nkoo" typeface="Ebrima"/>
-        <a:font script="Olck" typeface="Nirmala UI"/>
-        <a:font script="Osma" typeface="Ebrima"/>
-        <a:font script="Phag" typeface="Phagspa"/>
-        <a:font script="Syrn" typeface="Estrangelo Edessa"/>
-        <a:font script="Syrj" typeface="Estrangelo Edessa"/>
-        <a:font script="Syre" typeface="Estrangelo Edessa"/>
-        <a:font script="Sora" typeface="Nirmala UI"/>
-        <a:font script="Tale" typeface="Microsoft Tai Le"/>
-        <a:font script="Talu" typeface="Microsoft New Tai Lue"/>
-        <a:font script="Tfng" typeface="Ebrima"/>
-      </a:minorFont>
-    </a:fontScheme>
-    <a:fmtScheme name="Office">
-      <a:fillStyleLst>
-        <a:solidFill>
-          <a:schemeClr val="phClr"/>
-        </a:solidFill>
-        <a:gradFill rotWithShape="1">
-          <a:gsLst>
-            <a:gs pos="0">
-              <a:schemeClr val="phClr">
-                <a:lumMod val="110000"/>
-                <a:satMod val="105000"/>
-                <a:tint val="67000"/>
-              </a:schemeClr>
-            </a:gs>
-            <a:gs pos="50000">
-              <a:schemeClr val="phClr">
-                <a:lumMod val="105000"/>
-                <a:satMod val="103000"/>
-                <a:tint val="73000"/>
-              </a:schemeClr>
-            </a:gs>
-            <a:gs pos="100000">
-              <a:schemeClr val="phClr">
-                <a:lumMod val="105000"/>
-                <a:satMod val="109000"/>
-                <a:tint val="81000"/>
-              </a:schemeClr>
-            </a:gs>
-          </a:gsLst>
-          <a:lin ang="5400000" scaled="0"/>
-        </a:gradFill>
-        <a:gradFill rotWithShape="1">
-          <a:gsLst>
-            <a:gs pos="0">
-              <a:schemeClr val="phClr">
-                <a:satMod val="103000"/>
-                <a:lumMod val="102000"/>
-                <a:tint val="94000"/>
-              </a:schemeClr>
-            </a:gs>
-            <a:gs pos="50000">
-              <a:schemeClr val="phClr">
-                <a:satMod val="110000"/>
-                <a:lumMod val="100000"/>
-                <a:shade val="100000"/>
-              </a:schemeClr>
-            </a:gs>
-            <a:gs pos="100000">
-              <a:schemeClr val="phClr">
-                <a:lumMod val="99000"/>
-                <a:satMod val="120000"/>
-                <a:shade val="78000"/>
-              </a:schemeClr>
-            </a:gs>
-          </a:gsLst>
-          <a:lin ang="5400000" scaled="0"/>
-        </a:gradFill>
-      </a:fillStyleLst>
-      <a:lnStyleLst>
-        <a:ln w="12700" cap="flat" cmpd="sng" algn="ctr">
-          <a:solidFill>
-            <a:schemeClr val="phClr"/>
-          </a:solidFill>
-          <a:prstDash val="solid"/>
-          <a:miter lim="800000"/>
-        </a:ln>
-        <a:ln w="19050" cap="flat" cmpd="sng" algn="ctr">
-          <a:solidFill>
-            <a:schemeClr val="phClr"/>
-          </a:solidFill>
-          <a:prstDash val="solid"/>
-          <a:miter lim="800000"/>
-        </a:ln>
-        <a:ln w="25400" cap="flat" cmpd="sng" algn="ctr">
-          <a:solidFill>
-            <a:schemeClr val="phClr"/>
-          </a:solidFill>
-          <a:prstDash val="solid"/>
-          <a:miter lim="800000"/>
-        </a:ln>
-      </a:lnStyleLst>
-      <a:effectStyleLst>
-        <a:effectStyle>
-          <a:effectLst/>
-        </a:effectStyle>
-        <a:effectStyle>
-          <a:effectLst/>
-        </a:effectStyle>
-        <a:effectStyle>
-          <a:effectLst>
-            <a:outerShdw blurRad="57150" dist="19050" dir="5400000" algn="ctr" rotWithShape="0">
-              <a:srgbClr val="000000">
-                <a:alpha val="63000"/>
-              </a:srgbClr>
-            </a:outerShdw>
-          </a:effectLst>
-        </a:effectStyle>
-      </a:effectStyleLst>
-      <a:bgFillStyleLst>
-        <a:solidFill>
-          <a:schemeClr val="phClr"/>
-        </a:solidFill>
-        <a:solidFill>
-          <a:schemeClr val="phClr">
-            <a:tint val="95000"/>
-            <a:satMod val="170000"/>
-          </a:schemeClr>
-        </a:solidFill>
-        <a:gradFill rotWithShape="1">
-          <a:gsLst>
-            <a:gs pos="0">
-              <a:schemeClr val="phClr">
-                <a:tint val="93000"/>
-                <a:satMod val="150000"/>
-                <a:shade val="98000"/>
-                <a:lumMod val="102000"/>
-              </a:schemeClr>
-            </a:gs>
-            <a:gs pos="50000">
-              <a:schemeClr val="phClr">
-                <a:tint val="98000"/>
-                <a:satMod val="130000"/>
-                <a:shade val="90000"/>
-                <a:lumMod val="103000"/>
-              </a:schemeClr>
-            </a:gs>
-            <a:gs pos="100000">
-              <a:schemeClr val="phClr">
-                <a:shade val="63000"/>
-                <a:satMod val="120000"/>
-              </a:schemeClr>
-            </a:gs>
-          </a:gsLst>
-          <a:lin ang="5400000" scaled="0"/>
-        </a:gradFill>
-      </a:bgFillStyleLst>
-    </a:fmtScheme>
-  </a:themeElements>
-  <a:objectDefaults>
-    <a:lnDef>
-      <a:spPr/>
-      <a:bodyPr/>
-      <a:lstStyle/>
-      <a:style>
-        <a:lnRef idx="2">
-          <a:schemeClr val="accent1"/>
-        </a:lnRef>
-        <a:fillRef idx="0">
-          <a:schemeClr val="accent1"/>
-        </a:fillRef>
-        <a:effectRef idx="1">
-          <a:schemeClr val="accent1"/>
-        </a:effectRef>
-        <a:fontRef idx="minor">
-          <a:schemeClr val="tx1"/>
-        </a:fontRef>
-      </a:style>
-    </a:lnDef>
-  </a:objectDefaults>
-  <a:extraClrSchemeLst/>
-  <a:extLst>
-    <a:ext uri="{05A4C25C-085E-4340-85A3-A5531E510DB2}">
-      <thm15:themeFamily xmlns:thm15="http://schemas.microsoft.com/office/thememl/2012/main" name="Office Theme" id="{2E142A2C-CD16-42D6-873A-C26D2A0506FA}" vid="{1BDDFF52-6CD6-40A5-AB3C-68EB2F1E4D0A}"/>
-    </a:ext>
-  </a:extLst>
-</a:theme>
 </file>
</xml_diff>